<commit_message>
Docs: fairness, ablation, dashboard, adaptive RTO; deck slide 23; report section 8.6
Co-Authored-By: Claude Sonnet 5.5 <noreply@anthropic.com>
Claude-Session: https://claude.ai/code/session_01NX2zRNpdVAnzFNKmqomzKu
</commit_message>
<xml_diff>
--- a/docs/RUDP_Presentation.pptx
+++ b/docs/RUDP_Presentation.pptx
@@ -30,9 +30,10 @@
     <p:sldId id="278" r:id="rId24"/>
     <p:sldId id="279" r:id="rId25"/>
     <p:sldId id="280" r:id="rId26"/>
+    <p:sldId id="281" r:id="rId27"/>
   </p:sldIdLst>
   <p:notesMasterIdLst>
-    <p:notesMasterId r:id="rId27"/>
+    <p:notesMasterId r:id="rId28"/>
   </p:notesMasterIdLst>
   <p:sldSz cx="12192000" cy="6858000"/>
   <p:notesSz cx="6858000" cy="12192000"/>
@@ -2046,6 +2047,94 @@
             <a:fld id="{F7021451-1387-4CA6-816F-3879F97B5CBC}" type="slidenum">
               <a:rPr lang="en-US"/>
               <a:t>25</a:t>
+            </a:fld>
+            <a:endParaRPr lang="en-US"/>
+          </a:p>
+        </p:txBody>
+      </p:sp>
+    </p:spTree>
+    <p:extLst>
+      <p:ext uri="{BB962C8B-B14F-4D97-AF65-F5344CB8AC3E}">
+        <p14:creationId xmlns:p14="http://schemas.microsoft.com/office/powerpoint/2010/main" val="1024086991"/>
+      </p:ext>
+    </p:extLst>
+  </p:cSld>
+  <p:clrMapOvr>
+    <a:masterClrMapping/>
+  </p:clrMapOvr>
+</p:notes>
+</file>
+
+<file path=ppt/notesSlides/notesSlide26.xml><?xml version="1.0" encoding="utf-8"?>
+<p:notes xmlns:a="http://schemas.openxmlformats.org/drawingml/2006/main" xmlns:r="http://schemas.openxmlformats.org/officeDocument/2006/relationships" xmlns:p="http://schemas.openxmlformats.org/presentationml/2006/main">
+  <p:cSld>
+    <p:spTree>
+      <p:nvGrpSpPr>
+        <p:cNvPr id="1" name=""/>
+        <p:cNvGrpSpPr/>
+        <p:nvPr/>
+      </p:nvGrpSpPr>
+      <p:grpSpPr>
+        <a:xfrm>
+          <a:off x="0" y="0"/>
+          <a:ext cx="0" cy="0"/>
+          <a:chOff x="0" y="0"/>
+          <a:chExt cx="0" cy="0"/>
+        </a:xfrm>
+      </p:grpSpPr>
+      <p:sp>
+        <p:nvSpPr>
+          <p:cNvPr id="2" name="Slide Image Placeholder 1"/>
+          <p:cNvSpPr>
+            <a:spLocks noGrp="1" noRot="1" noChangeAspect="1"/>
+          </p:cNvSpPr>
+          <p:nvPr>
+            <p:ph type="sldImg"/>
+          </p:nvPr>
+        </p:nvSpPr>
+        <p:spPr/>
+      </p:sp>
+      <p:sp>
+        <p:nvSpPr>
+          <p:cNvPr id="3" name="Notes Placeholder 2"/>
+          <p:cNvSpPr>
+            <a:spLocks noGrp="1"/>
+          </p:cNvSpPr>
+          <p:nvPr>
+            <p:ph type="body" idx="1"/>
+          </p:nvPr>
+        </p:nvSpPr>
+        <p:spPr/>
+        <p:txBody>
+          <a:bodyPr/>
+          <a:lstStyle/>
+          <a:p>
+            <a:r>
+              <a:rPr lang="en-US" dirty="0"/>
+              <a:t/>
+            </a:r>
+            <a:endParaRPr lang="en-US" dirty="0"/>
+          </a:p>
+        </p:txBody>
+      </p:sp>
+      <p:sp>
+        <p:nvSpPr>
+          <p:cNvPr id="4" name="Slide Number Placeholder 3"/>
+          <p:cNvSpPr>
+            <a:spLocks noGrp="1"/>
+          </p:cNvSpPr>
+          <p:nvPr>
+            <p:ph type="sldNum" sz="quarter" idx="10"/>
+          </p:nvPr>
+        </p:nvSpPr>
+        <p:spPr/>
+        <p:txBody>
+          <a:bodyPr/>
+          <a:lstStyle/>
+          <a:p>
+            <a:fld id="{F7021451-1387-4CA6-816F-3879F97B5CBC}" type="slidenum">
+              <a:rPr lang="en-US"/>
+              <a:t>26</a:t>
             </a:fld>
             <a:endParaRPr lang="en-US"/>
           </a:p>
@@ -3271,7 +3360,7 @@
                 <a:ea typeface="Courier New" pitchFamily="34" charset="-122"/>
                 <a:cs typeface="Courier New" pitchFamily="34" charset="-120"/>
               </a:rPr>
-              <a:t>10 / 24   Smart-RUDP</a:t>
+              <a:t>10 / 25   Smart-RUDP</a:t>
             </a:r>
             <a:endParaRPr lang="en-US" sz="1000" dirty="0"/>
           </a:p>
@@ -3468,7 +3557,7 @@
                 <a:ea typeface="Courier New" pitchFamily="34" charset="-122"/>
                 <a:cs typeface="Courier New" pitchFamily="34" charset="-120"/>
               </a:rPr>
-              <a:t>11 / 24   Smart-RUDP</a:t>
+              <a:t>11 / 25   Smart-RUDP</a:t>
             </a:r>
             <a:endParaRPr lang="en-US" sz="1000" dirty="0"/>
           </a:p>
@@ -4298,7 +4387,7 @@
                 <a:ea typeface="Courier New" pitchFamily="34" charset="-122"/>
                 <a:cs typeface="Courier New" pitchFamily="34" charset="-120"/>
               </a:rPr>
-              <a:t>12 / 24   Smart-RUDP</a:t>
+              <a:t>12 / 25   Smart-RUDP</a:t>
             </a:r>
             <a:endParaRPr lang="en-US" sz="1000" dirty="0"/>
           </a:p>
@@ -4595,7 +4684,7 @@
                 <a:ea typeface="Courier New" pitchFamily="34" charset="-122"/>
                 <a:cs typeface="Courier New" pitchFamily="34" charset="-120"/>
               </a:rPr>
-              <a:t>13 / 24   Smart-RUDP</a:t>
+              <a:t>13 / 25   Smart-RUDP</a:t>
             </a:r>
             <a:endParaRPr lang="en-US" sz="1000" dirty="0"/>
           </a:p>
@@ -4895,7 +4984,7 @@
                 <a:ea typeface="Courier New" pitchFamily="34" charset="-122"/>
                 <a:cs typeface="Courier New" pitchFamily="34" charset="-120"/>
               </a:rPr>
-              <a:t>14 / 24   Smart-RUDP</a:t>
+              <a:t>14 / 25   Smart-RUDP</a:t>
             </a:r>
             <a:endParaRPr lang="en-US" sz="1000" dirty="0"/>
           </a:p>
@@ -5279,7 +5368,7 @@
                 <a:ea typeface="Courier New" pitchFamily="34" charset="-122"/>
                 <a:cs typeface="Courier New" pitchFamily="34" charset="-120"/>
               </a:rPr>
-              <a:t>15 / 24   Smart-RUDP</a:t>
+              <a:t>15 / 25   Smart-RUDP</a:t>
             </a:r>
             <a:endParaRPr lang="en-US" sz="1000" dirty="0"/>
           </a:p>
@@ -5737,7 +5826,7 @@
                 <a:ea typeface="Courier New" pitchFamily="34" charset="-122"/>
                 <a:cs typeface="Courier New" pitchFamily="34" charset="-120"/>
               </a:rPr>
-              <a:t>16 / 24   Smart-RUDP</a:t>
+              <a:t>16 / 25   Smart-RUDP</a:t>
             </a:r>
             <a:endParaRPr lang="en-US" sz="1000" dirty="0"/>
           </a:p>
@@ -6422,7 +6511,7 @@
                 <a:ea typeface="Courier New" pitchFamily="34" charset="-122"/>
                 <a:cs typeface="Courier New" pitchFamily="34" charset="-120"/>
               </a:rPr>
-              <a:t>17 / 24   Smart-RUDP</a:t>
+              <a:t>17 / 25   Smart-RUDP</a:t>
             </a:r>
             <a:endParaRPr lang="en-US" sz="1000" dirty="0"/>
           </a:p>
@@ -6662,7 +6751,7 @@
                 <a:ea typeface="Courier New" pitchFamily="34" charset="-122"/>
                 <a:cs typeface="Courier New" pitchFamily="34" charset="-120"/>
               </a:rPr>
-              <a:t>18 / 24   Smart-RUDP</a:t>
+              <a:t>18 / 25   Smart-RUDP</a:t>
             </a:r>
             <a:endParaRPr lang="en-US" sz="1000" dirty="0"/>
           </a:p>
@@ -6902,7 +6991,7 @@
                 <a:ea typeface="Courier New" pitchFamily="34" charset="-122"/>
                 <a:cs typeface="Courier New" pitchFamily="34" charset="-120"/>
               </a:rPr>
-              <a:t>19 / 24   Smart-RUDP</a:t>
+              <a:t>19 / 25   Smart-RUDP</a:t>
             </a:r>
             <a:endParaRPr lang="en-US" sz="1000" dirty="0"/>
           </a:p>
@@ -7124,7 +7213,7 @@
                 <a:ea typeface="Courier New" pitchFamily="34" charset="-122"/>
                 <a:cs typeface="Courier New" pitchFamily="34" charset="-120"/>
               </a:rPr>
-              <a:t>2 / 24   Smart-RUDP</a:t>
+              <a:t>2 / 25   Smart-RUDP</a:t>
             </a:r>
             <a:endParaRPr lang="en-US" sz="1000" dirty="0"/>
           </a:p>
@@ -7518,7 +7607,7 @@
                 <a:ea typeface="Courier New" pitchFamily="34" charset="-122"/>
                 <a:cs typeface="Courier New" pitchFamily="34" charset="-120"/>
               </a:rPr>
-              <a:t>20 / 24   Smart-RUDP</a:t>
+              <a:t>20 / 25   Smart-RUDP</a:t>
             </a:r>
             <a:endParaRPr lang="en-US" sz="1000" dirty="0"/>
           </a:p>
@@ -7842,7 +7931,7 @@
                 <a:ea typeface="Courier New" pitchFamily="34" charset="-122"/>
                 <a:cs typeface="Courier New" pitchFamily="34" charset="-120"/>
               </a:rPr>
-              <a:t>21 / 24   Smart-RUDP</a:t>
+              <a:t>21 / 25   Smart-RUDP</a:t>
             </a:r>
             <a:endParaRPr lang="en-US" sz="1000" dirty="0"/>
           </a:p>
@@ -9549,7 +9638,7 @@
                 <a:ea typeface="Courier New" pitchFamily="34" charset="-122"/>
                 <a:cs typeface="Courier New" pitchFamily="34" charset="-120"/>
               </a:rPr>
-              <a:t>22 / 24   Smart-RUDP</a:t>
+              <a:t>22 / 25   Smart-RUDP</a:t>
             </a:r>
             <a:endParaRPr lang="en-US" sz="1000" dirty="0"/>
           </a:p>
@@ -10893,7 +10982,7 @@
                 <a:ea typeface="Courier New" pitchFamily="34" charset="-122"/>
                 <a:cs typeface="Courier New" pitchFamily="34" charset="-120"/>
               </a:rPr>
-              <a:t>Learnings and future work</a:t>
+              <a:t>Fairness, ablations, chat fixes</a:t>
             </a:r>
             <a:endParaRPr lang="en-US" sz="3000" dirty="0"/>
           </a:p>
@@ -10932,47 +11021,1289 @@
                 <a:ea typeface="Courier New" pitchFamily="34" charset="-122"/>
                 <a:cs typeface="Courier New" pitchFamily="34" charset="-120"/>
               </a:rPr>
-              <a:t>23 / 24   Smart-RUDP</a:t>
+              <a:t>23 / 25   Smart-RUDP</a:t>
             </a:r>
             <a:endParaRPr lang="en-US" sz="1000" dirty="0"/>
           </a:p>
         </p:txBody>
       </p:sp>
-      <p:sp>
-        <p:nvSpPr>
-          <p:cNvPr id="4" name="Shape 2"/>
+      <p:graphicFrame>
+        <p:nvGraphicFramePr>
+          <p:cNvPr id="24" name="Table 0"/>
+          <p:cNvGraphicFramePr>
+            <a:graphicFrameLocks noGrp="1"/>
+          </p:cNvGraphicFramePr>
+          <p:nvPr>
+            <p:extLst>
+              <p:ext uri="{D42A27DB-BD31-4B8C-83A1-F6EECF244321}">
+                <p14:modId xmlns:p14="http://schemas.microsoft.com/office/powerpoint/2010/main" val="1579011935"/>
+              </p:ext>
+            </p:extLst>
+          </p:nvPr>
+        </p:nvGraphicFramePr>
+        <p:xfrm>
+          <a:off x="548640" y="1188720"/>
+          <a:ext cx="5852160" cy="914400"/>
+        </p:xfrm>
+        <a:graphic>
+          <a:graphicData uri="http://schemas.openxmlformats.org/drawingml/2006/table">
+            <a:tbl>
+              <a:tblPr/>
+              <a:tblGrid>
+                <a:gridCol w="3291840"/>
+                <a:gridCol w="1280160"/>
+                <a:gridCol w="1280160"/>
+              </a:tblGrid>
+              <a:tr h="384048">
+                <a:tc>
+                  <a:txBody>
+                    <a:bodyPr/>
+                    <a:lstStyle/>
+                    <a:p>
+                      <a:pPr indent="0" marL="0">
+                        <a:buNone/>
+                      </a:pPr>
+                      <a:r>
+                        <a:rPr lang="en-US" sz="1300" b="1" dirty="0">
+                          <a:solidFill>
+                            <a:srgbClr val="0B0F14"/>
+                          </a:solidFill>
+                          <a:latin typeface="Courier New" pitchFamily="34" charset="0"/>
+                          <a:ea typeface="Courier New" pitchFamily="34" charset="-122"/>
+                          <a:cs typeface="Courier New" pitchFamily="34" charset="-120"/>
+                        </a:rPr>
+                        <a:t>Two flows, one bottleneck</a:t>
+                      </a:r>
+                      <a:endParaRPr lang="en-US" sz="1300" dirty="0">
+                        <a:latin typeface="Courier New" charset="0"/>
+                        <a:ea typeface="Courier New" charset="0"/>
+                        <a:cs typeface="Courier New" charset="0"/>
+                      </a:endParaRPr>
+                    </a:p>
+                  </a:txBody>
+                  <a:tcPr marL="91440" marR="91440" marT="45720" marB="45720">
+                    <a:lnL w="12700" cap="flat" cmpd="sng" algn="ctr">
+                      <a:solidFill>
+                        <a:srgbClr val="2A3441"/>
+                      </a:solidFill>
+                      <a:prstDash val="solid"/>
+                      <a:round/>
+                      <a:headEnd type="none" w="med" len="med"/>
+                      <a:tailEnd type="none" w="med" len="med"/>
+                    </a:lnL>
+                    <a:lnR w="12700" cap="flat" cmpd="sng" algn="ctr">
+                      <a:solidFill>
+                        <a:srgbClr val="2A3441"/>
+                      </a:solidFill>
+                      <a:prstDash val="solid"/>
+                      <a:round/>
+                      <a:headEnd type="none" w="med" len="med"/>
+                      <a:tailEnd type="none" w="med" len="med"/>
+                    </a:lnR>
+                    <a:lnT w="12700" cap="flat" cmpd="sng" algn="ctr">
+                      <a:solidFill>
+                        <a:srgbClr val="2A3441"/>
+                      </a:solidFill>
+                      <a:prstDash val="solid"/>
+                      <a:round/>
+                      <a:headEnd type="none" w="med" len="med"/>
+                      <a:tailEnd type="none" w="med" len="med"/>
+                    </a:lnT>
+                    <a:lnB w="12700" cap="flat" cmpd="sng" algn="ctr">
+                      <a:solidFill>
+                        <a:srgbClr val="2A3441"/>
+                      </a:solidFill>
+                      <a:prstDash val="solid"/>
+                      <a:round/>
+                      <a:headEnd type="none" w="med" len="med"/>
+                      <a:tailEnd type="none" w="med" len="med"/>
+                    </a:lnB>
+                    <a:solidFill>
+                      <a:srgbClr val="39FF88"/>
+                    </a:solidFill>
+                  </a:tcPr>
+                </a:tc>
+                <a:tc>
+                  <a:txBody>
+                    <a:bodyPr/>
+                    <a:lstStyle/>
+                    <a:p>
+                      <a:pPr indent="0" marL="0">
+                        <a:buNone/>
+                      </a:pPr>
+                      <a:r>
+                        <a:rPr lang="en-US" sz="1300" b="1" dirty="0">
+                          <a:solidFill>
+                            <a:srgbClr val="0B0F14"/>
+                          </a:solidFill>
+                          <a:latin typeface="Courier New" pitchFamily="34" charset="0"/>
+                          <a:ea typeface="Courier New" pitchFamily="34" charset="-122"/>
+                          <a:cs typeface="Courier New" pitchFamily="34" charset="-120"/>
+                        </a:rPr>
+                        <a:t>Share of A</a:t>
+                      </a:r>
+                      <a:endParaRPr lang="en-US" sz="1300" dirty="0">
+                        <a:latin typeface="Courier New" charset="0"/>
+                        <a:ea typeface="Courier New" charset="0"/>
+                        <a:cs typeface="Courier New" charset="0"/>
+                      </a:endParaRPr>
+                    </a:p>
+                  </a:txBody>
+                  <a:tcPr marL="91440" marR="91440" marT="45720" marB="45720">
+                    <a:lnL w="12700" cap="flat" cmpd="sng" algn="ctr">
+                      <a:solidFill>
+                        <a:srgbClr val="2A3441"/>
+                      </a:solidFill>
+                      <a:prstDash val="solid"/>
+                      <a:round/>
+                      <a:headEnd type="none" w="med" len="med"/>
+                      <a:tailEnd type="none" w="med" len="med"/>
+                    </a:lnL>
+                    <a:lnR w="12700" cap="flat" cmpd="sng" algn="ctr">
+                      <a:solidFill>
+                        <a:srgbClr val="2A3441"/>
+                      </a:solidFill>
+                      <a:prstDash val="solid"/>
+                      <a:round/>
+                      <a:headEnd type="none" w="med" len="med"/>
+                      <a:tailEnd type="none" w="med" len="med"/>
+                    </a:lnR>
+                    <a:lnT w="12700" cap="flat" cmpd="sng" algn="ctr">
+                      <a:solidFill>
+                        <a:srgbClr val="2A3441"/>
+                      </a:solidFill>
+                      <a:prstDash val="solid"/>
+                      <a:round/>
+                      <a:headEnd type="none" w="med" len="med"/>
+                      <a:tailEnd type="none" w="med" len="med"/>
+                    </a:lnT>
+                    <a:lnB w="12700" cap="flat" cmpd="sng" algn="ctr">
+                      <a:solidFill>
+                        <a:srgbClr val="2A3441"/>
+                      </a:solidFill>
+                      <a:prstDash val="solid"/>
+                      <a:round/>
+                      <a:headEnd type="none" w="med" len="med"/>
+                      <a:tailEnd type="none" w="med" len="med"/>
+                    </a:lnB>
+                    <a:solidFill>
+                      <a:srgbClr val="39FF88"/>
+                    </a:solidFill>
+                  </a:tcPr>
+                </a:tc>
+                <a:tc>
+                  <a:txBody>
+                    <a:bodyPr/>
+                    <a:lstStyle/>
+                    <a:p>
+                      <a:pPr indent="0" marL="0">
+                        <a:buNone/>
+                      </a:pPr>
+                      <a:r>
+                        <a:rPr lang="en-US" sz="1300" b="1" dirty="0">
+                          <a:solidFill>
+                            <a:srgbClr val="0B0F14"/>
+                          </a:solidFill>
+                          <a:latin typeface="Courier New" pitchFamily="34" charset="0"/>
+                          <a:ea typeface="Courier New" pitchFamily="34" charset="-122"/>
+                          <a:cs typeface="Courier New" pitchFamily="34" charset="-120"/>
+                        </a:rPr>
+                        <a:t>Jain</a:t>
+                      </a:r>
+                      <a:endParaRPr lang="en-US" sz="1300" dirty="0">
+                        <a:latin typeface="Courier New" charset="0"/>
+                        <a:ea typeface="Courier New" charset="0"/>
+                        <a:cs typeface="Courier New" charset="0"/>
+                      </a:endParaRPr>
+                    </a:p>
+                  </a:txBody>
+                  <a:tcPr marL="91440" marR="91440" marT="45720" marB="45720">
+                    <a:lnL w="12700" cap="flat" cmpd="sng" algn="ctr">
+                      <a:solidFill>
+                        <a:srgbClr val="2A3441"/>
+                      </a:solidFill>
+                      <a:prstDash val="solid"/>
+                      <a:round/>
+                      <a:headEnd type="none" w="med" len="med"/>
+                      <a:tailEnd type="none" w="med" len="med"/>
+                    </a:lnL>
+                    <a:lnR w="12700" cap="flat" cmpd="sng" algn="ctr">
+                      <a:solidFill>
+                        <a:srgbClr val="2A3441"/>
+                      </a:solidFill>
+                      <a:prstDash val="solid"/>
+                      <a:round/>
+                      <a:headEnd type="none" w="med" len="med"/>
+                      <a:tailEnd type="none" w="med" len="med"/>
+                    </a:lnR>
+                    <a:lnT w="12700" cap="flat" cmpd="sng" algn="ctr">
+                      <a:solidFill>
+                        <a:srgbClr val="2A3441"/>
+                      </a:solidFill>
+                      <a:prstDash val="solid"/>
+                      <a:round/>
+                      <a:headEnd type="none" w="med" len="med"/>
+                      <a:tailEnd type="none" w="med" len="med"/>
+                    </a:lnT>
+                    <a:lnB w="12700" cap="flat" cmpd="sng" algn="ctr">
+                      <a:solidFill>
+                        <a:srgbClr val="2A3441"/>
+                      </a:solidFill>
+                      <a:prstDash val="solid"/>
+                      <a:round/>
+                      <a:headEnd type="none" w="med" len="med"/>
+                      <a:tailEnd type="none" w="med" len="med"/>
+                    </a:lnB>
+                    <a:solidFill>
+                      <a:srgbClr val="39FF88"/>
+                    </a:solidFill>
+                  </a:tcPr>
+                </a:tc>
+              </a:tr>
+              <a:tr h="384048">
+                <a:tc>
+                  <a:txBody>
+                    <a:bodyPr/>
+                    <a:lstStyle/>
+                    <a:p>
+                      <a:pPr indent="0" marL="0">
+                        <a:buNone/>
+                      </a:pPr>
+                      <a:r>
+                        <a:rPr lang="en-US" sz="1300" dirty="0">
+                          <a:solidFill>
+                            <a:srgbClr val="E6EDF3"/>
+                          </a:solidFill>
+                          <a:latin typeface="Calibri" pitchFamily="34" charset="0"/>
+                          <a:ea typeface="Calibri" pitchFamily="34" charset="-122"/>
+                          <a:cs typeface="Calibri" pitchFamily="34" charset="-120"/>
+                        </a:rPr>
+                        <a:t>AIMD vs AIMD (long path)</a:t>
+                      </a:r>
+                      <a:endParaRPr lang="en-US" sz="1300" dirty="0">
+                        <a:latin typeface="Calibri" charset="0"/>
+                        <a:ea typeface="Calibri" charset="0"/>
+                        <a:cs typeface="Calibri" charset="0"/>
+                      </a:endParaRPr>
+                    </a:p>
+                  </a:txBody>
+                  <a:tcPr marL="91440" marR="91440" marT="45720" marB="45720">
+                    <a:lnL w="12700" cap="flat" cmpd="sng" algn="ctr">
+                      <a:solidFill>
+                        <a:srgbClr val="2A3441"/>
+                      </a:solidFill>
+                      <a:prstDash val="solid"/>
+                      <a:round/>
+                      <a:headEnd type="none" w="med" len="med"/>
+                      <a:tailEnd type="none" w="med" len="med"/>
+                    </a:lnL>
+                    <a:lnR w="12700" cap="flat" cmpd="sng" algn="ctr">
+                      <a:solidFill>
+                        <a:srgbClr val="2A3441"/>
+                      </a:solidFill>
+                      <a:prstDash val="solid"/>
+                      <a:round/>
+                      <a:headEnd type="none" w="med" len="med"/>
+                      <a:tailEnd type="none" w="med" len="med"/>
+                    </a:lnR>
+                    <a:lnT w="12700" cap="flat" cmpd="sng" algn="ctr">
+                      <a:solidFill>
+                        <a:srgbClr val="2A3441"/>
+                      </a:solidFill>
+                      <a:prstDash val="solid"/>
+                      <a:round/>
+                      <a:headEnd type="none" w="med" len="med"/>
+                      <a:tailEnd type="none" w="med" len="med"/>
+                    </a:lnT>
+                    <a:lnB w="12700" cap="flat" cmpd="sng" algn="ctr">
+                      <a:solidFill>
+                        <a:srgbClr val="2A3441"/>
+                      </a:solidFill>
+                      <a:prstDash val="solid"/>
+                      <a:round/>
+                      <a:headEnd type="none" w="med" len="med"/>
+                      <a:tailEnd type="none" w="med" len="med"/>
+                    </a:lnB>
+                    <a:solidFill>
+                      <a:srgbClr val="141B24"/>
+                    </a:solidFill>
+                  </a:tcPr>
+                </a:tc>
+                <a:tc>
+                  <a:txBody>
+                    <a:bodyPr/>
+                    <a:lstStyle/>
+                    <a:p>
+                      <a:pPr indent="0" marL="0">
+                        <a:buNone/>
+                      </a:pPr>
+                      <a:r>
+                        <a:rPr lang="en-US" sz="1300" dirty="0">
+                          <a:solidFill>
+                            <a:srgbClr val="E6EDF3"/>
+                          </a:solidFill>
+                          <a:latin typeface="Calibri" pitchFamily="34" charset="0"/>
+                          <a:ea typeface="Calibri" pitchFamily="34" charset="-122"/>
+                          <a:cs typeface="Calibri" pitchFamily="34" charset="-120"/>
+                        </a:rPr>
+                        <a:t>51%</a:t>
+                      </a:r>
+                      <a:endParaRPr lang="en-US" sz="1300" dirty="0">
+                        <a:latin typeface="Calibri" charset="0"/>
+                        <a:ea typeface="Calibri" charset="0"/>
+                        <a:cs typeface="Calibri" charset="0"/>
+                      </a:endParaRPr>
+                    </a:p>
+                  </a:txBody>
+                  <a:tcPr marL="91440" marR="91440" marT="45720" marB="45720">
+                    <a:lnL w="12700" cap="flat" cmpd="sng" algn="ctr">
+                      <a:solidFill>
+                        <a:srgbClr val="2A3441"/>
+                      </a:solidFill>
+                      <a:prstDash val="solid"/>
+                      <a:round/>
+                      <a:headEnd type="none" w="med" len="med"/>
+                      <a:tailEnd type="none" w="med" len="med"/>
+                    </a:lnL>
+                    <a:lnR w="12700" cap="flat" cmpd="sng" algn="ctr">
+                      <a:solidFill>
+                        <a:srgbClr val="2A3441"/>
+                      </a:solidFill>
+                      <a:prstDash val="solid"/>
+                      <a:round/>
+                      <a:headEnd type="none" w="med" len="med"/>
+                      <a:tailEnd type="none" w="med" len="med"/>
+                    </a:lnR>
+                    <a:lnT w="12700" cap="flat" cmpd="sng" algn="ctr">
+                      <a:solidFill>
+                        <a:srgbClr val="2A3441"/>
+                      </a:solidFill>
+                      <a:prstDash val="solid"/>
+                      <a:round/>
+                      <a:headEnd type="none" w="med" len="med"/>
+                      <a:tailEnd type="none" w="med" len="med"/>
+                    </a:lnT>
+                    <a:lnB w="12700" cap="flat" cmpd="sng" algn="ctr">
+                      <a:solidFill>
+                        <a:srgbClr val="2A3441"/>
+                      </a:solidFill>
+                      <a:prstDash val="solid"/>
+                      <a:round/>
+                      <a:headEnd type="none" w="med" len="med"/>
+                      <a:tailEnd type="none" w="med" len="med"/>
+                    </a:lnB>
+                    <a:solidFill>
+                      <a:srgbClr val="141B24"/>
+                    </a:solidFill>
+                  </a:tcPr>
+                </a:tc>
+                <a:tc>
+                  <a:txBody>
+                    <a:bodyPr/>
+                    <a:lstStyle/>
+                    <a:p>
+                      <a:pPr indent="0" marL="0">
+                        <a:buNone/>
+                      </a:pPr>
+                      <a:r>
+                        <a:rPr lang="en-US" sz="1300" dirty="0">
+                          <a:solidFill>
+                            <a:srgbClr val="E6EDF3"/>
+                          </a:solidFill>
+                          <a:latin typeface="Calibri" pitchFamily="34" charset="0"/>
+                          <a:ea typeface="Calibri" pitchFamily="34" charset="-122"/>
+                          <a:cs typeface="Calibri" pitchFamily="34" charset="-120"/>
+                        </a:rPr>
+                        <a:t>0.999</a:t>
+                      </a:r>
+                      <a:endParaRPr lang="en-US" sz="1300" dirty="0">
+                        <a:latin typeface="Calibri" charset="0"/>
+                        <a:ea typeface="Calibri" charset="0"/>
+                        <a:cs typeface="Calibri" charset="0"/>
+                      </a:endParaRPr>
+                    </a:p>
+                  </a:txBody>
+                  <a:tcPr marL="91440" marR="91440" marT="45720" marB="45720">
+                    <a:lnL w="12700" cap="flat" cmpd="sng" algn="ctr">
+                      <a:solidFill>
+                        <a:srgbClr val="2A3441"/>
+                      </a:solidFill>
+                      <a:prstDash val="solid"/>
+                      <a:round/>
+                      <a:headEnd type="none" w="med" len="med"/>
+                      <a:tailEnd type="none" w="med" len="med"/>
+                    </a:lnL>
+                    <a:lnR w="12700" cap="flat" cmpd="sng" algn="ctr">
+                      <a:solidFill>
+                        <a:srgbClr val="2A3441"/>
+                      </a:solidFill>
+                      <a:prstDash val="solid"/>
+                      <a:round/>
+                      <a:headEnd type="none" w="med" len="med"/>
+                      <a:tailEnd type="none" w="med" len="med"/>
+                    </a:lnR>
+                    <a:lnT w="12700" cap="flat" cmpd="sng" algn="ctr">
+                      <a:solidFill>
+                        <a:srgbClr val="2A3441"/>
+                      </a:solidFill>
+                      <a:prstDash val="solid"/>
+                      <a:round/>
+                      <a:headEnd type="none" w="med" len="med"/>
+                      <a:tailEnd type="none" w="med" len="med"/>
+                    </a:lnT>
+                    <a:lnB w="12700" cap="flat" cmpd="sng" algn="ctr">
+                      <a:solidFill>
+                        <a:srgbClr val="2A3441"/>
+                      </a:solidFill>
+                      <a:prstDash val="solid"/>
+                      <a:round/>
+                      <a:headEnd type="none" w="med" len="med"/>
+                      <a:tailEnd type="none" w="med" len="med"/>
+                    </a:lnB>
+                    <a:solidFill>
+                      <a:srgbClr val="141B24"/>
+                    </a:solidFill>
+                  </a:tcPr>
+                </a:tc>
+              </a:tr>
+              <a:tr h="384048">
+                <a:tc>
+                  <a:txBody>
+                    <a:bodyPr/>
+                    <a:lstStyle/>
+                    <a:p>
+                      <a:pPr indent="0" marL="0">
+                        <a:buNone/>
+                      </a:pPr>
+                      <a:r>
+                        <a:rPr lang="en-US" sz="1300" dirty="0">
+                          <a:solidFill>
+                            <a:srgbClr val="E6EDF3"/>
+                          </a:solidFill>
+                          <a:latin typeface="Calibri" pitchFamily="34" charset="0"/>
+                          <a:ea typeface="Calibri" pitchFamily="34" charset="-122"/>
+                          <a:cs typeface="Calibri" pitchFamily="34" charset="-120"/>
+                        </a:rPr>
+                        <a:t>Deep vs deep (long path)</a:t>
+                      </a:r>
+                      <a:endParaRPr lang="en-US" sz="1300" dirty="0">
+                        <a:latin typeface="Calibri" charset="0"/>
+                        <a:ea typeface="Calibri" charset="0"/>
+                        <a:cs typeface="Calibri" charset="0"/>
+                      </a:endParaRPr>
+                    </a:p>
+                  </a:txBody>
+                  <a:tcPr marL="91440" marR="91440" marT="45720" marB="45720">
+                    <a:lnL w="12700" cap="flat" cmpd="sng" algn="ctr">
+                      <a:solidFill>
+                        <a:srgbClr val="2A3441"/>
+                      </a:solidFill>
+                      <a:prstDash val="solid"/>
+                      <a:round/>
+                      <a:headEnd type="none" w="med" len="med"/>
+                      <a:tailEnd type="none" w="med" len="med"/>
+                    </a:lnL>
+                    <a:lnR w="12700" cap="flat" cmpd="sng" algn="ctr">
+                      <a:solidFill>
+                        <a:srgbClr val="2A3441"/>
+                      </a:solidFill>
+                      <a:prstDash val="solid"/>
+                      <a:round/>
+                      <a:headEnd type="none" w="med" len="med"/>
+                      <a:tailEnd type="none" w="med" len="med"/>
+                    </a:lnR>
+                    <a:lnT w="12700" cap="flat" cmpd="sng" algn="ctr">
+                      <a:solidFill>
+                        <a:srgbClr val="2A3441"/>
+                      </a:solidFill>
+                      <a:prstDash val="solid"/>
+                      <a:round/>
+                      <a:headEnd type="none" w="med" len="med"/>
+                      <a:tailEnd type="none" w="med" len="med"/>
+                    </a:lnT>
+                    <a:lnB w="12700" cap="flat" cmpd="sng" algn="ctr">
+                      <a:solidFill>
+                        <a:srgbClr val="2A3441"/>
+                      </a:solidFill>
+                      <a:prstDash val="solid"/>
+                      <a:round/>
+                      <a:headEnd type="none" w="med" len="med"/>
+                      <a:tailEnd type="none" w="med" len="med"/>
+                    </a:lnB>
+                    <a:solidFill>
+                      <a:srgbClr val="141B24"/>
+                    </a:solidFill>
+                  </a:tcPr>
+                </a:tc>
+                <a:tc>
+                  <a:txBody>
+                    <a:bodyPr/>
+                    <a:lstStyle/>
+                    <a:p>
+                      <a:pPr indent="0" marL="0">
+                        <a:buNone/>
+                      </a:pPr>
+                      <a:r>
+                        <a:rPr lang="en-US" sz="1300" dirty="0">
+                          <a:solidFill>
+                            <a:srgbClr val="E6EDF3"/>
+                          </a:solidFill>
+                          <a:latin typeface="Calibri" pitchFamily="34" charset="0"/>
+                          <a:ea typeface="Calibri" pitchFamily="34" charset="-122"/>
+                          <a:cs typeface="Calibri" pitchFamily="34" charset="-120"/>
+                        </a:rPr>
+                        <a:t>59%</a:t>
+                      </a:r>
+                      <a:endParaRPr lang="en-US" sz="1300" dirty="0">
+                        <a:latin typeface="Calibri" charset="0"/>
+                        <a:ea typeface="Calibri" charset="0"/>
+                        <a:cs typeface="Calibri" charset="0"/>
+                      </a:endParaRPr>
+                    </a:p>
+                  </a:txBody>
+                  <a:tcPr marL="91440" marR="91440" marT="45720" marB="45720">
+                    <a:lnL w="12700" cap="flat" cmpd="sng" algn="ctr">
+                      <a:solidFill>
+                        <a:srgbClr val="2A3441"/>
+                      </a:solidFill>
+                      <a:prstDash val="solid"/>
+                      <a:round/>
+                      <a:headEnd type="none" w="med" len="med"/>
+                      <a:tailEnd type="none" w="med" len="med"/>
+                    </a:lnL>
+                    <a:lnR w="12700" cap="flat" cmpd="sng" algn="ctr">
+                      <a:solidFill>
+                        <a:srgbClr val="2A3441"/>
+                      </a:solidFill>
+                      <a:prstDash val="solid"/>
+                      <a:round/>
+                      <a:headEnd type="none" w="med" len="med"/>
+                      <a:tailEnd type="none" w="med" len="med"/>
+                    </a:lnR>
+                    <a:lnT w="12700" cap="flat" cmpd="sng" algn="ctr">
+                      <a:solidFill>
+                        <a:srgbClr val="2A3441"/>
+                      </a:solidFill>
+                      <a:prstDash val="solid"/>
+                      <a:round/>
+                      <a:headEnd type="none" w="med" len="med"/>
+                      <a:tailEnd type="none" w="med" len="med"/>
+                    </a:lnT>
+                    <a:lnB w="12700" cap="flat" cmpd="sng" algn="ctr">
+                      <a:solidFill>
+                        <a:srgbClr val="2A3441"/>
+                      </a:solidFill>
+                      <a:prstDash val="solid"/>
+                      <a:round/>
+                      <a:headEnd type="none" w="med" len="med"/>
+                      <a:tailEnd type="none" w="med" len="med"/>
+                    </a:lnB>
+                    <a:solidFill>
+                      <a:srgbClr val="141B24"/>
+                    </a:solidFill>
+                  </a:tcPr>
+                </a:tc>
+                <a:tc>
+                  <a:txBody>
+                    <a:bodyPr/>
+                    <a:lstStyle/>
+                    <a:p>
+                      <a:pPr indent="0" marL="0">
+                        <a:buNone/>
+                      </a:pPr>
+                      <a:r>
+                        <a:rPr lang="en-US" sz="1300" dirty="0">
+                          <a:solidFill>
+                            <a:srgbClr val="E6EDF3"/>
+                          </a:solidFill>
+                          <a:latin typeface="Calibri" pitchFamily="34" charset="0"/>
+                          <a:ea typeface="Calibri" pitchFamily="34" charset="-122"/>
+                          <a:cs typeface="Calibri" pitchFamily="34" charset="-120"/>
+                        </a:rPr>
+                        <a:t>0.969</a:t>
+                      </a:r>
+                      <a:endParaRPr lang="en-US" sz="1300" dirty="0">
+                        <a:latin typeface="Calibri" charset="0"/>
+                        <a:ea typeface="Calibri" charset="0"/>
+                        <a:cs typeface="Calibri" charset="0"/>
+                      </a:endParaRPr>
+                    </a:p>
+                  </a:txBody>
+                  <a:tcPr marL="91440" marR="91440" marT="45720" marB="45720">
+                    <a:lnL w="12700" cap="flat" cmpd="sng" algn="ctr">
+                      <a:solidFill>
+                        <a:srgbClr val="2A3441"/>
+                      </a:solidFill>
+                      <a:prstDash val="solid"/>
+                      <a:round/>
+                      <a:headEnd type="none" w="med" len="med"/>
+                      <a:tailEnd type="none" w="med" len="med"/>
+                    </a:lnL>
+                    <a:lnR w="12700" cap="flat" cmpd="sng" algn="ctr">
+                      <a:solidFill>
+                        <a:srgbClr val="2A3441"/>
+                      </a:solidFill>
+                      <a:prstDash val="solid"/>
+                      <a:round/>
+                      <a:headEnd type="none" w="med" len="med"/>
+                      <a:tailEnd type="none" w="med" len="med"/>
+                    </a:lnR>
+                    <a:lnT w="12700" cap="flat" cmpd="sng" algn="ctr">
+                      <a:solidFill>
+                        <a:srgbClr val="2A3441"/>
+                      </a:solidFill>
+                      <a:prstDash val="solid"/>
+                      <a:round/>
+                      <a:headEnd type="none" w="med" len="med"/>
+                      <a:tailEnd type="none" w="med" len="med"/>
+                    </a:lnT>
+                    <a:lnB w="12700" cap="flat" cmpd="sng" algn="ctr">
+                      <a:solidFill>
+                        <a:srgbClr val="2A3441"/>
+                      </a:solidFill>
+                      <a:prstDash val="solid"/>
+                      <a:round/>
+                      <a:headEnd type="none" w="med" len="med"/>
+                      <a:tailEnd type="none" w="med" len="med"/>
+                    </a:lnB>
+                    <a:solidFill>
+                      <a:srgbClr val="141B24"/>
+                    </a:solidFill>
+                  </a:tcPr>
+                </a:tc>
+              </a:tr>
+              <a:tr h="384048">
+                <a:tc>
+                  <a:txBody>
+                    <a:bodyPr/>
+                    <a:lstStyle/>
+                    <a:p>
+                      <a:pPr indent="0" marL="0">
+                        <a:buNone/>
+                      </a:pPr>
+                      <a:r>
+                        <a:rPr lang="en-US" sz="1300" dirty="0">
+                          <a:solidFill>
+                            <a:srgbClr val="E6EDF3"/>
+                          </a:solidFill>
+                          <a:latin typeface="Calibri" pitchFamily="34" charset="0"/>
+                          <a:ea typeface="Calibri" pitchFamily="34" charset="-122"/>
+                          <a:cs typeface="Calibri" pitchFamily="34" charset="-120"/>
+                        </a:rPr>
+                        <a:t>Deep vs AIMD (no-loss path)</a:t>
+                      </a:r>
+                      <a:endParaRPr lang="en-US" sz="1300" dirty="0">
+                        <a:latin typeface="Calibri" charset="0"/>
+                        <a:ea typeface="Calibri" charset="0"/>
+                        <a:cs typeface="Calibri" charset="0"/>
+                      </a:endParaRPr>
+                    </a:p>
+                  </a:txBody>
+                  <a:tcPr marL="91440" marR="91440" marT="45720" marB="45720">
+                    <a:lnL w="12700" cap="flat" cmpd="sng" algn="ctr">
+                      <a:solidFill>
+                        <a:srgbClr val="2A3441"/>
+                      </a:solidFill>
+                      <a:prstDash val="solid"/>
+                      <a:round/>
+                      <a:headEnd type="none" w="med" len="med"/>
+                      <a:tailEnd type="none" w="med" len="med"/>
+                    </a:lnL>
+                    <a:lnR w="12700" cap="flat" cmpd="sng" algn="ctr">
+                      <a:solidFill>
+                        <a:srgbClr val="2A3441"/>
+                      </a:solidFill>
+                      <a:prstDash val="solid"/>
+                      <a:round/>
+                      <a:headEnd type="none" w="med" len="med"/>
+                      <a:tailEnd type="none" w="med" len="med"/>
+                    </a:lnR>
+                    <a:lnT w="12700" cap="flat" cmpd="sng" algn="ctr">
+                      <a:solidFill>
+                        <a:srgbClr val="2A3441"/>
+                      </a:solidFill>
+                      <a:prstDash val="solid"/>
+                      <a:round/>
+                      <a:headEnd type="none" w="med" len="med"/>
+                      <a:tailEnd type="none" w="med" len="med"/>
+                    </a:lnT>
+                    <a:lnB w="12700" cap="flat" cmpd="sng" algn="ctr">
+                      <a:solidFill>
+                        <a:srgbClr val="2A3441"/>
+                      </a:solidFill>
+                      <a:prstDash val="solid"/>
+                      <a:round/>
+                      <a:headEnd type="none" w="med" len="med"/>
+                      <a:tailEnd type="none" w="med" len="med"/>
+                    </a:lnB>
+                    <a:solidFill>
+                      <a:srgbClr val="141B24"/>
+                    </a:solidFill>
+                  </a:tcPr>
+                </a:tc>
+                <a:tc>
+                  <a:txBody>
+                    <a:bodyPr/>
+                    <a:lstStyle/>
+                    <a:p>
+                      <a:pPr indent="0" marL="0">
+                        <a:buNone/>
+                      </a:pPr>
+                      <a:r>
+                        <a:rPr lang="en-US" sz="1300" dirty="0">
+                          <a:solidFill>
+                            <a:srgbClr val="E6EDF3"/>
+                          </a:solidFill>
+                          <a:latin typeface="Calibri" pitchFamily="34" charset="0"/>
+                          <a:ea typeface="Calibri" pitchFamily="34" charset="-122"/>
+                          <a:cs typeface="Calibri" pitchFamily="34" charset="-120"/>
+                        </a:rPr>
+                        <a:t>44%</a:t>
+                      </a:r>
+                      <a:endParaRPr lang="en-US" sz="1300" dirty="0">
+                        <a:latin typeface="Calibri" charset="0"/>
+                        <a:ea typeface="Calibri" charset="0"/>
+                        <a:cs typeface="Calibri" charset="0"/>
+                      </a:endParaRPr>
+                    </a:p>
+                  </a:txBody>
+                  <a:tcPr marL="91440" marR="91440" marT="45720" marB="45720">
+                    <a:lnL w="12700" cap="flat" cmpd="sng" algn="ctr">
+                      <a:solidFill>
+                        <a:srgbClr val="2A3441"/>
+                      </a:solidFill>
+                      <a:prstDash val="solid"/>
+                      <a:round/>
+                      <a:headEnd type="none" w="med" len="med"/>
+                      <a:tailEnd type="none" w="med" len="med"/>
+                    </a:lnL>
+                    <a:lnR w="12700" cap="flat" cmpd="sng" algn="ctr">
+                      <a:solidFill>
+                        <a:srgbClr val="2A3441"/>
+                      </a:solidFill>
+                      <a:prstDash val="solid"/>
+                      <a:round/>
+                      <a:headEnd type="none" w="med" len="med"/>
+                      <a:tailEnd type="none" w="med" len="med"/>
+                    </a:lnR>
+                    <a:lnT w="12700" cap="flat" cmpd="sng" algn="ctr">
+                      <a:solidFill>
+                        <a:srgbClr val="2A3441"/>
+                      </a:solidFill>
+                      <a:prstDash val="solid"/>
+                      <a:round/>
+                      <a:headEnd type="none" w="med" len="med"/>
+                      <a:tailEnd type="none" w="med" len="med"/>
+                    </a:lnT>
+                    <a:lnB w="12700" cap="flat" cmpd="sng" algn="ctr">
+                      <a:solidFill>
+                        <a:srgbClr val="2A3441"/>
+                      </a:solidFill>
+                      <a:prstDash val="solid"/>
+                      <a:round/>
+                      <a:headEnd type="none" w="med" len="med"/>
+                      <a:tailEnd type="none" w="med" len="med"/>
+                    </a:lnB>
+                    <a:solidFill>
+                      <a:srgbClr val="141B24"/>
+                    </a:solidFill>
+                  </a:tcPr>
+                </a:tc>
+                <a:tc>
+                  <a:txBody>
+                    <a:bodyPr/>
+                    <a:lstStyle/>
+                    <a:p>
+                      <a:pPr indent="0" marL="0">
+                        <a:buNone/>
+                      </a:pPr>
+                      <a:r>
+                        <a:rPr lang="en-US" sz="1300" dirty="0">
+                          <a:solidFill>
+                            <a:srgbClr val="E6EDF3"/>
+                          </a:solidFill>
+                          <a:latin typeface="Calibri" pitchFamily="34" charset="0"/>
+                          <a:ea typeface="Calibri" pitchFamily="34" charset="-122"/>
+                          <a:cs typeface="Calibri" pitchFamily="34" charset="-120"/>
+                        </a:rPr>
+                        <a:t>0.987</a:t>
+                      </a:r>
+                      <a:endParaRPr lang="en-US" sz="1300" dirty="0">
+                        <a:latin typeface="Calibri" charset="0"/>
+                        <a:ea typeface="Calibri" charset="0"/>
+                        <a:cs typeface="Calibri" charset="0"/>
+                      </a:endParaRPr>
+                    </a:p>
+                  </a:txBody>
+                  <a:tcPr marL="91440" marR="91440" marT="45720" marB="45720">
+                    <a:lnL w="12700" cap="flat" cmpd="sng" algn="ctr">
+                      <a:solidFill>
+                        <a:srgbClr val="2A3441"/>
+                      </a:solidFill>
+                      <a:prstDash val="solid"/>
+                      <a:round/>
+                      <a:headEnd type="none" w="med" len="med"/>
+                      <a:tailEnd type="none" w="med" len="med"/>
+                    </a:lnL>
+                    <a:lnR w="12700" cap="flat" cmpd="sng" algn="ctr">
+                      <a:solidFill>
+                        <a:srgbClr val="2A3441"/>
+                      </a:solidFill>
+                      <a:prstDash val="solid"/>
+                      <a:round/>
+                      <a:headEnd type="none" w="med" len="med"/>
+                      <a:tailEnd type="none" w="med" len="med"/>
+                    </a:lnR>
+                    <a:lnT w="12700" cap="flat" cmpd="sng" algn="ctr">
+                      <a:solidFill>
+                        <a:srgbClr val="2A3441"/>
+                      </a:solidFill>
+                      <a:prstDash val="solid"/>
+                      <a:round/>
+                      <a:headEnd type="none" w="med" len="med"/>
+                      <a:tailEnd type="none" w="med" len="med"/>
+                    </a:lnT>
+                    <a:lnB w="12700" cap="flat" cmpd="sng" algn="ctr">
+                      <a:solidFill>
+                        <a:srgbClr val="2A3441"/>
+                      </a:solidFill>
+                      <a:prstDash val="solid"/>
+                      <a:round/>
+                      <a:headEnd type="none" w="med" len="med"/>
+                      <a:tailEnd type="none" w="med" len="med"/>
+                    </a:lnB>
+                    <a:solidFill>
+                      <a:srgbClr val="141B24"/>
+                    </a:solidFill>
+                  </a:tcPr>
+                </a:tc>
+              </a:tr>
+              <a:tr h="384048">
+                <a:tc>
+                  <a:txBody>
+                    <a:bodyPr/>
+                    <a:lstStyle/>
+                    <a:p>
+                      <a:pPr indent="0" marL="0">
+                        <a:buNone/>
+                      </a:pPr>
+                      <a:r>
+                        <a:rPr lang="en-US" sz="1300" dirty="0">
+                          <a:solidFill>
+                            <a:srgbClr val="E6EDF3"/>
+                          </a:solidFill>
+                          <a:latin typeface="Calibri" pitchFamily="34" charset="0"/>
+                          <a:ea typeface="Calibri" pitchFamily="34" charset="-122"/>
+                          <a:cs typeface="Calibri" pitchFamily="34" charset="-120"/>
+                        </a:rPr>
+                        <a:t>Deep vs AIMD (long path)</a:t>
+                      </a:r>
+                      <a:endParaRPr lang="en-US" sz="1300" dirty="0">
+                        <a:latin typeface="Calibri" charset="0"/>
+                        <a:ea typeface="Calibri" charset="0"/>
+                        <a:cs typeface="Calibri" charset="0"/>
+                      </a:endParaRPr>
+                    </a:p>
+                  </a:txBody>
+                  <a:tcPr marL="91440" marR="91440" marT="45720" marB="45720">
+                    <a:lnL w="12700" cap="flat" cmpd="sng" algn="ctr">
+                      <a:solidFill>
+                        <a:srgbClr val="2A3441"/>
+                      </a:solidFill>
+                      <a:prstDash val="solid"/>
+                      <a:round/>
+                      <a:headEnd type="none" w="med" len="med"/>
+                      <a:tailEnd type="none" w="med" len="med"/>
+                    </a:lnL>
+                    <a:lnR w="12700" cap="flat" cmpd="sng" algn="ctr">
+                      <a:solidFill>
+                        <a:srgbClr val="2A3441"/>
+                      </a:solidFill>
+                      <a:prstDash val="solid"/>
+                      <a:round/>
+                      <a:headEnd type="none" w="med" len="med"/>
+                      <a:tailEnd type="none" w="med" len="med"/>
+                    </a:lnR>
+                    <a:lnT w="12700" cap="flat" cmpd="sng" algn="ctr">
+                      <a:solidFill>
+                        <a:srgbClr val="2A3441"/>
+                      </a:solidFill>
+                      <a:prstDash val="solid"/>
+                      <a:round/>
+                      <a:headEnd type="none" w="med" len="med"/>
+                      <a:tailEnd type="none" w="med" len="med"/>
+                    </a:lnT>
+                    <a:lnB w="12700" cap="flat" cmpd="sng" algn="ctr">
+                      <a:solidFill>
+                        <a:srgbClr val="2A3441"/>
+                      </a:solidFill>
+                      <a:prstDash val="solid"/>
+                      <a:round/>
+                      <a:headEnd type="none" w="med" len="med"/>
+                      <a:tailEnd type="none" w="med" len="med"/>
+                    </a:lnB>
+                    <a:solidFill>
+                      <a:srgbClr val="141B24"/>
+                    </a:solidFill>
+                  </a:tcPr>
+                </a:tc>
+                <a:tc>
+                  <a:txBody>
+                    <a:bodyPr/>
+                    <a:lstStyle/>
+                    <a:p>
+                      <a:pPr indent="0" marL="0">
+                        <a:buNone/>
+                      </a:pPr>
+                      <a:r>
+                        <a:rPr lang="en-US" sz="1300" dirty="0">
+                          <a:solidFill>
+                            <a:srgbClr val="E6EDF3"/>
+                          </a:solidFill>
+                          <a:latin typeface="Calibri" pitchFamily="34" charset="0"/>
+                          <a:ea typeface="Calibri" pitchFamily="34" charset="-122"/>
+                          <a:cs typeface="Calibri" pitchFamily="34" charset="-120"/>
+                        </a:rPr>
+                        <a:t>74%</a:t>
+                      </a:r>
+                      <a:endParaRPr lang="en-US" sz="1300" dirty="0">
+                        <a:latin typeface="Calibri" charset="0"/>
+                        <a:ea typeface="Calibri" charset="0"/>
+                        <a:cs typeface="Calibri" charset="0"/>
+                      </a:endParaRPr>
+                    </a:p>
+                  </a:txBody>
+                  <a:tcPr marL="91440" marR="91440" marT="45720" marB="45720">
+                    <a:lnL w="12700" cap="flat" cmpd="sng" algn="ctr">
+                      <a:solidFill>
+                        <a:srgbClr val="2A3441"/>
+                      </a:solidFill>
+                      <a:prstDash val="solid"/>
+                      <a:round/>
+                      <a:headEnd type="none" w="med" len="med"/>
+                      <a:tailEnd type="none" w="med" len="med"/>
+                    </a:lnL>
+                    <a:lnR w="12700" cap="flat" cmpd="sng" algn="ctr">
+                      <a:solidFill>
+                        <a:srgbClr val="2A3441"/>
+                      </a:solidFill>
+                      <a:prstDash val="solid"/>
+                      <a:round/>
+                      <a:headEnd type="none" w="med" len="med"/>
+                      <a:tailEnd type="none" w="med" len="med"/>
+                    </a:lnR>
+                    <a:lnT w="12700" cap="flat" cmpd="sng" algn="ctr">
+                      <a:solidFill>
+                        <a:srgbClr val="2A3441"/>
+                      </a:solidFill>
+                      <a:prstDash val="solid"/>
+                      <a:round/>
+                      <a:headEnd type="none" w="med" len="med"/>
+                      <a:tailEnd type="none" w="med" len="med"/>
+                    </a:lnT>
+                    <a:lnB w="12700" cap="flat" cmpd="sng" algn="ctr">
+                      <a:solidFill>
+                        <a:srgbClr val="2A3441"/>
+                      </a:solidFill>
+                      <a:prstDash val="solid"/>
+                      <a:round/>
+                      <a:headEnd type="none" w="med" len="med"/>
+                      <a:tailEnd type="none" w="med" len="med"/>
+                    </a:lnB>
+                    <a:solidFill>
+                      <a:srgbClr val="141B24"/>
+                    </a:solidFill>
+                  </a:tcPr>
+                </a:tc>
+                <a:tc>
+                  <a:txBody>
+                    <a:bodyPr/>
+                    <a:lstStyle/>
+                    <a:p>
+                      <a:pPr indent="0" marL="0">
+                        <a:buNone/>
+                      </a:pPr>
+                      <a:r>
+                        <a:rPr lang="en-US" sz="1300" dirty="0">
+                          <a:solidFill>
+                            <a:srgbClr val="E6EDF3"/>
+                          </a:solidFill>
+                          <a:latin typeface="Calibri" pitchFamily="34" charset="0"/>
+                          <a:ea typeface="Calibri" pitchFamily="34" charset="-122"/>
+                          <a:cs typeface="Calibri" pitchFamily="34" charset="-120"/>
+                        </a:rPr>
+                        <a:t>0.819</a:t>
+                      </a:r>
+                      <a:endParaRPr lang="en-US" sz="1300" dirty="0">
+                        <a:latin typeface="Calibri" charset="0"/>
+                        <a:ea typeface="Calibri" charset="0"/>
+                        <a:cs typeface="Calibri" charset="0"/>
+                      </a:endParaRPr>
+                    </a:p>
+                  </a:txBody>
+                  <a:tcPr marL="91440" marR="91440" marT="45720" marB="45720">
+                    <a:lnL w="12700" cap="flat" cmpd="sng" algn="ctr">
+                      <a:solidFill>
+                        <a:srgbClr val="2A3441"/>
+                      </a:solidFill>
+                      <a:prstDash val="solid"/>
+                      <a:round/>
+                      <a:headEnd type="none" w="med" len="med"/>
+                      <a:tailEnd type="none" w="med" len="med"/>
+                    </a:lnL>
+                    <a:lnR w="12700" cap="flat" cmpd="sng" algn="ctr">
+                      <a:solidFill>
+                        <a:srgbClr val="2A3441"/>
+                      </a:solidFill>
+                      <a:prstDash val="solid"/>
+                      <a:round/>
+                      <a:headEnd type="none" w="med" len="med"/>
+                      <a:tailEnd type="none" w="med" len="med"/>
+                    </a:lnR>
+                    <a:lnT w="12700" cap="flat" cmpd="sng" algn="ctr">
+                      <a:solidFill>
+                        <a:srgbClr val="2A3441"/>
+                      </a:solidFill>
+                      <a:prstDash val="solid"/>
+                      <a:round/>
+                      <a:headEnd type="none" w="med" len="med"/>
+                      <a:tailEnd type="none" w="med" len="med"/>
+                    </a:lnT>
+                    <a:lnB w="12700" cap="flat" cmpd="sng" algn="ctr">
+                      <a:solidFill>
+                        <a:srgbClr val="2A3441"/>
+                      </a:solidFill>
+                      <a:prstDash val="solid"/>
+                      <a:round/>
+                      <a:headEnd type="none" w="med" len="med"/>
+                      <a:tailEnd type="none" w="med" len="med"/>
+                    </a:lnB>
+                    <a:solidFill>
+                      <a:srgbClr val="141B24"/>
+                    </a:solidFill>
+                  </a:tcPr>
+                </a:tc>
+              </a:tr>
+              <a:tr h="384048">
+                <a:tc>
+                  <a:txBody>
+                    <a:bodyPr/>
+                    <a:lstStyle/>
+                    <a:p>
+                      <a:pPr indent="0" marL="0">
+                        <a:buNone/>
+                      </a:pPr>
+                      <a:r>
+                        <a:rPr lang="en-US" sz="1300" dirty="0">
+                          <a:solidFill>
+                            <a:srgbClr val="E6EDF3"/>
+                          </a:solidFill>
+                          <a:latin typeface="Calibri" pitchFamily="34" charset="0"/>
+                          <a:ea typeface="Calibri" pitchFamily="34" charset="-122"/>
+                          <a:cs typeface="Calibri" pitchFamily="34" charset="-120"/>
+                        </a:rPr>
+                        <a:t>Fixed 8 vs AIMD (long path)</a:t>
+                      </a:r>
+                      <a:endParaRPr lang="en-US" sz="1300" dirty="0">
+                        <a:latin typeface="Calibri" charset="0"/>
+                        <a:ea typeface="Calibri" charset="0"/>
+                        <a:cs typeface="Calibri" charset="0"/>
+                      </a:endParaRPr>
+                    </a:p>
+                  </a:txBody>
+                  <a:tcPr marL="91440" marR="91440" marT="45720" marB="45720">
+                    <a:lnL w="12700" cap="flat" cmpd="sng" algn="ctr">
+                      <a:solidFill>
+                        <a:srgbClr val="2A3441"/>
+                      </a:solidFill>
+                      <a:prstDash val="solid"/>
+                      <a:round/>
+                      <a:headEnd type="none" w="med" len="med"/>
+                      <a:tailEnd type="none" w="med" len="med"/>
+                    </a:lnL>
+                    <a:lnR w="12700" cap="flat" cmpd="sng" algn="ctr">
+                      <a:solidFill>
+                        <a:srgbClr val="2A3441"/>
+                      </a:solidFill>
+                      <a:prstDash val="solid"/>
+                      <a:round/>
+                      <a:headEnd type="none" w="med" len="med"/>
+                      <a:tailEnd type="none" w="med" len="med"/>
+                    </a:lnR>
+                    <a:lnT w="12700" cap="flat" cmpd="sng" algn="ctr">
+                      <a:solidFill>
+                        <a:srgbClr val="2A3441"/>
+                      </a:solidFill>
+                      <a:prstDash val="solid"/>
+                      <a:round/>
+                      <a:headEnd type="none" w="med" len="med"/>
+                      <a:tailEnd type="none" w="med" len="med"/>
+                    </a:lnT>
+                    <a:lnB w="12700" cap="flat" cmpd="sng" algn="ctr">
+                      <a:solidFill>
+                        <a:srgbClr val="2A3441"/>
+                      </a:solidFill>
+                      <a:prstDash val="solid"/>
+                      <a:round/>
+                      <a:headEnd type="none" w="med" len="med"/>
+                      <a:tailEnd type="none" w="med" len="med"/>
+                    </a:lnB>
+                    <a:solidFill>
+                      <a:srgbClr val="141B24"/>
+                    </a:solidFill>
+                  </a:tcPr>
+                </a:tc>
+                <a:tc>
+                  <a:txBody>
+                    <a:bodyPr/>
+                    <a:lstStyle/>
+                    <a:p>
+                      <a:pPr indent="0" marL="0">
+                        <a:buNone/>
+                      </a:pPr>
+                      <a:r>
+                        <a:rPr lang="en-US" sz="1300" dirty="0">
+                          <a:solidFill>
+                            <a:srgbClr val="E6EDF3"/>
+                          </a:solidFill>
+                          <a:latin typeface="Calibri" pitchFamily="34" charset="0"/>
+                          <a:ea typeface="Calibri" pitchFamily="34" charset="-122"/>
+                          <a:cs typeface="Calibri" pitchFamily="34" charset="-120"/>
+                        </a:rPr>
+                        <a:t>72%</a:t>
+                      </a:r>
+                      <a:endParaRPr lang="en-US" sz="1300" dirty="0">
+                        <a:latin typeface="Calibri" charset="0"/>
+                        <a:ea typeface="Calibri" charset="0"/>
+                        <a:cs typeface="Calibri" charset="0"/>
+                      </a:endParaRPr>
+                    </a:p>
+                  </a:txBody>
+                  <a:tcPr marL="91440" marR="91440" marT="45720" marB="45720">
+                    <a:lnL w="12700" cap="flat" cmpd="sng" algn="ctr">
+                      <a:solidFill>
+                        <a:srgbClr val="2A3441"/>
+                      </a:solidFill>
+                      <a:prstDash val="solid"/>
+                      <a:round/>
+                      <a:headEnd type="none" w="med" len="med"/>
+                      <a:tailEnd type="none" w="med" len="med"/>
+                    </a:lnL>
+                    <a:lnR w="12700" cap="flat" cmpd="sng" algn="ctr">
+                      <a:solidFill>
+                        <a:srgbClr val="2A3441"/>
+                      </a:solidFill>
+                      <a:prstDash val="solid"/>
+                      <a:round/>
+                      <a:headEnd type="none" w="med" len="med"/>
+                      <a:tailEnd type="none" w="med" len="med"/>
+                    </a:lnR>
+                    <a:lnT w="12700" cap="flat" cmpd="sng" algn="ctr">
+                      <a:solidFill>
+                        <a:srgbClr val="2A3441"/>
+                      </a:solidFill>
+                      <a:prstDash val="solid"/>
+                      <a:round/>
+                      <a:headEnd type="none" w="med" len="med"/>
+                      <a:tailEnd type="none" w="med" len="med"/>
+                    </a:lnT>
+                    <a:lnB w="12700" cap="flat" cmpd="sng" algn="ctr">
+                      <a:solidFill>
+                        <a:srgbClr val="2A3441"/>
+                      </a:solidFill>
+                      <a:prstDash val="solid"/>
+                      <a:round/>
+                      <a:headEnd type="none" w="med" len="med"/>
+                      <a:tailEnd type="none" w="med" len="med"/>
+                    </a:lnB>
+                    <a:solidFill>
+                      <a:srgbClr val="141B24"/>
+                    </a:solidFill>
+                  </a:tcPr>
+                </a:tc>
+                <a:tc>
+                  <a:txBody>
+                    <a:bodyPr/>
+                    <a:lstStyle/>
+                    <a:p>
+                      <a:pPr indent="0" marL="0">
+                        <a:buNone/>
+                      </a:pPr>
+                      <a:r>
+                        <a:rPr lang="en-US" sz="1300" dirty="0">
+                          <a:solidFill>
+                            <a:srgbClr val="E6EDF3"/>
+                          </a:solidFill>
+                          <a:latin typeface="Calibri" pitchFamily="34" charset="0"/>
+                          <a:ea typeface="Calibri" pitchFamily="34" charset="-122"/>
+                          <a:cs typeface="Calibri" pitchFamily="34" charset="-120"/>
+                        </a:rPr>
+                        <a:t>0.843</a:t>
+                      </a:r>
+                      <a:endParaRPr lang="en-US" sz="1300" dirty="0">
+                        <a:latin typeface="Calibri" charset="0"/>
+                        <a:ea typeface="Calibri" charset="0"/>
+                        <a:cs typeface="Calibri" charset="0"/>
+                      </a:endParaRPr>
+                    </a:p>
+                  </a:txBody>
+                  <a:tcPr marL="91440" marR="91440" marT="45720" marB="45720">
+                    <a:lnL w="12700" cap="flat" cmpd="sng" algn="ctr">
+                      <a:solidFill>
+                        <a:srgbClr val="2A3441"/>
+                      </a:solidFill>
+                      <a:prstDash val="solid"/>
+                      <a:round/>
+                      <a:headEnd type="none" w="med" len="med"/>
+                      <a:tailEnd type="none" w="med" len="med"/>
+                    </a:lnL>
+                    <a:lnR w="12700" cap="flat" cmpd="sng" algn="ctr">
+                      <a:solidFill>
+                        <a:srgbClr val="2A3441"/>
+                      </a:solidFill>
+                      <a:prstDash val="solid"/>
+                      <a:round/>
+                      <a:headEnd type="none" w="med" len="med"/>
+                      <a:tailEnd type="none" w="med" len="med"/>
+                    </a:lnR>
+                    <a:lnT w="12700" cap="flat" cmpd="sng" algn="ctr">
+                      <a:solidFill>
+                        <a:srgbClr val="2A3441"/>
+                      </a:solidFill>
+                      <a:prstDash val="solid"/>
+                      <a:round/>
+                      <a:headEnd type="none" w="med" len="med"/>
+                      <a:tailEnd type="none" w="med" len="med"/>
+                    </a:lnT>
+                    <a:lnB w="12700" cap="flat" cmpd="sng" algn="ctr">
+                      <a:solidFill>
+                        <a:srgbClr val="2A3441"/>
+                      </a:solidFill>
+                      <a:prstDash val="solid"/>
+                      <a:round/>
+                      <a:headEnd type="none" w="med" len="med"/>
+                      <a:tailEnd type="none" w="med" len="med"/>
+                    </a:lnB>
+                    <a:solidFill>
+                      <a:srgbClr val="141B24"/>
+                    </a:solidFill>
+                  </a:tcPr>
+                </a:tc>
+              </a:tr>
+            </a:tbl>
+          </a:graphicData>
+        </a:graphic>
+      </p:graphicFrame>
+      <p:sp>
+        <p:nvSpPr>
+          <p:cNvPr id="5" name="Text 2"/>
           <p:cNvSpPr/>
           <p:nvPr/>
         </p:nvSpPr>
         <p:spPr>
           <a:xfrm>
-            <a:off x="548640" y="1371600"/>
-            <a:ext cx="5394960" cy="4206240"/>
-          </a:xfrm>
-          <a:prstGeom prst="rect">
-            <a:avLst/>
-          </a:prstGeom>
-          <a:solidFill>
-            <a:srgbClr val="141B24"/>
-          </a:solidFill>
-          <a:ln w="12700">
-            <a:solidFill>
-              <a:srgbClr val="39FF88"/>
-            </a:solidFill>
-            <a:prstDash val="solid"/>
-          </a:ln>
-        </p:spPr>
-      </p:sp>
-      <p:sp>
-        <p:nvSpPr>
-          <p:cNvPr id="5" name="Text 3"/>
-          <p:cNvSpPr/>
-          <p:nvPr/>
-        </p:nvSpPr>
-        <p:spPr>
-          <a:xfrm>
-            <a:off x="731520" y="1508760"/>
-            <a:ext cx="5029200" cy="457200"/>
+            <a:off x="6766560" y="1188720"/>
+            <a:ext cx="5029200" cy="4937760"/>
           </a:xfrm>
           <a:prstGeom prst="rect">
             <a:avLst/>
@@ -10981,53 +12312,18 @@
           <a:ln/>
         </p:spPr>
         <p:txBody>
-          <a:bodyPr wrap="square" lIns="0" tIns="0" rIns="0" bIns="0" rtlCol="0" anchor="ctr"/>
-          <a:lstStyle/>
-          <a:p>
-            <a:pPr indent="0" marL="0">
-              <a:buNone/>
-            </a:pPr>
-            <a:r>
-              <a:rPr lang="en-US" sz="2000" b="1" dirty="0">
-                <a:solidFill>
-                  <a:srgbClr val="39FF88"/>
-                </a:solidFill>
-                <a:latin typeface="Courier New" pitchFamily="34" charset="0"/>
-                <a:ea typeface="Courier New" pitchFamily="34" charset="-122"/>
-                <a:cs typeface="Courier New" pitchFamily="34" charset="-120"/>
-              </a:rPr>
-              <a:t>Learned</a:t>
-            </a:r>
-            <a:endParaRPr lang="en-US" sz="2000" dirty="0"/>
-          </a:p>
-        </p:txBody>
-      </p:sp>
-      <p:sp>
-        <p:nvSpPr>
-          <p:cNvPr id="6" name="Text 4"/>
-          <p:cNvSpPr/>
-          <p:nvPr/>
-        </p:nvSpPr>
-        <p:spPr>
-          <a:xfrm>
-            <a:off x="731520" y="2011680"/>
-            <a:ext cx="5029200" cy="3429000"/>
-          </a:xfrm>
-          <a:prstGeom prst="rect">
-            <a:avLst/>
-          </a:prstGeom>
-          <a:noFill/>
-          <a:ln/>
-        </p:spPr>
-        <p:txBody>
           <a:bodyPr wrap="square" lIns="0" tIns="0" rIns="0" bIns="0" rtlCol="0" anchor="t"/>
           <a:lstStyle/>
           <a:p>
-            <a:pPr indent="0" marL="0">
-              <a:buNone/>
-            </a:pPr>
-            <a:r>
-              <a:rPr lang="en-US" sz="2000" dirty="0">
+            <a:pPr marL="342900" indent="-342900">
+              <a:spcAft>
+                <a:spcPts val="800"/>
+              </a:spcAft>
+              <a:buSzPct val="100000"/>
+              <a:buChar char="•"/>
+            </a:pPr>
+            <a:r>
+              <a:rPr lang="en-US" sz="1400" dirty="0">
                 <a:solidFill>
                   <a:srgbClr val="E6EDF3"/>
                 </a:solidFill>
@@ -11035,16 +12331,20 @@
                 <a:ea typeface="Calibri" pitchFamily="34" charset="-122"/>
                 <a:cs typeface="Calibri" pitchFamily="34" charset="-120"/>
               </a:rPr>
-              <a:t>Reliability is a set of simple rules working together.</a:t>
-            </a:r>
-            <a:endParaRPr lang="en-US" sz="2000" dirty="0"/>
-          </a:p>
-          <a:p>
-            <a:pPr indent="0" marL="0">
-              <a:buNone/>
-            </a:pPr>
-            <a:r>
-              <a:rPr lang="en-US" sz="2000" dirty="0">
+              <a:t>Fair on short paths; takes 74% against AIMD on the 120 ms path, like a fixed window</a:t>
+            </a:r>
+            <a:endParaRPr lang="en-US" sz="1400" dirty="0"/>
+          </a:p>
+          <a:p>
+            <a:pPr marL="342900" indent="-342900">
+              <a:spcAft>
+                <a:spcPts val="800"/>
+              </a:spcAft>
+              <a:buSzPct val="100000"/>
+              <a:buChar char="•"/>
+            </a:pPr>
+            <a:r>
+              <a:rPr lang="en-US" sz="1400" dirty="0">
                 <a:solidFill>
                   <a:srgbClr val="E6EDF3"/>
                 </a:solidFill>
@@ -11052,16 +12352,20 @@
                 <a:ea typeface="Calibri" pitchFamily="34" charset="-122"/>
                 <a:cs typeface="Calibri" pitchFamily="34" charset="-120"/>
               </a:rPr>
-              <a:t>Congestion control matters as much as retransmission.</a:t>
-            </a:r>
-            <a:endParaRPr lang="en-US" sz="2000" dirty="0"/>
-          </a:p>
-          <a:p>
-            <a:pPr indent="0" marL="0">
-              <a:buNone/>
-            </a:pPr>
-            <a:r>
-              <a:rPr lang="en-US" sz="2000" dirty="0">
+              <a:t>Ablation: the no-shrink mask is what matters (6.54 s without it, about 3.3 s with it; AIMD 7.16 s)</a:t>
+            </a:r>
+            <a:endParaRPr lang="en-US" sz="1400" dirty="0"/>
+          </a:p>
+          <a:p>
+            <a:pPr marL="342900" indent="-342900">
+              <a:spcAft>
+                <a:spcPts val="800"/>
+              </a:spcAft>
+              <a:buSzPct val="100000"/>
+              <a:buChar char="•"/>
+            </a:pPr>
+            <a:r>
+              <a:rPr lang="en-US" sz="1400" dirty="0">
                 <a:solidFill>
                   <a:srgbClr val="E6EDF3"/>
                 </a:solidFill>
@@ -11069,102 +12373,20 @@
                 <a:ea typeface="Calibri" pitchFamily="34" charset="-122"/>
                 <a:cs typeface="Calibri" pitchFamily="34" charset="-120"/>
               </a:rPr>
-              <a:t>Testing tools fail in surprising ways.</a:t>
-            </a:r>
-            <a:endParaRPr lang="en-US" sz="2000" dirty="0"/>
-          </a:p>
-        </p:txBody>
-      </p:sp>
-      <p:sp>
-        <p:nvSpPr>
-          <p:cNvPr id="7" name="Shape 5"/>
-          <p:cNvSpPr/>
-          <p:nvPr/>
-        </p:nvSpPr>
-        <p:spPr>
-          <a:xfrm>
-            <a:off x="6217920" y="1371600"/>
-            <a:ext cx="5394960" cy="4206240"/>
-          </a:xfrm>
-          <a:prstGeom prst="rect">
-            <a:avLst/>
-          </a:prstGeom>
-          <a:solidFill>
-            <a:srgbClr val="141B24"/>
-          </a:solidFill>
-          <a:ln w="12700">
-            <a:solidFill>
-              <a:srgbClr val="FFB000"/>
-            </a:solidFill>
-            <a:prstDash val="solid"/>
-          </a:ln>
-        </p:spPr>
-      </p:sp>
-      <p:sp>
-        <p:nvSpPr>
-          <p:cNvPr id="8" name="Text 6"/>
-          <p:cNvSpPr/>
-          <p:nvPr/>
-        </p:nvSpPr>
-        <p:spPr>
-          <a:xfrm>
-            <a:off x="6400800" y="1508760"/>
-            <a:ext cx="5029200" cy="457200"/>
-          </a:xfrm>
-          <a:prstGeom prst="rect">
-            <a:avLst/>
-          </a:prstGeom>
-          <a:noFill/>
-          <a:ln/>
-        </p:spPr>
-        <p:txBody>
-          <a:bodyPr wrap="square" lIns="0" tIns="0" rIns="0" bIns="0" rtlCol="0" anchor="ctr"/>
-          <a:lstStyle/>
-          <a:p>
-            <a:pPr indent="0" marL="0">
-              <a:buNone/>
-            </a:pPr>
-            <a:r>
-              <a:rPr lang="en-US" sz="2000" b="1" dirty="0">
-                <a:solidFill>
-                  <a:srgbClr val="FFB000"/>
-                </a:solidFill>
-                <a:latin typeface="Courier New" pitchFamily="34" charset="0"/>
-                <a:ea typeface="Courier New" pitchFamily="34" charset="-122"/>
-                <a:cs typeface="Courier New" pitchFamily="34" charset="-120"/>
-              </a:rPr>
-              <a:t>Next</a:t>
-            </a:r>
-            <a:endParaRPr lang="en-US" sz="2000" dirty="0"/>
-          </a:p>
-        </p:txBody>
-      </p:sp>
-      <p:sp>
-        <p:nvSpPr>
-          <p:cNvPr id="9" name="Text 7"/>
-          <p:cNvSpPr/>
-          <p:nvPr/>
-        </p:nvSpPr>
-        <p:spPr>
-          <a:xfrm>
-            <a:off x="6400800" y="2011680"/>
-            <a:ext cx="5029200" cy="3429000"/>
-          </a:xfrm>
-          <a:prstGeom prst="rect">
-            <a:avLst/>
-          </a:prstGeom>
-          <a:noFill/>
-          <a:ln/>
-        </p:spPr>
-        <p:txBody>
-          <a:bodyPr wrap="square" lIns="0" tIns="0" rIns="0" bIns="0" rtlCol="0" anchor="t"/>
-          <a:lstStyle/>
-          <a:p>
-            <a:pPr indent="0" marL="0">
-              <a:buNone/>
-            </a:pPr>
-            <a:r>
-              <a:rPr lang="en-US" sz="2000" dirty="0">
+              <a:t>Other parts (delay penalty, last action, throughput input) showed no measurable value</a:t>
+            </a:r>
+            <a:endParaRPr lang="en-US" sz="1400" dirty="0"/>
+          </a:p>
+          <a:p>
+            <a:pPr marL="342900" indent="-342900">
+              <a:spcAft>
+                <a:spcPts val="800"/>
+              </a:spcAft>
+              <a:buSzPct val="100000"/>
+              <a:buChar char="•"/>
+            </a:pPr>
+            <a:r>
+              <a:rPr lang="en-US" sz="1400" dirty="0">
                 <a:solidFill>
                   <a:srgbClr val="E6EDF3"/>
                 </a:solidFill>
@@ -11172,16 +12394,20 @@
                 <a:ea typeface="Calibri" pitchFamily="34" charset="-122"/>
                 <a:cs typeface="Calibri" pitchFamily="34" charset="-120"/>
               </a:rPr>
-              <a:t>Train the neural agent in C / on real netem</a:t>
-            </a:r>
-            <a:endParaRPr lang="en-US" sz="2000" dirty="0"/>
-          </a:p>
-          <a:p>
-            <a:pPr indent="0" marL="0">
-              <a:buNone/>
-            </a:pPr>
-            <a:r>
-              <a:rPr lang="en-US" sz="2000" dirty="0">
+              <a:t>Same recipe gave 3.2 to 7.4 s across seeds: seed sensitivity is a real weakness</a:t>
+            </a:r>
+            <a:endParaRPr lang="en-US" sz="1400" dirty="0"/>
+          </a:p>
+          <a:p>
+            <a:pPr marL="342900" indent="-342900">
+              <a:spcAft>
+                <a:spcPts val="800"/>
+              </a:spcAft>
+              <a:buSzPct val="100000"/>
+              <a:buChar char="•"/>
+            </a:pPr>
+            <a:r>
+              <a:rPr lang="en-US" sz="1400" dirty="0">
                 <a:solidFill>
                   <a:srgbClr val="E6EDF3"/>
                 </a:solidFill>
@@ -11189,65 +12415,48 @@
                 <a:ea typeface="Calibri" pitchFamily="34" charset="-122"/>
                 <a:cs typeface="Calibri" pitchFamily="34" charset="-120"/>
               </a:rPr>
-              <a:t>Selective ACK where throughput limits the path</a:t>
-            </a:r>
-            <a:endParaRPr lang="en-US" sz="2000" dirty="0"/>
-          </a:p>
+              <a:t>Found and fixed a dup-ACK retransmission storm in the chat gateway; added a live dashboard and an adaptive RTO</a:t>
+            </a:r>
+            <a:endParaRPr lang="en-US" sz="1400" dirty="0"/>
+          </a:p>
+        </p:txBody>
+      </p:sp>
+      <p:sp>
+        <p:nvSpPr>
+          <p:cNvPr id="6" name="Text 3"/>
+          <p:cNvSpPr/>
+          <p:nvPr/>
+        </p:nvSpPr>
+        <p:spPr>
+          <a:xfrm>
+            <a:off x="548640" y="3840480"/>
+            <a:ext cx="5852160" cy="731520"/>
+          </a:xfrm>
+          <a:prstGeom prst="rect">
+            <a:avLst/>
+          </a:prstGeom>
+          <a:noFill/>
+          <a:ln/>
+        </p:spPr>
+        <p:txBody>
+          <a:bodyPr wrap="square" lIns="0" tIns="0" rIns="0" bIns="0" rtlCol="0" anchor="ctr"/>
+          <a:lstStyle/>
           <a:p>
             <a:pPr indent="0" marL="0">
               <a:buNone/>
             </a:pPr>
             <a:r>
-              <a:rPr lang="en-US" sz="2000" dirty="0">
-                <a:solidFill>
-                  <a:srgbClr val="E6EDF3"/>
+              <a:rPr lang="en-US" sz="1300" dirty="0">
+                <a:solidFill>
+                  <a:srgbClr val="8B98A5"/>
                 </a:solidFill>
                 <a:latin typeface="Calibri" pitchFamily="34" charset="0"/>
                 <a:ea typeface="Calibri" pitchFamily="34" charset="-122"/>
                 <a:cs typeface="Calibri" pitchFamily="34" charset="-120"/>
               </a:rPr>
-              <a:t>Kernel netem and real multi-machine tests</a:t>
-            </a:r>
-            <a:endParaRPr lang="en-US" sz="2000" dirty="0"/>
-          </a:p>
-        </p:txBody>
-      </p:sp>
-      <p:sp>
-        <p:nvSpPr>
-          <p:cNvPr id="10" name="Text 8"/>
-          <p:cNvSpPr/>
-          <p:nvPr/>
-        </p:nvSpPr>
-        <p:spPr>
-          <a:xfrm>
-            <a:off x="548640" y="5852160"/>
-            <a:ext cx="10972800" cy="365760"/>
-          </a:xfrm>
-          <a:prstGeom prst="rect">
-            <a:avLst/>
-          </a:prstGeom>
-          <a:noFill/>
-          <a:ln/>
-        </p:spPr>
-        <p:txBody>
-          <a:bodyPr wrap="square" lIns="0" tIns="0" rIns="0" bIns="0" rtlCol="0" anchor="ctr"/>
-          <a:lstStyle/>
-          <a:p>
-            <a:pPr indent="0" marL="0">
-              <a:buNone/>
-            </a:pPr>
-            <a:r>
-              <a:rPr lang="en-US" sz="1400" dirty="0">
-                <a:solidFill>
-                  <a:srgbClr val="8B98A5"/>
-                </a:solidFill>
-                <a:latin typeface="Calibri" pitchFamily="34" charset="0"/>
-                <a:ea typeface="Calibri" pitchFamily="34" charset="-122"/>
-                <a:cs typeface="Calibri" pitchFamily="34" charset="-120"/>
-              </a:rPr>
-              <a:t>Limits: Go-Back-N wastes bandwidth and suffers under reordering; C tests use an emulated path; the tabular agent did not beat AIMD in C.</a:t>
-            </a:r>
-            <a:endParaRPr lang="en-US" sz="1400" dirty="0"/>
+              <a:t>Simulator, 20 seeds; ablation on 48 stress paths. Code: web/fairness_test.py, web/ablate.py.</a:t>
+            </a:r>
+            <a:endParaRPr lang="en-US" sz="1300" dirty="0"/>
           </a:p>
         </p:txBody>
       </p:sp>
@@ -11291,8 +12500,8 @@
         </p:nvSpPr>
         <p:spPr>
           <a:xfrm>
-            <a:off x="731520" y="2103120"/>
-            <a:ext cx="10058400" cy="1097280"/>
+            <a:off x="548640" y="320040"/>
+            <a:ext cx="11064240" cy="731520"/>
           </a:xfrm>
           <a:prstGeom prst="rect">
             <a:avLst/>
@@ -11308,7 +12517,7 @@
               <a:buNone/>
             </a:pPr>
             <a:r>
-              <a:rPr lang="en-US" sz="6400" b="1" dirty="0">
+              <a:rPr lang="en-US" sz="3000" b="1" dirty="0">
                 <a:solidFill>
                   <a:srgbClr val="39FF88"/>
                 </a:solidFill>
@@ -11316,9 +12525,9 @@
                 <a:ea typeface="Courier New" pitchFamily="34" charset="-122"/>
                 <a:cs typeface="Courier New" pitchFamily="34" charset="-120"/>
               </a:rPr>
-              <a:t>Thank you</a:t>
-            </a:r>
-            <a:endParaRPr lang="en-US" sz="6400" dirty="0"/>
+              <a:t>Learnings and future work</a:t>
+            </a:r>
+            <a:endParaRPr lang="en-US" sz="3000" dirty="0"/>
           </a:p>
         </p:txBody>
       </p:sp>
@@ -11330,8 +12539,8 @@
         </p:nvSpPr>
         <p:spPr>
           <a:xfrm>
-            <a:off x="731520" y="3474720"/>
-            <a:ext cx="10058400" cy="548640"/>
+            <a:off x="9418320" y="6446520"/>
+            <a:ext cx="2377440" cy="274320"/>
           </a:xfrm>
           <a:prstGeom prst="rect">
             <a:avLst/>
@@ -11343,34 +12552,59 @@
           <a:bodyPr wrap="square" lIns="0" tIns="0" rIns="0" bIns="0" rtlCol="0" anchor="ctr"/>
           <a:lstStyle/>
           <a:p>
-            <a:pPr indent="0" marL="0">
+            <a:pPr algn="r" indent="0" marL="0">
               <a:buNone/>
             </a:pPr>
             <a:r>
-              <a:rPr lang="en-US" sz="2600" dirty="0">
-                <a:solidFill>
-                  <a:srgbClr val="E6EDF3"/>
+              <a:rPr lang="en-US" sz="1000" dirty="0">
+                <a:solidFill>
+                  <a:srgbClr val="8B98A5"/>
                 </a:solidFill>
                 <a:latin typeface="Courier New" pitchFamily="34" charset="0"/>
                 <a:ea typeface="Courier New" pitchFamily="34" charset="-122"/>
                 <a:cs typeface="Courier New" pitchFamily="34" charset="-120"/>
               </a:rPr>
-              <a:t>github.com/Capsturrrr/rudp</a:t>
-            </a:r>
-            <a:endParaRPr lang="en-US" sz="2600" dirty="0"/>
-          </a:p>
-        </p:txBody>
-      </p:sp>
-      <p:sp>
-        <p:nvSpPr>
-          <p:cNvPr id="4" name="Text 2"/>
+              <a:t>24 / 25   Smart-RUDP</a:t>
+            </a:r>
+            <a:endParaRPr lang="en-US" sz="1000" dirty="0"/>
+          </a:p>
+        </p:txBody>
+      </p:sp>
+      <p:sp>
+        <p:nvSpPr>
+          <p:cNvPr id="4" name="Shape 2"/>
           <p:cNvSpPr/>
           <p:nvPr/>
         </p:nvSpPr>
         <p:spPr>
           <a:xfrm>
-            <a:off x="731520" y="4206240"/>
-            <a:ext cx="10058400" cy="457200"/>
+            <a:off x="548640" y="1371600"/>
+            <a:ext cx="5394960" cy="4206240"/>
+          </a:xfrm>
+          <a:prstGeom prst="rect">
+            <a:avLst/>
+          </a:prstGeom>
+          <a:solidFill>
+            <a:srgbClr val="141B24"/>
+          </a:solidFill>
+          <a:ln w="12700">
+            <a:solidFill>
+              <a:srgbClr val="39FF88"/>
+            </a:solidFill>
+            <a:prstDash val="solid"/>
+          </a:ln>
+        </p:spPr>
+      </p:sp>
+      <p:sp>
+        <p:nvSpPr>
+          <p:cNvPr id="5" name="Text 3"/>
+          <p:cNvSpPr/>
+          <p:nvPr/>
+        </p:nvSpPr>
+        <p:spPr>
+          <a:xfrm>
+            <a:off x="731520" y="1508760"/>
+            <a:ext cx="5029200" cy="457200"/>
           </a:xfrm>
           <a:prstGeom prst="rect">
             <a:avLst/>
@@ -11386,17 +12620,266 @@
               <a:buNone/>
             </a:pPr>
             <a:r>
-              <a:rPr lang="en-US" sz="1800" dirty="0">
-                <a:solidFill>
-                  <a:srgbClr val="8B98A5"/>
+              <a:rPr lang="en-US" sz="2000" b="1" dirty="0">
+                <a:solidFill>
+                  <a:srgbClr val="39FF88"/>
+                </a:solidFill>
+                <a:latin typeface="Courier New" pitchFamily="34" charset="0"/>
+                <a:ea typeface="Courier New" pitchFamily="34" charset="-122"/>
+                <a:cs typeface="Courier New" pitchFamily="34" charset="-120"/>
+              </a:rPr>
+              <a:t>Learned</a:t>
+            </a:r>
+            <a:endParaRPr lang="en-US" sz="2000" dirty="0"/>
+          </a:p>
+        </p:txBody>
+      </p:sp>
+      <p:sp>
+        <p:nvSpPr>
+          <p:cNvPr id="6" name="Text 4"/>
+          <p:cNvSpPr/>
+          <p:nvPr/>
+        </p:nvSpPr>
+        <p:spPr>
+          <a:xfrm>
+            <a:off x="731520" y="2011680"/>
+            <a:ext cx="5029200" cy="3429000"/>
+          </a:xfrm>
+          <a:prstGeom prst="rect">
+            <a:avLst/>
+          </a:prstGeom>
+          <a:noFill/>
+          <a:ln/>
+        </p:spPr>
+        <p:txBody>
+          <a:bodyPr wrap="square" lIns="0" tIns="0" rIns="0" bIns="0" rtlCol="0" anchor="t"/>
+          <a:lstStyle/>
+          <a:p>
+            <a:pPr indent="0" marL="0">
+              <a:buNone/>
+            </a:pPr>
+            <a:r>
+              <a:rPr lang="en-US" sz="2000" dirty="0">
+                <a:solidFill>
+                  <a:srgbClr val="E6EDF3"/>
                 </a:solidFill>
                 <a:latin typeface="Calibri" pitchFamily="34" charset="0"/>
                 <a:ea typeface="Calibri" pitchFamily="34" charset="-122"/>
                 <a:cs typeface="Calibri" pitchFamily="34" charset="-120"/>
               </a:rPr>
-              <a:t>Harshavardhan Mallela   Rohit Arya   Shloak Sinha</a:t>
-            </a:r>
-            <a:endParaRPr lang="en-US" sz="1800" dirty="0"/>
+              <a:t>Reliability is a set of simple rules working together.</a:t>
+            </a:r>
+            <a:endParaRPr lang="en-US" sz="2000" dirty="0"/>
+          </a:p>
+          <a:p>
+            <a:pPr indent="0" marL="0">
+              <a:buNone/>
+            </a:pPr>
+            <a:r>
+              <a:rPr lang="en-US" sz="2000" dirty="0">
+                <a:solidFill>
+                  <a:srgbClr val="E6EDF3"/>
+                </a:solidFill>
+                <a:latin typeface="Calibri" pitchFamily="34" charset="0"/>
+                <a:ea typeface="Calibri" pitchFamily="34" charset="-122"/>
+                <a:cs typeface="Calibri" pitchFamily="34" charset="-120"/>
+              </a:rPr>
+              <a:t>Congestion control matters as much as retransmission.</a:t>
+            </a:r>
+            <a:endParaRPr lang="en-US" sz="2000" dirty="0"/>
+          </a:p>
+          <a:p>
+            <a:pPr indent="0" marL="0">
+              <a:buNone/>
+            </a:pPr>
+            <a:r>
+              <a:rPr lang="en-US" sz="2000" dirty="0">
+                <a:solidFill>
+                  <a:srgbClr val="E6EDF3"/>
+                </a:solidFill>
+                <a:latin typeface="Calibri" pitchFamily="34" charset="0"/>
+                <a:ea typeface="Calibri" pitchFamily="34" charset="-122"/>
+                <a:cs typeface="Calibri" pitchFamily="34" charset="-120"/>
+              </a:rPr>
+              <a:t>Testing tools fail in surprising ways.</a:t>
+            </a:r>
+            <a:endParaRPr lang="en-US" sz="2000" dirty="0"/>
+          </a:p>
+        </p:txBody>
+      </p:sp>
+      <p:sp>
+        <p:nvSpPr>
+          <p:cNvPr id="7" name="Shape 5"/>
+          <p:cNvSpPr/>
+          <p:nvPr/>
+        </p:nvSpPr>
+        <p:spPr>
+          <a:xfrm>
+            <a:off x="6217920" y="1371600"/>
+            <a:ext cx="5394960" cy="4206240"/>
+          </a:xfrm>
+          <a:prstGeom prst="rect">
+            <a:avLst/>
+          </a:prstGeom>
+          <a:solidFill>
+            <a:srgbClr val="141B24"/>
+          </a:solidFill>
+          <a:ln w="12700">
+            <a:solidFill>
+              <a:srgbClr val="FFB000"/>
+            </a:solidFill>
+            <a:prstDash val="solid"/>
+          </a:ln>
+        </p:spPr>
+      </p:sp>
+      <p:sp>
+        <p:nvSpPr>
+          <p:cNvPr id="8" name="Text 6"/>
+          <p:cNvSpPr/>
+          <p:nvPr/>
+        </p:nvSpPr>
+        <p:spPr>
+          <a:xfrm>
+            <a:off x="6400800" y="1508760"/>
+            <a:ext cx="5029200" cy="457200"/>
+          </a:xfrm>
+          <a:prstGeom prst="rect">
+            <a:avLst/>
+          </a:prstGeom>
+          <a:noFill/>
+          <a:ln/>
+        </p:spPr>
+        <p:txBody>
+          <a:bodyPr wrap="square" lIns="0" tIns="0" rIns="0" bIns="0" rtlCol="0" anchor="ctr"/>
+          <a:lstStyle/>
+          <a:p>
+            <a:pPr indent="0" marL="0">
+              <a:buNone/>
+            </a:pPr>
+            <a:r>
+              <a:rPr lang="en-US" sz="2000" b="1" dirty="0">
+                <a:solidFill>
+                  <a:srgbClr val="FFB000"/>
+                </a:solidFill>
+                <a:latin typeface="Courier New" pitchFamily="34" charset="0"/>
+                <a:ea typeface="Courier New" pitchFamily="34" charset="-122"/>
+                <a:cs typeface="Courier New" pitchFamily="34" charset="-120"/>
+              </a:rPr>
+              <a:t>Next</a:t>
+            </a:r>
+            <a:endParaRPr lang="en-US" sz="2000" dirty="0"/>
+          </a:p>
+        </p:txBody>
+      </p:sp>
+      <p:sp>
+        <p:nvSpPr>
+          <p:cNvPr id="9" name="Text 7"/>
+          <p:cNvSpPr/>
+          <p:nvPr/>
+        </p:nvSpPr>
+        <p:spPr>
+          <a:xfrm>
+            <a:off x="6400800" y="2011680"/>
+            <a:ext cx="5029200" cy="3429000"/>
+          </a:xfrm>
+          <a:prstGeom prst="rect">
+            <a:avLst/>
+          </a:prstGeom>
+          <a:noFill/>
+          <a:ln/>
+        </p:spPr>
+        <p:txBody>
+          <a:bodyPr wrap="square" lIns="0" tIns="0" rIns="0" bIns="0" rtlCol="0" anchor="t"/>
+          <a:lstStyle/>
+          <a:p>
+            <a:pPr indent="0" marL="0">
+              <a:buNone/>
+            </a:pPr>
+            <a:r>
+              <a:rPr lang="en-US" sz="2000" dirty="0">
+                <a:solidFill>
+                  <a:srgbClr val="E6EDF3"/>
+                </a:solidFill>
+                <a:latin typeface="Calibri" pitchFamily="34" charset="0"/>
+                <a:ea typeface="Calibri" pitchFamily="34" charset="-122"/>
+                <a:cs typeface="Calibri" pitchFamily="34" charset="-120"/>
+              </a:rPr>
+              <a:t>Train the neural agent in C / on real netem</a:t>
+            </a:r>
+            <a:endParaRPr lang="en-US" sz="2000" dirty="0"/>
+          </a:p>
+          <a:p>
+            <a:pPr indent="0" marL="0">
+              <a:buNone/>
+            </a:pPr>
+            <a:r>
+              <a:rPr lang="en-US" sz="2000" dirty="0">
+                <a:solidFill>
+                  <a:srgbClr val="E6EDF3"/>
+                </a:solidFill>
+                <a:latin typeface="Calibri" pitchFamily="34" charset="0"/>
+                <a:ea typeface="Calibri" pitchFamily="34" charset="-122"/>
+                <a:cs typeface="Calibri" pitchFamily="34" charset="-120"/>
+              </a:rPr>
+              <a:t>Selective ACK where throughput limits the path</a:t>
+            </a:r>
+            <a:endParaRPr lang="en-US" sz="2000" dirty="0"/>
+          </a:p>
+          <a:p>
+            <a:pPr indent="0" marL="0">
+              <a:buNone/>
+            </a:pPr>
+            <a:r>
+              <a:rPr lang="en-US" sz="2000" dirty="0">
+                <a:solidFill>
+                  <a:srgbClr val="E6EDF3"/>
+                </a:solidFill>
+                <a:latin typeface="Calibri" pitchFamily="34" charset="0"/>
+                <a:ea typeface="Calibri" pitchFamily="34" charset="-122"/>
+                <a:cs typeface="Calibri" pitchFamily="34" charset="-120"/>
+              </a:rPr>
+              <a:t>Kernel netem and real multi-machine tests</a:t>
+            </a:r>
+            <a:endParaRPr lang="en-US" sz="2000" dirty="0"/>
+          </a:p>
+        </p:txBody>
+      </p:sp>
+      <p:sp>
+        <p:nvSpPr>
+          <p:cNvPr id="10" name="Text 8"/>
+          <p:cNvSpPr/>
+          <p:nvPr/>
+        </p:nvSpPr>
+        <p:spPr>
+          <a:xfrm>
+            <a:off x="548640" y="5852160"/>
+            <a:ext cx="10972800" cy="365760"/>
+          </a:xfrm>
+          <a:prstGeom prst="rect">
+            <a:avLst/>
+          </a:prstGeom>
+          <a:noFill/>
+          <a:ln/>
+        </p:spPr>
+        <p:txBody>
+          <a:bodyPr wrap="square" lIns="0" tIns="0" rIns="0" bIns="0" rtlCol="0" anchor="ctr"/>
+          <a:lstStyle/>
+          <a:p>
+            <a:pPr indent="0" marL="0">
+              <a:buNone/>
+            </a:pPr>
+            <a:r>
+              <a:rPr lang="en-US" sz="1400" dirty="0">
+                <a:solidFill>
+                  <a:srgbClr val="8B98A5"/>
+                </a:solidFill>
+                <a:latin typeface="Calibri" pitchFamily="34" charset="0"/>
+                <a:ea typeface="Calibri" pitchFamily="34" charset="-122"/>
+                <a:cs typeface="Calibri" pitchFamily="34" charset="-120"/>
+              </a:rPr>
+              <a:t>Limits: Go-Back-N wastes bandwidth and suffers under reordering; C tests use an emulated path; the tabular agent did not beat AIMD in C.</a:t>
+            </a:r>
+            <a:endParaRPr lang="en-US" sz="1400" dirty="0"/>
           </a:p>
         </p:txBody>
       </p:sp>
@@ -11440,6 +12923,155 @@
         </p:nvSpPr>
         <p:spPr>
           <a:xfrm>
+            <a:off x="731520" y="2103120"/>
+            <a:ext cx="10058400" cy="1097280"/>
+          </a:xfrm>
+          <a:prstGeom prst="rect">
+            <a:avLst/>
+          </a:prstGeom>
+          <a:noFill/>
+          <a:ln/>
+        </p:spPr>
+        <p:txBody>
+          <a:bodyPr wrap="square" lIns="0" tIns="0" rIns="0" bIns="0" rtlCol="0" anchor="ctr"/>
+          <a:lstStyle/>
+          <a:p>
+            <a:pPr indent="0" marL="0">
+              <a:buNone/>
+            </a:pPr>
+            <a:r>
+              <a:rPr lang="en-US" sz="6400" b="1" dirty="0">
+                <a:solidFill>
+                  <a:srgbClr val="39FF88"/>
+                </a:solidFill>
+                <a:latin typeface="Courier New" pitchFamily="34" charset="0"/>
+                <a:ea typeface="Courier New" pitchFamily="34" charset="-122"/>
+                <a:cs typeface="Courier New" pitchFamily="34" charset="-120"/>
+              </a:rPr>
+              <a:t>Thank you</a:t>
+            </a:r>
+            <a:endParaRPr lang="en-US" sz="6400" dirty="0"/>
+          </a:p>
+        </p:txBody>
+      </p:sp>
+      <p:sp>
+        <p:nvSpPr>
+          <p:cNvPr id="3" name="Text 1"/>
+          <p:cNvSpPr/>
+          <p:nvPr/>
+        </p:nvSpPr>
+        <p:spPr>
+          <a:xfrm>
+            <a:off x="731520" y="3474720"/>
+            <a:ext cx="10058400" cy="548640"/>
+          </a:xfrm>
+          <a:prstGeom prst="rect">
+            <a:avLst/>
+          </a:prstGeom>
+          <a:noFill/>
+          <a:ln/>
+        </p:spPr>
+        <p:txBody>
+          <a:bodyPr wrap="square" lIns="0" tIns="0" rIns="0" bIns="0" rtlCol="0" anchor="ctr"/>
+          <a:lstStyle/>
+          <a:p>
+            <a:pPr indent="0" marL="0">
+              <a:buNone/>
+            </a:pPr>
+            <a:r>
+              <a:rPr lang="en-US" sz="2600" dirty="0">
+                <a:solidFill>
+                  <a:srgbClr val="E6EDF3"/>
+                </a:solidFill>
+                <a:latin typeface="Courier New" pitchFamily="34" charset="0"/>
+                <a:ea typeface="Courier New" pitchFamily="34" charset="-122"/>
+                <a:cs typeface="Courier New" pitchFamily="34" charset="-120"/>
+              </a:rPr>
+              <a:t>github.com/Capsturrrr/rudp</a:t>
+            </a:r>
+            <a:endParaRPr lang="en-US" sz="2600" dirty="0"/>
+          </a:p>
+        </p:txBody>
+      </p:sp>
+      <p:sp>
+        <p:nvSpPr>
+          <p:cNvPr id="4" name="Text 2"/>
+          <p:cNvSpPr/>
+          <p:nvPr/>
+        </p:nvSpPr>
+        <p:spPr>
+          <a:xfrm>
+            <a:off x="731520" y="4206240"/>
+            <a:ext cx="10058400" cy="457200"/>
+          </a:xfrm>
+          <a:prstGeom prst="rect">
+            <a:avLst/>
+          </a:prstGeom>
+          <a:noFill/>
+          <a:ln/>
+        </p:spPr>
+        <p:txBody>
+          <a:bodyPr wrap="square" lIns="0" tIns="0" rIns="0" bIns="0" rtlCol="0" anchor="ctr"/>
+          <a:lstStyle/>
+          <a:p>
+            <a:pPr indent="0" marL="0">
+              <a:buNone/>
+            </a:pPr>
+            <a:r>
+              <a:rPr lang="en-US" sz="1800" dirty="0">
+                <a:solidFill>
+                  <a:srgbClr val="8B98A5"/>
+                </a:solidFill>
+                <a:latin typeface="Calibri" pitchFamily="34" charset="0"/>
+                <a:ea typeface="Calibri" pitchFamily="34" charset="-122"/>
+                <a:cs typeface="Calibri" pitchFamily="34" charset="-120"/>
+              </a:rPr>
+              <a:t>Harshavardhan Mallela   Rohit Arya   Shloak Sinha</a:t>
+            </a:r>
+            <a:endParaRPr lang="en-US" sz="1800" dirty="0"/>
+          </a:p>
+        </p:txBody>
+      </p:sp>
+    </p:spTree>
+  </p:cSld>
+  <p:clrMapOvr>
+    <a:masterClrMapping/>
+  </p:clrMapOvr>
+</p:sld>
+</file>
+
+<file path=ppt/slides/slide26.xml><?xml version="1.0" encoding="utf-8"?>
+<p:sld xmlns:a="http://schemas.openxmlformats.org/drawingml/2006/main" xmlns:r="http://schemas.openxmlformats.org/officeDocument/2006/relationships" xmlns:p="http://schemas.openxmlformats.org/presentationml/2006/main">
+  <p:cSld name="Slide 26">
+    <p:bg>
+      <p:bgPr>
+        <a:solidFill>
+          <a:srgbClr val="0B0F14"/>
+        </a:solidFill>
+      </p:bgPr>
+    </p:bg>
+    <p:spTree>
+      <p:nvGrpSpPr>
+        <p:cNvPr id="1" name=""/>
+        <p:cNvGrpSpPr/>
+        <p:nvPr/>
+      </p:nvGrpSpPr>
+      <p:grpSpPr>
+        <a:xfrm>
+          <a:off x="0" y="0"/>
+          <a:ext cx="0" cy="0"/>
+          <a:chOff x="0" y="0"/>
+          <a:chExt cx="0" cy="0"/>
+        </a:xfrm>
+      </p:grpSpPr>
+      <p:sp>
+        <p:nvSpPr>
+          <p:cNvPr id="2" name="Text 0"/>
+          <p:cNvSpPr/>
+          <p:nvPr/>
+        </p:nvSpPr>
+        <p:spPr>
+          <a:xfrm>
             <a:off x="548640" y="320040"/>
             <a:ext cx="11064240" cy="731520"/>
           </a:xfrm>
@@ -11744,7 +13376,7 @@
                 <a:ea typeface="Courier New" pitchFamily="34" charset="-122"/>
                 <a:cs typeface="Courier New" pitchFamily="34" charset="-120"/>
               </a:rPr>
-              <a:t>3 / 24   Smart-RUDP</a:t>
+              <a:t>3 / 25   Smart-RUDP</a:t>
             </a:r>
             <a:endParaRPr lang="en-US" sz="1000" dirty="0"/>
           </a:p>
@@ -12138,7 +13770,7 @@
                 <a:ea typeface="Courier New" pitchFamily="34" charset="-122"/>
                 <a:cs typeface="Courier New" pitchFamily="34" charset="-120"/>
               </a:rPr>
-              <a:t>4 / 24   Smart-RUDP</a:t>
+              <a:t>4 / 25   Smart-RUDP</a:t>
             </a:r>
             <a:endParaRPr lang="en-US" sz="1000" dirty="0"/>
           </a:p>
@@ -12699,7 +14331,7 @@
                 <a:ea typeface="Courier New" pitchFamily="34" charset="-122"/>
                 <a:cs typeface="Courier New" pitchFamily="34" charset="-120"/>
               </a:rPr>
-              <a:t>5 / 24   Smart-RUDP</a:t>
+              <a:t>5 / 25   Smart-RUDP</a:t>
             </a:r>
             <a:endParaRPr lang="en-US" sz="1000" dirty="0"/>
           </a:p>
@@ -14138,7 +15770,7 @@
                 <a:ea typeface="Courier New" pitchFamily="34" charset="-122"/>
                 <a:cs typeface="Courier New" pitchFamily="34" charset="-120"/>
               </a:rPr>
-              <a:t>6 / 24   Smart-RUDP</a:t>
+              <a:t>6 / 25   Smart-RUDP</a:t>
             </a:r>
             <a:endParaRPr lang="en-US" sz="1000" dirty="0"/>
           </a:p>
@@ -15373,7 +17005,7 @@
                 <a:ea typeface="Courier New" pitchFamily="34" charset="-122"/>
                 <a:cs typeface="Courier New" pitchFamily="34" charset="-120"/>
               </a:rPr>
-              <a:t>7 / 24   Smart-RUDP</a:t>
+              <a:t>7 / 25   Smart-RUDP</a:t>
             </a:r>
             <a:endParaRPr lang="en-US" sz="1000" dirty="0"/>
           </a:p>
@@ -15816,7 +17448,7 @@
                 <a:ea typeface="Courier New" pitchFamily="34" charset="-122"/>
                 <a:cs typeface="Courier New" pitchFamily="34" charset="-120"/>
               </a:rPr>
-              <a:t>8 / 24   Smart-RUDP</a:t>
+              <a:t>8 / 25   Smart-RUDP</a:t>
             </a:r>
             <a:endParaRPr lang="en-US" sz="1000" dirty="0"/>
           </a:p>
@@ -16116,7 +17748,7 @@
                 <a:ea typeface="Courier New" pitchFamily="34" charset="-122"/>
                 <a:cs typeface="Courier New" pitchFamily="34" charset="-120"/>
               </a:rPr>
-              <a:t>9 / 24   Smart-RUDP</a:t>
+              <a:t>9 / 25   Smart-RUDP</a:t>
             </a:r>
             <a:endParaRPr lang="en-US" sz="1000" dirty="0"/>
           </a:p>

</xml_diff>

<commit_message>
Validity check: equal window caps in C, realistic-recovery simulator, retrained agent; docs updated
Co-Authored-By: Claude Sonnet 5.5 <noreply@anthropic.com>
Claude-Session: https://claude.ai/code/session_01NX2zRNpdVAnzFNKmqomzKu
</commit_message>
<xml_diff>
--- a/docs/RUDP_Presentation.pptx
+++ b/docs/RUDP_Presentation.pptx
@@ -7982,7 +7982,7 @@
                           <a:ea typeface="Courier New" pitchFamily="34" charset="-122"/>
                           <a:cs typeface="Courier New" pitchFamily="34" charset="-120"/>
                         </a:rPr>
-                        <a:t>48 unseen paths (simulated)</a:t>
+                        <a:t>48 paths, original simulator</a:t>
                       </a:r>
                       <a:endParaRPr lang="en-US" sz="1300" dirty="0">
                         <a:latin typeface="Courier New" charset="0"/>
@@ -9528,7 +9528,7 @@
                 <a:ea typeface="Calibri" pitchFamily="34" charset="-122"/>
                 <a:cs typeface="Calibri" pitchFamily="34" charset="-120"/>
               </a:rPr>
-              <a:t>The TCP row is a model, not kernel TCP. Real netem numbers need a Linux machine: netem_baselines.sh.</a:t>
+              <a:t>Caveat: this simulator allowed a dup-ACK retransmission storm. With the realistic rule, stress means are AIMD 7.75 s, neural 7.27 s: about level. The TCP row is a model, not kernel TCP.</a:t>
             </a:r>
             <a:endParaRPr lang="en-US" sz="1300" dirty="0"/>
           </a:p>
@@ -10872,7 +10872,7 @@
                 <a:ea typeface="Calibri" pitchFamily="34" charset="-122"/>
                 <a:cs typeface="Calibri" pitchFamily="34" charset="-120"/>
               </a:rPr>
-              <a:t>Caveats: trained in a simulator; emulated paths; AIMD cap 128 vs agents 32; agent retransmits more on random loss</a:t>
+              <a:t>Caveats: trained in a simulator; emulated paths (not real networks); agent retransmits more on random loss</a:t>
             </a:r>
             <a:endParaRPr lang="en-US" sz="1500" dirty="0"/>
           </a:p>
@@ -10911,7 +10911,7 @@
                 <a:ea typeface="Calibri" pitchFamily="34" charset="-122"/>
                 <a:cs typeface="Calibri" pitchFamily="34" charset="-120"/>
               </a:rPr>
-              <a:t>15 runs per cell (satellite: 8), 95% confidence intervals. Code: src/deep_cc.h, web/dqn.py, eval_ci2.sh.</a:t>
+              <a:t>15 runs per cell (satellite: 8), 95% intervals. Equal-cap check (AIMD capped at 32, 10 runs): neural still wins by 19%, 29%, 28%, all significant (eval_ci4.sh).</a:t>
             </a:r>
             <a:endParaRPr lang="en-US" sz="1300" dirty="0"/>
           </a:p>

</xml_diff>

<commit_message>
Hybrid AIMD hand-over, timeout-cut experiment, calibrated simulator options; report 8.8, deck slide 24, docs
Co-Authored-By: Claude Sonnet 5.5 <noreply@anthropic.com>
Claude-Session: https://claude.ai/code/session_01NX2zRNpdVAnzFNKmqomzKu
</commit_message>
<xml_diff>
--- a/docs/RUDP_Presentation.pptx
+++ b/docs/RUDP_Presentation.pptx
@@ -31,9 +31,10 @@
     <p:sldId id="279" r:id="rId25"/>
     <p:sldId id="280" r:id="rId26"/>
     <p:sldId id="281" r:id="rId27"/>
+    <p:sldId id="282" r:id="rId28"/>
   </p:sldIdLst>
   <p:notesMasterIdLst>
-    <p:notesMasterId r:id="rId28"/>
+    <p:notesMasterId r:id="rId29"/>
   </p:notesMasterIdLst>
   <p:sldSz cx="12192000" cy="6858000"/>
   <p:notesSz cx="6858000" cy="12192000"/>
@@ -2135,6 +2136,94 @@
             <a:fld id="{F7021451-1387-4CA6-816F-3879F97B5CBC}" type="slidenum">
               <a:rPr lang="en-US"/>
               <a:t>26</a:t>
+            </a:fld>
+            <a:endParaRPr lang="en-US"/>
+          </a:p>
+        </p:txBody>
+      </p:sp>
+    </p:spTree>
+    <p:extLst>
+      <p:ext uri="{BB962C8B-B14F-4D97-AF65-F5344CB8AC3E}">
+        <p14:creationId xmlns:p14="http://schemas.microsoft.com/office/powerpoint/2010/main" val="1024086991"/>
+      </p:ext>
+    </p:extLst>
+  </p:cSld>
+  <p:clrMapOvr>
+    <a:masterClrMapping/>
+  </p:clrMapOvr>
+</p:notes>
+</file>
+
+<file path=ppt/notesSlides/notesSlide27.xml><?xml version="1.0" encoding="utf-8"?>
+<p:notes xmlns:a="http://schemas.openxmlformats.org/drawingml/2006/main" xmlns:r="http://schemas.openxmlformats.org/officeDocument/2006/relationships" xmlns:p="http://schemas.openxmlformats.org/presentationml/2006/main">
+  <p:cSld>
+    <p:spTree>
+      <p:nvGrpSpPr>
+        <p:cNvPr id="1" name=""/>
+        <p:cNvGrpSpPr/>
+        <p:nvPr/>
+      </p:nvGrpSpPr>
+      <p:grpSpPr>
+        <a:xfrm>
+          <a:off x="0" y="0"/>
+          <a:ext cx="0" cy="0"/>
+          <a:chOff x="0" y="0"/>
+          <a:chExt cx="0" cy="0"/>
+        </a:xfrm>
+      </p:grpSpPr>
+      <p:sp>
+        <p:nvSpPr>
+          <p:cNvPr id="2" name="Slide Image Placeholder 1"/>
+          <p:cNvSpPr>
+            <a:spLocks noGrp="1" noRot="1" noChangeAspect="1"/>
+          </p:cNvSpPr>
+          <p:nvPr>
+            <p:ph type="sldImg"/>
+          </p:nvPr>
+        </p:nvSpPr>
+        <p:spPr/>
+      </p:sp>
+      <p:sp>
+        <p:nvSpPr>
+          <p:cNvPr id="3" name="Notes Placeholder 2"/>
+          <p:cNvSpPr>
+            <a:spLocks noGrp="1"/>
+          </p:cNvSpPr>
+          <p:nvPr>
+            <p:ph type="body" idx="1"/>
+          </p:nvPr>
+        </p:nvSpPr>
+        <p:spPr/>
+        <p:txBody>
+          <a:bodyPr/>
+          <a:lstStyle/>
+          <a:p>
+            <a:r>
+              <a:rPr lang="en-US" dirty="0"/>
+              <a:t/>
+            </a:r>
+            <a:endParaRPr lang="en-US" dirty="0"/>
+          </a:p>
+        </p:txBody>
+      </p:sp>
+      <p:sp>
+        <p:nvSpPr>
+          <p:cNvPr id="4" name="Slide Number Placeholder 3"/>
+          <p:cNvSpPr>
+            <a:spLocks noGrp="1"/>
+          </p:cNvSpPr>
+          <p:nvPr>
+            <p:ph type="sldNum" sz="quarter" idx="10"/>
+          </p:nvPr>
+        </p:nvSpPr>
+        <p:spPr/>
+        <p:txBody>
+          <a:bodyPr/>
+          <a:lstStyle/>
+          <a:p>
+            <a:fld id="{F7021451-1387-4CA6-816F-3879F97B5CBC}" type="slidenum">
+              <a:rPr lang="en-US"/>
+              <a:t>27</a:t>
             </a:fld>
             <a:endParaRPr lang="en-US"/>
           </a:p>
@@ -3360,7 +3449,7 @@
                 <a:ea typeface="Courier New" pitchFamily="34" charset="-122"/>
                 <a:cs typeface="Courier New" pitchFamily="34" charset="-120"/>
               </a:rPr>
-              <a:t>10 / 25   Smart-RUDP</a:t>
+              <a:t>10 / 26   Smart-RUDP</a:t>
             </a:r>
             <a:endParaRPr lang="en-US" sz="1000" dirty="0"/>
           </a:p>
@@ -3557,7 +3646,7 @@
                 <a:ea typeface="Courier New" pitchFamily="34" charset="-122"/>
                 <a:cs typeface="Courier New" pitchFamily="34" charset="-120"/>
               </a:rPr>
-              <a:t>11 / 25   Smart-RUDP</a:t>
+              <a:t>11 / 26   Smart-RUDP</a:t>
             </a:r>
             <a:endParaRPr lang="en-US" sz="1000" dirty="0"/>
           </a:p>
@@ -4387,7 +4476,7 @@
                 <a:ea typeface="Courier New" pitchFamily="34" charset="-122"/>
                 <a:cs typeface="Courier New" pitchFamily="34" charset="-120"/>
               </a:rPr>
-              <a:t>12 / 25   Smart-RUDP</a:t>
+              <a:t>12 / 26   Smart-RUDP</a:t>
             </a:r>
             <a:endParaRPr lang="en-US" sz="1000" dirty="0"/>
           </a:p>
@@ -4684,7 +4773,7 @@
                 <a:ea typeface="Courier New" pitchFamily="34" charset="-122"/>
                 <a:cs typeface="Courier New" pitchFamily="34" charset="-120"/>
               </a:rPr>
-              <a:t>13 / 25   Smart-RUDP</a:t>
+              <a:t>13 / 26   Smart-RUDP</a:t>
             </a:r>
             <a:endParaRPr lang="en-US" sz="1000" dirty="0"/>
           </a:p>
@@ -4984,7 +5073,7 @@
                 <a:ea typeface="Courier New" pitchFamily="34" charset="-122"/>
                 <a:cs typeface="Courier New" pitchFamily="34" charset="-120"/>
               </a:rPr>
-              <a:t>14 / 25   Smart-RUDP</a:t>
+              <a:t>14 / 26   Smart-RUDP</a:t>
             </a:r>
             <a:endParaRPr lang="en-US" sz="1000" dirty="0"/>
           </a:p>
@@ -5368,7 +5457,7 @@
                 <a:ea typeface="Courier New" pitchFamily="34" charset="-122"/>
                 <a:cs typeface="Courier New" pitchFamily="34" charset="-120"/>
               </a:rPr>
-              <a:t>15 / 25   Smart-RUDP</a:t>
+              <a:t>15 / 26   Smart-RUDP</a:t>
             </a:r>
             <a:endParaRPr lang="en-US" sz="1000" dirty="0"/>
           </a:p>
@@ -5826,7 +5915,7 @@
                 <a:ea typeface="Courier New" pitchFamily="34" charset="-122"/>
                 <a:cs typeface="Courier New" pitchFamily="34" charset="-120"/>
               </a:rPr>
-              <a:t>16 / 25   Smart-RUDP</a:t>
+              <a:t>16 / 26   Smart-RUDP</a:t>
             </a:r>
             <a:endParaRPr lang="en-US" sz="1000" dirty="0"/>
           </a:p>
@@ -6511,7 +6600,7 @@
                 <a:ea typeface="Courier New" pitchFamily="34" charset="-122"/>
                 <a:cs typeface="Courier New" pitchFamily="34" charset="-120"/>
               </a:rPr>
-              <a:t>17 / 25   Smart-RUDP</a:t>
+              <a:t>17 / 26   Smart-RUDP</a:t>
             </a:r>
             <a:endParaRPr lang="en-US" sz="1000" dirty="0"/>
           </a:p>
@@ -6751,7 +6840,7 @@
                 <a:ea typeface="Courier New" pitchFamily="34" charset="-122"/>
                 <a:cs typeface="Courier New" pitchFamily="34" charset="-120"/>
               </a:rPr>
-              <a:t>18 / 25   Smart-RUDP</a:t>
+              <a:t>18 / 26   Smart-RUDP</a:t>
             </a:r>
             <a:endParaRPr lang="en-US" sz="1000" dirty="0"/>
           </a:p>
@@ -6991,7 +7080,7 @@
                 <a:ea typeface="Courier New" pitchFamily="34" charset="-122"/>
                 <a:cs typeface="Courier New" pitchFamily="34" charset="-120"/>
               </a:rPr>
-              <a:t>19 / 25   Smart-RUDP</a:t>
+              <a:t>19 / 26   Smart-RUDP</a:t>
             </a:r>
             <a:endParaRPr lang="en-US" sz="1000" dirty="0"/>
           </a:p>
@@ -7213,7 +7302,7 @@
                 <a:ea typeface="Courier New" pitchFamily="34" charset="-122"/>
                 <a:cs typeface="Courier New" pitchFamily="34" charset="-120"/>
               </a:rPr>
-              <a:t>2 / 25   Smart-RUDP</a:t>
+              <a:t>2 / 26   Smart-RUDP</a:t>
             </a:r>
             <a:endParaRPr lang="en-US" sz="1000" dirty="0"/>
           </a:p>
@@ -7607,7 +7696,7 @@
                 <a:ea typeface="Courier New" pitchFamily="34" charset="-122"/>
                 <a:cs typeface="Courier New" pitchFamily="34" charset="-120"/>
               </a:rPr>
-              <a:t>20 / 25   Smart-RUDP</a:t>
+              <a:t>20 / 26   Smart-RUDP</a:t>
             </a:r>
             <a:endParaRPr lang="en-US" sz="1000" dirty="0"/>
           </a:p>
@@ -7931,7 +8020,7 @@
                 <a:ea typeface="Courier New" pitchFamily="34" charset="-122"/>
                 <a:cs typeface="Courier New" pitchFamily="34" charset="-120"/>
               </a:rPr>
-              <a:t>21 / 25   Smart-RUDP</a:t>
+              <a:t>21 / 26   Smart-RUDP</a:t>
             </a:r>
             <a:endParaRPr lang="en-US" sz="1000" dirty="0"/>
           </a:p>
@@ -9638,7 +9727,7 @@
                 <a:ea typeface="Courier New" pitchFamily="34" charset="-122"/>
                 <a:cs typeface="Courier New" pitchFamily="34" charset="-120"/>
               </a:rPr>
-              <a:t>22 / 25   Smart-RUDP</a:t>
+              <a:t>22 / 26   Smart-RUDP</a:t>
             </a:r>
             <a:endParaRPr lang="en-US" sz="1000" dirty="0"/>
           </a:p>
@@ -11021,7 +11110,7 @@
                 <a:ea typeface="Courier New" pitchFamily="34" charset="-122"/>
                 <a:cs typeface="Courier New" pitchFamily="34" charset="-120"/>
               </a:rPr>
-              <a:t>23 / 25   Smart-RUDP</a:t>
+              <a:t>23 / 26   Smart-RUDP</a:t>
             </a:r>
             <a:endParaRPr lang="en-US" sz="1000" dirty="0"/>
           </a:p>
@@ -12525,7 +12614,7 @@
                 <a:ea typeface="Courier New" pitchFamily="34" charset="-122"/>
                 <a:cs typeface="Courier New" pitchFamily="34" charset="-120"/>
               </a:rPr>
-              <a:t>Learnings and future work</a:t>
+              <a:t>Safety net: hand over to AIMD</a:t>
             </a:r>
             <a:endParaRPr lang="en-US" sz="3000" dirty="0"/>
           </a:p>
@@ -12564,47 +12653,1424 @@
                 <a:ea typeface="Courier New" pitchFamily="34" charset="-122"/>
                 <a:cs typeface="Courier New" pitchFamily="34" charset="-120"/>
               </a:rPr>
-              <a:t>24 / 25   Smart-RUDP</a:t>
+              <a:t>24 / 26   Smart-RUDP</a:t>
             </a:r>
             <a:endParaRPr lang="en-US" sz="1000" dirty="0"/>
           </a:p>
         </p:txBody>
       </p:sp>
-      <p:sp>
-        <p:nvSpPr>
-          <p:cNvPr id="4" name="Shape 2"/>
+      <p:graphicFrame>
+        <p:nvGraphicFramePr>
+          <p:cNvPr id="25" name="Table 0"/>
+          <p:cNvGraphicFramePr>
+            <a:graphicFrameLocks noGrp="1"/>
+          </p:cNvGraphicFramePr>
+          <p:nvPr>
+            <p:extLst>
+              <p:ext uri="{D42A27DB-BD31-4B8C-83A1-F6EECF244321}">
+                <p14:modId xmlns:p14="http://schemas.microsoft.com/office/powerpoint/2010/main" val="1579011935"/>
+              </p:ext>
+            </p:extLst>
+          </p:nvPr>
+        </p:nvGraphicFramePr>
+        <p:xfrm>
+          <a:off x="548640" y="1188720"/>
+          <a:ext cx="6035040" cy="914400"/>
+        </p:xfrm>
+        <a:graphic>
+          <a:graphicData uri="http://schemas.openxmlformats.org/drawingml/2006/table">
+            <a:tbl>
+              <a:tblPr/>
+              <a:tblGrid>
+                <a:gridCol w="2468880"/>
+                <a:gridCol w="1097280"/>
+                <a:gridCol w="1188720"/>
+                <a:gridCol w="1280160"/>
+              </a:tblGrid>
+              <a:tr h="420624">
+                <a:tc>
+                  <a:txBody>
+                    <a:bodyPr/>
+                    <a:lstStyle/>
+                    <a:p>
+                      <a:pPr indent="0" marL="0">
+                        <a:buNone/>
+                      </a:pPr>
+                      <a:r>
+                        <a:rPr lang="en-US" sz="1300" b="1" dirty="0">
+                          <a:solidFill>
+                            <a:srgbClr val="0B0F14"/>
+                          </a:solidFill>
+                          <a:latin typeface="Courier New" pitchFamily="34" charset="0"/>
+                          <a:ea typeface="Courier New" pitchFamily="34" charset="-122"/>
+                          <a:cs typeface="Courier New" pitchFamily="34" charset="-120"/>
+                        </a:rPr>
+                        <a:t>C transport, seconds</a:t>
+                      </a:r>
+                      <a:endParaRPr lang="en-US" sz="1300" dirty="0">
+                        <a:latin typeface="Courier New" charset="0"/>
+                        <a:ea typeface="Courier New" charset="0"/>
+                        <a:cs typeface="Courier New" charset="0"/>
+                      </a:endParaRPr>
+                    </a:p>
+                  </a:txBody>
+                  <a:tcPr marL="91440" marR="91440" marT="45720" marB="45720">
+                    <a:lnL w="12700" cap="flat" cmpd="sng" algn="ctr">
+                      <a:solidFill>
+                        <a:srgbClr val="2A3441"/>
+                      </a:solidFill>
+                      <a:prstDash val="solid"/>
+                      <a:round/>
+                      <a:headEnd type="none" w="med" len="med"/>
+                      <a:tailEnd type="none" w="med" len="med"/>
+                    </a:lnL>
+                    <a:lnR w="12700" cap="flat" cmpd="sng" algn="ctr">
+                      <a:solidFill>
+                        <a:srgbClr val="2A3441"/>
+                      </a:solidFill>
+                      <a:prstDash val="solid"/>
+                      <a:round/>
+                      <a:headEnd type="none" w="med" len="med"/>
+                      <a:tailEnd type="none" w="med" len="med"/>
+                    </a:lnR>
+                    <a:lnT w="12700" cap="flat" cmpd="sng" algn="ctr">
+                      <a:solidFill>
+                        <a:srgbClr val="2A3441"/>
+                      </a:solidFill>
+                      <a:prstDash val="solid"/>
+                      <a:round/>
+                      <a:headEnd type="none" w="med" len="med"/>
+                      <a:tailEnd type="none" w="med" len="med"/>
+                    </a:lnT>
+                    <a:lnB w="12700" cap="flat" cmpd="sng" algn="ctr">
+                      <a:solidFill>
+                        <a:srgbClr val="2A3441"/>
+                      </a:solidFill>
+                      <a:prstDash val="solid"/>
+                      <a:round/>
+                      <a:headEnd type="none" w="med" len="med"/>
+                      <a:tailEnd type="none" w="med" len="med"/>
+                    </a:lnB>
+                    <a:solidFill>
+                      <a:srgbClr val="39FF88"/>
+                    </a:solidFill>
+                  </a:tcPr>
+                </a:tc>
+                <a:tc>
+                  <a:txBody>
+                    <a:bodyPr/>
+                    <a:lstStyle/>
+                    <a:p>
+                      <a:pPr indent="0" marL="0">
+                        <a:buNone/>
+                      </a:pPr>
+                      <a:r>
+                        <a:rPr lang="en-US" sz="1300" b="1" dirty="0">
+                          <a:solidFill>
+                            <a:srgbClr val="0B0F14"/>
+                          </a:solidFill>
+                          <a:latin typeface="Courier New" pitchFamily="34" charset="0"/>
+                          <a:ea typeface="Courier New" pitchFamily="34" charset="-122"/>
+                          <a:cs typeface="Courier New" pitchFamily="34" charset="-120"/>
+                        </a:rPr>
+                        <a:t>AIMD 32</a:t>
+                      </a:r>
+                      <a:endParaRPr lang="en-US" sz="1300" dirty="0">
+                        <a:latin typeface="Courier New" charset="0"/>
+                        <a:ea typeface="Courier New" charset="0"/>
+                        <a:cs typeface="Courier New" charset="0"/>
+                      </a:endParaRPr>
+                    </a:p>
+                  </a:txBody>
+                  <a:tcPr marL="91440" marR="91440" marT="45720" marB="45720">
+                    <a:lnL w="12700" cap="flat" cmpd="sng" algn="ctr">
+                      <a:solidFill>
+                        <a:srgbClr val="2A3441"/>
+                      </a:solidFill>
+                      <a:prstDash val="solid"/>
+                      <a:round/>
+                      <a:headEnd type="none" w="med" len="med"/>
+                      <a:tailEnd type="none" w="med" len="med"/>
+                    </a:lnL>
+                    <a:lnR w="12700" cap="flat" cmpd="sng" algn="ctr">
+                      <a:solidFill>
+                        <a:srgbClr val="2A3441"/>
+                      </a:solidFill>
+                      <a:prstDash val="solid"/>
+                      <a:round/>
+                      <a:headEnd type="none" w="med" len="med"/>
+                      <a:tailEnd type="none" w="med" len="med"/>
+                    </a:lnR>
+                    <a:lnT w="12700" cap="flat" cmpd="sng" algn="ctr">
+                      <a:solidFill>
+                        <a:srgbClr val="2A3441"/>
+                      </a:solidFill>
+                      <a:prstDash val="solid"/>
+                      <a:round/>
+                      <a:headEnd type="none" w="med" len="med"/>
+                      <a:tailEnd type="none" w="med" len="med"/>
+                    </a:lnT>
+                    <a:lnB w="12700" cap="flat" cmpd="sng" algn="ctr">
+                      <a:solidFill>
+                        <a:srgbClr val="2A3441"/>
+                      </a:solidFill>
+                      <a:prstDash val="solid"/>
+                      <a:round/>
+                      <a:headEnd type="none" w="med" len="med"/>
+                      <a:tailEnd type="none" w="med" len="med"/>
+                    </a:lnB>
+                    <a:solidFill>
+                      <a:srgbClr val="39FF88"/>
+                    </a:solidFill>
+                  </a:tcPr>
+                </a:tc>
+                <a:tc>
+                  <a:txBody>
+                    <a:bodyPr/>
+                    <a:lstStyle/>
+                    <a:p>
+                      <a:pPr indent="0" marL="0">
+                        <a:buNone/>
+                      </a:pPr>
+                      <a:r>
+                        <a:rPr lang="en-US" sz="1300" b="1" dirty="0">
+                          <a:solidFill>
+                            <a:srgbClr val="0B0F14"/>
+                          </a:solidFill>
+                          <a:latin typeface="Courier New" pitchFamily="34" charset="0"/>
+                          <a:ea typeface="Courier New" pitchFamily="34" charset="-122"/>
+                          <a:cs typeface="Courier New" pitchFamily="34" charset="-120"/>
+                        </a:rPr>
+                        <a:t>Neural</a:t>
+                      </a:r>
+                      <a:endParaRPr lang="en-US" sz="1300" dirty="0">
+                        <a:latin typeface="Courier New" charset="0"/>
+                        <a:ea typeface="Courier New" charset="0"/>
+                        <a:cs typeface="Courier New" charset="0"/>
+                      </a:endParaRPr>
+                    </a:p>
+                  </a:txBody>
+                  <a:tcPr marL="91440" marR="91440" marT="45720" marB="45720">
+                    <a:lnL w="12700" cap="flat" cmpd="sng" algn="ctr">
+                      <a:solidFill>
+                        <a:srgbClr val="2A3441"/>
+                      </a:solidFill>
+                      <a:prstDash val="solid"/>
+                      <a:round/>
+                      <a:headEnd type="none" w="med" len="med"/>
+                      <a:tailEnd type="none" w="med" len="med"/>
+                    </a:lnL>
+                    <a:lnR w="12700" cap="flat" cmpd="sng" algn="ctr">
+                      <a:solidFill>
+                        <a:srgbClr val="2A3441"/>
+                      </a:solidFill>
+                      <a:prstDash val="solid"/>
+                      <a:round/>
+                      <a:headEnd type="none" w="med" len="med"/>
+                      <a:tailEnd type="none" w="med" len="med"/>
+                    </a:lnR>
+                    <a:lnT w="12700" cap="flat" cmpd="sng" algn="ctr">
+                      <a:solidFill>
+                        <a:srgbClr val="2A3441"/>
+                      </a:solidFill>
+                      <a:prstDash val="solid"/>
+                      <a:round/>
+                      <a:headEnd type="none" w="med" len="med"/>
+                      <a:tailEnd type="none" w="med" len="med"/>
+                    </a:lnT>
+                    <a:lnB w="12700" cap="flat" cmpd="sng" algn="ctr">
+                      <a:solidFill>
+                        <a:srgbClr val="2A3441"/>
+                      </a:solidFill>
+                      <a:prstDash val="solid"/>
+                      <a:round/>
+                      <a:headEnd type="none" w="med" len="med"/>
+                      <a:tailEnd type="none" w="med" len="med"/>
+                    </a:lnB>
+                    <a:solidFill>
+                      <a:srgbClr val="39FF88"/>
+                    </a:solidFill>
+                  </a:tcPr>
+                </a:tc>
+                <a:tc>
+                  <a:txBody>
+                    <a:bodyPr/>
+                    <a:lstStyle/>
+                    <a:p>
+                      <a:pPr indent="0" marL="0">
+                        <a:buNone/>
+                      </a:pPr>
+                      <a:r>
+                        <a:rPr lang="en-US" sz="1300" b="1" dirty="0">
+                          <a:solidFill>
+                            <a:srgbClr val="0B0F14"/>
+                          </a:solidFill>
+                          <a:latin typeface="Courier New" pitchFamily="34" charset="0"/>
+                          <a:ea typeface="Courier New" pitchFamily="34" charset="-122"/>
+                          <a:cs typeface="Courier New" pitchFamily="34" charset="-120"/>
+                        </a:rPr>
+                        <a:t>Hybrid</a:t>
+                      </a:r>
+                      <a:endParaRPr lang="en-US" sz="1300" dirty="0">
+                        <a:latin typeface="Courier New" charset="0"/>
+                        <a:ea typeface="Courier New" charset="0"/>
+                        <a:cs typeface="Courier New" charset="0"/>
+                      </a:endParaRPr>
+                    </a:p>
+                  </a:txBody>
+                  <a:tcPr marL="91440" marR="91440" marT="45720" marB="45720">
+                    <a:lnL w="12700" cap="flat" cmpd="sng" algn="ctr">
+                      <a:solidFill>
+                        <a:srgbClr val="2A3441"/>
+                      </a:solidFill>
+                      <a:prstDash val="solid"/>
+                      <a:round/>
+                      <a:headEnd type="none" w="med" len="med"/>
+                      <a:tailEnd type="none" w="med" len="med"/>
+                    </a:lnL>
+                    <a:lnR w="12700" cap="flat" cmpd="sng" algn="ctr">
+                      <a:solidFill>
+                        <a:srgbClr val="2A3441"/>
+                      </a:solidFill>
+                      <a:prstDash val="solid"/>
+                      <a:round/>
+                      <a:headEnd type="none" w="med" len="med"/>
+                      <a:tailEnd type="none" w="med" len="med"/>
+                    </a:lnR>
+                    <a:lnT w="12700" cap="flat" cmpd="sng" algn="ctr">
+                      <a:solidFill>
+                        <a:srgbClr val="2A3441"/>
+                      </a:solidFill>
+                      <a:prstDash val="solid"/>
+                      <a:round/>
+                      <a:headEnd type="none" w="med" len="med"/>
+                      <a:tailEnd type="none" w="med" len="med"/>
+                    </a:lnT>
+                    <a:lnB w="12700" cap="flat" cmpd="sng" algn="ctr">
+                      <a:solidFill>
+                        <a:srgbClr val="2A3441"/>
+                      </a:solidFill>
+                      <a:prstDash val="solid"/>
+                      <a:round/>
+                      <a:headEnd type="none" w="med" len="med"/>
+                      <a:tailEnd type="none" w="med" len="med"/>
+                    </a:lnB>
+                    <a:solidFill>
+                      <a:srgbClr val="39FF88"/>
+                    </a:solidFill>
+                  </a:tcPr>
+                </a:tc>
+              </a:tr>
+              <a:tr h="420624">
+                <a:tc>
+                  <a:txBody>
+                    <a:bodyPr/>
+                    <a:lstStyle/>
+                    <a:p>
+                      <a:pPr indent="0" marL="0">
+                        <a:buNone/>
+                      </a:pPr>
+                      <a:r>
+                        <a:rPr lang="en-US" sz="1300" dirty="0">
+                          <a:solidFill>
+                            <a:srgbClr val="E6EDF3"/>
+                          </a:solidFill>
+                          <a:latin typeface="Calibri" pitchFamily="34" charset="0"/>
+                          <a:ea typeface="Calibri" pitchFamily="34" charset="-122"/>
+                          <a:cs typeface="Calibri" pitchFamily="34" charset="-120"/>
+                        </a:rPr>
+                        <a:t>5G-like</a:t>
+                      </a:r>
+                      <a:endParaRPr lang="en-US" sz="1300" dirty="0">
+                        <a:latin typeface="Calibri" charset="0"/>
+                        <a:ea typeface="Calibri" charset="0"/>
+                        <a:cs typeface="Calibri" charset="0"/>
+                      </a:endParaRPr>
+                    </a:p>
+                  </a:txBody>
+                  <a:tcPr marL="91440" marR="91440" marT="45720" marB="45720">
+                    <a:lnL w="12700" cap="flat" cmpd="sng" algn="ctr">
+                      <a:solidFill>
+                        <a:srgbClr val="2A3441"/>
+                      </a:solidFill>
+                      <a:prstDash val="solid"/>
+                      <a:round/>
+                      <a:headEnd type="none" w="med" len="med"/>
+                      <a:tailEnd type="none" w="med" len="med"/>
+                    </a:lnL>
+                    <a:lnR w="12700" cap="flat" cmpd="sng" algn="ctr">
+                      <a:solidFill>
+                        <a:srgbClr val="2A3441"/>
+                      </a:solidFill>
+                      <a:prstDash val="solid"/>
+                      <a:round/>
+                      <a:headEnd type="none" w="med" len="med"/>
+                      <a:tailEnd type="none" w="med" len="med"/>
+                    </a:lnR>
+                    <a:lnT w="12700" cap="flat" cmpd="sng" algn="ctr">
+                      <a:solidFill>
+                        <a:srgbClr val="2A3441"/>
+                      </a:solidFill>
+                      <a:prstDash val="solid"/>
+                      <a:round/>
+                      <a:headEnd type="none" w="med" len="med"/>
+                      <a:tailEnd type="none" w="med" len="med"/>
+                    </a:lnT>
+                    <a:lnB w="12700" cap="flat" cmpd="sng" algn="ctr">
+                      <a:solidFill>
+                        <a:srgbClr val="2A3441"/>
+                      </a:solidFill>
+                      <a:prstDash val="solid"/>
+                      <a:round/>
+                      <a:headEnd type="none" w="med" len="med"/>
+                      <a:tailEnd type="none" w="med" len="med"/>
+                    </a:lnB>
+                    <a:solidFill>
+                      <a:srgbClr val="141B24"/>
+                    </a:solidFill>
+                  </a:tcPr>
+                </a:tc>
+                <a:tc>
+                  <a:txBody>
+                    <a:bodyPr/>
+                    <a:lstStyle/>
+                    <a:p>
+                      <a:pPr indent="0" marL="0">
+                        <a:buNone/>
+                      </a:pPr>
+                      <a:r>
+                        <a:rPr lang="en-US" sz="1300" dirty="0">
+                          <a:solidFill>
+                            <a:srgbClr val="E6EDF3"/>
+                          </a:solidFill>
+                          <a:latin typeface="Calibri" pitchFamily="34" charset="0"/>
+                          <a:ea typeface="Calibri" pitchFamily="34" charset="-122"/>
+                          <a:cs typeface="Calibri" pitchFamily="34" charset="-120"/>
+                        </a:rPr>
+                        <a:t>1.48</a:t>
+                      </a:r>
+                      <a:endParaRPr lang="en-US" sz="1300" dirty="0">
+                        <a:latin typeface="Calibri" charset="0"/>
+                        <a:ea typeface="Calibri" charset="0"/>
+                        <a:cs typeface="Calibri" charset="0"/>
+                      </a:endParaRPr>
+                    </a:p>
+                  </a:txBody>
+                  <a:tcPr marL="91440" marR="91440" marT="45720" marB="45720">
+                    <a:lnL w="12700" cap="flat" cmpd="sng" algn="ctr">
+                      <a:solidFill>
+                        <a:srgbClr val="2A3441"/>
+                      </a:solidFill>
+                      <a:prstDash val="solid"/>
+                      <a:round/>
+                      <a:headEnd type="none" w="med" len="med"/>
+                      <a:tailEnd type="none" w="med" len="med"/>
+                    </a:lnL>
+                    <a:lnR w="12700" cap="flat" cmpd="sng" algn="ctr">
+                      <a:solidFill>
+                        <a:srgbClr val="2A3441"/>
+                      </a:solidFill>
+                      <a:prstDash val="solid"/>
+                      <a:round/>
+                      <a:headEnd type="none" w="med" len="med"/>
+                      <a:tailEnd type="none" w="med" len="med"/>
+                    </a:lnR>
+                    <a:lnT w="12700" cap="flat" cmpd="sng" algn="ctr">
+                      <a:solidFill>
+                        <a:srgbClr val="2A3441"/>
+                      </a:solidFill>
+                      <a:prstDash val="solid"/>
+                      <a:round/>
+                      <a:headEnd type="none" w="med" len="med"/>
+                      <a:tailEnd type="none" w="med" len="med"/>
+                    </a:lnT>
+                    <a:lnB w="12700" cap="flat" cmpd="sng" algn="ctr">
+                      <a:solidFill>
+                        <a:srgbClr val="2A3441"/>
+                      </a:solidFill>
+                      <a:prstDash val="solid"/>
+                      <a:round/>
+                      <a:headEnd type="none" w="med" len="med"/>
+                      <a:tailEnd type="none" w="med" len="med"/>
+                    </a:lnB>
+                    <a:solidFill>
+                      <a:srgbClr val="141B24"/>
+                    </a:solidFill>
+                  </a:tcPr>
+                </a:tc>
+                <a:tc>
+                  <a:txBody>
+                    <a:bodyPr/>
+                    <a:lstStyle/>
+                    <a:p>
+                      <a:pPr indent="0" marL="0">
+                        <a:buNone/>
+                      </a:pPr>
+                      <a:r>
+                        <a:rPr lang="en-US" sz="1300" dirty="0">
+                          <a:solidFill>
+                            <a:srgbClr val="E6EDF3"/>
+                          </a:solidFill>
+                          <a:latin typeface="Calibri" pitchFamily="34" charset="0"/>
+                          <a:ea typeface="Calibri" pitchFamily="34" charset="-122"/>
+                          <a:cs typeface="Calibri" pitchFamily="34" charset="-120"/>
+                        </a:rPr>
+                        <a:t>1.17</a:t>
+                      </a:r>
+                      <a:endParaRPr lang="en-US" sz="1300" dirty="0">
+                        <a:latin typeface="Calibri" charset="0"/>
+                        <a:ea typeface="Calibri" charset="0"/>
+                        <a:cs typeface="Calibri" charset="0"/>
+                      </a:endParaRPr>
+                    </a:p>
+                  </a:txBody>
+                  <a:tcPr marL="91440" marR="91440" marT="45720" marB="45720">
+                    <a:lnL w="12700" cap="flat" cmpd="sng" algn="ctr">
+                      <a:solidFill>
+                        <a:srgbClr val="2A3441"/>
+                      </a:solidFill>
+                      <a:prstDash val="solid"/>
+                      <a:round/>
+                      <a:headEnd type="none" w="med" len="med"/>
+                      <a:tailEnd type="none" w="med" len="med"/>
+                    </a:lnL>
+                    <a:lnR w="12700" cap="flat" cmpd="sng" algn="ctr">
+                      <a:solidFill>
+                        <a:srgbClr val="2A3441"/>
+                      </a:solidFill>
+                      <a:prstDash val="solid"/>
+                      <a:round/>
+                      <a:headEnd type="none" w="med" len="med"/>
+                      <a:tailEnd type="none" w="med" len="med"/>
+                    </a:lnR>
+                    <a:lnT w="12700" cap="flat" cmpd="sng" algn="ctr">
+                      <a:solidFill>
+                        <a:srgbClr val="2A3441"/>
+                      </a:solidFill>
+                      <a:prstDash val="solid"/>
+                      <a:round/>
+                      <a:headEnd type="none" w="med" len="med"/>
+                      <a:tailEnd type="none" w="med" len="med"/>
+                    </a:lnT>
+                    <a:lnB w="12700" cap="flat" cmpd="sng" algn="ctr">
+                      <a:solidFill>
+                        <a:srgbClr val="2A3441"/>
+                      </a:solidFill>
+                      <a:prstDash val="solid"/>
+                      <a:round/>
+                      <a:headEnd type="none" w="med" len="med"/>
+                      <a:tailEnd type="none" w="med" len="med"/>
+                    </a:lnB>
+                    <a:solidFill>
+                      <a:srgbClr val="141B24"/>
+                    </a:solidFill>
+                  </a:tcPr>
+                </a:tc>
+                <a:tc>
+                  <a:txBody>
+                    <a:bodyPr/>
+                    <a:lstStyle/>
+                    <a:p>
+                      <a:pPr indent="0" marL="0">
+                        <a:buNone/>
+                      </a:pPr>
+                      <a:r>
+                        <a:rPr lang="en-US" sz="1300" dirty="0">
+                          <a:solidFill>
+                            <a:srgbClr val="E6EDF3"/>
+                          </a:solidFill>
+                          <a:latin typeface="Calibri" pitchFamily="34" charset="0"/>
+                          <a:ea typeface="Calibri" pitchFamily="34" charset="-122"/>
+                          <a:cs typeface="Calibri" pitchFamily="34" charset="-120"/>
+                        </a:rPr>
+                        <a:t>1.23</a:t>
+                      </a:r>
+                      <a:endParaRPr lang="en-US" sz="1300" dirty="0">
+                        <a:latin typeface="Calibri" charset="0"/>
+                        <a:ea typeface="Calibri" charset="0"/>
+                        <a:cs typeface="Calibri" charset="0"/>
+                      </a:endParaRPr>
+                    </a:p>
+                  </a:txBody>
+                  <a:tcPr marL="91440" marR="91440" marT="45720" marB="45720">
+                    <a:lnL w="12700" cap="flat" cmpd="sng" algn="ctr">
+                      <a:solidFill>
+                        <a:srgbClr val="2A3441"/>
+                      </a:solidFill>
+                      <a:prstDash val="solid"/>
+                      <a:round/>
+                      <a:headEnd type="none" w="med" len="med"/>
+                      <a:tailEnd type="none" w="med" len="med"/>
+                    </a:lnL>
+                    <a:lnR w="12700" cap="flat" cmpd="sng" algn="ctr">
+                      <a:solidFill>
+                        <a:srgbClr val="2A3441"/>
+                      </a:solidFill>
+                      <a:prstDash val="solid"/>
+                      <a:round/>
+                      <a:headEnd type="none" w="med" len="med"/>
+                      <a:tailEnd type="none" w="med" len="med"/>
+                    </a:lnR>
+                    <a:lnT w="12700" cap="flat" cmpd="sng" algn="ctr">
+                      <a:solidFill>
+                        <a:srgbClr val="2A3441"/>
+                      </a:solidFill>
+                      <a:prstDash val="solid"/>
+                      <a:round/>
+                      <a:headEnd type="none" w="med" len="med"/>
+                      <a:tailEnd type="none" w="med" len="med"/>
+                    </a:lnT>
+                    <a:lnB w="12700" cap="flat" cmpd="sng" algn="ctr">
+                      <a:solidFill>
+                        <a:srgbClr val="2A3441"/>
+                      </a:solidFill>
+                      <a:prstDash val="solid"/>
+                      <a:round/>
+                      <a:headEnd type="none" w="med" len="med"/>
+                      <a:tailEnd type="none" w="med" len="med"/>
+                    </a:lnB>
+                    <a:solidFill>
+                      <a:srgbClr val="141B24"/>
+                    </a:solidFill>
+                  </a:tcPr>
+                </a:tc>
+              </a:tr>
+              <a:tr h="420624">
+                <a:tc>
+                  <a:txBody>
+                    <a:bodyPr/>
+                    <a:lstStyle/>
+                    <a:p>
+                      <a:pPr indent="0" marL="0">
+                        <a:buNone/>
+                      </a:pPr>
+                      <a:r>
+                        <a:rPr lang="en-US" sz="1300" dirty="0">
+                          <a:solidFill>
+                            <a:srgbClr val="E6EDF3"/>
+                          </a:solidFill>
+                          <a:latin typeface="Calibri" pitchFamily="34" charset="0"/>
+                          <a:ea typeface="Calibri" pitchFamily="34" charset="-122"/>
+                          <a:cs typeface="Calibri" pitchFamily="34" charset="-120"/>
+                        </a:rPr>
+                        <a:t>Lossy 2%</a:t>
+                      </a:r>
+                      <a:endParaRPr lang="en-US" sz="1300" dirty="0">
+                        <a:latin typeface="Calibri" charset="0"/>
+                        <a:ea typeface="Calibri" charset="0"/>
+                        <a:cs typeface="Calibri" charset="0"/>
+                      </a:endParaRPr>
+                    </a:p>
+                  </a:txBody>
+                  <a:tcPr marL="91440" marR="91440" marT="45720" marB="45720">
+                    <a:lnL w="12700" cap="flat" cmpd="sng" algn="ctr">
+                      <a:solidFill>
+                        <a:srgbClr val="2A3441"/>
+                      </a:solidFill>
+                      <a:prstDash val="solid"/>
+                      <a:round/>
+                      <a:headEnd type="none" w="med" len="med"/>
+                      <a:tailEnd type="none" w="med" len="med"/>
+                    </a:lnL>
+                    <a:lnR w="12700" cap="flat" cmpd="sng" algn="ctr">
+                      <a:solidFill>
+                        <a:srgbClr val="2A3441"/>
+                      </a:solidFill>
+                      <a:prstDash val="solid"/>
+                      <a:round/>
+                      <a:headEnd type="none" w="med" len="med"/>
+                      <a:tailEnd type="none" w="med" len="med"/>
+                    </a:lnR>
+                    <a:lnT w="12700" cap="flat" cmpd="sng" algn="ctr">
+                      <a:solidFill>
+                        <a:srgbClr val="2A3441"/>
+                      </a:solidFill>
+                      <a:prstDash val="solid"/>
+                      <a:round/>
+                      <a:headEnd type="none" w="med" len="med"/>
+                      <a:tailEnd type="none" w="med" len="med"/>
+                    </a:lnT>
+                    <a:lnB w="12700" cap="flat" cmpd="sng" algn="ctr">
+                      <a:solidFill>
+                        <a:srgbClr val="2A3441"/>
+                      </a:solidFill>
+                      <a:prstDash val="solid"/>
+                      <a:round/>
+                      <a:headEnd type="none" w="med" len="med"/>
+                      <a:tailEnd type="none" w="med" len="med"/>
+                    </a:lnB>
+                    <a:solidFill>
+                      <a:srgbClr val="141B24"/>
+                    </a:solidFill>
+                  </a:tcPr>
+                </a:tc>
+                <a:tc>
+                  <a:txBody>
+                    <a:bodyPr/>
+                    <a:lstStyle/>
+                    <a:p>
+                      <a:pPr indent="0" marL="0">
+                        <a:buNone/>
+                      </a:pPr>
+                      <a:r>
+                        <a:rPr lang="en-US" sz="1300" dirty="0">
+                          <a:solidFill>
+                            <a:srgbClr val="E6EDF3"/>
+                          </a:solidFill>
+                          <a:latin typeface="Calibri" pitchFamily="34" charset="0"/>
+                          <a:ea typeface="Calibri" pitchFamily="34" charset="-122"/>
+                          <a:cs typeface="Calibri" pitchFamily="34" charset="-120"/>
+                        </a:rPr>
+                        <a:t>9.04</a:t>
+                      </a:r>
+                      <a:endParaRPr lang="en-US" sz="1300" dirty="0">
+                        <a:latin typeface="Calibri" charset="0"/>
+                        <a:ea typeface="Calibri" charset="0"/>
+                        <a:cs typeface="Calibri" charset="0"/>
+                      </a:endParaRPr>
+                    </a:p>
+                  </a:txBody>
+                  <a:tcPr marL="91440" marR="91440" marT="45720" marB="45720">
+                    <a:lnL w="12700" cap="flat" cmpd="sng" algn="ctr">
+                      <a:solidFill>
+                        <a:srgbClr val="2A3441"/>
+                      </a:solidFill>
+                      <a:prstDash val="solid"/>
+                      <a:round/>
+                      <a:headEnd type="none" w="med" len="med"/>
+                      <a:tailEnd type="none" w="med" len="med"/>
+                    </a:lnL>
+                    <a:lnR w="12700" cap="flat" cmpd="sng" algn="ctr">
+                      <a:solidFill>
+                        <a:srgbClr val="2A3441"/>
+                      </a:solidFill>
+                      <a:prstDash val="solid"/>
+                      <a:round/>
+                      <a:headEnd type="none" w="med" len="med"/>
+                      <a:tailEnd type="none" w="med" len="med"/>
+                    </a:lnR>
+                    <a:lnT w="12700" cap="flat" cmpd="sng" algn="ctr">
+                      <a:solidFill>
+                        <a:srgbClr val="2A3441"/>
+                      </a:solidFill>
+                      <a:prstDash val="solid"/>
+                      <a:round/>
+                      <a:headEnd type="none" w="med" len="med"/>
+                      <a:tailEnd type="none" w="med" len="med"/>
+                    </a:lnT>
+                    <a:lnB w="12700" cap="flat" cmpd="sng" algn="ctr">
+                      <a:solidFill>
+                        <a:srgbClr val="2A3441"/>
+                      </a:solidFill>
+                      <a:prstDash val="solid"/>
+                      <a:round/>
+                      <a:headEnd type="none" w="med" len="med"/>
+                      <a:tailEnd type="none" w="med" len="med"/>
+                    </a:lnB>
+                    <a:solidFill>
+                      <a:srgbClr val="141B24"/>
+                    </a:solidFill>
+                  </a:tcPr>
+                </a:tc>
+                <a:tc>
+                  <a:txBody>
+                    <a:bodyPr/>
+                    <a:lstStyle/>
+                    <a:p>
+                      <a:pPr indent="0" marL="0">
+                        <a:buNone/>
+                      </a:pPr>
+                      <a:r>
+                        <a:rPr lang="en-US" sz="1300" dirty="0">
+                          <a:solidFill>
+                            <a:srgbClr val="E6EDF3"/>
+                          </a:solidFill>
+                          <a:latin typeface="Calibri" pitchFamily="34" charset="0"/>
+                          <a:ea typeface="Calibri" pitchFamily="34" charset="-122"/>
+                          <a:cs typeface="Calibri" pitchFamily="34" charset="-120"/>
+                        </a:rPr>
+                        <a:t>7.53</a:t>
+                      </a:r>
+                      <a:endParaRPr lang="en-US" sz="1300" dirty="0">
+                        <a:latin typeface="Calibri" charset="0"/>
+                        <a:ea typeface="Calibri" charset="0"/>
+                        <a:cs typeface="Calibri" charset="0"/>
+                      </a:endParaRPr>
+                    </a:p>
+                  </a:txBody>
+                  <a:tcPr marL="91440" marR="91440" marT="45720" marB="45720">
+                    <a:lnL w="12700" cap="flat" cmpd="sng" algn="ctr">
+                      <a:solidFill>
+                        <a:srgbClr val="2A3441"/>
+                      </a:solidFill>
+                      <a:prstDash val="solid"/>
+                      <a:round/>
+                      <a:headEnd type="none" w="med" len="med"/>
+                      <a:tailEnd type="none" w="med" len="med"/>
+                    </a:lnL>
+                    <a:lnR w="12700" cap="flat" cmpd="sng" algn="ctr">
+                      <a:solidFill>
+                        <a:srgbClr val="2A3441"/>
+                      </a:solidFill>
+                      <a:prstDash val="solid"/>
+                      <a:round/>
+                      <a:headEnd type="none" w="med" len="med"/>
+                      <a:tailEnd type="none" w="med" len="med"/>
+                    </a:lnR>
+                    <a:lnT w="12700" cap="flat" cmpd="sng" algn="ctr">
+                      <a:solidFill>
+                        <a:srgbClr val="2A3441"/>
+                      </a:solidFill>
+                      <a:prstDash val="solid"/>
+                      <a:round/>
+                      <a:headEnd type="none" w="med" len="med"/>
+                      <a:tailEnd type="none" w="med" len="med"/>
+                    </a:lnT>
+                    <a:lnB w="12700" cap="flat" cmpd="sng" algn="ctr">
+                      <a:solidFill>
+                        <a:srgbClr val="2A3441"/>
+                      </a:solidFill>
+                      <a:prstDash val="solid"/>
+                      <a:round/>
+                      <a:headEnd type="none" w="med" len="med"/>
+                      <a:tailEnd type="none" w="med" len="med"/>
+                    </a:lnB>
+                    <a:solidFill>
+                      <a:srgbClr val="141B24"/>
+                    </a:solidFill>
+                  </a:tcPr>
+                </a:tc>
+                <a:tc>
+                  <a:txBody>
+                    <a:bodyPr/>
+                    <a:lstStyle/>
+                    <a:p>
+                      <a:pPr indent="0" marL="0">
+                        <a:buNone/>
+                      </a:pPr>
+                      <a:r>
+                        <a:rPr lang="en-US" sz="1300" dirty="0">
+                          <a:solidFill>
+                            <a:srgbClr val="E6EDF3"/>
+                          </a:solidFill>
+                          <a:latin typeface="Calibri" pitchFamily="34" charset="0"/>
+                          <a:ea typeface="Calibri" pitchFamily="34" charset="-122"/>
+                          <a:cs typeface="Calibri" pitchFamily="34" charset="-120"/>
+                        </a:rPr>
+                        <a:t>7.57</a:t>
+                      </a:r>
+                      <a:endParaRPr lang="en-US" sz="1300" dirty="0">
+                        <a:latin typeface="Calibri" charset="0"/>
+                        <a:ea typeface="Calibri" charset="0"/>
+                        <a:cs typeface="Calibri" charset="0"/>
+                      </a:endParaRPr>
+                    </a:p>
+                  </a:txBody>
+                  <a:tcPr marL="91440" marR="91440" marT="45720" marB="45720">
+                    <a:lnL w="12700" cap="flat" cmpd="sng" algn="ctr">
+                      <a:solidFill>
+                        <a:srgbClr val="2A3441"/>
+                      </a:solidFill>
+                      <a:prstDash val="solid"/>
+                      <a:round/>
+                      <a:headEnd type="none" w="med" len="med"/>
+                      <a:tailEnd type="none" w="med" len="med"/>
+                    </a:lnL>
+                    <a:lnR w="12700" cap="flat" cmpd="sng" algn="ctr">
+                      <a:solidFill>
+                        <a:srgbClr val="2A3441"/>
+                      </a:solidFill>
+                      <a:prstDash val="solid"/>
+                      <a:round/>
+                      <a:headEnd type="none" w="med" len="med"/>
+                      <a:tailEnd type="none" w="med" len="med"/>
+                    </a:lnR>
+                    <a:lnT w="12700" cap="flat" cmpd="sng" algn="ctr">
+                      <a:solidFill>
+                        <a:srgbClr val="2A3441"/>
+                      </a:solidFill>
+                      <a:prstDash val="solid"/>
+                      <a:round/>
+                      <a:headEnd type="none" w="med" len="med"/>
+                      <a:tailEnd type="none" w="med" len="med"/>
+                    </a:lnT>
+                    <a:lnB w="12700" cap="flat" cmpd="sng" algn="ctr">
+                      <a:solidFill>
+                        <a:srgbClr val="2A3441"/>
+                      </a:solidFill>
+                      <a:prstDash val="solid"/>
+                      <a:round/>
+                      <a:headEnd type="none" w="med" len="med"/>
+                      <a:tailEnd type="none" w="med" len="med"/>
+                    </a:lnB>
+                    <a:solidFill>
+                      <a:srgbClr val="141B24"/>
+                    </a:solidFill>
+                  </a:tcPr>
+                </a:tc>
+              </a:tr>
+              <a:tr h="420624">
+                <a:tc>
+                  <a:txBody>
+                    <a:bodyPr/>
+                    <a:lstStyle/>
+                    <a:p>
+                      <a:pPr indent="0" marL="0">
+                        <a:buNone/>
+                      </a:pPr>
+                      <a:r>
+                        <a:rPr lang="en-US" sz="1300" dirty="0">
+                          <a:solidFill>
+                            <a:srgbClr val="E6EDF3"/>
+                          </a:solidFill>
+                          <a:latin typeface="Calibri" pitchFamily="34" charset="0"/>
+                          <a:ea typeface="Calibri" pitchFamily="34" charset="-122"/>
+                          <a:cs typeface="Calibri" pitchFamily="34" charset="-120"/>
+                        </a:rPr>
+                        <a:t>Satellite-like</a:t>
+                      </a:r>
+                      <a:endParaRPr lang="en-US" sz="1300" dirty="0">
+                        <a:latin typeface="Calibri" charset="0"/>
+                        <a:ea typeface="Calibri" charset="0"/>
+                        <a:cs typeface="Calibri" charset="0"/>
+                      </a:endParaRPr>
+                    </a:p>
+                  </a:txBody>
+                  <a:tcPr marL="91440" marR="91440" marT="45720" marB="45720">
+                    <a:lnL w="12700" cap="flat" cmpd="sng" algn="ctr">
+                      <a:solidFill>
+                        <a:srgbClr val="2A3441"/>
+                      </a:solidFill>
+                      <a:prstDash val="solid"/>
+                      <a:round/>
+                      <a:headEnd type="none" w="med" len="med"/>
+                      <a:tailEnd type="none" w="med" len="med"/>
+                    </a:lnL>
+                    <a:lnR w="12700" cap="flat" cmpd="sng" algn="ctr">
+                      <a:solidFill>
+                        <a:srgbClr val="2A3441"/>
+                      </a:solidFill>
+                      <a:prstDash val="solid"/>
+                      <a:round/>
+                      <a:headEnd type="none" w="med" len="med"/>
+                      <a:tailEnd type="none" w="med" len="med"/>
+                    </a:lnR>
+                    <a:lnT w="12700" cap="flat" cmpd="sng" algn="ctr">
+                      <a:solidFill>
+                        <a:srgbClr val="2A3441"/>
+                      </a:solidFill>
+                      <a:prstDash val="solid"/>
+                      <a:round/>
+                      <a:headEnd type="none" w="med" len="med"/>
+                      <a:tailEnd type="none" w="med" len="med"/>
+                    </a:lnT>
+                    <a:lnB w="12700" cap="flat" cmpd="sng" algn="ctr">
+                      <a:solidFill>
+                        <a:srgbClr val="2A3441"/>
+                      </a:solidFill>
+                      <a:prstDash val="solid"/>
+                      <a:round/>
+                      <a:headEnd type="none" w="med" len="med"/>
+                      <a:tailEnd type="none" w="med" len="med"/>
+                    </a:lnB>
+                    <a:solidFill>
+                      <a:srgbClr val="141B24"/>
+                    </a:solidFill>
+                  </a:tcPr>
+                </a:tc>
+                <a:tc>
+                  <a:txBody>
+                    <a:bodyPr/>
+                    <a:lstStyle/>
+                    <a:p>
+                      <a:pPr indent="0" marL="0">
+                        <a:buNone/>
+                      </a:pPr>
+                      <a:r>
+                        <a:rPr lang="en-US" sz="1300" dirty="0">
+                          <a:solidFill>
+                            <a:srgbClr val="E6EDF3"/>
+                          </a:solidFill>
+                          <a:latin typeface="Calibri" pitchFamily="34" charset="0"/>
+                          <a:ea typeface="Calibri" pitchFamily="34" charset="-122"/>
+                          <a:cs typeface="Calibri" pitchFamily="34" charset="-120"/>
+                        </a:rPr>
+                        <a:t>19.7</a:t>
+                      </a:r>
+                      <a:endParaRPr lang="en-US" sz="1300" dirty="0">
+                        <a:latin typeface="Calibri" charset="0"/>
+                        <a:ea typeface="Calibri" charset="0"/>
+                        <a:cs typeface="Calibri" charset="0"/>
+                      </a:endParaRPr>
+                    </a:p>
+                  </a:txBody>
+                  <a:tcPr marL="91440" marR="91440" marT="45720" marB="45720">
+                    <a:lnL w="12700" cap="flat" cmpd="sng" algn="ctr">
+                      <a:solidFill>
+                        <a:srgbClr val="2A3441"/>
+                      </a:solidFill>
+                      <a:prstDash val="solid"/>
+                      <a:round/>
+                      <a:headEnd type="none" w="med" len="med"/>
+                      <a:tailEnd type="none" w="med" len="med"/>
+                    </a:lnL>
+                    <a:lnR w="12700" cap="flat" cmpd="sng" algn="ctr">
+                      <a:solidFill>
+                        <a:srgbClr val="2A3441"/>
+                      </a:solidFill>
+                      <a:prstDash val="solid"/>
+                      <a:round/>
+                      <a:headEnd type="none" w="med" len="med"/>
+                      <a:tailEnd type="none" w="med" len="med"/>
+                    </a:lnR>
+                    <a:lnT w="12700" cap="flat" cmpd="sng" algn="ctr">
+                      <a:solidFill>
+                        <a:srgbClr val="2A3441"/>
+                      </a:solidFill>
+                      <a:prstDash val="solid"/>
+                      <a:round/>
+                      <a:headEnd type="none" w="med" len="med"/>
+                      <a:tailEnd type="none" w="med" len="med"/>
+                    </a:lnT>
+                    <a:lnB w="12700" cap="flat" cmpd="sng" algn="ctr">
+                      <a:solidFill>
+                        <a:srgbClr val="2A3441"/>
+                      </a:solidFill>
+                      <a:prstDash val="solid"/>
+                      <a:round/>
+                      <a:headEnd type="none" w="med" len="med"/>
+                      <a:tailEnd type="none" w="med" len="med"/>
+                    </a:lnB>
+                    <a:solidFill>
+                      <a:srgbClr val="141B24"/>
+                    </a:solidFill>
+                  </a:tcPr>
+                </a:tc>
+                <a:tc>
+                  <a:txBody>
+                    <a:bodyPr/>
+                    <a:lstStyle/>
+                    <a:p>
+                      <a:pPr indent="0" marL="0">
+                        <a:buNone/>
+                      </a:pPr>
+                      <a:r>
+                        <a:rPr lang="en-US" sz="1300" dirty="0">
+                          <a:solidFill>
+                            <a:srgbClr val="E6EDF3"/>
+                          </a:solidFill>
+                          <a:latin typeface="Calibri" pitchFamily="34" charset="0"/>
+                          <a:ea typeface="Calibri" pitchFamily="34" charset="-122"/>
+                          <a:cs typeface="Calibri" pitchFamily="34" charset="-120"/>
+                        </a:rPr>
+                        <a:t>13.4</a:t>
+                      </a:r>
+                      <a:endParaRPr lang="en-US" sz="1300" dirty="0">
+                        <a:latin typeface="Calibri" charset="0"/>
+                        <a:ea typeface="Calibri" charset="0"/>
+                        <a:cs typeface="Calibri" charset="0"/>
+                      </a:endParaRPr>
+                    </a:p>
+                  </a:txBody>
+                  <a:tcPr marL="91440" marR="91440" marT="45720" marB="45720">
+                    <a:lnL w="12700" cap="flat" cmpd="sng" algn="ctr">
+                      <a:solidFill>
+                        <a:srgbClr val="2A3441"/>
+                      </a:solidFill>
+                      <a:prstDash val="solid"/>
+                      <a:round/>
+                      <a:headEnd type="none" w="med" len="med"/>
+                      <a:tailEnd type="none" w="med" len="med"/>
+                    </a:lnL>
+                    <a:lnR w="12700" cap="flat" cmpd="sng" algn="ctr">
+                      <a:solidFill>
+                        <a:srgbClr val="2A3441"/>
+                      </a:solidFill>
+                      <a:prstDash val="solid"/>
+                      <a:round/>
+                      <a:headEnd type="none" w="med" len="med"/>
+                      <a:tailEnd type="none" w="med" len="med"/>
+                    </a:lnR>
+                    <a:lnT w="12700" cap="flat" cmpd="sng" algn="ctr">
+                      <a:solidFill>
+                        <a:srgbClr val="2A3441"/>
+                      </a:solidFill>
+                      <a:prstDash val="solid"/>
+                      <a:round/>
+                      <a:headEnd type="none" w="med" len="med"/>
+                      <a:tailEnd type="none" w="med" len="med"/>
+                    </a:lnT>
+                    <a:lnB w="12700" cap="flat" cmpd="sng" algn="ctr">
+                      <a:solidFill>
+                        <a:srgbClr val="2A3441"/>
+                      </a:solidFill>
+                      <a:prstDash val="solid"/>
+                      <a:round/>
+                      <a:headEnd type="none" w="med" len="med"/>
+                      <a:tailEnd type="none" w="med" len="med"/>
+                    </a:lnB>
+                    <a:solidFill>
+                      <a:srgbClr val="141B24"/>
+                    </a:solidFill>
+                  </a:tcPr>
+                </a:tc>
+                <a:tc>
+                  <a:txBody>
+                    <a:bodyPr/>
+                    <a:lstStyle/>
+                    <a:p>
+                      <a:pPr indent="0" marL="0">
+                        <a:buNone/>
+                      </a:pPr>
+                      <a:r>
+                        <a:rPr lang="en-US" sz="1300" dirty="0">
+                          <a:solidFill>
+                            <a:srgbClr val="E6EDF3"/>
+                          </a:solidFill>
+                          <a:latin typeface="Calibri" pitchFamily="34" charset="0"/>
+                          <a:ea typeface="Calibri" pitchFamily="34" charset="-122"/>
+                          <a:cs typeface="Calibri" pitchFamily="34" charset="-120"/>
+                        </a:rPr>
+                        <a:t>13.7</a:t>
+                      </a:r>
+                      <a:endParaRPr lang="en-US" sz="1300" dirty="0">
+                        <a:latin typeface="Calibri" charset="0"/>
+                        <a:ea typeface="Calibri" charset="0"/>
+                        <a:cs typeface="Calibri" charset="0"/>
+                      </a:endParaRPr>
+                    </a:p>
+                  </a:txBody>
+                  <a:tcPr marL="91440" marR="91440" marT="45720" marB="45720">
+                    <a:lnL w="12700" cap="flat" cmpd="sng" algn="ctr">
+                      <a:solidFill>
+                        <a:srgbClr val="2A3441"/>
+                      </a:solidFill>
+                      <a:prstDash val="solid"/>
+                      <a:round/>
+                      <a:headEnd type="none" w="med" len="med"/>
+                      <a:tailEnd type="none" w="med" len="med"/>
+                    </a:lnL>
+                    <a:lnR w="12700" cap="flat" cmpd="sng" algn="ctr">
+                      <a:solidFill>
+                        <a:srgbClr val="2A3441"/>
+                      </a:solidFill>
+                      <a:prstDash val="solid"/>
+                      <a:round/>
+                      <a:headEnd type="none" w="med" len="med"/>
+                      <a:tailEnd type="none" w="med" len="med"/>
+                    </a:lnR>
+                    <a:lnT w="12700" cap="flat" cmpd="sng" algn="ctr">
+                      <a:solidFill>
+                        <a:srgbClr val="2A3441"/>
+                      </a:solidFill>
+                      <a:prstDash val="solid"/>
+                      <a:round/>
+                      <a:headEnd type="none" w="med" len="med"/>
+                      <a:tailEnd type="none" w="med" len="med"/>
+                    </a:lnT>
+                    <a:lnB w="12700" cap="flat" cmpd="sng" algn="ctr">
+                      <a:solidFill>
+                        <a:srgbClr val="2A3441"/>
+                      </a:solidFill>
+                      <a:prstDash val="solid"/>
+                      <a:round/>
+                      <a:headEnd type="none" w="med" len="med"/>
+                      <a:tailEnd type="none" w="med" len="med"/>
+                    </a:lnB>
+                    <a:solidFill>
+                      <a:srgbClr val="141B24"/>
+                    </a:solidFill>
+                  </a:tcPr>
+                </a:tc>
+              </a:tr>
+              <a:tr h="420624">
+                <a:tc>
+                  <a:txBody>
+                    <a:bodyPr/>
+                    <a:lstStyle/>
+                    <a:p>
+                      <a:pPr indent="0" marL="0">
+                        <a:buNone/>
+                      </a:pPr>
+                      <a:r>
+                        <a:rPr lang="en-US" sz="1300" dirty="0">
+                          <a:solidFill>
+                            <a:srgbClr val="E6EDF3"/>
+                          </a:solidFill>
+                          <a:latin typeface="Calibri" pitchFamily="34" charset="0"/>
+                          <a:ea typeface="Calibri" pitchFamily="34" charset="-122"/>
+                          <a:cs typeface="Calibri" pitchFamily="34" charset="-120"/>
+                        </a:rPr>
+                        <a:t>Hostile, 10% loss</a:t>
+                      </a:r>
+                      <a:endParaRPr lang="en-US" sz="1300" dirty="0">
+                        <a:latin typeface="Calibri" charset="0"/>
+                        <a:ea typeface="Calibri" charset="0"/>
+                        <a:cs typeface="Calibri" charset="0"/>
+                      </a:endParaRPr>
+                    </a:p>
+                  </a:txBody>
+                  <a:tcPr marL="91440" marR="91440" marT="45720" marB="45720">
+                    <a:lnL w="12700" cap="flat" cmpd="sng" algn="ctr">
+                      <a:solidFill>
+                        <a:srgbClr val="2A3441"/>
+                      </a:solidFill>
+                      <a:prstDash val="solid"/>
+                      <a:round/>
+                      <a:headEnd type="none" w="med" len="med"/>
+                      <a:tailEnd type="none" w="med" len="med"/>
+                    </a:lnL>
+                    <a:lnR w="12700" cap="flat" cmpd="sng" algn="ctr">
+                      <a:solidFill>
+                        <a:srgbClr val="2A3441"/>
+                      </a:solidFill>
+                      <a:prstDash val="solid"/>
+                      <a:round/>
+                      <a:headEnd type="none" w="med" len="med"/>
+                      <a:tailEnd type="none" w="med" len="med"/>
+                    </a:lnR>
+                    <a:lnT w="12700" cap="flat" cmpd="sng" algn="ctr">
+                      <a:solidFill>
+                        <a:srgbClr val="2A3441"/>
+                      </a:solidFill>
+                      <a:prstDash val="solid"/>
+                      <a:round/>
+                      <a:headEnd type="none" w="med" len="med"/>
+                      <a:tailEnd type="none" w="med" len="med"/>
+                    </a:lnT>
+                    <a:lnB w="12700" cap="flat" cmpd="sng" algn="ctr">
+                      <a:solidFill>
+                        <a:srgbClr val="2A3441"/>
+                      </a:solidFill>
+                      <a:prstDash val="solid"/>
+                      <a:round/>
+                      <a:headEnd type="none" w="med" len="med"/>
+                      <a:tailEnd type="none" w="med" len="med"/>
+                    </a:lnB>
+                    <a:solidFill>
+                      <a:srgbClr val="141B24"/>
+                    </a:solidFill>
+                  </a:tcPr>
+                </a:tc>
+                <a:tc>
+                  <a:txBody>
+                    <a:bodyPr/>
+                    <a:lstStyle/>
+                    <a:p>
+                      <a:pPr indent="0" marL="0">
+                        <a:buNone/>
+                      </a:pPr>
+                      <a:r>
+                        <a:rPr lang="en-US" sz="1300" dirty="0">
+                          <a:solidFill>
+                            <a:srgbClr val="E6EDF3"/>
+                          </a:solidFill>
+                          <a:latin typeface="Calibri" pitchFamily="34" charset="0"/>
+                          <a:ea typeface="Calibri" pitchFamily="34" charset="-122"/>
+                          <a:cs typeface="Calibri" pitchFamily="34" charset="-120"/>
+                        </a:rPr>
+                        <a:t>11.1</a:t>
+                      </a:r>
+                      <a:endParaRPr lang="en-US" sz="1300" dirty="0">
+                        <a:latin typeface="Calibri" charset="0"/>
+                        <a:ea typeface="Calibri" charset="0"/>
+                        <a:cs typeface="Calibri" charset="0"/>
+                      </a:endParaRPr>
+                    </a:p>
+                  </a:txBody>
+                  <a:tcPr marL="91440" marR="91440" marT="45720" marB="45720">
+                    <a:lnL w="12700" cap="flat" cmpd="sng" algn="ctr">
+                      <a:solidFill>
+                        <a:srgbClr val="2A3441"/>
+                      </a:solidFill>
+                      <a:prstDash val="solid"/>
+                      <a:round/>
+                      <a:headEnd type="none" w="med" len="med"/>
+                      <a:tailEnd type="none" w="med" len="med"/>
+                    </a:lnL>
+                    <a:lnR w="12700" cap="flat" cmpd="sng" algn="ctr">
+                      <a:solidFill>
+                        <a:srgbClr val="2A3441"/>
+                      </a:solidFill>
+                      <a:prstDash val="solid"/>
+                      <a:round/>
+                      <a:headEnd type="none" w="med" len="med"/>
+                      <a:tailEnd type="none" w="med" len="med"/>
+                    </a:lnR>
+                    <a:lnT w="12700" cap="flat" cmpd="sng" algn="ctr">
+                      <a:solidFill>
+                        <a:srgbClr val="2A3441"/>
+                      </a:solidFill>
+                      <a:prstDash val="solid"/>
+                      <a:round/>
+                      <a:headEnd type="none" w="med" len="med"/>
+                      <a:tailEnd type="none" w="med" len="med"/>
+                    </a:lnT>
+                    <a:lnB w="12700" cap="flat" cmpd="sng" algn="ctr">
+                      <a:solidFill>
+                        <a:srgbClr val="2A3441"/>
+                      </a:solidFill>
+                      <a:prstDash val="solid"/>
+                      <a:round/>
+                      <a:headEnd type="none" w="med" len="med"/>
+                      <a:tailEnd type="none" w="med" len="med"/>
+                    </a:lnB>
+                    <a:solidFill>
+                      <a:srgbClr val="141B24"/>
+                    </a:solidFill>
+                  </a:tcPr>
+                </a:tc>
+                <a:tc>
+                  <a:txBody>
+                    <a:bodyPr/>
+                    <a:lstStyle/>
+                    <a:p>
+                      <a:pPr indent="0" marL="0">
+                        <a:buNone/>
+                      </a:pPr>
+                      <a:r>
+                        <a:rPr lang="en-US" sz="1300" dirty="0">
+                          <a:solidFill>
+                            <a:srgbClr val="E6EDF3"/>
+                          </a:solidFill>
+                          <a:latin typeface="Calibri" pitchFamily="34" charset="0"/>
+                          <a:ea typeface="Calibri" pitchFamily="34" charset="-122"/>
+                          <a:cs typeface="Calibri" pitchFamily="34" charset="-120"/>
+                        </a:rPr>
+                        <a:t>84.9</a:t>
+                      </a:r>
+                      <a:endParaRPr lang="en-US" sz="1300" dirty="0">
+                        <a:latin typeface="Calibri" charset="0"/>
+                        <a:ea typeface="Calibri" charset="0"/>
+                        <a:cs typeface="Calibri" charset="0"/>
+                      </a:endParaRPr>
+                    </a:p>
+                  </a:txBody>
+                  <a:tcPr marL="91440" marR="91440" marT="45720" marB="45720">
+                    <a:lnL w="12700" cap="flat" cmpd="sng" algn="ctr">
+                      <a:solidFill>
+                        <a:srgbClr val="2A3441"/>
+                      </a:solidFill>
+                      <a:prstDash val="solid"/>
+                      <a:round/>
+                      <a:headEnd type="none" w="med" len="med"/>
+                      <a:tailEnd type="none" w="med" len="med"/>
+                    </a:lnL>
+                    <a:lnR w="12700" cap="flat" cmpd="sng" algn="ctr">
+                      <a:solidFill>
+                        <a:srgbClr val="2A3441"/>
+                      </a:solidFill>
+                      <a:prstDash val="solid"/>
+                      <a:round/>
+                      <a:headEnd type="none" w="med" len="med"/>
+                      <a:tailEnd type="none" w="med" len="med"/>
+                    </a:lnR>
+                    <a:lnT w="12700" cap="flat" cmpd="sng" algn="ctr">
+                      <a:solidFill>
+                        <a:srgbClr val="2A3441"/>
+                      </a:solidFill>
+                      <a:prstDash val="solid"/>
+                      <a:round/>
+                      <a:headEnd type="none" w="med" len="med"/>
+                      <a:tailEnd type="none" w="med" len="med"/>
+                    </a:lnT>
+                    <a:lnB w="12700" cap="flat" cmpd="sng" algn="ctr">
+                      <a:solidFill>
+                        <a:srgbClr val="2A3441"/>
+                      </a:solidFill>
+                      <a:prstDash val="solid"/>
+                      <a:round/>
+                      <a:headEnd type="none" w="med" len="med"/>
+                      <a:tailEnd type="none" w="med" len="med"/>
+                    </a:lnB>
+                    <a:solidFill>
+                      <a:srgbClr val="141B24"/>
+                    </a:solidFill>
+                  </a:tcPr>
+                </a:tc>
+                <a:tc>
+                  <a:txBody>
+                    <a:bodyPr/>
+                    <a:lstStyle/>
+                    <a:p>
+                      <a:pPr indent="0" marL="0">
+                        <a:buNone/>
+                      </a:pPr>
+                      <a:r>
+                        <a:rPr lang="en-US" sz="1300" dirty="0">
+                          <a:solidFill>
+                            <a:srgbClr val="E6EDF3"/>
+                          </a:solidFill>
+                          <a:latin typeface="Calibri" pitchFamily="34" charset="0"/>
+                          <a:ea typeface="Calibri" pitchFamily="34" charset="-122"/>
+                          <a:cs typeface="Calibri" pitchFamily="34" charset="-120"/>
+                        </a:rPr>
+                        <a:t>13.9</a:t>
+                      </a:r>
+                      <a:endParaRPr lang="en-US" sz="1300" dirty="0">
+                        <a:latin typeface="Calibri" charset="0"/>
+                        <a:ea typeface="Calibri" charset="0"/>
+                        <a:cs typeface="Calibri" charset="0"/>
+                      </a:endParaRPr>
+                    </a:p>
+                  </a:txBody>
+                  <a:tcPr marL="91440" marR="91440" marT="45720" marB="45720">
+                    <a:lnL w="12700" cap="flat" cmpd="sng" algn="ctr">
+                      <a:solidFill>
+                        <a:srgbClr val="2A3441"/>
+                      </a:solidFill>
+                      <a:prstDash val="solid"/>
+                      <a:round/>
+                      <a:headEnd type="none" w="med" len="med"/>
+                      <a:tailEnd type="none" w="med" len="med"/>
+                    </a:lnL>
+                    <a:lnR w="12700" cap="flat" cmpd="sng" algn="ctr">
+                      <a:solidFill>
+                        <a:srgbClr val="2A3441"/>
+                      </a:solidFill>
+                      <a:prstDash val="solid"/>
+                      <a:round/>
+                      <a:headEnd type="none" w="med" len="med"/>
+                      <a:tailEnd type="none" w="med" len="med"/>
+                    </a:lnR>
+                    <a:lnT w="12700" cap="flat" cmpd="sng" algn="ctr">
+                      <a:solidFill>
+                        <a:srgbClr val="2A3441"/>
+                      </a:solidFill>
+                      <a:prstDash val="solid"/>
+                      <a:round/>
+                      <a:headEnd type="none" w="med" len="med"/>
+                      <a:tailEnd type="none" w="med" len="med"/>
+                    </a:lnT>
+                    <a:lnB w="12700" cap="flat" cmpd="sng" algn="ctr">
+                      <a:solidFill>
+                        <a:srgbClr val="2A3441"/>
+                      </a:solidFill>
+                      <a:prstDash val="solid"/>
+                      <a:round/>
+                      <a:headEnd type="none" w="med" len="med"/>
+                      <a:tailEnd type="none" w="med" len="med"/>
+                    </a:lnB>
+                    <a:solidFill>
+                      <a:srgbClr val="141B24"/>
+                    </a:solidFill>
+                  </a:tcPr>
+                </a:tc>
+              </a:tr>
+            </a:tbl>
+          </a:graphicData>
+        </a:graphic>
+      </p:graphicFrame>
+      <p:sp>
+        <p:nvSpPr>
+          <p:cNvPr id="5" name="Text 2"/>
           <p:cNvSpPr/>
           <p:nvPr/>
         </p:nvSpPr>
         <p:spPr>
           <a:xfrm>
-            <a:off x="548640" y="1371600"/>
-            <a:ext cx="5394960" cy="4206240"/>
-          </a:xfrm>
-          <a:prstGeom prst="rect">
-            <a:avLst/>
-          </a:prstGeom>
-          <a:solidFill>
-            <a:srgbClr val="141B24"/>
-          </a:solidFill>
-          <a:ln w="12700">
-            <a:solidFill>
-              <a:srgbClr val="39FF88"/>
-            </a:solidFill>
-            <a:prstDash val="solid"/>
-          </a:ln>
-        </p:spPr>
-      </p:sp>
-      <p:sp>
-        <p:nvSpPr>
-          <p:cNvPr id="5" name="Text 3"/>
-          <p:cNvSpPr/>
-          <p:nvPr/>
-        </p:nvSpPr>
-        <p:spPr>
-          <a:xfrm>
-            <a:off x="731520" y="1508760"/>
-            <a:ext cx="5029200" cy="457200"/>
+            <a:off x="6949440" y="1188720"/>
+            <a:ext cx="4846320" cy="4937760"/>
           </a:xfrm>
           <a:prstGeom prst="rect">
             <a:avLst/>
@@ -12613,37 +14079,125 @@
           <a:ln/>
         </p:spPr>
         <p:txBody>
-          <a:bodyPr wrap="square" lIns="0" tIns="0" rIns="0" bIns="0" rtlCol="0" anchor="ctr"/>
-          <a:lstStyle/>
-          <a:p>
-            <a:pPr indent="0" marL="0">
-              <a:buNone/>
-            </a:pPr>
-            <a:r>
-              <a:rPr lang="en-US" sz="2000" b="1" dirty="0">
-                <a:solidFill>
-                  <a:srgbClr val="39FF88"/>
-                </a:solidFill>
-                <a:latin typeface="Courier New" pitchFamily="34" charset="0"/>
-                <a:ea typeface="Courier New" pitchFamily="34" charset="-122"/>
-                <a:cs typeface="Courier New" pitchFamily="34" charset="-120"/>
-              </a:rPr>
-              <a:t>Learned</a:t>
-            </a:r>
-            <a:endParaRPr lang="en-US" sz="2000" dirty="0"/>
-          </a:p>
-        </p:txBody>
-      </p:sp>
-      <p:sp>
-        <p:nvSpPr>
-          <p:cNvPr id="6" name="Text 4"/>
+          <a:bodyPr wrap="square" lIns="0" tIns="0" rIns="0" bIns="0" rtlCol="0" anchor="t"/>
+          <a:lstStyle/>
+          <a:p>
+            <a:pPr marL="342900" indent="-342900">
+              <a:spcAft>
+                <a:spcPts val="800"/>
+              </a:spcAft>
+              <a:buSzPct val="100000"/>
+              <a:buChar char="•"/>
+            </a:pPr>
+            <a:r>
+              <a:rPr lang="en-US" sz="1400" dirty="0">
+                <a:solidFill>
+                  <a:srgbClr val="E6EDF3"/>
+                </a:solidFill>
+                <a:latin typeface="Calibri" pitchFamily="34" charset="0"/>
+                <a:ea typeface="Calibri" pitchFamily="34" charset="-122"/>
+                <a:cs typeface="Calibri" pitchFamily="34" charset="-120"/>
+              </a:rPr>
+              <a:t>Problem found: at 10% loss the neural agent is 7x slower than AIMD</a:t>
+            </a:r>
+            <a:endParaRPr lang="en-US" sz="1400" dirty="0"/>
+          </a:p>
+          <a:p>
+            <a:pPr marL="342900" indent="-342900">
+              <a:spcAft>
+                <a:spcPts val="800"/>
+              </a:spcAft>
+              <a:buSzPct val="100000"/>
+              <a:buChar char="•"/>
+            </a:pPr>
+            <a:r>
+              <a:rPr lang="en-US" sz="1400" dirty="0">
+                <a:solidFill>
+                  <a:srgbClr val="E6EDF3"/>
+                </a:solidFill>
+                <a:latin typeface="Calibri" pitchFamily="34" charset="0"/>
+                <a:ea typeface="Calibri" pitchFamily="34" charset="-122"/>
+                <a:cs typeface="Calibri" pitchFamily="34" charset="-120"/>
+              </a:rPr>
+              <a:t>Fix: while a decision interval loses 10% or more, AIMD drives the window; after 3 clean intervals the agent resumes</a:t>
+            </a:r>
+            <a:endParaRPr lang="en-US" sz="1400" dirty="0"/>
+          </a:p>
+          <a:p>
+            <a:pPr marL="342900" indent="-342900">
+              <a:spcAft>
+                <a:spcPts val="800"/>
+              </a:spcAft>
+              <a:buSzPct val="100000"/>
+              <a:buChar char="•"/>
+            </a:pPr>
+            <a:r>
+              <a:rPr lang="en-US" sz="1400" dirty="0">
+                <a:solidFill>
+                  <a:srgbClr val="E6EDF3"/>
+                </a:solidFill>
+                <a:latin typeface="Calibri" pitchFamily="34" charset="0"/>
+                <a:ea typeface="Calibri" pitchFamily="34" charset="-122"/>
+                <a:cs typeface="Calibri" pitchFamily="34" charset="-120"/>
+              </a:rPr>
+              <a:t>Keeps the wins on the three benign paths, and the hostile path is no longer significantly different from AIMD</a:t>
+            </a:r>
+            <a:endParaRPr lang="en-US" sz="1400" dirty="0"/>
+          </a:p>
+          <a:p>
+            <a:pPr marL="342900" indent="-342900">
+              <a:spcAft>
+                <a:spcPts val="800"/>
+              </a:spcAft>
+              <a:buSzPct val="100000"/>
+              <a:buChar char="•"/>
+            </a:pPr>
+            <a:r>
+              <a:rPr lang="en-US" sz="1400" dirty="0">
+                <a:solidFill>
+                  <a:srgbClr val="E6EDF3"/>
+                </a:solidFill>
+                <a:latin typeface="Calibri" pitchFamily="34" charset="0"/>
+                <a:ea typeface="Calibri" pitchFamily="34" charset="-122"/>
+                <a:cs typeface="Calibri" pitchFamily="34" charset="-120"/>
+              </a:rPr>
+              <a:t>A timeout cut (x0.25) was tried and dropped: it helped the hostile path but hurt the 2% path (24 s vs 9 s)</a:t>
+            </a:r>
+            <a:endParaRPr lang="en-US" sz="1400" dirty="0"/>
+          </a:p>
+          <a:p>
+            <a:pPr marL="342900" indent="-342900">
+              <a:spcAft>
+                <a:spcPts val="800"/>
+              </a:spcAft>
+              <a:buSzPct val="100000"/>
+              <a:buChar char="•"/>
+            </a:pPr>
+            <a:r>
+              <a:rPr lang="en-US" sz="1400" dirty="0">
+                <a:solidFill>
+                  <a:srgbClr val="E6EDF3"/>
+                </a:solidFill>
+                <a:latin typeface="Calibri" pitchFamily="34" charset="0"/>
+                <a:ea typeface="Calibri" pitchFamily="34" charset="-122"/>
+                <a:cs typeface="Calibri" pitchFamily="34" charset="-120"/>
+              </a:rPr>
+              <a:t>Honest summary: the agent helps on clean-to-moderate paths; it needs a classical safety net elsewhere</a:t>
+            </a:r>
+            <a:endParaRPr lang="en-US" sz="1400" dirty="0"/>
+          </a:p>
+        </p:txBody>
+      </p:sp>
+      <p:sp>
+        <p:nvSpPr>
+          <p:cNvPr id="6" name="Text 3"/>
           <p:cNvSpPr/>
           <p:nvPr/>
         </p:nvSpPr>
         <p:spPr>
           <a:xfrm>
-            <a:off x="731520" y="2011680"/>
-            <a:ext cx="5029200" cy="3429000"/>
+            <a:off x="548640" y="3840480"/>
+            <a:ext cx="6035040" cy="731520"/>
           </a:xfrm>
           <a:prstGeom prst="rect">
             <a:avLst/>
@@ -12652,234 +14206,24 @@
           <a:ln/>
         </p:spPr>
         <p:txBody>
-          <a:bodyPr wrap="square" lIns="0" tIns="0" rIns="0" bIns="0" rtlCol="0" anchor="t"/>
+          <a:bodyPr wrap="square" lIns="0" tIns="0" rIns="0" bIns="0" rtlCol="0" anchor="ctr"/>
           <a:lstStyle/>
           <a:p>
             <a:pPr indent="0" marL="0">
               <a:buNone/>
             </a:pPr>
             <a:r>
-              <a:rPr lang="en-US" sz="2000" dirty="0">
-                <a:solidFill>
-                  <a:srgbClr val="E6EDF3"/>
+              <a:rPr lang="en-US" sz="1300" dirty="0">
+                <a:solidFill>
+                  <a:srgbClr val="8B98A5"/>
                 </a:solidFill>
                 <a:latin typeface="Calibri" pitchFamily="34" charset="0"/>
                 <a:ea typeface="Calibri" pitchFamily="34" charset="-122"/>
                 <a:cs typeface="Calibri" pitchFamily="34" charset="-120"/>
               </a:rPr>
-              <a:t>Reliability is a set of simple rules working together.</a:t>
-            </a:r>
-            <a:endParaRPr lang="en-US" sz="2000" dirty="0"/>
-          </a:p>
-          <a:p>
-            <a:pPr indent="0" marL="0">
-              <a:buNone/>
-            </a:pPr>
-            <a:r>
-              <a:rPr lang="en-US" sz="2000" dirty="0">
-                <a:solidFill>
-                  <a:srgbClr val="E6EDF3"/>
-                </a:solidFill>
-                <a:latin typeface="Calibri" pitchFamily="34" charset="0"/>
-                <a:ea typeface="Calibri" pitchFamily="34" charset="-122"/>
-                <a:cs typeface="Calibri" pitchFamily="34" charset="-120"/>
-              </a:rPr>
-              <a:t>Congestion control matters as much as retransmission.</a:t>
-            </a:r>
-            <a:endParaRPr lang="en-US" sz="2000" dirty="0"/>
-          </a:p>
-          <a:p>
-            <a:pPr indent="0" marL="0">
-              <a:buNone/>
-            </a:pPr>
-            <a:r>
-              <a:rPr lang="en-US" sz="2000" dirty="0">
-                <a:solidFill>
-                  <a:srgbClr val="E6EDF3"/>
-                </a:solidFill>
-                <a:latin typeface="Calibri" pitchFamily="34" charset="0"/>
-                <a:ea typeface="Calibri" pitchFamily="34" charset="-122"/>
-                <a:cs typeface="Calibri" pitchFamily="34" charset="-120"/>
-              </a:rPr>
-              <a:t>Testing tools fail in surprising ways.</a:t>
-            </a:r>
-            <a:endParaRPr lang="en-US" sz="2000" dirty="0"/>
-          </a:p>
-        </p:txBody>
-      </p:sp>
-      <p:sp>
-        <p:nvSpPr>
-          <p:cNvPr id="7" name="Shape 5"/>
-          <p:cNvSpPr/>
-          <p:nvPr/>
-        </p:nvSpPr>
-        <p:spPr>
-          <a:xfrm>
-            <a:off x="6217920" y="1371600"/>
-            <a:ext cx="5394960" cy="4206240"/>
-          </a:xfrm>
-          <a:prstGeom prst="rect">
-            <a:avLst/>
-          </a:prstGeom>
-          <a:solidFill>
-            <a:srgbClr val="141B24"/>
-          </a:solidFill>
-          <a:ln w="12700">
-            <a:solidFill>
-              <a:srgbClr val="FFB000"/>
-            </a:solidFill>
-            <a:prstDash val="solid"/>
-          </a:ln>
-        </p:spPr>
-      </p:sp>
-      <p:sp>
-        <p:nvSpPr>
-          <p:cNvPr id="8" name="Text 6"/>
-          <p:cNvSpPr/>
-          <p:nvPr/>
-        </p:nvSpPr>
-        <p:spPr>
-          <a:xfrm>
-            <a:off x="6400800" y="1508760"/>
-            <a:ext cx="5029200" cy="457200"/>
-          </a:xfrm>
-          <a:prstGeom prst="rect">
-            <a:avLst/>
-          </a:prstGeom>
-          <a:noFill/>
-          <a:ln/>
-        </p:spPr>
-        <p:txBody>
-          <a:bodyPr wrap="square" lIns="0" tIns="0" rIns="0" bIns="0" rtlCol="0" anchor="ctr"/>
-          <a:lstStyle/>
-          <a:p>
-            <a:pPr indent="0" marL="0">
-              <a:buNone/>
-            </a:pPr>
-            <a:r>
-              <a:rPr lang="en-US" sz="2000" b="1" dirty="0">
-                <a:solidFill>
-                  <a:srgbClr val="FFB000"/>
-                </a:solidFill>
-                <a:latin typeface="Courier New" pitchFamily="34" charset="0"/>
-                <a:ea typeface="Courier New" pitchFamily="34" charset="-122"/>
-                <a:cs typeface="Courier New" pitchFamily="34" charset="-120"/>
-              </a:rPr>
-              <a:t>Next</a:t>
-            </a:r>
-            <a:endParaRPr lang="en-US" sz="2000" dirty="0"/>
-          </a:p>
-        </p:txBody>
-      </p:sp>
-      <p:sp>
-        <p:nvSpPr>
-          <p:cNvPr id="9" name="Text 7"/>
-          <p:cNvSpPr/>
-          <p:nvPr/>
-        </p:nvSpPr>
-        <p:spPr>
-          <a:xfrm>
-            <a:off x="6400800" y="2011680"/>
-            <a:ext cx="5029200" cy="3429000"/>
-          </a:xfrm>
-          <a:prstGeom prst="rect">
-            <a:avLst/>
-          </a:prstGeom>
-          <a:noFill/>
-          <a:ln/>
-        </p:spPr>
-        <p:txBody>
-          <a:bodyPr wrap="square" lIns="0" tIns="0" rIns="0" bIns="0" rtlCol="0" anchor="t"/>
-          <a:lstStyle/>
-          <a:p>
-            <a:pPr indent="0" marL="0">
-              <a:buNone/>
-            </a:pPr>
-            <a:r>
-              <a:rPr lang="en-US" sz="2000" dirty="0">
-                <a:solidFill>
-                  <a:srgbClr val="E6EDF3"/>
-                </a:solidFill>
-                <a:latin typeface="Calibri" pitchFamily="34" charset="0"/>
-                <a:ea typeface="Calibri" pitchFamily="34" charset="-122"/>
-                <a:cs typeface="Calibri" pitchFamily="34" charset="-120"/>
-              </a:rPr>
-              <a:t>Train the neural agent in C / on real netem</a:t>
-            </a:r>
-            <a:endParaRPr lang="en-US" sz="2000" dirty="0"/>
-          </a:p>
-          <a:p>
-            <a:pPr indent="0" marL="0">
-              <a:buNone/>
-            </a:pPr>
-            <a:r>
-              <a:rPr lang="en-US" sz="2000" dirty="0">
-                <a:solidFill>
-                  <a:srgbClr val="E6EDF3"/>
-                </a:solidFill>
-                <a:latin typeface="Calibri" pitchFamily="34" charset="0"/>
-                <a:ea typeface="Calibri" pitchFamily="34" charset="-122"/>
-                <a:cs typeface="Calibri" pitchFamily="34" charset="-120"/>
-              </a:rPr>
-              <a:t>Selective ACK where throughput limits the path</a:t>
-            </a:r>
-            <a:endParaRPr lang="en-US" sz="2000" dirty="0"/>
-          </a:p>
-          <a:p>
-            <a:pPr indent="0" marL="0">
-              <a:buNone/>
-            </a:pPr>
-            <a:r>
-              <a:rPr lang="en-US" sz="2000" dirty="0">
-                <a:solidFill>
-                  <a:srgbClr val="E6EDF3"/>
-                </a:solidFill>
-                <a:latin typeface="Calibri" pitchFamily="34" charset="0"/>
-                <a:ea typeface="Calibri" pitchFamily="34" charset="-122"/>
-                <a:cs typeface="Calibri" pitchFamily="34" charset="-120"/>
-              </a:rPr>
-              <a:t>Kernel netem and real multi-machine tests</a:t>
-            </a:r>
-            <a:endParaRPr lang="en-US" sz="2000" dirty="0"/>
-          </a:p>
-        </p:txBody>
-      </p:sp>
-      <p:sp>
-        <p:nvSpPr>
-          <p:cNvPr id="10" name="Text 8"/>
-          <p:cNvSpPr/>
-          <p:nvPr/>
-        </p:nvSpPr>
-        <p:spPr>
-          <a:xfrm>
-            <a:off x="548640" y="5852160"/>
-            <a:ext cx="10972800" cy="365760"/>
-          </a:xfrm>
-          <a:prstGeom prst="rect">
-            <a:avLst/>
-          </a:prstGeom>
-          <a:noFill/>
-          <a:ln/>
-        </p:spPr>
-        <p:txBody>
-          <a:bodyPr wrap="square" lIns="0" tIns="0" rIns="0" bIns="0" rtlCol="0" anchor="ctr"/>
-          <a:lstStyle/>
-          <a:p>
-            <a:pPr indent="0" marL="0">
-              <a:buNone/>
-            </a:pPr>
-            <a:r>
-              <a:rPr lang="en-US" sz="1400" dirty="0">
-                <a:solidFill>
-                  <a:srgbClr val="8B98A5"/>
-                </a:solidFill>
-                <a:latin typeface="Calibri" pitchFamily="34" charset="0"/>
-                <a:ea typeface="Calibri" pitchFamily="34" charset="-122"/>
-                <a:cs typeface="Calibri" pitchFamily="34" charset="-120"/>
-              </a:rPr>
-              <a:t>Limits: Go-Back-N wastes bandwidth and suffers under reordering; C tests use an emulated path; the tabular agent did not beat AIMD in C.</a:t>
-            </a:r>
-            <a:endParaRPr lang="en-US" sz="1400" dirty="0"/>
+              <a:t>10 runs per cell (hostile: 5 runs, 300 packets), 95% intervals. Flag: --hybrid 0.10. Code: eval_ci6.sh.</a:t>
+            </a:r>
+            <a:endParaRPr lang="en-US" sz="1300" dirty="0"/>
           </a:p>
         </p:txBody>
       </p:sp>
@@ -12923,8 +14267,8 @@
         </p:nvSpPr>
         <p:spPr>
           <a:xfrm>
-            <a:off x="731520" y="2103120"/>
-            <a:ext cx="10058400" cy="1097280"/>
+            <a:off x="548640" y="320040"/>
+            <a:ext cx="11064240" cy="731520"/>
           </a:xfrm>
           <a:prstGeom prst="rect">
             <a:avLst/>
@@ -12940,7 +14284,7 @@
               <a:buNone/>
             </a:pPr>
             <a:r>
-              <a:rPr lang="en-US" sz="6400" b="1" dirty="0">
+              <a:rPr lang="en-US" sz="3000" b="1" dirty="0">
                 <a:solidFill>
                   <a:srgbClr val="39FF88"/>
                 </a:solidFill>
@@ -12948,9 +14292,9 @@
                 <a:ea typeface="Courier New" pitchFamily="34" charset="-122"/>
                 <a:cs typeface="Courier New" pitchFamily="34" charset="-120"/>
               </a:rPr>
-              <a:t>Thank you</a:t>
-            </a:r>
-            <a:endParaRPr lang="en-US" sz="6400" dirty="0"/>
+              <a:t>Learnings and future work</a:t>
+            </a:r>
+            <a:endParaRPr lang="en-US" sz="3000" dirty="0"/>
           </a:p>
         </p:txBody>
       </p:sp>
@@ -12962,8 +14306,8 @@
         </p:nvSpPr>
         <p:spPr>
           <a:xfrm>
-            <a:off x="731520" y="3474720"/>
-            <a:ext cx="10058400" cy="548640"/>
+            <a:off x="9418320" y="6446520"/>
+            <a:ext cx="2377440" cy="274320"/>
           </a:xfrm>
           <a:prstGeom prst="rect">
             <a:avLst/>
@@ -12975,34 +14319,59 @@
           <a:bodyPr wrap="square" lIns="0" tIns="0" rIns="0" bIns="0" rtlCol="0" anchor="ctr"/>
           <a:lstStyle/>
           <a:p>
-            <a:pPr indent="0" marL="0">
+            <a:pPr algn="r" indent="0" marL="0">
               <a:buNone/>
             </a:pPr>
             <a:r>
-              <a:rPr lang="en-US" sz="2600" dirty="0">
-                <a:solidFill>
-                  <a:srgbClr val="E6EDF3"/>
+              <a:rPr lang="en-US" sz="1000" dirty="0">
+                <a:solidFill>
+                  <a:srgbClr val="8B98A5"/>
                 </a:solidFill>
                 <a:latin typeface="Courier New" pitchFamily="34" charset="0"/>
                 <a:ea typeface="Courier New" pitchFamily="34" charset="-122"/>
                 <a:cs typeface="Courier New" pitchFamily="34" charset="-120"/>
               </a:rPr>
-              <a:t>github.com/Capsturrrr/rudp</a:t>
-            </a:r>
-            <a:endParaRPr lang="en-US" sz="2600" dirty="0"/>
-          </a:p>
-        </p:txBody>
-      </p:sp>
-      <p:sp>
-        <p:nvSpPr>
-          <p:cNvPr id="4" name="Text 2"/>
+              <a:t>25 / 26   Smart-RUDP</a:t>
+            </a:r>
+            <a:endParaRPr lang="en-US" sz="1000" dirty="0"/>
+          </a:p>
+        </p:txBody>
+      </p:sp>
+      <p:sp>
+        <p:nvSpPr>
+          <p:cNvPr id="4" name="Shape 2"/>
           <p:cNvSpPr/>
           <p:nvPr/>
         </p:nvSpPr>
         <p:spPr>
           <a:xfrm>
-            <a:off x="731520" y="4206240"/>
-            <a:ext cx="10058400" cy="457200"/>
+            <a:off x="548640" y="1371600"/>
+            <a:ext cx="5394960" cy="4206240"/>
+          </a:xfrm>
+          <a:prstGeom prst="rect">
+            <a:avLst/>
+          </a:prstGeom>
+          <a:solidFill>
+            <a:srgbClr val="141B24"/>
+          </a:solidFill>
+          <a:ln w="12700">
+            <a:solidFill>
+              <a:srgbClr val="39FF88"/>
+            </a:solidFill>
+            <a:prstDash val="solid"/>
+          </a:ln>
+        </p:spPr>
+      </p:sp>
+      <p:sp>
+        <p:nvSpPr>
+          <p:cNvPr id="5" name="Text 3"/>
+          <p:cNvSpPr/>
+          <p:nvPr/>
+        </p:nvSpPr>
+        <p:spPr>
+          <a:xfrm>
+            <a:off x="731520" y="1508760"/>
+            <a:ext cx="5029200" cy="457200"/>
           </a:xfrm>
           <a:prstGeom prst="rect">
             <a:avLst/>
@@ -13018,17 +14387,266 @@
               <a:buNone/>
             </a:pPr>
             <a:r>
-              <a:rPr lang="en-US" sz="1800" dirty="0">
-                <a:solidFill>
-                  <a:srgbClr val="8B98A5"/>
+              <a:rPr lang="en-US" sz="2000" b="1" dirty="0">
+                <a:solidFill>
+                  <a:srgbClr val="39FF88"/>
+                </a:solidFill>
+                <a:latin typeface="Courier New" pitchFamily="34" charset="0"/>
+                <a:ea typeface="Courier New" pitchFamily="34" charset="-122"/>
+                <a:cs typeface="Courier New" pitchFamily="34" charset="-120"/>
+              </a:rPr>
+              <a:t>Learned</a:t>
+            </a:r>
+            <a:endParaRPr lang="en-US" sz="2000" dirty="0"/>
+          </a:p>
+        </p:txBody>
+      </p:sp>
+      <p:sp>
+        <p:nvSpPr>
+          <p:cNvPr id="6" name="Text 4"/>
+          <p:cNvSpPr/>
+          <p:nvPr/>
+        </p:nvSpPr>
+        <p:spPr>
+          <a:xfrm>
+            <a:off x="731520" y="2011680"/>
+            <a:ext cx="5029200" cy="3429000"/>
+          </a:xfrm>
+          <a:prstGeom prst="rect">
+            <a:avLst/>
+          </a:prstGeom>
+          <a:noFill/>
+          <a:ln/>
+        </p:spPr>
+        <p:txBody>
+          <a:bodyPr wrap="square" lIns="0" tIns="0" rIns="0" bIns="0" rtlCol="0" anchor="t"/>
+          <a:lstStyle/>
+          <a:p>
+            <a:pPr indent="0" marL="0">
+              <a:buNone/>
+            </a:pPr>
+            <a:r>
+              <a:rPr lang="en-US" sz="2000" dirty="0">
+                <a:solidFill>
+                  <a:srgbClr val="E6EDF3"/>
                 </a:solidFill>
                 <a:latin typeface="Calibri" pitchFamily="34" charset="0"/>
                 <a:ea typeface="Calibri" pitchFamily="34" charset="-122"/>
                 <a:cs typeface="Calibri" pitchFamily="34" charset="-120"/>
               </a:rPr>
-              <a:t>Harshavardhan Mallela   Rohit Arya   Shloak Sinha</a:t>
-            </a:r>
-            <a:endParaRPr lang="en-US" sz="1800" dirty="0"/>
+              <a:t>Reliability is a set of simple rules working together.</a:t>
+            </a:r>
+            <a:endParaRPr lang="en-US" sz="2000" dirty="0"/>
+          </a:p>
+          <a:p>
+            <a:pPr indent="0" marL="0">
+              <a:buNone/>
+            </a:pPr>
+            <a:r>
+              <a:rPr lang="en-US" sz="2000" dirty="0">
+                <a:solidFill>
+                  <a:srgbClr val="E6EDF3"/>
+                </a:solidFill>
+                <a:latin typeface="Calibri" pitchFamily="34" charset="0"/>
+                <a:ea typeface="Calibri" pitchFamily="34" charset="-122"/>
+                <a:cs typeface="Calibri" pitchFamily="34" charset="-120"/>
+              </a:rPr>
+              <a:t>Congestion control matters as much as retransmission.</a:t>
+            </a:r>
+            <a:endParaRPr lang="en-US" sz="2000" dirty="0"/>
+          </a:p>
+          <a:p>
+            <a:pPr indent="0" marL="0">
+              <a:buNone/>
+            </a:pPr>
+            <a:r>
+              <a:rPr lang="en-US" sz="2000" dirty="0">
+                <a:solidFill>
+                  <a:srgbClr val="E6EDF3"/>
+                </a:solidFill>
+                <a:latin typeface="Calibri" pitchFamily="34" charset="0"/>
+                <a:ea typeface="Calibri" pitchFamily="34" charset="-122"/>
+                <a:cs typeface="Calibri" pitchFamily="34" charset="-120"/>
+              </a:rPr>
+              <a:t>Testing tools fail in surprising ways.</a:t>
+            </a:r>
+            <a:endParaRPr lang="en-US" sz="2000" dirty="0"/>
+          </a:p>
+        </p:txBody>
+      </p:sp>
+      <p:sp>
+        <p:nvSpPr>
+          <p:cNvPr id="7" name="Shape 5"/>
+          <p:cNvSpPr/>
+          <p:nvPr/>
+        </p:nvSpPr>
+        <p:spPr>
+          <a:xfrm>
+            <a:off x="6217920" y="1371600"/>
+            <a:ext cx="5394960" cy="4206240"/>
+          </a:xfrm>
+          <a:prstGeom prst="rect">
+            <a:avLst/>
+          </a:prstGeom>
+          <a:solidFill>
+            <a:srgbClr val="141B24"/>
+          </a:solidFill>
+          <a:ln w="12700">
+            <a:solidFill>
+              <a:srgbClr val="FFB000"/>
+            </a:solidFill>
+            <a:prstDash val="solid"/>
+          </a:ln>
+        </p:spPr>
+      </p:sp>
+      <p:sp>
+        <p:nvSpPr>
+          <p:cNvPr id="8" name="Text 6"/>
+          <p:cNvSpPr/>
+          <p:nvPr/>
+        </p:nvSpPr>
+        <p:spPr>
+          <a:xfrm>
+            <a:off x="6400800" y="1508760"/>
+            <a:ext cx="5029200" cy="457200"/>
+          </a:xfrm>
+          <a:prstGeom prst="rect">
+            <a:avLst/>
+          </a:prstGeom>
+          <a:noFill/>
+          <a:ln/>
+        </p:spPr>
+        <p:txBody>
+          <a:bodyPr wrap="square" lIns="0" tIns="0" rIns="0" bIns="0" rtlCol="0" anchor="ctr"/>
+          <a:lstStyle/>
+          <a:p>
+            <a:pPr indent="0" marL="0">
+              <a:buNone/>
+            </a:pPr>
+            <a:r>
+              <a:rPr lang="en-US" sz="2000" b="1" dirty="0">
+                <a:solidFill>
+                  <a:srgbClr val="FFB000"/>
+                </a:solidFill>
+                <a:latin typeface="Courier New" pitchFamily="34" charset="0"/>
+                <a:ea typeface="Courier New" pitchFamily="34" charset="-122"/>
+                <a:cs typeface="Courier New" pitchFamily="34" charset="-120"/>
+              </a:rPr>
+              <a:t>Next</a:t>
+            </a:r>
+            <a:endParaRPr lang="en-US" sz="2000" dirty="0"/>
+          </a:p>
+        </p:txBody>
+      </p:sp>
+      <p:sp>
+        <p:nvSpPr>
+          <p:cNvPr id="9" name="Text 7"/>
+          <p:cNvSpPr/>
+          <p:nvPr/>
+        </p:nvSpPr>
+        <p:spPr>
+          <a:xfrm>
+            <a:off x="6400800" y="2011680"/>
+            <a:ext cx="5029200" cy="3429000"/>
+          </a:xfrm>
+          <a:prstGeom prst="rect">
+            <a:avLst/>
+          </a:prstGeom>
+          <a:noFill/>
+          <a:ln/>
+        </p:spPr>
+        <p:txBody>
+          <a:bodyPr wrap="square" lIns="0" tIns="0" rIns="0" bIns="0" rtlCol="0" anchor="t"/>
+          <a:lstStyle/>
+          <a:p>
+            <a:pPr indent="0" marL="0">
+              <a:buNone/>
+            </a:pPr>
+            <a:r>
+              <a:rPr lang="en-US" sz="2000" dirty="0">
+                <a:solidFill>
+                  <a:srgbClr val="E6EDF3"/>
+                </a:solidFill>
+                <a:latin typeface="Calibri" pitchFamily="34" charset="0"/>
+                <a:ea typeface="Calibri" pitchFamily="34" charset="-122"/>
+                <a:cs typeface="Calibri" pitchFamily="34" charset="-120"/>
+              </a:rPr>
+              <a:t>Train the neural agent in C / on real netem</a:t>
+            </a:r>
+            <a:endParaRPr lang="en-US" sz="2000" dirty="0"/>
+          </a:p>
+          <a:p>
+            <a:pPr indent="0" marL="0">
+              <a:buNone/>
+            </a:pPr>
+            <a:r>
+              <a:rPr lang="en-US" sz="2000" dirty="0">
+                <a:solidFill>
+                  <a:srgbClr val="E6EDF3"/>
+                </a:solidFill>
+                <a:latin typeface="Calibri" pitchFamily="34" charset="0"/>
+                <a:ea typeface="Calibri" pitchFamily="34" charset="-122"/>
+                <a:cs typeface="Calibri" pitchFamily="34" charset="-120"/>
+              </a:rPr>
+              <a:t>Selective ACK where throughput limits the path</a:t>
+            </a:r>
+            <a:endParaRPr lang="en-US" sz="2000" dirty="0"/>
+          </a:p>
+          <a:p>
+            <a:pPr indent="0" marL="0">
+              <a:buNone/>
+            </a:pPr>
+            <a:r>
+              <a:rPr lang="en-US" sz="2000" dirty="0">
+                <a:solidFill>
+                  <a:srgbClr val="E6EDF3"/>
+                </a:solidFill>
+                <a:latin typeface="Calibri" pitchFamily="34" charset="0"/>
+                <a:ea typeface="Calibri" pitchFamily="34" charset="-122"/>
+                <a:cs typeface="Calibri" pitchFamily="34" charset="-120"/>
+              </a:rPr>
+              <a:t>Kernel netem and real multi-machine tests</a:t>
+            </a:r>
+            <a:endParaRPr lang="en-US" sz="2000" dirty="0"/>
+          </a:p>
+        </p:txBody>
+      </p:sp>
+      <p:sp>
+        <p:nvSpPr>
+          <p:cNvPr id="10" name="Text 8"/>
+          <p:cNvSpPr/>
+          <p:nvPr/>
+        </p:nvSpPr>
+        <p:spPr>
+          <a:xfrm>
+            <a:off x="548640" y="5852160"/>
+            <a:ext cx="10972800" cy="365760"/>
+          </a:xfrm>
+          <a:prstGeom prst="rect">
+            <a:avLst/>
+          </a:prstGeom>
+          <a:noFill/>
+          <a:ln/>
+        </p:spPr>
+        <p:txBody>
+          <a:bodyPr wrap="square" lIns="0" tIns="0" rIns="0" bIns="0" rtlCol="0" anchor="ctr"/>
+          <a:lstStyle/>
+          <a:p>
+            <a:pPr indent="0" marL="0">
+              <a:buNone/>
+            </a:pPr>
+            <a:r>
+              <a:rPr lang="en-US" sz="1400" dirty="0">
+                <a:solidFill>
+                  <a:srgbClr val="8B98A5"/>
+                </a:solidFill>
+                <a:latin typeface="Calibri" pitchFamily="34" charset="0"/>
+                <a:ea typeface="Calibri" pitchFamily="34" charset="-122"/>
+                <a:cs typeface="Calibri" pitchFamily="34" charset="-120"/>
+              </a:rPr>
+              <a:t>Limits: Go-Back-N wastes bandwidth and suffers under reordering; C tests use an emulated path; the tabular agent did not beat AIMD in C.</a:t>
+            </a:r>
+            <a:endParaRPr lang="en-US" sz="1400" dirty="0"/>
           </a:p>
         </p:txBody>
       </p:sp>
@@ -13072,6 +14690,155 @@
         </p:nvSpPr>
         <p:spPr>
           <a:xfrm>
+            <a:off x="731520" y="2103120"/>
+            <a:ext cx="10058400" cy="1097280"/>
+          </a:xfrm>
+          <a:prstGeom prst="rect">
+            <a:avLst/>
+          </a:prstGeom>
+          <a:noFill/>
+          <a:ln/>
+        </p:spPr>
+        <p:txBody>
+          <a:bodyPr wrap="square" lIns="0" tIns="0" rIns="0" bIns="0" rtlCol="0" anchor="ctr"/>
+          <a:lstStyle/>
+          <a:p>
+            <a:pPr indent="0" marL="0">
+              <a:buNone/>
+            </a:pPr>
+            <a:r>
+              <a:rPr lang="en-US" sz="6400" b="1" dirty="0">
+                <a:solidFill>
+                  <a:srgbClr val="39FF88"/>
+                </a:solidFill>
+                <a:latin typeface="Courier New" pitchFamily="34" charset="0"/>
+                <a:ea typeface="Courier New" pitchFamily="34" charset="-122"/>
+                <a:cs typeface="Courier New" pitchFamily="34" charset="-120"/>
+              </a:rPr>
+              <a:t>Thank you</a:t>
+            </a:r>
+            <a:endParaRPr lang="en-US" sz="6400" dirty="0"/>
+          </a:p>
+        </p:txBody>
+      </p:sp>
+      <p:sp>
+        <p:nvSpPr>
+          <p:cNvPr id="3" name="Text 1"/>
+          <p:cNvSpPr/>
+          <p:nvPr/>
+        </p:nvSpPr>
+        <p:spPr>
+          <a:xfrm>
+            <a:off x="731520" y="3474720"/>
+            <a:ext cx="10058400" cy="548640"/>
+          </a:xfrm>
+          <a:prstGeom prst="rect">
+            <a:avLst/>
+          </a:prstGeom>
+          <a:noFill/>
+          <a:ln/>
+        </p:spPr>
+        <p:txBody>
+          <a:bodyPr wrap="square" lIns="0" tIns="0" rIns="0" bIns="0" rtlCol="0" anchor="ctr"/>
+          <a:lstStyle/>
+          <a:p>
+            <a:pPr indent="0" marL="0">
+              <a:buNone/>
+            </a:pPr>
+            <a:r>
+              <a:rPr lang="en-US" sz="2600" dirty="0">
+                <a:solidFill>
+                  <a:srgbClr val="E6EDF3"/>
+                </a:solidFill>
+                <a:latin typeface="Courier New" pitchFamily="34" charset="0"/>
+                <a:ea typeface="Courier New" pitchFamily="34" charset="-122"/>
+                <a:cs typeface="Courier New" pitchFamily="34" charset="-120"/>
+              </a:rPr>
+              <a:t>github.com/Capsturrrr/rudp</a:t>
+            </a:r>
+            <a:endParaRPr lang="en-US" sz="2600" dirty="0"/>
+          </a:p>
+        </p:txBody>
+      </p:sp>
+      <p:sp>
+        <p:nvSpPr>
+          <p:cNvPr id="4" name="Text 2"/>
+          <p:cNvSpPr/>
+          <p:nvPr/>
+        </p:nvSpPr>
+        <p:spPr>
+          <a:xfrm>
+            <a:off x="731520" y="4206240"/>
+            <a:ext cx="10058400" cy="457200"/>
+          </a:xfrm>
+          <a:prstGeom prst="rect">
+            <a:avLst/>
+          </a:prstGeom>
+          <a:noFill/>
+          <a:ln/>
+        </p:spPr>
+        <p:txBody>
+          <a:bodyPr wrap="square" lIns="0" tIns="0" rIns="0" bIns="0" rtlCol="0" anchor="ctr"/>
+          <a:lstStyle/>
+          <a:p>
+            <a:pPr indent="0" marL="0">
+              <a:buNone/>
+            </a:pPr>
+            <a:r>
+              <a:rPr lang="en-US" sz="1800" dirty="0">
+                <a:solidFill>
+                  <a:srgbClr val="8B98A5"/>
+                </a:solidFill>
+                <a:latin typeface="Calibri" pitchFamily="34" charset="0"/>
+                <a:ea typeface="Calibri" pitchFamily="34" charset="-122"/>
+                <a:cs typeface="Calibri" pitchFamily="34" charset="-120"/>
+              </a:rPr>
+              <a:t>Harshavardhan Mallela   Rohit Arya   Shloak Sinha</a:t>
+            </a:r>
+            <a:endParaRPr lang="en-US" sz="1800" dirty="0"/>
+          </a:p>
+        </p:txBody>
+      </p:sp>
+    </p:spTree>
+  </p:cSld>
+  <p:clrMapOvr>
+    <a:masterClrMapping/>
+  </p:clrMapOvr>
+</p:sld>
+</file>
+
+<file path=ppt/slides/slide27.xml><?xml version="1.0" encoding="utf-8"?>
+<p:sld xmlns:a="http://schemas.openxmlformats.org/drawingml/2006/main" xmlns:r="http://schemas.openxmlformats.org/officeDocument/2006/relationships" xmlns:p="http://schemas.openxmlformats.org/presentationml/2006/main">
+  <p:cSld name="Slide 27">
+    <p:bg>
+      <p:bgPr>
+        <a:solidFill>
+          <a:srgbClr val="0B0F14"/>
+        </a:solidFill>
+      </p:bgPr>
+    </p:bg>
+    <p:spTree>
+      <p:nvGrpSpPr>
+        <p:cNvPr id="1" name=""/>
+        <p:cNvGrpSpPr/>
+        <p:nvPr/>
+      </p:nvGrpSpPr>
+      <p:grpSpPr>
+        <a:xfrm>
+          <a:off x="0" y="0"/>
+          <a:ext cx="0" cy="0"/>
+          <a:chOff x="0" y="0"/>
+          <a:chExt cx="0" cy="0"/>
+        </a:xfrm>
+      </p:grpSpPr>
+      <p:sp>
+        <p:nvSpPr>
+          <p:cNvPr id="2" name="Text 0"/>
+          <p:cNvSpPr/>
+          <p:nvPr/>
+        </p:nvSpPr>
+        <p:spPr>
+          <a:xfrm>
             <a:off x="548640" y="320040"/>
             <a:ext cx="11064240" cy="731520"/>
           </a:xfrm>
@@ -13376,7 +15143,7 @@
                 <a:ea typeface="Courier New" pitchFamily="34" charset="-122"/>
                 <a:cs typeface="Courier New" pitchFamily="34" charset="-120"/>
               </a:rPr>
-              <a:t>3 / 25   Smart-RUDP</a:t>
+              <a:t>3 / 26   Smart-RUDP</a:t>
             </a:r>
             <a:endParaRPr lang="en-US" sz="1000" dirty="0"/>
           </a:p>
@@ -13770,7 +15537,7 @@
                 <a:ea typeface="Courier New" pitchFamily="34" charset="-122"/>
                 <a:cs typeface="Courier New" pitchFamily="34" charset="-120"/>
               </a:rPr>
-              <a:t>4 / 25   Smart-RUDP</a:t>
+              <a:t>4 / 26   Smart-RUDP</a:t>
             </a:r>
             <a:endParaRPr lang="en-US" sz="1000" dirty="0"/>
           </a:p>
@@ -14331,7 +16098,7 @@
                 <a:ea typeface="Courier New" pitchFamily="34" charset="-122"/>
                 <a:cs typeface="Courier New" pitchFamily="34" charset="-120"/>
               </a:rPr>
-              <a:t>5 / 25   Smart-RUDP</a:t>
+              <a:t>5 / 26   Smart-RUDP</a:t>
             </a:r>
             <a:endParaRPr lang="en-US" sz="1000" dirty="0"/>
           </a:p>
@@ -15770,7 +17537,7 @@
                 <a:ea typeface="Courier New" pitchFamily="34" charset="-122"/>
                 <a:cs typeface="Courier New" pitchFamily="34" charset="-120"/>
               </a:rPr>
-              <a:t>6 / 25   Smart-RUDP</a:t>
+              <a:t>6 / 26   Smart-RUDP</a:t>
             </a:r>
             <a:endParaRPr lang="en-US" sz="1000" dirty="0"/>
           </a:p>
@@ -17005,7 +18772,7 @@
                 <a:ea typeface="Courier New" pitchFamily="34" charset="-122"/>
                 <a:cs typeface="Courier New" pitchFamily="34" charset="-120"/>
               </a:rPr>
-              <a:t>7 / 25   Smart-RUDP</a:t>
+              <a:t>7 / 26   Smart-RUDP</a:t>
             </a:r>
             <a:endParaRPr lang="en-US" sz="1000" dirty="0"/>
           </a:p>
@@ -17448,7 +19215,7 @@
                 <a:ea typeface="Courier New" pitchFamily="34" charset="-122"/>
                 <a:cs typeface="Courier New" pitchFamily="34" charset="-120"/>
               </a:rPr>
-              <a:t>8 / 25   Smart-RUDP</a:t>
+              <a:t>8 / 26   Smart-RUDP</a:t>
             </a:r>
             <a:endParaRPr lang="en-US" sz="1000" dirty="0"/>
           </a:p>
@@ -17748,7 +19515,7 @@
                 <a:ea typeface="Courier New" pitchFamily="34" charset="-122"/>
                 <a:cs typeface="Courier New" pitchFamily="34" charset="-120"/>
               </a:rPr>
-              <a:t>9 / 25   Smart-RUDP</a:t>
+              <a:t>9 / 26   Smart-RUDP</a:t>
             </a:r>
             <a:endParaRPr lang="en-US" sz="1000" dirty="0"/>
           </a:p>

</xml_diff>

<commit_message>
Selective Repeat replaces Go-Back-N as the default (C client/server, smart_client, chat, gateway); --gbn / RUDP_GBN for comparison; eval_ci7; docs
Co-Authored-By: Claude Sonnet 5.5 <noreply@anthropic.com>
Claude-Session: https://claude.ai/code/session_01NX2zRNpdVAnzFNKmqomzKu
</commit_message>
<xml_diff>
--- a/docs/RUDP_Presentation.pptx
+++ b/docs/RUDP_Presentation.pptx
@@ -32,9 +32,10 @@
     <p:sldId id="280" r:id="rId26"/>
     <p:sldId id="281" r:id="rId27"/>
     <p:sldId id="282" r:id="rId28"/>
+    <p:sldId id="283" r:id="rId29"/>
   </p:sldIdLst>
   <p:notesMasterIdLst>
-    <p:notesMasterId r:id="rId29"/>
+    <p:notesMasterId r:id="rId30"/>
   </p:notesMasterIdLst>
   <p:sldSz cx="12192000" cy="6858000"/>
   <p:notesSz cx="6858000" cy="12192000"/>
@@ -2224,6 +2225,94 @@
             <a:fld id="{F7021451-1387-4CA6-816F-3879F97B5CBC}" type="slidenum">
               <a:rPr lang="en-US"/>
               <a:t>27</a:t>
+            </a:fld>
+            <a:endParaRPr lang="en-US"/>
+          </a:p>
+        </p:txBody>
+      </p:sp>
+    </p:spTree>
+    <p:extLst>
+      <p:ext uri="{BB962C8B-B14F-4D97-AF65-F5344CB8AC3E}">
+        <p14:creationId xmlns:p14="http://schemas.microsoft.com/office/powerpoint/2010/main" val="1024086991"/>
+      </p:ext>
+    </p:extLst>
+  </p:cSld>
+  <p:clrMapOvr>
+    <a:masterClrMapping/>
+  </p:clrMapOvr>
+</p:notes>
+</file>
+
+<file path=ppt/notesSlides/notesSlide28.xml><?xml version="1.0" encoding="utf-8"?>
+<p:notes xmlns:a="http://schemas.openxmlformats.org/drawingml/2006/main" xmlns:r="http://schemas.openxmlformats.org/officeDocument/2006/relationships" xmlns:p="http://schemas.openxmlformats.org/presentationml/2006/main">
+  <p:cSld>
+    <p:spTree>
+      <p:nvGrpSpPr>
+        <p:cNvPr id="1" name=""/>
+        <p:cNvGrpSpPr/>
+        <p:nvPr/>
+      </p:nvGrpSpPr>
+      <p:grpSpPr>
+        <a:xfrm>
+          <a:off x="0" y="0"/>
+          <a:ext cx="0" cy="0"/>
+          <a:chOff x="0" y="0"/>
+          <a:chExt cx="0" cy="0"/>
+        </a:xfrm>
+      </p:grpSpPr>
+      <p:sp>
+        <p:nvSpPr>
+          <p:cNvPr id="2" name="Slide Image Placeholder 1"/>
+          <p:cNvSpPr>
+            <a:spLocks noGrp="1" noRot="1" noChangeAspect="1"/>
+          </p:cNvSpPr>
+          <p:nvPr>
+            <p:ph type="sldImg"/>
+          </p:nvPr>
+        </p:nvSpPr>
+        <p:spPr/>
+      </p:sp>
+      <p:sp>
+        <p:nvSpPr>
+          <p:cNvPr id="3" name="Notes Placeholder 2"/>
+          <p:cNvSpPr>
+            <a:spLocks noGrp="1"/>
+          </p:cNvSpPr>
+          <p:nvPr>
+            <p:ph type="body" idx="1"/>
+          </p:nvPr>
+        </p:nvSpPr>
+        <p:spPr/>
+        <p:txBody>
+          <a:bodyPr/>
+          <a:lstStyle/>
+          <a:p>
+            <a:r>
+              <a:rPr lang="en-US" dirty="0"/>
+              <a:t/>
+            </a:r>
+            <a:endParaRPr lang="en-US" dirty="0"/>
+          </a:p>
+        </p:txBody>
+      </p:sp>
+      <p:sp>
+        <p:nvSpPr>
+          <p:cNvPr id="4" name="Slide Number Placeholder 3"/>
+          <p:cNvSpPr>
+            <a:spLocks noGrp="1"/>
+          </p:cNvSpPr>
+          <p:nvPr>
+            <p:ph type="sldNum" sz="quarter" idx="10"/>
+          </p:nvPr>
+        </p:nvSpPr>
+        <p:spPr/>
+        <p:txBody>
+          <a:bodyPr/>
+          <a:lstStyle/>
+          <a:p>
+            <a:fld id="{F7021451-1387-4CA6-816F-3879F97B5CBC}" type="slidenum">
+              <a:rPr lang="en-US"/>
+              <a:t>28</a:t>
             </a:fld>
             <a:endParaRPr lang="en-US"/>
           </a:p>
@@ -3449,7 +3538,7 @@
                 <a:ea typeface="Courier New" pitchFamily="34" charset="-122"/>
                 <a:cs typeface="Courier New" pitchFamily="34" charset="-120"/>
               </a:rPr>
-              <a:t>10 / 26   Smart-RUDP</a:t>
+              <a:t>10 / 27   Smart-RUDP</a:t>
             </a:r>
             <a:endParaRPr lang="en-US" sz="1000" dirty="0"/>
           </a:p>
@@ -3646,7 +3735,7 @@
                 <a:ea typeface="Courier New" pitchFamily="34" charset="-122"/>
                 <a:cs typeface="Courier New" pitchFamily="34" charset="-120"/>
               </a:rPr>
-              <a:t>11 / 26   Smart-RUDP</a:t>
+              <a:t>11 / 27   Smart-RUDP</a:t>
             </a:r>
             <a:endParaRPr lang="en-US" sz="1000" dirty="0"/>
           </a:p>
@@ -4476,7 +4565,7 @@
                 <a:ea typeface="Courier New" pitchFamily="34" charset="-122"/>
                 <a:cs typeface="Courier New" pitchFamily="34" charset="-120"/>
               </a:rPr>
-              <a:t>12 / 26   Smart-RUDP</a:t>
+              <a:t>12 / 27   Smart-RUDP</a:t>
             </a:r>
             <a:endParaRPr lang="en-US" sz="1000" dirty="0"/>
           </a:p>
@@ -4773,7 +4862,7 @@
                 <a:ea typeface="Courier New" pitchFamily="34" charset="-122"/>
                 <a:cs typeface="Courier New" pitchFamily="34" charset="-120"/>
               </a:rPr>
-              <a:t>13 / 26   Smart-RUDP</a:t>
+              <a:t>13 / 27   Smart-RUDP</a:t>
             </a:r>
             <a:endParaRPr lang="en-US" sz="1000" dirty="0"/>
           </a:p>
@@ -5073,7 +5162,7 @@
                 <a:ea typeface="Courier New" pitchFamily="34" charset="-122"/>
                 <a:cs typeface="Courier New" pitchFamily="34" charset="-120"/>
               </a:rPr>
-              <a:t>14 / 26   Smart-RUDP</a:t>
+              <a:t>14 / 27   Smart-RUDP</a:t>
             </a:r>
             <a:endParaRPr lang="en-US" sz="1000" dirty="0"/>
           </a:p>
@@ -5457,7 +5546,7 @@
                 <a:ea typeface="Courier New" pitchFamily="34" charset="-122"/>
                 <a:cs typeface="Courier New" pitchFamily="34" charset="-120"/>
               </a:rPr>
-              <a:t>15 / 26   Smart-RUDP</a:t>
+              <a:t>15 / 27   Smart-RUDP</a:t>
             </a:r>
             <a:endParaRPr lang="en-US" sz="1000" dirty="0"/>
           </a:p>
@@ -5915,7 +6004,7 @@
                 <a:ea typeface="Courier New" pitchFamily="34" charset="-122"/>
                 <a:cs typeface="Courier New" pitchFamily="34" charset="-120"/>
               </a:rPr>
-              <a:t>16 / 26   Smart-RUDP</a:t>
+              <a:t>16 / 27   Smart-RUDP</a:t>
             </a:r>
             <a:endParaRPr lang="en-US" sz="1000" dirty="0"/>
           </a:p>
@@ -6600,7 +6689,7 @@
                 <a:ea typeface="Courier New" pitchFamily="34" charset="-122"/>
                 <a:cs typeface="Courier New" pitchFamily="34" charset="-120"/>
               </a:rPr>
-              <a:t>17 / 26   Smart-RUDP</a:t>
+              <a:t>17 / 27   Smart-RUDP</a:t>
             </a:r>
             <a:endParaRPr lang="en-US" sz="1000" dirty="0"/>
           </a:p>
@@ -6840,7 +6929,7 @@
                 <a:ea typeface="Courier New" pitchFamily="34" charset="-122"/>
                 <a:cs typeface="Courier New" pitchFamily="34" charset="-120"/>
               </a:rPr>
-              <a:t>18 / 26   Smart-RUDP</a:t>
+              <a:t>18 / 27   Smart-RUDP</a:t>
             </a:r>
             <a:endParaRPr lang="en-US" sz="1000" dirty="0"/>
           </a:p>
@@ -7080,7 +7169,7 @@
                 <a:ea typeface="Courier New" pitchFamily="34" charset="-122"/>
                 <a:cs typeface="Courier New" pitchFamily="34" charset="-120"/>
               </a:rPr>
-              <a:t>19 / 26   Smart-RUDP</a:t>
+              <a:t>19 / 27   Smart-RUDP</a:t>
             </a:r>
             <a:endParaRPr lang="en-US" sz="1000" dirty="0"/>
           </a:p>
@@ -7302,7 +7391,7 @@
                 <a:ea typeface="Courier New" pitchFamily="34" charset="-122"/>
                 <a:cs typeface="Courier New" pitchFamily="34" charset="-120"/>
               </a:rPr>
-              <a:t>2 / 26   Smart-RUDP</a:t>
+              <a:t>2 / 27   Smart-RUDP</a:t>
             </a:r>
             <a:endParaRPr lang="en-US" sz="1000" dirty="0"/>
           </a:p>
@@ -7696,7 +7785,7 @@
                 <a:ea typeface="Courier New" pitchFamily="34" charset="-122"/>
                 <a:cs typeface="Courier New" pitchFamily="34" charset="-120"/>
               </a:rPr>
-              <a:t>20 / 26   Smart-RUDP</a:t>
+              <a:t>20 / 27   Smart-RUDP</a:t>
             </a:r>
             <a:endParaRPr lang="en-US" sz="1000" dirty="0"/>
           </a:p>
@@ -8020,7 +8109,7 @@
                 <a:ea typeface="Courier New" pitchFamily="34" charset="-122"/>
                 <a:cs typeface="Courier New" pitchFamily="34" charset="-120"/>
               </a:rPr>
-              <a:t>21 / 26   Smart-RUDP</a:t>
+              <a:t>21 / 27   Smart-RUDP</a:t>
             </a:r>
             <a:endParaRPr lang="en-US" sz="1000" dirty="0"/>
           </a:p>
@@ -9727,7 +9816,7 @@
                 <a:ea typeface="Courier New" pitchFamily="34" charset="-122"/>
                 <a:cs typeface="Courier New" pitchFamily="34" charset="-120"/>
               </a:rPr>
-              <a:t>22 / 26   Smart-RUDP</a:t>
+              <a:t>22 / 27   Smart-RUDP</a:t>
             </a:r>
             <a:endParaRPr lang="en-US" sz="1000" dirty="0"/>
           </a:p>
@@ -11110,7 +11199,7 @@
                 <a:ea typeface="Courier New" pitchFamily="34" charset="-122"/>
                 <a:cs typeface="Courier New" pitchFamily="34" charset="-120"/>
               </a:rPr>
-              <a:t>23 / 26   Smart-RUDP</a:t>
+              <a:t>23 / 27   Smart-RUDP</a:t>
             </a:r>
             <a:endParaRPr lang="en-US" sz="1000" dirty="0"/>
           </a:p>
@@ -12653,7 +12742,7 @@
                 <a:ea typeface="Courier New" pitchFamily="34" charset="-122"/>
                 <a:cs typeface="Courier New" pitchFamily="34" charset="-120"/>
               </a:rPr>
-              <a:t>24 / 26   Smart-RUDP</a:t>
+              <a:t>24 / 27   Smart-RUDP</a:t>
             </a:r>
             <a:endParaRPr lang="en-US" sz="1000" dirty="0"/>
           </a:p>
@@ -14292,7 +14381,7 @@
                 <a:ea typeface="Courier New" pitchFamily="34" charset="-122"/>
                 <a:cs typeface="Courier New" pitchFamily="34" charset="-120"/>
               </a:rPr>
-              <a:t>Learnings and future work</a:t>
+              <a:t>Selective Repeat is now the default</a:t>
             </a:r>
             <a:endParaRPr lang="en-US" sz="3000" dirty="0"/>
           </a:p>
@@ -14331,47 +14420,1424 @@
                 <a:ea typeface="Courier New" pitchFamily="34" charset="-122"/>
                 <a:cs typeface="Courier New" pitchFamily="34" charset="-120"/>
               </a:rPr>
-              <a:t>25 / 26   Smart-RUDP</a:t>
+              <a:t>25 / 27   Smart-RUDP</a:t>
             </a:r>
             <a:endParaRPr lang="en-US" sz="1000" dirty="0"/>
           </a:p>
         </p:txBody>
       </p:sp>
-      <p:sp>
-        <p:nvSpPr>
-          <p:cNvPr id="4" name="Shape 2"/>
+      <p:graphicFrame>
+        <p:nvGraphicFramePr>
+          <p:cNvPr id="26" name="Table 0"/>
+          <p:cNvGraphicFramePr>
+            <a:graphicFrameLocks noGrp="1"/>
+          </p:cNvGraphicFramePr>
+          <p:nvPr>
+            <p:extLst>
+              <p:ext uri="{D42A27DB-BD31-4B8C-83A1-F6EECF244321}">
+                <p14:modId xmlns:p14="http://schemas.microsoft.com/office/powerpoint/2010/main" val="1579011935"/>
+              </p:ext>
+            </p:extLst>
+          </p:nvPr>
+        </p:nvGraphicFramePr>
+        <p:xfrm>
+          <a:off x="548640" y="1188720"/>
+          <a:ext cx="6035040" cy="914400"/>
+        </p:xfrm>
+        <a:graphic>
+          <a:graphicData uri="http://schemas.openxmlformats.org/drawingml/2006/table">
+            <a:tbl>
+              <a:tblPr/>
+              <a:tblGrid>
+                <a:gridCol w="2468880"/>
+                <a:gridCol w="1188720"/>
+                <a:gridCol w="1188720"/>
+                <a:gridCol w="1188720"/>
+              </a:tblGrid>
+              <a:tr h="420624">
+                <a:tc>
+                  <a:txBody>
+                    <a:bodyPr/>
+                    <a:lstStyle/>
+                    <a:p>
+                      <a:pPr indent="0" marL="0">
+                        <a:buNone/>
+                      </a:pPr>
+                      <a:r>
+                        <a:rPr lang="en-US" sz="1300" b="1" dirty="0">
+                          <a:solidFill>
+                            <a:srgbClr val="0B0F14"/>
+                          </a:solidFill>
+                          <a:latin typeface="Courier New" pitchFamily="34" charset="0"/>
+                          <a:ea typeface="Courier New" pitchFamily="34" charset="-122"/>
+                          <a:cs typeface="Courier New" pitchFamily="34" charset="-120"/>
+                        </a:rPr>
+                        <a:t>C transport, seconds</a:t>
+                      </a:r>
+                      <a:endParaRPr lang="en-US" sz="1300" dirty="0">
+                        <a:latin typeface="Courier New" charset="0"/>
+                        <a:ea typeface="Courier New" charset="0"/>
+                        <a:cs typeface="Courier New" charset="0"/>
+                      </a:endParaRPr>
+                    </a:p>
+                  </a:txBody>
+                  <a:tcPr marL="91440" marR="91440" marT="45720" marB="45720">
+                    <a:lnL w="12700" cap="flat" cmpd="sng" algn="ctr">
+                      <a:solidFill>
+                        <a:srgbClr val="2A3441"/>
+                      </a:solidFill>
+                      <a:prstDash val="solid"/>
+                      <a:round/>
+                      <a:headEnd type="none" w="med" len="med"/>
+                      <a:tailEnd type="none" w="med" len="med"/>
+                    </a:lnL>
+                    <a:lnR w="12700" cap="flat" cmpd="sng" algn="ctr">
+                      <a:solidFill>
+                        <a:srgbClr val="2A3441"/>
+                      </a:solidFill>
+                      <a:prstDash val="solid"/>
+                      <a:round/>
+                      <a:headEnd type="none" w="med" len="med"/>
+                      <a:tailEnd type="none" w="med" len="med"/>
+                    </a:lnR>
+                    <a:lnT w="12700" cap="flat" cmpd="sng" algn="ctr">
+                      <a:solidFill>
+                        <a:srgbClr val="2A3441"/>
+                      </a:solidFill>
+                      <a:prstDash val="solid"/>
+                      <a:round/>
+                      <a:headEnd type="none" w="med" len="med"/>
+                      <a:tailEnd type="none" w="med" len="med"/>
+                    </a:lnT>
+                    <a:lnB w="12700" cap="flat" cmpd="sng" algn="ctr">
+                      <a:solidFill>
+                        <a:srgbClr val="2A3441"/>
+                      </a:solidFill>
+                      <a:prstDash val="solid"/>
+                      <a:round/>
+                      <a:headEnd type="none" w="med" len="med"/>
+                      <a:tailEnd type="none" w="med" len="med"/>
+                    </a:lnB>
+                    <a:solidFill>
+                      <a:srgbClr val="39FF88"/>
+                    </a:solidFill>
+                  </a:tcPr>
+                </a:tc>
+                <a:tc>
+                  <a:txBody>
+                    <a:bodyPr/>
+                    <a:lstStyle/>
+                    <a:p>
+                      <a:pPr indent="0" marL="0">
+                        <a:buNone/>
+                      </a:pPr>
+                      <a:r>
+                        <a:rPr lang="en-US" sz="1300" b="1" dirty="0">
+                          <a:solidFill>
+                            <a:srgbClr val="0B0F14"/>
+                          </a:solidFill>
+                          <a:latin typeface="Courier New" pitchFamily="34" charset="0"/>
+                          <a:ea typeface="Courier New" pitchFamily="34" charset="-122"/>
+                          <a:cs typeface="Courier New" pitchFamily="34" charset="-120"/>
+                        </a:rPr>
+                        <a:t>AIMD 32</a:t>
+                      </a:r>
+                      <a:endParaRPr lang="en-US" sz="1300" dirty="0">
+                        <a:latin typeface="Courier New" charset="0"/>
+                        <a:ea typeface="Courier New" charset="0"/>
+                        <a:cs typeface="Courier New" charset="0"/>
+                      </a:endParaRPr>
+                    </a:p>
+                  </a:txBody>
+                  <a:tcPr marL="91440" marR="91440" marT="45720" marB="45720">
+                    <a:lnL w="12700" cap="flat" cmpd="sng" algn="ctr">
+                      <a:solidFill>
+                        <a:srgbClr val="2A3441"/>
+                      </a:solidFill>
+                      <a:prstDash val="solid"/>
+                      <a:round/>
+                      <a:headEnd type="none" w="med" len="med"/>
+                      <a:tailEnd type="none" w="med" len="med"/>
+                    </a:lnL>
+                    <a:lnR w="12700" cap="flat" cmpd="sng" algn="ctr">
+                      <a:solidFill>
+                        <a:srgbClr val="2A3441"/>
+                      </a:solidFill>
+                      <a:prstDash val="solid"/>
+                      <a:round/>
+                      <a:headEnd type="none" w="med" len="med"/>
+                      <a:tailEnd type="none" w="med" len="med"/>
+                    </a:lnR>
+                    <a:lnT w="12700" cap="flat" cmpd="sng" algn="ctr">
+                      <a:solidFill>
+                        <a:srgbClr val="2A3441"/>
+                      </a:solidFill>
+                      <a:prstDash val="solid"/>
+                      <a:round/>
+                      <a:headEnd type="none" w="med" len="med"/>
+                      <a:tailEnd type="none" w="med" len="med"/>
+                    </a:lnT>
+                    <a:lnB w="12700" cap="flat" cmpd="sng" algn="ctr">
+                      <a:solidFill>
+                        <a:srgbClr val="2A3441"/>
+                      </a:solidFill>
+                      <a:prstDash val="solid"/>
+                      <a:round/>
+                      <a:headEnd type="none" w="med" len="med"/>
+                      <a:tailEnd type="none" w="med" len="med"/>
+                    </a:lnB>
+                    <a:solidFill>
+                      <a:srgbClr val="39FF88"/>
+                    </a:solidFill>
+                  </a:tcPr>
+                </a:tc>
+                <a:tc>
+                  <a:txBody>
+                    <a:bodyPr/>
+                    <a:lstStyle/>
+                    <a:p>
+                      <a:pPr indent="0" marL="0">
+                        <a:buNone/>
+                      </a:pPr>
+                      <a:r>
+                        <a:rPr lang="en-US" sz="1300" b="1" dirty="0">
+                          <a:solidFill>
+                            <a:srgbClr val="0B0F14"/>
+                          </a:solidFill>
+                          <a:latin typeface="Courier New" pitchFamily="34" charset="0"/>
+                          <a:ea typeface="Courier New" pitchFamily="34" charset="-122"/>
+                          <a:cs typeface="Courier New" pitchFamily="34" charset="-120"/>
+                        </a:rPr>
+                        <a:t>Neural</a:t>
+                      </a:r>
+                      <a:endParaRPr lang="en-US" sz="1300" dirty="0">
+                        <a:latin typeface="Courier New" charset="0"/>
+                        <a:ea typeface="Courier New" charset="0"/>
+                        <a:cs typeface="Courier New" charset="0"/>
+                      </a:endParaRPr>
+                    </a:p>
+                  </a:txBody>
+                  <a:tcPr marL="91440" marR="91440" marT="45720" marB="45720">
+                    <a:lnL w="12700" cap="flat" cmpd="sng" algn="ctr">
+                      <a:solidFill>
+                        <a:srgbClr val="2A3441"/>
+                      </a:solidFill>
+                      <a:prstDash val="solid"/>
+                      <a:round/>
+                      <a:headEnd type="none" w="med" len="med"/>
+                      <a:tailEnd type="none" w="med" len="med"/>
+                    </a:lnL>
+                    <a:lnR w="12700" cap="flat" cmpd="sng" algn="ctr">
+                      <a:solidFill>
+                        <a:srgbClr val="2A3441"/>
+                      </a:solidFill>
+                      <a:prstDash val="solid"/>
+                      <a:round/>
+                      <a:headEnd type="none" w="med" len="med"/>
+                      <a:tailEnd type="none" w="med" len="med"/>
+                    </a:lnR>
+                    <a:lnT w="12700" cap="flat" cmpd="sng" algn="ctr">
+                      <a:solidFill>
+                        <a:srgbClr val="2A3441"/>
+                      </a:solidFill>
+                      <a:prstDash val="solid"/>
+                      <a:round/>
+                      <a:headEnd type="none" w="med" len="med"/>
+                      <a:tailEnd type="none" w="med" len="med"/>
+                    </a:lnT>
+                    <a:lnB w="12700" cap="flat" cmpd="sng" algn="ctr">
+                      <a:solidFill>
+                        <a:srgbClr val="2A3441"/>
+                      </a:solidFill>
+                      <a:prstDash val="solid"/>
+                      <a:round/>
+                      <a:headEnd type="none" w="med" len="med"/>
+                      <a:tailEnd type="none" w="med" len="med"/>
+                    </a:lnB>
+                    <a:solidFill>
+                      <a:srgbClr val="39FF88"/>
+                    </a:solidFill>
+                  </a:tcPr>
+                </a:tc>
+                <a:tc>
+                  <a:txBody>
+                    <a:bodyPr/>
+                    <a:lstStyle/>
+                    <a:p>
+                      <a:pPr indent="0" marL="0">
+                        <a:buNone/>
+                      </a:pPr>
+                      <a:r>
+                        <a:rPr lang="en-US" sz="1300" b="1" dirty="0">
+                          <a:solidFill>
+                            <a:srgbClr val="0B0F14"/>
+                          </a:solidFill>
+                          <a:latin typeface="Courier New" pitchFamily="34" charset="0"/>
+                          <a:ea typeface="Courier New" pitchFamily="34" charset="-122"/>
+                          <a:cs typeface="Courier New" pitchFamily="34" charset="-120"/>
+                        </a:rPr>
+                        <a:t>Gain</a:t>
+                      </a:r>
+                      <a:endParaRPr lang="en-US" sz="1300" dirty="0">
+                        <a:latin typeface="Courier New" charset="0"/>
+                        <a:ea typeface="Courier New" charset="0"/>
+                        <a:cs typeface="Courier New" charset="0"/>
+                      </a:endParaRPr>
+                    </a:p>
+                  </a:txBody>
+                  <a:tcPr marL="91440" marR="91440" marT="45720" marB="45720">
+                    <a:lnL w="12700" cap="flat" cmpd="sng" algn="ctr">
+                      <a:solidFill>
+                        <a:srgbClr val="2A3441"/>
+                      </a:solidFill>
+                      <a:prstDash val="solid"/>
+                      <a:round/>
+                      <a:headEnd type="none" w="med" len="med"/>
+                      <a:tailEnd type="none" w="med" len="med"/>
+                    </a:lnL>
+                    <a:lnR w="12700" cap="flat" cmpd="sng" algn="ctr">
+                      <a:solidFill>
+                        <a:srgbClr val="2A3441"/>
+                      </a:solidFill>
+                      <a:prstDash val="solid"/>
+                      <a:round/>
+                      <a:headEnd type="none" w="med" len="med"/>
+                      <a:tailEnd type="none" w="med" len="med"/>
+                    </a:lnR>
+                    <a:lnT w="12700" cap="flat" cmpd="sng" algn="ctr">
+                      <a:solidFill>
+                        <a:srgbClr val="2A3441"/>
+                      </a:solidFill>
+                      <a:prstDash val="solid"/>
+                      <a:round/>
+                      <a:headEnd type="none" w="med" len="med"/>
+                      <a:tailEnd type="none" w="med" len="med"/>
+                    </a:lnT>
+                    <a:lnB w="12700" cap="flat" cmpd="sng" algn="ctr">
+                      <a:solidFill>
+                        <a:srgbClr val="2A3441"/>
+                      </a:solidFill>
+                      <a:prstDash val="solid"/>
+                      <a:round/>
+                      <a:headEnd type="none" w="med" len="med"/>
+                      <a:tailEnd type="none" w="med" len="med"/>
+                    </a:lnB>
+                    <a:solidFill>
+                      <a:srgbClr val="39FF88"/>
+                    </a:solidFill>
+                  </a:tcPr>
+                </a:tc>
+              </a:tr>
+              <a:tr h="420624">
+                <a:tc>
+                  <a:txBody>
+                    <a:bodyPr/>
+                    <a:lstStyle/>
+                    <a:p>
+                      <a:pPr indent="0" marL="0">
+                        <a:buNone/>
+                      </a:pPr>
+                      <a:r>
+                        <a:rPr lang="en-US" sz="1300" dirty="0">
+                          <a:solidFill>
+                            <a:srgbClr val="E6EDF3"/>
+                          </a:solidFill>
+                          <a:latin typeface="Calibri" pitchFamily="34" charset="0"/>
+                          <a:ea typeface="Calibri" pitchFamily="34" charset="-122"/>
+                          <a:cs typeface="Calibri" pitchFamily="34" charset="-120"/>
+                        </a:rPr>
+                        <a:t>5G-like</a:t>
+                      </a:r>
+                      <a:endParaRPr lang="en-US" sz="1300" dirty="0">
+                        <a:latin typeface="Calibri" charset="0"/>
+                        <a:ea typeface="Calibri" charset="0"/>
+                        <a:cs typeface="Calibri" charset="0"/>
+                      </a:endParaRPr>
+                    </a:p>
+                  </a:txBody>
+                  <a:tcPr marL="91440" marR="91440" marT="45720" marB="45720">
+                    <a:lnL w="12700" cap="flat" cmpd="sng" algn="ctr">
+                      <a:solidFill>
+                        <a:srgbClr val="2A3441"/>
+                      </a:solidFill>
+                      <a:prstDash val="solid"/>
+                      <a:round/>
+                      <a:headEnd type="none" w="med" len="med"/>
+                      <a:tailEnd type="none" w="med" len="med"/>
+                    </a:lnL>
+                    <a:lnR w="12700" cap="flat" cmpd="sng" algn="ctr">
+                      <a:solidFill>
+                        <a:srgbClr val="2A3441"/>
+                      </a:solidFill>
+                      <a:prstDash val="solid"/>
+                      <a:round/>
+                      <a:headEnd type="none" w="med" len="med"/>
+                      <a:tailEnd type="none" w="med" len="med"/>
+                    </a:lnR>
+                    <a:lnT w="12700" cap="flat" cmpd="sng" algn="ctr">
+                      <a:solidFill>
+                        <a:srgbClr val="2A3441"/>
+                      </a:solidFill>
+                      <a:prstDash val="solid"/>
+                      <a:round/>
+                      <a:headEnd type="none" w="med" len="med"/>
+                      <a:tailEnd type="none" w="med" len="med"/>
+                    </a:lnT>
+                    <a:lnB w="12700" cap="flat" cmpd="sng" algn="ctr">
+                      <a:solidFill>
+                        <a:srgbClr val="2A3441"/>
+                      </a:solidFill>
+                      <a:prstDash val="solid"/>
+                      <a:round/>
+                      <a:headEnd type="none" w="med" len="med"/>
+                      <a:tailEnd type="none" w="med" len="med"/>
+                    </a:lnB>
+                    <a:solidFill>
+                      <a:srgbClr val="141B24"/>
+                    </a:solidFill>
+                  </a:tcPr>
+                </a:tc>
+                <a:tc>
+                  <a:txBody>
+                    <a:bodyPr/>
+                    <a:lstStyle/>
+                    <a:p>
+                      <a:pPr indent="0" marL="0">
+                        <a:buNone/>
+                      </a:pPr>
+                      <a:r>
+                        <a:rPr lang="en-US" sz="1300" dirty="0">
+                          <a:solidFill>
+                            <a:srgbClr val="E6EDF3"/>
+                          </a:solidFill>
+                          <a:latin typeface="Calibri" pitchFamily="34" charset="0"/>
+                          <a:ea typeface="Calibri" pitchFamily="34" charset="-122"/>
+                          <a:cs typeface="Calibri" pitchFamily="34" charset="-120"/>
+                        </a:rPr>
+                        <a:t>1.27</a:t>
+                      </a:r>
+                      <a:endParaRPr lang="en-US" sz="1300" dirty="0">
+                        <a:latin typeface="Calibri" charset="0"/>
+                        <a:ea typeface="Calibri" charset="0"/>
+                        <a:cs typeface="Calibri" charset="0"/>
+                      </a:endParaRPr>
+                    </a:p>
+                  </a:txBody>
+                  <a:tcPr marL="91440" marR="91440" marT="45720" marB="45720">
+                    <a:lnL w="12700" cap="flat" cmpd="sng" algn="ctr">
+                      <a:solidFill>
+                        <a:srgbClr val="2A3441"/>
+                      </a:solidFill>
+                      <a:prstDash val="solid"/>
+                      <a:round/>
+                      <a:headEnd type="none" w="med" len="med"/>
+                      <a:tailEnd type="none" w="med" len="med"/>
+                    </a:lnL>
+                    <a:lnR w="12700" cap="flat" cmpd="sng" algn="ctr">
+                      <a:solidFill>
+                        <a:srgbClr val="2A3441"/>
+                      </a:solidFill>
+                      <a:prstDash val="solid"/>
+                      <a:round/>
+                      <a:headEnd type="none" w="med" len="med"/>
+                      <a:tailEnd type="none" w="med" len="med"/>
+                    </a:lnR>
+                    <a:lnT w="12700" cap="flat" cmpd="sng" algn="ctr">
+                      <a:solidFill>
+                        <a:srgbClr val="2A3441"/>
+                      </a:solidFill>
+                      <a:prstDash val="solid"/>
+                      <a:round/>
+                      <a:headEnd type="none" w="med" len="med"/>
+                      <a:tailEnd type="none" w="med" len="med"/>
+                    </a:lnT>
+                    <a:lnB w="12700" cap="flat" cmpd="sng" algn="ctr">
+                      <a:solidFill>
+                        <a:srgbClr val="2A3441"/>
+                      </a:solidFill>
+                      <a:prstDash val="solid"/>
+                      <a:round/>
+                      <a:headEnd type="none" w="med" len="med"/>
+                      <a:tailEnd type="none" w="med" len="med"/>
+                    </a:lnB>
+                    <a:solidFill>
+                      <a:srgbClr val="141B24"/>
+                    </a:solidFill>
+                  </a:tcPr>
+                </a:tc>
+                <a:tc>
+                  <a:txBody>
+                    <a:bodyPr/>
+                    <a:lstStyle/>
+                    <a:p>
+                      <a:pPr indent="0" marL="0">
+                        <a:buNone/>
+                      </a:pPr>
+                      <a:r>
+                        <a:rPr lang="en-US" sz="1300" dirty="0">
+                          <a:solidFill>
+                            <a:srgbClr val="E6EDF3"/>
+                          </a:solidFill>
+                          <a:latin typeface="Calibri" pitchFamily="34" charset="0"/>
+                          <a:ea typeface="Calibri" pitchFamily="34" charset="-122"/>
+                          <a:cs typeface="Calibri" pitchFamily="34" charset="-120"/>
+                        </a:rPr>
+                        <a:t>1.16</a:t>
+                      </a:r>
+                      <a:endParaRPr lang="en-US" sz="1300" dirty="0">
+                        <a:latin typeface="Calibri" charset="0"/>
+                        <a:ea typeface="Calibri" charset="0"/>
+                        <a:cs typeface="Calibri" charset="0"/>
+                      </a:endParaRPr>
+                    </a:p>
+                  </a:txBody>
+                  <a:tcPr marL="91440" marR="91440" marT="45720" marB="45720">
+                    <a:lnL w="12700" cap="flat" cmpd="sng" algn="ctr">
+                      <a:solidFill>
+                        <a:srgbClr val="2A3441"/>
+                      </a:solidFill>
+                      <a:prstDash val="solid"/>
+                      <a:round/>
+                      <a:headEnd type="none" w="med" len="med"/>
+                      <a:tailEnd type="none" w="med" len="med"/>
+                    </a:lnL>
+                    <a:lnR w="12700" cap="flat" cmpd="sng" algn="ctr">
+                      <a:solidFill>
+                        <a:srgbClr val="2A3441"/>
+                      </a:solidFill>
+                      <a:prstDash val="solid"/>
+                      <a:round/>
+                      <a:headEnd type="none" w="med" len="med"/>
+                      <a:tailEnd type="none" w="med" len="med"/>
+                    </a:lnR>
+                    <a:lnT w="12700" cap="flat" cmpd="sng" algn="ctr">
+                      <a:solidFill>
+                        <a:srgbClr val="2A3441"/>
+                      </a:solidFill>
+                      <a:prstDash val="solid"/>
+                      <a:round/>
+                      <a:headEnd type="none" w="med" len="med"/>
+                      <a:tailEnd type="none" w="med" len="med"/>
+                    </a:lnT>
+                    <a:lnB w="12700" cap="flat" cmpd="sng" algn="ctr">
+                      <a:solidFill>
+                        <a:srgbClr val="2A3441"/>
+                      </a:solidFill>
+                      <a:prstDash val="solid"/>
+                      <a:round/>
+                      <a:headEnd type="none" w="med" len="med"/>
+                      <a:tailEnd type="none" w="med" len="med"/>
+                    </a:lnB>
+                    <a:solidFill>
+                      <a:srgbClr val="141B24"/>
+                    </a:solidFill>
+                  </a:tcPr>
+                </a:tc>
+                <a:tc>
+                  <a:txBody>
+                    <a:bodyPr/>
+                    <a:lstStyle/>
+                    <a:p>
+                      <a:pPr indent="0" marL="0">
+                        <a:buNone/>
+                      </a:pPr>
+                      <a:r>
+                        <a:rPr lang="en-US" sz="1300" dirty="0">
+                          <a:solidFill>
+                            <a:srgbClr val="E6EDF3"/>
+                          </a:solidFill>
+                          <a:latin typeface="Calibri" pitchFamily="34" charset="0"/>
+                          <a:ea typeface="Calibri" pitchFamily="34" charset="-122"/>
+                          <a:cs typeface="Calibri" pitchFamily="34" charset="-120"/>
+                        </a:rPr>
+                        <a:t>9%</a:t>
+                      </a:r>
+                      <a:endParaRPr lang="en-US" sz="1300" dirty="0">
+                        <a:latin typeface="Calibri" charset="0"/>
+                        <a:ea typeface="Calibri" charset="0"/>
+                        <a:cs typeface="Calibri" charset="0"/>
+                      </a:endParaRPr>
+                    </a:p>
+                  </a:txBody>
+                  <a:tcPr marL="91440" marR="91440" marT="45720" marB="45720">
+                    <a:lnL w="12700" cap="flat" cmpd="sng" algn="ctr">
+                      <a:solidFill>
+                        <a:srgbClr val="2A3441"/>
+                      </a:solidFill>
+                      <a:prstDash val="solid"/>
+                      <a:round/>
+                      <a:headEnd type="none" w="med" len="med"/>
+                      <a:tailEnd type="none" w="med" len="med"/>
+                    </a:lnL>
+                    <a:lnR w="12700" cap="flat" cmpd="sng" algn="ctr">
+                      <a:solidFill>
+                        <a:srgbClr val="2A3441"/>
+                      </a:solidFill>
+                      <a:prstDash val="solid"/>
+                      <a:round/>
+                      <a:headEnd type="none" w="med" len="med"/>
+                      <a:tailEnd type="none" w="med" len="med"/>
+                    </a:lnR>
+                    <a:lnT w="12700" cap="flat" cmpd="sng" algn="ctr">
+                      <a:solidFill>
+                        <a:srgbClr val="2A3441"/>
+                      </a:solidFill>
+                      <a:prstDash val="solid"/>
+                      <a:round/>
+                      <a:headEnd type="none" w="med" len="med"/>
+                      <a:tailEnd type="none" w="med" len="med"/>
+                    </a:lnT>
+                    <a:lnB w="12700" cap="flat" cmpd="sng" algn="ctr">
+                      <a:solidFill>
+                        <a:srgbClr val="2A3441"/>
+                      </a:solidFill>
+                      <a:prstDash val="solid"/>
+                      <a:round/>
+                      <a:headEnd type="none" w="med" len="med"/>
+                      <a:tailEnd type="none" w="med" len="med"/>
+                    </a:lnB>
+                    <a:solidFill>
+                      <a:srgbClr val="141B24"/>
+                    </a:solidFill>
+                  </a:tcPr>
+                </a:tc>
+              </a:tr>
+              <a:tr h="420624">
+                <a:tc>
+                  <a:txBody>
+                    <a:bodyPr/>
+                    <a:lstStyle/>
+                    <a:p>
+                      <a:pPr indent="0" marL="0">
+                        <a:buNone/>
+                      </a:pPr>
+                      <a:r>
+                        <a:rPr lang="en-US" sz="1300" dirty="0">
+                          <a:solidFill>
+                            <a:srgbClr val="E6EDF3"/>
+                          </a:solidFill>
+                          <a:latin typeface="Calibri" pitchFamily="34" charset="0"/>
+                          <a:ea typeface="Calibri" pitchFamily="34" charset="-122"/>
+                          <a:cs typeface="Calibri" pitchFamily="34" charset="-120"/>
+                        </a:rPr>
+                        <a:t>Lossy 2%</a:t>
+                      </a:r>
+                      <a:endParaRPr lang="en-US" sz="1300" dirty="0">
+                        <a:latin typeface="Calibri" charset="0"/>
+                        <a:ea typeface="Calibri" charset="0"/>
+                        <a:cs typeface="Calibri" charset="0"/>
+                      </a:endParaRPr>
+                    </a:p>
+                  </a:txBody>
+                  <a:tcPr marL="91440" marR="91440" marT="45720" marB="45720">
+                    <a:lnL w="12700" cap="flat" cmpd="sng" algn="ctr">
+                      <a:solidFill>
+                        <a:srgbClr val="2A3441"/>
+                      </a:solidFill>
+                      <a:prstDash val="solid"/>
+                      <a:round/>
+                      <a:headEnd type="none" w="med" len="med"/>
+                      <a:tailEnd type="none" w="med" len="med"/>
+                    </a:lnL>
+                    <a:lnR w="12700" cap="flat" cmpd="sng" algn="ctr">
+                      <a:solidFill>
+                        <a:srgbClr val="2A3441"/>
+                      </a:solidFill>
+                      <a:prstDash val="solid"/>
+                      <a:round/>
+                      <a:headEnd type="none" w="med" len="med"/>
+                      <a:tailEnd type="none" w="med" len="med"/>
+                    </a:lnR>
+                    <a:lnT w="12700" cap="flat" cmpd="sng" algn="ctr">
+                      <a:solidFill>
+                        <a:srgbClr val="2A3441"/>
+                      </a:solidFill>
+                      <a:prstDash val="solid"/>
+                      <a:round/>
+                      <a:headEnd type="none" w="med" len="med"/>
+                      <a:tailEnd type="none" w="med" len="med"/>
+                    </a:lnT>
+                    <a:lnB w="12700" cap="flat" cmpd="sng" algn="ctr">
+                      <a:solidFill>
+                        <a:srgbClr val="2A3441"/>
+                      </a:solidFill>
+                      <a:prstDash val="solid"/>
+                      <a:round/>
+                      <a:headEnd type="none" w="med" len="med"/>
+                      <a:tailEnd type="none" w="med" len="med"/>
+                    </a:lnB>
+                    <a:solidFill>
+                      <a:srgbClr val="141B24"/>
+                    </a:solidFill>
+                  </a:tcPr>
+                </a:tc>
+                <a:tc>
+                  <a:txBody>
+                    <a:bodyPr/>
+                    <a:lstStyle/>
+                    <a:p>
+                      <a:pPr indent="0" marL="0">
+                        <a:buNone/>
+                      </a:pPr>
+                      <a:r>
+                        <a:rPr lang="en-US" sz="1300" dirty="0">
+                          <a:solidFill>
+                            <a:srgbClr val="E6EDF3"/>
+                          </a:solidFill>
+                          <a:latin typeface="Calibri" pitchFamily="34" charset="0"/>
+                          <a:ea typeface="Calibri" pitchFamily="34" charset="-122"/>
+                          <a:cs typeface="Calibri" pitchFamily="34" charset="-120"/>
+                        </a:rPr>
+                        <a:t>7.99</a:t>
+                      </a:r>
+                      <a:endParaRPr lang="en-US" sz="1300" dirty="0">
+                        <a:latin typeface="Calibri" charset="0"/>
+                        <a:ea typeface="Calibri" charset="0"/>
+                        <a:cs typeface="Calibri" charset="0"/>
+                      </a:endParaRPr>
+                    </a:p>
+                  </a:txBody>
+                  <a:tcPr marL="91440" marR="91440" marT="45720" marB="45720">
+                    <a:lnL w="12700" cap="flat" cmpd="sng" algn="ctr">
+                      <a:solidFill>
+                        <a:srgbClr val="2A3441"/>
+                      </a:solidFill>
+                      <a:prstDash val="solid"/>
+                      <a:round/>
+                      <a:headEnd type="none" w="med" len="med"/>
+                      <a:tailEnd type="none" w="med" len="med"/>
+                    </a:lnL>
+                    <a:lnR w="12700" cap="flat" cmpd="sng" algn="ctr">
+                      <a:solidFill>
+                        <a:srgbClr val="2A3441"/>
+                      </a:solidFill>
+                      <a:prstDash val="solid"/>
+                      <a:round/>
+                      <a:headEnd type="none" w="med" len="med"/>
+                      <a:tailEnd type="none" w="med" len="med"/>
+                    </a:lnR>
+                    <a:lnT w="12700" cap="flat" cmpd="sng" algn="ctr">
+                      <a:solidFill>
+                        <a:srgbClr val="2A3441"/>
+                      </a:solidFill>
+                      <a:prstDash val="solid"/>
+                      <a:round/>
+                      <a:headEnd type="none" w="med" len="med"/>
+                      <a:tailEnd type="none" w="med" len="med"/>
+                    </a:lnT>
+                    <a:lnB w="12700" cap="flat" cmpd="sng" algn="ctr">
+                      <a:solidFill>
+                        <a:srgbClr val="2A3441"/>
+                      </a:solidFill>
+                      <a:prstDash val="solid"/>
+                      <a:round/>
+                      <a:headEnd type="none" w="med" len="med"/>
+                      <a:tailEnd type="none" w="med" len="med"/>
+                    </a:lnB>
+                    <a:solidFill>
+                      <a:srgbClr val="141B24"/>
+                    </a:solidFill>
+                  </a:tcPr>
+                </a:tc>
+                <a:tc>
+                  <a:txBody>
+                    <a:bodyPr/>
+                    <a:lstStyle/>
+                    <a:p>
+                      <a:pPr indent="0" marL="0">
+                        <a:buNone/>
+                      </a:pPr>
+                      <a:r>
+                        <a:rPr lang="en-US" sz="1300" dirty="0">
+                          <a:solidFill>
+                            <a:srgbClr val="E6EDF3"/>
+                          </a:solidFill>
+                          <a:latin typeface="Calibri" pitchFamily="34" charset="0"/>
+                          <a:ea typeface="Calibri" pitchFamily="34" charset="-122"/>
+                          <a:cs typeface="Calibri" pitchFamily="34" charset="-120"/>
+                        </a:rPr>
+                        <a:t>4.29</a:t>
+                      </a:r>
+                      <a:endParaRPr lang="en-US" sz="1300" dirty="0">
+                        <a:latin typeface="Calibri" charset="0"/>
+                        <a:ea typeface="Calibri" charset="0"/>
+                        <a:cs typeface="Calibri" charset="0"/>
+                      </a:endParaRPr>
+                    </a:p>
+                  </a:txBody>
+                  <a:tcPr marL="91440" marR="91440" marT="45720" marB="45720">
+                    <a:lnL w="12700" cap="flat" cmpd="sng" algn="ctr">
+                      <a:solidFill>
+                        <a:srgbClr val="2A3441"/>
+                      </a:solidFill>
+                      <a:prstDash val="solid"/>
+                      <a:round/>
+                      <a:headEnd type="none" w="med" len="med"/>
+                      <a:tailEnd type="none" w="med" len="med"/>
+                    </a:lnL>
+                    <a:lnR w="12700" cap="flat" cmpd="sng" algn="ctr">
+                      <a:solidFill>
+                        <a:srgbClr val="2A3441"/>
+                      </a:solidFill>
+                      <a:prstDash val="solid"/>
+                      <a:round/>
+                      <a:headEnd type="none" w="med" len="med"/>
+                      <a:tailEnd type="none" w="med" len="med"/>
+                    </a:lnR>
+                    <a:lnT w="12700" cap="flat" cmpd="sng" algn="ctr">
+                      <a:solidFill>
+                        <a:srgbClr val="2A3441"/>
+                      </a:solidFill>
+                      <a:prstDash val="solid"/>
+                      <a:round/>
+                      <a:headEnd type="none" w="med" len="med"/>
+                      <a:tailEnd type="none" w="med" len="med"/>
+                    </a:lnT>
+                    <a:lnB w="12700" cap="flat" cmpd="sng" algn="ctr">
+                      <a:solidFill>
+                        <a:srgbClr val="2A3441"/>
+                      </a:solidFill>
+                      <a:prstDash val="solid"/>
+                      <a:round/>
+                      <a:headEnd type="none" w="med" len="med"/>
+                      <a:tailEnd type="none" w="med" len="med"/>
+                    </a:lnB>
+                    <a:solidFill>
+                      <a:srgbClr val="141B24"/>
+                    </a:solidFill>
+                  </a:tcPr>
+                </a:tc>
+                <a:tc>
+                  <a:txBody>
+                    <a:bodyPr/>
+                    <a:lstStyle/>
+                    <a:p>
+                      <a:pPr indent="0" marL="0">
+                        <a:buNone/>
+                      </a:pPr>
+                      <a:r>
+                        <a:rPr lang="en-US" sz="1300" dirty="0">
+                          <a:solidFill>
+                            <a:srgbClr val="E6EDF3"/>
+                          </a:solidFill>
+                          <a:latin typeface="Calibri" pitchFamily="34" charset="0"/>
+                          <a:ea typeface="Calibri" pitchFamily="34" charset="-122"/>
+                          <a:cs typeface="Calibri" pitchFamily="34" charset="-120"/>
+                        </a:rPr>
+                        <a:t>46%</a:t>
+                      </a:r>
+                      <a:endParaRPr lang="en-US" sz="1300" dirty="0">
+                        <a:latin typeface="Calibri" charset="0"/>
+                        <a:ea typeface="Calibri" charset="0"/>
+                        <a:cs typeface="Calibri" charset="0"/>
+                      </a:endParaRPr>
+                    </a:p>
+                  </a:txBody>
+                  <a:tcPr marL="91440" marR="91440" marT="45720" marB="45720">
+                    <a:lnL w="12700" cap="flat" cmpd="sng" algn="ctr">
+                      <a:solidFill>
+                        <a:srgbClr val="2A3441"/>
+                      </a:solidFill>
+                      <a:prstDash val="solid"/>
+                      <a:round/>
+                      <a:headEnd type="none" w="med" len="med"/>
+                      <a:tailEnd type="none" w="med" len="med"/>
+                    </a:lnL>
+                    <a:lnR w="12700" cap="flat" cmpd="sng" algn="ctr">
+                      <a:solidFill>
+                        <a:srgbClr val="2A3441"/>
+                      </a:solidFill>
+                      <a:prstDash val="solid"/>
+                      <a:round/>
+                      <a:headEnd type="none" w="med" len="med"/>
+                      <a:tailEnd type="none" w="med" len="med"/>
+                    </a:lnR>
+                    <a:lnT w="12700" cap="flat" cmpd="sng" algn="ctr">
+                      <a:solidFill>
+                        <a:srgbClr val="2A3441"/>
+                      </a:solidFill>
+                      <a:prstDash val="solid"/>
+                      <a:round/>
+                      <a:headEnd type="none" w="med" len="med"/>
+                      <a:tailEnd type="none" w="med" len="med"/>
+                    </a:lnT>
+                    <a:lnB w="12700" cap="flat" cmpd="sng" algn="ctr">
+                      <a:solidFill>
+                        <a:srgbClr val="2A3441"/>
+                      </a:solidFill>
+                      <a:prstDash val="solid"/>
+                      <a:round/>
+                      <a:headEnd type="none" w="med" len="med"/>
+                      <a:tailEnd type="none" w="med" len="med"/>
+                    </a:lnB>
+                    <a:solidFill>
+                      <a:srgbClr val="141B24"/>
+                    </a:solidFill>
+                  </a:tcPr>
+                </a:tc>
+              </a:tr>
+              <a:tr h="420624">
+                <a:tc>
+                  <a:txBody>
+                    <a:bodyPr/>
+                    <a:lstStyle/>
+                    <a:p>
+                      <a:pPr indent="0" marL="0">
+                        <a:buNone/>
+                      </a:pPr>
+                      <a:r>
+                        <a:rPr lang="en-US" sz="1300" dirty="0">
+                          <a:solidFill>
+                            <a:srgbClr val="E6EDF3"/>
+                          </a:solidFill>
+                          <a:latin typeface="Calibri" pitchFamily="34" charset="0"/>
+                          <a:ea typeface="Calibri" pitchFamily="34" charset="-122"/>
+                          <a:cs typeface="Calibri" pitchFamily="34" charset="-120"/>
+                        </a:rPr>
+                        <a:t>Satellite-like</a:t>
+                      </a:r>
+                      <a:endParaRPr lang="en-US" sz="1300" dirty="0">
+                        <a:latin typeface="Calibri" charset="0"/>
+                        <a:ea typeface="Calibri" charset="0"/>
+                        <a:cs typeface="Calibri" charset="0"/>
+                      </a:endParaRPr>
+                    </a:p>
+                  </a:txBody>
+                  <a:tcPr marL="91440" marR="91440" marT="45720" marB="45720">
+                    <a:lnL w="12700" cap="flat" cmpd="sng" algn="ctr">
+                      <a:solidFill>
+                        <a:srgbClr val="2A3441"/>
+                      </a:solidFill>
+                      <a:prstDash val="solid"/>
+                      <a:round/>
+                      <a:headEnd type="none" w="med" len="med"/>
+                      <a:tailEnd type="none" w="med" len="med"/>
+                    </a:lnL>
+                    <a:lnR w="12700" cap="flat" cmpd="sng" algn="ctr">
+                      <a:solidFill>
+                        <a:srgbClr val="2A3441"/>
+                      </a:solidFill>
+                      <a:prstDash val="solid"/>
+                      <a:round/>
+                      <a:headEnd type="none" w="med" len="med"/>
+                      <a:tailEnd type="none" w="med" len="med"/>
+                    </a:lnR>
+                    <a:lnT w="12700" cap="flat" cmpd="sng" algn="ctr">
+                      <a:solidFill>
+                        <a:srgbClr val="2A3441"/>
+                      </a:solidFill>
+                      <a:prstDash val="solid"/>
+                      <a:round/>
+                      <a:headEnd type="none" w="med" len="med"/>
+                      <a:tailEnd type="none" w="med" len="med"/>
+                    </a:lnT>
+                    <a:lnB w="12700" cap="flat" cmpd="sng" algn="ctr">
+                      <a:solidFill>
+                        <a:srgbClr val="2A3441"/>
+                      </a:solidFill>
+                      <a:prstDash val="solid"/>
+                      <a:round/>
+                      <a:headEnd type="none" w="med" len="med"/>
+                      <a:tailEnd type="none" w="med" len="med"/>
+                    </a:lnB>
+                    <a:solidFill>
+                      <a:srgbClr val="141B24"/>
+                    </a:solidFill>
+                  </a:tcPr>
+                </a:tc>
+                <a:tc>
+                  <a:txBody>
+                    <a:bodyPr/>
+                    <a:lstStyle/>
+                    <a:p>
+                      <a:pPr indent="0" marL="0">
+                        <a:buNone/>
+                      </a:pPr>
+                      <a:r>
+                        <a:rPr lang="en-US" sz="1300" dirty="0">
+                          <a:solidFill>
+                            <a:srgbClr val="E6EDF3"/>
+                          </a:solidFill>
+                          <a:latin typeface="Calibri" pitchFamily="34" charset="0"/>
+                          <a:ea typeface="Calibri" pitchFamily="34" charset="-122"/>
+                          <a:cs typeface="Calibri" pitchFamily="34" charset="-120"/>
+                        </a:rPr>
+                        <a:t>25.7</a:t>
+                      </a:r>
+                      <a:endParaRPr lang="en-US" sz="1300" dirty="0">
+                        <a:latin typeface="Calibri" charset="0"/>
+                        <a:ea typeface="Calibri" charset="0"/>
+                        <a:cs typeface="Calibri" charset="0"/>
+                      </a:endParaRPr>
+                    </a:p>
+                  </a:txBody>
+                  <a:tcPr marL="91440" marR="91440" marT="45720" marB="45720">
+                    <a:lnL w="12700" cap="flat" cmpd="sng" algn="ctr">
+                      <a:solidFill>
+                        <a:srgbClr val="2A3441"/>
+                      </a:solidFill>
+                      <a:prstDash val="solid"/>
+                      <a:round/>
+                      <a:headEnd type="none" w="med" len="med"/>
+                      <a:tailEnd type="none" w="med" len="med"/>
+                    </a:lnL>
+                    <a:lnR w="12700" cap="flat" cmpd="sng" algn="ctr">
+                      <a:solidFill>
+                        <a:srgbClr val="2A3441"/>
+                      </a:solidFill>
+                      <a:prstDash val="solid"/>
+                      <a:round/>
+                      <a:headEnd type="none" w="med" len="med"/>
+                      <a:tailEnd type="none" w="med" len="med"/>
+                    </a:lnR>
+                    <a:lnT w="12700" cap="flat" cmpd="sng" algn="ctr">
+                      <a:solidFill>
+                        <a:srgbClr val="2A3441"/>
+                      </a:solidFill>
+                      <a:prstDash val="solid"/>
+                      <a:round/>
+                      <a:headEnd type="none" w="med" len="med"/>
+                      <a:tailEnd type="none" w="med" len="med"/>
+                    </a:lnT>
+                    <a:lnB w="12700" cap="flat" cmpd="sng" algn="ctr">
+                      <a:solidFill>
+                        <a:srgbClr val="2A3441"/>
+                      </a:solidFill>
+                      <a:prstDash val="solid"/>
+                      <a:round/>
+                      <a:headEnd type="none" w="med" len="med"/>
+                      <a:tailEnd type="none" w="med" len="med"/>
+                    </a:lnB>
+                    <a:solidFill>
+                      <a:srgbClr val="141B24"/>
+                    </a:solidFill>
+                  </a:tcPr>
+                </a:tc>
+                <a:tc>
+                  <a:txBody>
+                    <a:bodyPr/>
+                    <a:lstStyle/>
+                    <a:p>
+                      <a:pPr indent="0" marL="0">
+                        <a:buNone/>
+                      </a:pPr>
+                      <a:r>
+                        <a:rPr lang="en-US" sz="1300" dirty="0">
+                          <a:solidFill>
+                            <a:srgbClr val="E6EDF3"/>
+                          </a:solidFill>
+                          <a:latin typeface="Calibri" pitchFamily="34" charset="0"/>
+                          <a:ea typeface="Calibri" pitchFamily="34" charset="-122"/>
+                          <a:cs typeface="Calibri" pitchFamily="34" charset="-120"/>
+                        </a:rPr>
+                        <a:t>12.9</a:t>
+                      </a:r>
+                      <a:endParaRPr lang="en-US" sz="1300" dirty="0">
+                        <a:latin typeface="Calibri" charset="0"/>
+                        <a:ea typeface="Calibri" charset="0"/>
+                        <a:cs typeface="Calibri" charset="0"/>
+                      </a:endParaRPr>
+                    </a:p>
+                  </a:txBody>
+                  <a:tcPr marL="91440" marR="91440" marT="45720" marB="45720">
+                    <a:lnL w="12700" cap="flat" cmpd="sng" algn="ctr">
+                      <a:solidFill>
+                        <a:srgbClr val="2A3441"/>
+                      </a:solidFill>
+                      <a:prstDash val="solid"/>
+                      <a:round/>
+                      <a:headEnd type="none" w="med" len="med"/>
+                      <a:tailEnd type="none" w="med" len="med"/>
+                    </a:lnL>
+                    <a:lnR w="12700" cap="flat" cmpd="sng" algn="ctr">
+                      <a:solidFill>
+                        <a:srgbClr val="2A3441"/>
+                      </a:solidFill>
+                      <a:prstDash val="solid"/>
+                      <a:round/>
+                      <a:headEnd type="none" w="med" len="med"/>
+                      <a:tailEnd type="none" w="med" len="med"/>
+                    </a:lnR>
+                    <a:lnT w="12700" cap="flat" cmpd="sng" algn="ctr">
+                      <a:solidFill>
+                        <a:srgbClr val="2A3441"/>
+                      </a:solidFill>
+                      <a:prstDash val="solid"/>
+                      <a:round/>
+                      <a:headEnd type="none" w="med" len="med"/>
+                      <a:tailEnd type="none" w="med" len="med"/>
+                    </a:lnT>
+                    <a:lnB w="12700" cap="flat" cmpd="sng" algn="ctr">
+                      <a:solidFill>
+                        <a:srgbClr val="2A3441"/>
+                      </a:solidFill>
+                      <a:prstDash val="solid"/>
+                      <a:round/>
+                      <a:headEnd type="none" w="med" len="med"/>
+                      <a:tailEnd type="none" w="med" len="med"/>
+                    </a:lnB>
+                    <a:solidFill>
+                      <a:srgbClr val="141B24"/>
+                    </a:solidFill>
+                  </a:tcPr>
+                </a:tc>
+                <a:tc>
+                  <a:txBody>
+                    <a:bodyPr/>
+                    <a:lstStyle/>
+                    <a:p>
+                      <a:pPr indent="0" marL="0">
+                        <a:buNone/>
+                      </a:pPr>
+                      <a:r>
+                        <a:rPr lang="en-US" sz="1300" dirty="0">
+                          <a:solidFill>
+                            <a:srgbClr val="E6EDF3"/>
+                          </a:solidFill>
+                          <a:latin typeface="Calibri" pitchFamily="34" charset="0"/>
+                          <a:ea typeface="Calibri" pitchFamily="34" charset="-122"/>
+                          <a:cs typeface="Calibri" pitchFamily="34" charset="-120"/>
+                        </a:rPr>
+                        <a:t>50%</a:t>
+                      </a:r>
+                      <a:endParaRPr lang="en-US" sz="1300" dirty="0">
+                        <a:latin typeface="Calibri" charset="0"/>
+                        <a:ea typeface="Calibri" charset="0"/>
+                        <a:cs typeface="Calibri" charset="0"/>
+                      </a:endParaRPr>
+                    </a:p>
+                  </a:txBody>
+                  <a:tcPr marL="91440" marR="91440" marT="45720" marB="45720">
+                    <a:lnL w="12700" cap="flat" cmpd="sng" algn="ctr">
+                      <a:solidFill>
+                        <a:srgbClr val="2A3441"/>
+                      </a:solidFill>
+                      <a:prstDash val="solid"/>
+                      <a:round/>
+                      <a:headEnd type="none" w="med" len="med"/>
+                      <a:tailEnd type="none" w="med" len="med"/>
+                    </a:lnL>
+                    <a:lnR w="12700" cap="flat" cmpd="sng" algn="ctr">
+                      <a:solidFill>
+                        <a:srgbClr val="2A3441"/>
+                      </a:solidFill>
+                      <a:prstDash val="solid"/>
+                      <a:round/>
+                      <a:headEnd type="none" w="med" len="med"/>
+                      <a:tailEnd type="none" w="med" len="med"/>
+                    </a:lnR>
+                    <a:lnT w="12700" cap="flat" cmpd="sng" algn="ctr">
+                      <a:solidFill>
+                        <a:srgbClr val="2A3441"/>
+                      </a:solidFill>
+                      <a:prstDash val="solid"/>
+                      <a:round/>
+                      <a:headEnd type="none" w="med" len="med"/>
+                      <a:tailEnd type="none" w="med" len="med"/>
+                    </a:lnT>
+                    <a:lnB w="12700" cap="flat" cmpd="sng" algn="ctr">
+                      <a:solidFill>
+                        <a:srgbClr val="2A3441"/>
+                      </a:solidFill>
+                      <a:prstDash val="solid"/>
+                      <a:round/>
+                      <a:headEnd type="none" w="med" len="med"/>
+                      <a:tailEnd type="none" w="med" len="med"/>
+                    </a:lnB>
+                    <a:solidFill>
+                      <a:srgbClr val="141B24"/>
+                    </a:solidFill>
+                  </a:tcPr>
+                </a:tc>
+              </a:tr>
+              <a:tr h="420624">
+                <a:tc>
+                  <a:txBody>
+                    <a:bodyPr/>
+                    <a:lstStyle/>
+                    <a:p>
+                      <a:pPr indent="0" marL="0">
+                        <a:buNone/>
+                      </a:pPr>
+                      <a:r>
+                        <a:rPr lang="en-US" sz="1300" dirty="0">
+                          <a:solidFill>
+                            <a:srgbClr val="E6EDF3"/>
+                          </a:solidFill>
+                          <a:latin typeface="Calibri" pitchFamily="34" charset="0"/>
+                          <a:ea typeface="Calibri" pitchFamily="34" charset="-122"/>
+                          <a:cs typeface="Calibri" pitchFamily="34" charset="-120"/>
+                        </a:rPr>
+                        <a:t>Hostile, 10% loss</a:t>
+                      </a:r>
+                      <a:endParaRPr lang="en-US" sz="1300" dirty="0">
+                        <a:latin typeface="Calibri" charset="0"/>
+                        <a:ea typeface="Calibri" charset="0"/>
+                        <a:cs typeface="Calibri" charset="0"/>
+                      </a:endParaRPr>
+                    </a:p>
+                  </a:txBody>
+                  <a:tcPr marL="91440" marR="91440" marT="45720" marB="45720">
+                    <a:lnL w="12700" cap="flat" cmpd="sng" algn="ctr">
+                      <a:solidFill>
+                        <a:srgbClr val="2A3441"/>
+                      </a:solidFill>
+                      <a:prstDash val="solid"/>
+                      <a:round/>
+                      <a:headEnd type="none" w="med" len="med"/>
+                      <a:tailEnd type="none" w="med" len="med"/>
+                    </a:lnL>
+                    <a:lnR w="12700" cap="flat" cmpd="sng" algn="ctr">
+                      <a:solidFill>
+                        <a:srgbClr val="2A3441"/>
+                      </a:solidFill>
+                      <a:prstDash val="solid"/>
+                      <a:round/>
+                      <a:headEnd type="none" w="med" len="med"/>
+                      <a:tailEnd type="none" w="med" len="med"/>
+                    </a:lnR>
+                    <a:lnT w="12700" cap="flat" cmpd="sng" algn="ctr">
+                      <a:solidFill>
+                        <a:srgbClr val="2A3441"/>
+                      </a:solidFill>
+                      <a:prstDash val="solid"/>
+                      <a:round/>
+                      <a:headEnd type="none" w="med" len="med"/>
+                      <a:tailEnd type="none" w="med" len="med"/>
+                    </a:lnT>
+                    <a:lnB w="12700" cap="flat" cmpd="sng" algn="ctr">
+                      <a:solidFill>
+                        <a:srgbClr val="2A3441"/>
+                      </a:solidFill>
+                      <a:prstDash val="solid"/>
+                      <a:round/>
+                      <a:headEnd type="none" w="med" len="med"/>
+                      <a:tailEnd type="none" w="med" len="med"/>
+                    </a:lnB>
+                    <a:solidFill>
+                      <a:srgbClr val="141B24"/>
+                    </a:solidFill>
+                  </a:tcPr>
+                </a:tc>
+                <a:tc>
+                  <a:txBody>
+                    <a:bodyPr/>
+                    <a:lstStyle/>
+                    <a:p>
+                      <a:pPr indent="0" marL="0">
+                        <a:buNone/>
+                      </a:pPr>
+                      <a:r>
+                        <a:rPr lang="en-US" sz="1300" dirty="0">
+                          <a:solidFill>
+                            <a:srgbClr val="E6EDF3"/>
+                          </a:solidFill>
+                          <a:latin typeface="Calibri" pitchFamily="34" charset="0"/>
+                          <a:ea typeface="Calibri" pitchFamily="34" charset="-122"/>
+                          <a:cs typeface="Calibri" pitchFamily="34" charset="-120"/>
+                        </a:rPr>
+                        <a:t>7.3</a:t>
+                      </a:r>
+                      <a:endParaRPr lang="en-US" sz="1300" dirty="0">
+                        <a:latin typeface="Calibri" charset="0"/>
+                        <a:ea typeface="Calibri" charset="0"/>
+                        <a:cs typeface="Calibri" charset="0"/>
+                      </a:endParaRPr>
+                    </a:p>
+                  </a:txBody>
+                  <a:tcPr marL="91440" marR="91440" marT="45720" marB="45720">
+                    <a:lnL w="12700" cap="flat" cmpd="sng" algn="ctr">
+                      <a:solidFill>
+                        <a:srgbClr val="2A3441"/>
+                      </a:solidFill>
+                      <a:prstDash val="solid"/>
+                      <a:round/>
+                      <a:headEnd type="none" w="med" len="med"/>
+                      <a:tailEnd type="none" w="med" len="med"/>
+                    </a:lnL>
+                    <a:lnR w="12700" cap="flat" cmpd="sng" algn="ctr">
+                      <a:solidFill>
+                        <a:srgbClr val="2A3441"/>
+                      </a:solidFill>
+                      <a:prstDash val="solid"/>
+                      <a:round/>
+                      <a:headEnd type="none" w="med" len="med"/>
+                      <a:tailEnd type="none" w="med" len="med"/>
+                    </a:lnR>
+                    <a:lnT w="12700" cap="flat" cmpd="sng" algn="ctr">
+                      <a:solidFill>
+                        <a:srgbClr val="2A3441"/>
+                      </a:solidFill>
+                      <a:prstDash val="solid"/>
+                      <a:round/>
+                      <a:headEnd type="none" w="med" len="med"/>
+                      <a:tailEnd type="none" w="med" len="med"/>
+                    </a:lnT>
+                    <a:lnB w="12700" cap="flat" cmpd="sng" algn="ctr">
+                      <a:solidFill>
+                        <a:srgbClr val="2A3441"/>
+                      </a:solidFill>
+                      <a:prstDash val="solid"/>
+                      <a:round/>
+                      <a:headEnd type="none" w="med" len="med"/>
+                      <a:tailEnd type="none" w="med" len="med"/>
+                    </a:lnB>
+                    <a:solidFill>
+                      <a:srgbClr val="141B24"/>
+                    </a:solidFill>
+                  </a:tcPr>
+                </a:tc>
+                <a:tc>
+                  <a:txBody>
+                    <a:bodyPr/>
+                    <a:lstStyle/>
+                    <a:p>
+                      <a:pPr indent="0" marL="0">
+                        <a:buNone/>
+                      </a:pPr>
+                      <a:r>
+                        <a:rPr lang="en-US" sz="1300" dirty="0">
+                          <a:solidFill>
+                            <a:srgbClr val="E6EDF3"/>
+                          </a:solidFill>
+                          <a:latin typeface="Calibri" pitchFamily="34" charset="0"/>
+                          <a:ea typeface="Calibri" pitchFamily="34" charset="-122"/>
+                          <a:cs typeface="Calibri" pitchFamily="34" charset="-120"/>
+                        </a:rPr>
+                        <a:t>8.1</a:t>
+                      </a:r>
+                      <a:endParaRPr lang="en-US" sz="1300" dirty="0">
+                        <a:latin typeface="Calibri" charset="0"/>
+                        <a:ea typeface="Calibri" charset="0"/>
+                        <a:cs typeface="Calibri" charset="0"/>
+                      </a:endParaRPr>
+                    </a:p>
+                  </a:txBody>
+                  <a:tcPr marL="91440" marR="91440" marT="45720" marB="45720">
+                    <a:lnL w="12700" cap="flat" cmpd="sng" algn="ctr">
+                      <a:solidFill>
+                        <a:srgbClr val="2A3441"/>
+                      </a:solidFill>
+                      <a:prstDash val="solid"/>
+                      <a:round/>
+                      <a:headEnd type="none" w="med" len="med"/>
+                      <a:tailEnd type="none" w="med" len="med"/>
+                    </a:lnL>
+                    <a:lnR w="12700" cap="flat" cmpd="sng" algn="ctr">
+                      <a:solidFill>
+                        <a:srgbClr val="2A3441"/>
+                      </a:solidFill>
+                      <a:prstDash val="solid"/>
+                      <a:round/>
+                      <a:headEnd type="none" w="med" len="med"/>
+                      <a:tailEnd type="none" w="med" len="med"/>
+                    </a:lnR>
+                    <a:lnT w="12700" cap="flat" cmpd="sng" algn="ctr">
+                      <a:solidFill>
+                        <a:srgbClr val="2A3441"/>
+                      </a:solidFill>
+                      <a:prstDash val="solid"/>
+                      <a:round/>
+                      <a:headEnd type="none" w="med" len="med"/>
+                      <a:tailEnd type="none" w="med" len="med"/>
+                    </a:lnT>
+                    <a:lnB w="12700" cap="flat" cmpd="sng" algn="ctr">
+                      <a:solidFill>
+                        <a:srgbClr val="2A3441"/>
+                      </a:solidFill>
+                      <a:prstDash val="solid"/>
+                      <a:round/>
+                      <a:headEnd type="none" w="med" len="med"/>
+                      <a:tailEnd type="none" w="med" len="med"/>
+                    </a:lnB>
+                    <a:solidFill>
+                      <a:srgbClr val="141B24"/>
+                    </a:solidFill>
+                  </a:tcPr>
+                </a:tc>
+                <a:tc>
+                  <a:txBody>
+                    <a:bodyPr/>
+                    <a:lstStyle/>
+                    <a:p>
+                      <a:pPr indent="0" marL="0">
+                        <a:buNone/>
+                      </a:pPr>
+                      <a:r>
+                        <a:rPr lang="en-US" sz="1300" dirty="0">
+                          <a:solidFill>
+                            <a:srgbClr val="E6EDF3"/>
+                          </a:solidFill>
+                          <a:latin typeface="Calibri" pitchFamily="34" charset="0"/>
+                          <a:ea typeface="Calibri" pitchFamily="34" charset="-122"/>
+                          <a:cs typeface="Calibri" pitchFamily="34" charset="-120"/>
+                        </a:rPr>
+                        <a:t>tie</a:t>
+                      </a:r>
+                      <a:endParaRPr lang="en-US" sz="1300" dirty="0">
+                        <a:latin typeface="Calibri" charset="0"/>
+                        <a:ea typeface="Calibri" charset="0"/>
+                        <a:cs typeface="Calibri" charset="0"/>
+                      </a:endParaRPr>
+                    </a:p>
+                  </a:txBody>
+                  <a:tcPr marL="91440" marR="91440" marT="45720" marB="45720">
+                    <a:lnL w="12700" cap="flat" cmpd="sng" algn="ctr">
+                      <a:solidFill>
+                        <a:srgbClr val="2A3441"/>
+                      </a:solidFill>
+                      <a:prstDash val="solid"/>
+                      <a:round/>
+                      <a:headEnd type="none" w="med" len="med"/>
+                      <a:tailEnd type="none" w="med" len="med"/>
+                    </a:lnL>
+                    <a:lnR w="12700" cap="flat" cmpd="sng" algn="ctr">
+                      <a:solidFill>
+                        <a:srgbClr val="2A3441"/>
+                      </a:solidFill>
+                      <a:prstDash val="solid"/>
+                      <a:round/>
+                      <a:headEnd type="none" w="med" len="med"/>
+                      <a:tailEnd type="none" w="med" len="med"/>
+                    </a:lnR>
+                    <a:lnT w="12700" cap="flat" cmpd="sng" algn="ctr">
+                      <a:solidFill>
+                        <a:srgbClr val="2A3441"/>
+                      </a:solidFill>
+                      <a:prstDash val="solid"/>
+                      <a:round/>
+                      <a:headEnd type="none" w="med" len="med"/>
+                      <a:tailEnd type="none" w="med" len="med"/>
+                    </a:lnT>
+                    <a:lnB w="12700" cap="flat" cmpd="sng" algn="ctr">
+                      <a:solidFill>
+                        <a:srgbClr val="2A3441"/>
+                      </a:solidFill>
+                      <a:prstDash val="solid"/>
+                      <a:round/>
+                      <a:headEnd type="none" w="med" len="med"/>
+                      <a:tailEnd type="none" w="med" len="med"/>
+                    </a:lnB>
+                    <a:solidFill>
+                      <a:srgbClr val="141B24"/>
+                    </a:solidFill>
+                  </a:tcPr>
+                </a:tc>
+              </a:tr>
+            </a:tbl>
+          </a:graphicData>
+        </a:graphic>
+      </p:graphicFrame>
+      <p:sp>
+        <p:nvSpPr>
+          <p:cNvPr id="5" name="Text 2"/>
           <p:cNvSpPr/>
           <p:nvPr/>
         </p:nvSpPr>
         <p:spPr>
           <a:xfrm>
-            <a:off x="548640" y="1371600"/>
-            <a:ext cx="5394960" cy="4206240"/>
-          </a:xfrm>
-          <a:prstGeom prst="rect">
-            <a:avLst/>
-          </a:prstGeom>
-          <a:solidFill>
-            <a:srgbClr val="141B24"/>
-          </a:solidFill>
-          <a:ln w="12700">
-            <a:solidFill>
-              <a:srgbClr val="39FF88"/>
-            </a:solidFill>
-            <a:prstDash val="solid"/>
-          </a:ln>
-        </p:spPr>
-      </p:sp>
-      <p:sp>
-        <p:nvSpPr>
-          <p:cNvPr id="5" name="Text 3"/>
-          <p:cNvSpPr/>
-          <p:nvPr/>
-        </p:nvSpPr>
-        <p:spPr>
-          <a:xfrm>
-            <a:off x="731520" y="1508760"/>
-            <a:ext cx="5029200" cy="457200"/>
+            <a:off x="6949440" y="1188720"/>
+            <a:ext cx="4846320" cy="4937760"/>
           </a:xfrm>
           <a:prstGeom prst="rect">
             <a:avLst/>
@@ -14380,37 +15846,125 @@
           <a:ln/>
         </p:spPr>
         <p:txBody>
-          <a:bodyPr wrap="square" lIns="0" tIns="0" rIns="0" bIns="0" rtlCol="0" anchor="ctr"/>
+          <a:bodyPr wrap="square" lIns="0" tIns="0" rIns="0" bIns="0" rtlCol="0" anchor="t"/>
           <a:lstStyle/>
           <a:p>
-            <a:pPr indent="0" marL="0">
-              <a:buNone/>
-            </a:pPr>
-            <a:r>
-              <a:rPr lang="en-US" sz="2000" b="1" dirty="0">
-                <a:solidFill>
-                  <a:srgbClr val="39FF88"/>
-                </a:solidFill>
-                <a:latin typeface="Courier New" pitchFamily="34" charset="0"/>
-                <a:ea typeface="Courier New" pitchFamily="34" charset="-122"/>
-                <a:cs typeface="Courier New" pitchFamily="34" charset="-120"/>
-              </a:rPr>
-              <a:t>Learned</a:t>
-            </a:r>
-            <a:endParaRPr lang="en-US" sz="2000" dirty="0"/>
-          </a:p>
-        </p:txBody>
-      </p:sp>
-      <p:sp>
-        <p:nvSpPr>
-          <p:cNvPr id="6" name="Text 4"/>
+            <a:pPr marL="342900" indent="-342900">
+              <a:spcAft>
+                <a:spcPts val="800"/>
+              </a:spcAft>
+              <a:buSzPct val="100000"/>
+              <a:buChar char="•"/>
+            </a:pPr>
+            <a:r>
+              <a:rPr lang="en-US" sz="1400" dirty="0">
+                <a:solidFill>
+                  <a:srgbClr val="E6EDF3"/>
+                </a:solidFill>
+                <a:latin typeface="Calibri" pitchFamily="34" charset="0"/>
+                <a:ea typeface="Calibri" pitchFamily="34" charset="-122"/>
+                <a:cs typeface="Calibri" pitchFamily="34" charset="-120"/>
+              </a:rPr>
+              <a:t>Receiver buffers out-of-order packets (64 window) and reports them in a bitmap in every ACK</a:t>
+            </a:r>
+            <a:endParaRPr lang="en-US" sz="1400" dirty="0"/>
+          </a:p>
+          <a:p>
+            <a:pPr marL="342900" indent="-342900">
+              <a:spcAft>
+                <a:spcPts val="800"/>
+              </a:spcAft>
+              <a:buSzPct val="100000"/>
+              <a:buChar char="•"/>
+            </a:pPr>
+            <a:r>
+              <a:rPr lang="en-US" sz="1400" dirty="0">
+                <a:solidFill>
+                  <a:srgbClr val="E6EDF3"/>
+                </a:solidFill>
+                <a:latin typeface="Calibri" pitchFamily="34" charset="0"/>
+                <a:ea typeface="Calibri" pitchFamily="34" charset="-122"/>
+                <a:cs typeface="Calibri" pitchFamily="34" charset="-120"/>
+              </a:rPr>
+              <a:t>Sender: one timer per packet; resends only the missing ones</a:t>
+            </a:r>
+            <a:endParaRPr lang="en-US" sz="1400" dirty="0"/>
+          </a:p>
+          <a:p>
+            <a:pPr marL="342900" indent="-342900">
+              <a:spcAft>
+                <a:spcPts val="800"/>
+              </a:spcAft>
+              <a:buSzPct val="100000"/>
+              <a:buChar char="•"/>
+            </a:pPr>
+            <a:r>
+              <a:rPr lang="en-US" sz="1400" dirty="0">
+                <a:solidFill>
+                  <a:srgbClr val="E6EDF3"/>
+                </a:solidFill>
+                <a:latin typeface="Calibri" pitchFamily="34" charset="0"/>
+                <a:ea typeface="Calibri" pitchFamily="34" charset="-122"/>
+                <a:cs typeface="Calibri" pitchFamily="34" charset="-120"/>
+              </a:rPr>
+              <a:t>Retransmissions drop about 10x; web chat 200 messages: 6.4 s vs 11.9 s (AIMD)</a:t>
+            </a:r>
+            <a:endParaRPr lang="en-US" sz="1400" dirty="0"/>
+          </a:p>
+          <a:p>
+            <a:pPr marL="342900" indent="-342900">
+              <a:spcAft>
+                <a:spcPts val="800"/>
+              </a:spcAft>
+              <a:buSzPct val="100000"/>
+              <a:buChar char="•"/>
+            </a:pPr>
+            <a:r>
+              <a:rPr lang="en-US" sz="1400" dirty="0">
+                <a:solidFill>
+                  <a:srgbClr val="E6EDF3"/>
+                </a:solidFill>
+                <a:latin typeface="Calibri" pitchFamily="34" charset="0"/>
+                <a:ea typeface="Calibri" pitchFamily="34" charset="-122"/>
+                <a:cs typeface="Calibri" pitchFamily="34" charset="-120"/>
+              </a:rPr>
+              <a:t>The neural agent now wins by more, and the 10% loss failure was mostly a Go-Back-N effect</a:t>
+            </a:r>
+            <a:endParaRPr lang="en-US" sz="1400" dirty="0"/>
+          </a:p>
+          <a:p>
+            <a:pPr marL="342900" indent="-342900">
+              <a:spcAft>
+                <a:spcPts val="800"/>
+              </a:spcAft>
+              <a:buSzPct val="100000"/>
+              <a:buChar char="•"/>
+            </a:pPr>
+            <a:r>
+              <a:rPr lang="en-US" sz="1400" dirty="0">
+                <a:solidFill>
+                  <a:srgbClr val="E6EDF3"/>
+                </a:solidFill>
+                <a:latin typeface="Calibri" pitchFamily="34" charset="0"/>
+                <a:ea typeface="Calibri" pitchFamily="34" charset="-122"/>
+                <a:cs typeface="Calibri" pitchFamily="34" charset="-120"/>
+              </a:rPr>
+              <a:t>Go-Back-N kept for comparison: --gbn / RUDP_GBN</a:t>
+            </a:r>
+            <a:endParaRPr lang="en-US" sz="1400" dirty="0"/>
+          </a:p>
+        </p:txBody>
+      </p:sp>
+      <p:sp>
+        <p:nvSpPr>
+          <p:cNvPr id="6" name="Text 3"/>
           <p:cNvSpPr/>
           <p:nvPr/>
         </p:nvSpPr>
         <p:spPr>
           <a:xfrm>
-            <a:off x="731520" y="2011680"/>
-            <a:ext cx="5029200" cy="3429000"/>
+            <a:off x="548640" y="3840480"/>
+            <a:ext cx="6035040" cy="731520"/>
           </a:xfrm>
           <a:prstGeom prst="rect">
             <a:avLst/>
@@ -14419,234 +15973,24 @@
           <a:ln/>
         </p:spPr>
         <p:txBody>
-          <a:bodyPr wrap="square" lIns="0" tIns="0" rIns="0" bIns="0" rtlCol="0" anchor="t"/>
+          <a:bodyPr wrap="square" lIns="0" tIns="0" rIns="0" bIns="0" rtlCol="0" anchor="ctr"/>
           <a:lstStyle/>
           <a:p>
             <a:pPr indent="0" marL="0">
               <a:buNone/>
             </a:pPr>
             <a:r>
-              <a:rPr lang="en-US" sz="2000" dirty="0">
-                <a:solidFill>
-                  <a:srgbClr val="E6EDF3"/>
+              <a:rPr lang="en-US" sz="1300" dirty="0">
+                <a:solidFill>
+                  <a:srgbClr val="8B98A5"/>
                 </a:solidFill>
                 <a:latin typeface="Calibri" pitchFamily="34" charset="0"/>
                 <a:ea typeface="Calibri" pitchFamily="34" charset="-122"/>
                 <a:cs typeface="Calibri" pitchFamily="34" charset="-120"/>
               </a:rPr>
-              <a:t>Reliability is a set of simple rules working together.</a:t>
-            </a:r>
-            <a:endParaRPr lang="en-US" sz="2000" dirty="0"/>
-          </a:p>
-          <a:p>
-            <a:pPr indent="0" marL="0">
-              <a:buNone/>
-            </a:pPr>
-            <a:r>
-              <a:rPr lang="en-US" sz="2000" dirty="0">
-                <a:solidFill>
-                  <a:srgbClr val="E6EDF3"/>
-                </a:solidFill>
-                <a:latin typeface="Calibri" pitchFamily="34" charset="0"/>
-                <a:ea typeface="Calibri" pitchFamily="34" charset="-122"/>
-                <a:cs typeface="Calibri" pitchFamily="34" charset="-120"/>
-              </a:rPr>
-              <a:t>Congestion control matters as much as retransmission.</a:t>
-            </a:r>
-            <a:endParaRPr lang="en-US" sz="2000" dirty="0"/>
-          </a:p>
-          <a:p>
-            <a:pPr indent="0" marL="0">
-              <a:buNone/>
-            </a:pPr>
-            <a:r>
-              <a:rPr lang="en-US" sz="2000" dirty="0">
-                <a:solidFill>
-                  <a:srgbClr val="E6EDF3"/>
-                </a:solidFill>
-                <a:latin typeface="Calibri" pitchFamily="34" charset="0"/>
-                <a:ea typeface="Calibri" pitchFamily="34" charset="-122"/>
-                <a:cs typeface="Calibri" pitchFamily="34" charset="-120"/>
-              </a:rPr>
-              <a:t>Testing tools fail in surprising ways.</a:t>
-            </a:r>
-            <a:endParaRPr lang="en-US" sz="2000" dirty="0"/>
-          </a:p>
-        </p:txBody>
-      </p:sp>
-      <p:sp>
-        <p:nvSpPr>
-          <p:cNvPr id="7" name="Shape 5"/>
-          <p:cNvSpPr/>
-          <p:nvPr/>
-        </p:nvSpPr>
-        <p:spPr>
-          <a:xfrm>
-            <a:off x="6217920" y="1371600"/>
-            <a:ext cx="5394960" cy="4206240"/>
-          </a:xfrm>
-          <a:prstGeom prst="rect">
-            <a:avLst/>
-          </a:prstGeom>
-          <a:solidFill>
-            <a:srgbClr val="141B24"/>
-          </a:solidFill>
-          <a:ln w="12700">
-            <a:solidFill>
-              <a:srgbClr val="FFB000"/>
-            </a:solidFill>
-            <a:prstDash val="solid"/>
-          </a:ln>
-        </p:spPr>
-      </p:sp>
-      <p:sp>
-        <p:nvSpPr>
-          <p:cNvPr id="8" name="Text 6"/>
-          <p:cNvSpPr/>
-          <p:nvPr/>
-        </p:nvSpPr>
-        <p:spPr>
-          <a:xfrm>
-            <a:off x="6400800" y="1508760"/>
-            <a:ext cx="5029200" cy="457200"/>
-          </a:xfrm>
-          <a:prstGeom prst="rect">
-            <a:avLst/>
-          </a:prstGeom>
-          <a:noFill/>
-          <a:ln/>
-        </p:spPr>
-        <p:txBody>
-          <a:bodyPr wrap="square" lIns="0" tIns="0" rIns="0" bIns="0" rtlCol="0" anchor="ctr"/>
-          <a:lstStyle/>
-          <a:p>
-            <a:pPr indent="0" marL="0">
-              <a:buNone/>
-            </a:pPr>
-            <a:r>
-              <a:rPr lang="en-US" sz="2000" b="1" dirty="0">
-                <a:solidFill>
-                  <a:srgbClr val="FFB000"/>
-                </a:solidFill>
-                <a:latin typeface="Courier New" pitchFamily="34" charset="0"/>
-                <a:ea typeface="Courier New" pitchFamily="34" charset="-122"/>
-                <a:cs typeface="Courier New" pitchFamily="34" charset="-120"/>
-              </a:rPr>
-              <a:t>Next</a:t>
-            </a:r>
-            <a:endParaRPr lang="en-US" sz="2000" dirty="0"/>
-          </a:p>
-        </p:txBody>
-      </p:sp>
-      <p:sp>
-        <p:nvSpPr>
-          <p:cNvPr id="9" name="Text 7"/>
-          <p:cNvSpPr/>
-          <p:nvPr/>
-        </p:nvSpPr>
-        <p:spPr>
-          <a:xfrm>
-            <a:off x="6400800" y="2011680"/>
-            <a:ext cx="5029200" cy="3429000"/>
-          </a:xfrm>
-          <a:prstGeom prst="rect">
-            <a:avLst/>
-          </a:prstGeom>
-          <a:noFill/>
-          <a:ln/>
-        </p:spPr>
-        <p:txBody>
-          <a:bodyPr wrap="square" lIns="0" tIns="0" rIns="0" bIns="0" rtlCol="0" anchor="t"/>
-          <a:lstStyle/>
-          <a:p>
-            <a:pPr indent="0" marL="0">
-              <a:buNone/>
-            </a:pPr>
-            <a:r>
-              <a:rPr lang="en-US" sz="2000" dirty="0">
-                <a:solidFill>
-                  <a:srgbClr val="E6EDF3"/>
-                </a:solidFill>
-                <a:latin typeface="Calibri" pitchFamily="34" charset="0"/>
-                <a:ea typeface="Calibri" pitchFamily="34" charset="-122"/>
-                <a:cs typeface="Calibri" pitchFamily="34" charset="-120"/>
-              </a:rPr>
-              <a:t>Train the neural agent in C / on real netem</a:t>
-            </a:r>
-            <a:endParaRPr lang="en-US" sz="2000" dirty="0"/>
-          </a:p>
-          <a:p>
-            <a:pPr indent="0" marL="0">
-              <a:buNone/>
-            </a:pPr>
-            <a:r>
-              <a:rPr lang="en-US" sz="2000" dirty="0">
-                <a:solidFill>
-                  <a:srgbClr val="E6EDF3"/>
-                </a:solidFill>
-                <a:latin typeface="Calibri" pitchFamily="34" charset="0"/>
-                <a:ea typeface="Calibri" pitchFamily="34" charset="-122"/>
-                <a:cs typeface="Calibri" pitchFamily="34" charset="-120"/>
-              </a:rPr>
-              <a:t>Selective ACK where throughput limits the path</a:t>
-            </a:r>
-            <a:endParaRPr lang="en-US" sz="2000" dirty="0"/>
-          </a:p>
-          <a:p>
-            <a:pPr indent="0" marL="0">
-              <a:buNone/>
-            </a:pPr>
-            <a:r>
-              <a:rPr lang="en-US" sz="2000" dirty="0">
-                <a:solidFill>
-                  <a:srgbClr val="E6EDF3"/>
-                </a:solidFill>
-                <a:latin typeface="Calibri" pitchFamily="34" charset="0"/>
-                <a:ea typeface="Calibri" pitchFamily="34" charset="-122"/>
-                <a:cs typeface="Calibri" pitchFamily="34" charset="-120"/>
-              </a:rPr>
-              <a:t>Kernel netem and real multi-machine tests</a:t>
-            </a:r>
-            <a:endParaRPr lang="en-US" sz="2000" dirty="0"/>
-          </a:p>
-        </p:txBody>
-      </p:sp>
-      <p:sp>
-        <p:nvSpPr>
-          <p:cNvPr id="10" name="Text 8"/>
-          <p:cNvSpPr/>
-          <p:nvPr/>
-        </p:nvSpPr>
-        <p:spPr>
-          <a:xfrm>
-            <a:off x="548640" y="5852160"/>
-            <a:ext cx="10972800" cy="365760"/>
-          </a:xfrm>
-          <a:prstGeom prst="rect">
-            <a:avLst/>
-          </a:prstGeom>
-          <a:noFill/>
-          <a:ln/>
-        </p:spPr>
-        <p:txBody>
-          <a:bodyPr wrap="square" lIns="0" tIns="0" rIns="0" bIns="0" rtlCol="0" anchor="ctr"/>
-          <a:lstStyle/>
-          <a:p>
-            <a:pPr indent="0" marL="0">
-              <a:buNone/>
-            </a:pPr>
-            <a:r>
-              <a:rPr lang="en-US" sz="1400" dirty="0">
-                <a:solidFill>
-                  <a:srgbClr val="8B98A5"/>
-                </a:solidFill>
-                <a:latin typeface="Calibri" pitchFamily="34" charset="0"/>
-                <a:ea typeface="Calibri" pitchFamily="34" charset="-122"/>
-                <a:cs typeface="Calibri" pitchFamily="34" charset="-120"/>
-              </a:rPr>
-              <a:t>Limits: Go-Back-N wastes bandwidth and suffers under reordering; C tests use an emulated path; the tabular agent did not beat AIMD in C.</a:t>
-            </a:r>
-            <a:endParaRPr lang="en-US" sz="1400" dirty="0"/>
+              <a:t>10 runs per cell (hostile: 5), 95% intervals, all gains significant except the hostile row. Code: eval_ci7.sh.</a:t>
+            </a:r>
+            <a:endParaRPr lang="en-US" sz="1300" dirty="0"/>
           </a:p>
         </p:txBody>
       </p:sp>
@@ -14690,8 +16034,8 @@
         </p:nvSpPr>
         <p:spPr>
           <a:xfrm>
-            <a:off x="731520" y="2103120"/>
-            <a:ext cx="10058400" cy="1097280"/>
+            <a:off x="548640" y="320040"/>
+            <a:ext cx="11064240" cy="731520"/>
           </a:xfrm>
           <a:prstGeom prst="rect">
             <a:avLst/>
@@ -14707,7 +16051,7 @@
               <a:buNone/>
             </a:pPr>
             <a:r>
-              <a:rPr lang="en-US" sz="6400" b="1" dirty="0">
+              <a:rPr lang="en-US" sz="3000" b="1" dirty="0">
                 <a:solidFill>
                   <a:srgbClr val="39FF88"/>
                 </a:solidFill>
@@ -14715,9 +16059,9 @@
                 <a:ea typeface="Courier New" pitchFamily="34" charset="-122"/>
                 <a:cs typeface="Courier New" pitchFamily="34" charset="-120"/>
               </a:rPr>
-              <a:t>Thank you</a:t>
-            </a:r>
-            <a:endParaRPr lang="en-US" sz="6400" dirty="0"/>
+              <a:t>Learnings and future work</a:t>
+            </a:r>
+            <a:endParaRPr lang="en-US" sz="3000" dirty="0"/>
           </a:p>
         </p:txBody>
       </p:sp>
@@ -14729,8 +16073,8 @@
         </p:nvSpPr>
         <p:spPr>
           <a:xfrm>
-            <a:off x="731520" y="3474720"/>
-            <a:ext cx="10058400" cy="548640"/>
+            <a:off x="9418320" y="6446520"/>
+            <a:ext cx="2377440" cy="274320"/>
           </a:xfrm>
           <a:prstGeom prst="rect">
             <a:avLst/>
@@ -14742,34 +16086,59 @@
           <a:bodyPr wrap="square" lIns="0" tIns="0" rIns="0" bIns="0" rtlCol="0" anchor="ctr"/>
           <a:lstStyle/>
           <a:p>
-            <a:pPr indent="0" marL="0">
+            <a:pPr algn="r" indent="0" marL="0">
               <a:buNone/>
             </a:pPr>
             <a:r>
-              <a:rPr lang="en-US" sz="2600" dirty="0">
-                <a:solidFill>
-                  <a:srgbClr val="E6EDF3"/>
+              <a:rPr lang="en-US" sz="1000" dirty="0">
+                <a:solidFill>
+                  <a:srgbClr val="8B98A5"/>
                 </a:solidFill>
                 <a:latin typeface="Courier New" pitchFamily="34" charset="0"/>
                 <a:ea typeface="Courier New" pitchFamily="34" charset="-122"/>
                 <a:cs typeface="Courier New" pitchFamily="34" charset="-120"/>
               </a:rPr>
-              <a:t>github.com/Capsturrrr/rudp</a:t>
-            </a:r>
-            <a:endParaRPr lang="en-US" sz="2600" dirty="0"/>
-          </a:p>
-        </p:txBody>
-      </p:sp>
-      <p:sp>
-        <p:nvSpPr>
-          <p:cNvPr id="4" name="Text 2"/>
+              <a:t>26 / 27   Smart-RUDP</a:t>
+            </a:r>
+            <a:endParaRPr lang="en-US" sz="1000" dirty="0"/>
+          </a:p>
+        </p:txBody>
+      </p:sp>
+      <p:sp>
+        <p:nvSpPr>
+          <p:cNvPr id="4" name="Shape 2"/>
           <p:cNvSpPr/>
           <p:nvPr/>
         </p:nvSpPr>
         <p:spPr>
           <a:xfrm>
-            <a:off x="731520" y="4206240"/>
-            <a:ext cx="10058400" cy="457200"/>
+            <a:off x="548640" y="1371600"/>
+            <a:ext cx="5394960" cy="4206240"/>
+          </a:xfrm>
+          <a:prstGeom prst="rect">
+            <a:avLst/>
+          </a:prstGeom>
+          <a:solidFill>
+            <a:srgbClr val="141B24"/>
+          </a:solidFill>
+          <a:ln w="12700">
+            <a:solidFill>
+              <a:srgbClr val="39FF88"/>
+            </a:solidFill>
+            <a:prstDash val="solid"/>
+          </a:ln>
+        </p:spPr>
+      </p:sp>
+      <p:sp>
+        <p:nvSpPr>
+          <p:cNvPr id="5" name="Text 3"/>
+          <p:cNvSpPr/>
+          <p:nvPr/>
+        </p:nvSpPr>
+        <p:spPr>
+          <a:xfrm>
+            <a:off x="731520" y="1508760"/>
+            <a:ext cx="5029200" cy="457200"/>
           </a:xfrm>
           <a:prstGeom prst="rect">
             <a:avLst/>
@@ -14785,17 +16154,266 @@
               <a:buNone/>
             </a:pPr>
             <a:r>
-              <a:rPr lang="en-US" sz="1800" dirty="0">
-                <a:solidFill>
-                  <a:srgbClr val="8B98A5"/>
+              <a:rPr lang="en-US" sz="2000" b="1" dirty="0">
+                <a:solidFill>
+                  <a:srgbClr val="39FF88"/>
+                </a:solidFill>
+                <a:latin typeface="Courier New" pitchFamily="34" charset="0"/>
+                <a:ea typeface="Courier New" pitchFamily="34" charset="-122"/>
+                <a:cs typeface="Courier New" pitchFamily="34" charset="-120"/>
+              </a:rPr>
+              <a:t>Learned</a:t>
+            </a:r>
+            <a:endParaRPr lang="en-US" sz="2000" dirty="0"/>
+          </a:p>
+        </p:txBody>
+      </p:sp>
+      <p:sp>
+        <p:nvSpPr>
+          <p:cNvPr id="6" name="Text 4"/>
+          <p:cNvSpPr/>
+          <p:nvPr/>
+        </p:nvSpPr>
+        <p:spPr>
+          <a:xfrm>
+            <a:off x="731520" y="2011680"/>
+            <a:ext cx="5029200" cy="3429000"/>
+          </a:xfrm>
+          <a:prstGeom prst="rect">
+            <a:avLst/>
+          </a:prstGeom>
+          <a:noFill/>
+          <a:ln/>
+        </p:spPr>
+        <p:txBody>
+          <a:bodyPr wrap="square" lIns="0" tIns="0" rIns="0" bIns="0" rtlCol="0" anchor="t"/>
+          <a:lstStyle/>
+          <a:p>
+            <a:pPr indent="0" marL="0">
+              <a:buNone/>
+            </a:pPr>
+            <a:r>
+              <a:rPr lang="en-US" sz="2000" dirty="0">
+                <a:solidFill>
+                  <a:srgbClr val="E6EDF3"/>
                 </a:solidFill>
                 <a:latin typeface="Calibri" pitchFamily="34" charset="0"/>
                 <a:ea typeface="Calibri" pitchFamily="34" charset="-122"/>
                 <a:cs typeface="Calibri" pitchFamily="34" charset="-120"/>
               </a:rPr>
-              <a:t>Harshavardhan Mallela   Rohit Arya   Shloak Sinha</a:t>
-            </a:r>
-            <a:endParaRPr lang="en-US" sz="1800" dirty="0"/>
+              <a:t>Reliability is a set of simple rules working together.</a:t>
+            </a:r>
+            <a:endParaRPr lang="en-US" sz="2000" dirty="0"/>
+          </a:p>
+          <a:p>
+            <a:pPr indent="0" marL="0">
+              <a:buNone/>
+            </a:pPr>
+            <a:r>
+              <a:rPr lang="en-US" sz="2000" dirty="0">
+                <a:solidFill>
+                  <a:srgbClr val="E6EDF3"/>
+                </a:solidFill>
+                <a:latin typeface="Calibri" pitchFamily="34" charset="0"/>
+                <a:ea typeface="Calibri" pitchFamily="34" charset="-122"/>
+                <a:cs typeface="Calibri" pitchFamily="34" charset="-120"/>
+              </a:rPr>
+              <a:t>Congestion control matters as much as retransmission.</a:t>
+            </a:r>
+            <a:endParaRPr lang="en-US" sz="2000" dirty="0"/>
+          </a:p>
+          <a:p>
+            <a:pPr indent="0" marL="0">
+              <a:buNone/>
+            </a:pPr>
+            <a:r>
+              <a:rPr lang="en-US" sz="2000" dirty="0">
+                <a:solidFill>
+                  <a:srgbClr val="E6EDF3"/>
+                </a:solidFill>
+                <a:latin typeface="Calibri" pitchFamily="34" charset="0"/>
+                <a:ea typeface="Calibri" pitchFamily="34" charset="-122"/>
+                <a:cs typeface="Calibri" pitchFamily="34" charset="-120"/>
+              </a:rPr>
+              <a:t>Testing tools fail in surprising ways.</a:t>
+            </a:r>
+            <a:endParaRPr lang="en-US" sz="2000" dirty="0"/>
+          </a:p>
+        </p:txBody>
+      </p:sp>
+      <p:sp>
+        <p:nvSpPr>
+          <p:cNvPr id="7" name="Shape 5"/>
+          <p:cNvSpPr/>
+          <p:nvPr/>
+        </p:nvSpPr>
+        <p:spPr>
+          <a:xfrm>
+            <a:off x="6217920" y="1371600"/>
+            <a:ext cx="5394960" cy="4206240"/>
+          </a:xfrm>
+          <a:prstGeom prst="rect">
+            <a:avLst/>
+          </a:prstGeom>
+          <a:solidFill>
+            <a:srgbClr val="141B24"/>
+          </a:solidFill>
+          <a:ln w="12700">
+            <a:solidFill>
+              <a:srgbClr val="FFB000"/>
+            </a:solidFill>
+            <a:prstDash val="solid"/>
+          </a:ln>
+        </p:spPr>
+      </p:sp>
+      <p:sp>
+        <p:nvSpPr>
+          <p:cNvPr id="8" name="Text 6"/>
+          <p:cNvSpPr/>
+          <p:nvPr/>
+        </p:nvSpPr>
+        <p:spPr>
+          <a:xfrm>
+            <a:off x="6400800" y="1508760"/>
+            <a:ext cx="5029200" cy="457200"/>
+          </a:xfrm>
+          <a:prstGeom prst="rect">
+            <a:avLst/>
+          </a:prstGeom>
+          <a:noFill/>
+          <a:ln/>
+        </p:spPr>
+        <p:txBody>
+          <a:bodyPr wrap="square" lIns="0" tIns="0" rIns="0" bIns="0" rtlCol="0" anchor="ctr"/>
+          <a:lstStyle/>
+          <a:p>
+            <a:pPr indent="0" marL="0">
+              <a:buNone/>
+            </a:pPr>
+            <a:r>
+              <a:rPr lang="en-US" sz="2000" b="1" dirty="0">
+                <a:solidFill>
+                  <a:srgbClr val="FFB000"/>
+                </a:solidFill>
+                <a:latin typeface="Courier New" pitchFamily="34" charset="0"/>
+                <a:ea typeface="Courier New" pitchFamily="34" charset="-122"/>
+                <a:cs typeface="Courier New" pitchFamily="34" charset="-120"/>
+              </a:rPr>
+              <a:t>Next</a:t>
+            </a:r>
+            <a:endParaRPr lang="en-US" sz="2000" dirty="0"/>
+          </a:p>
+        </p:txBody>
+      </p:sp>
+      <p:sp>
+        <p:nvSpPr>
+          <p:cNvPr id="9" name="Text 7"/>
+          <p:cNvSpPr/>
+          <p:nvPr/>
+        </p:nvSpPr>
+        <p:spPr>
+          <a:xfrm>
+            <a:off x="6400800" y="2011680"/>
+            <a:ext cx="5029200" cy="3429000"/>
+          </a:xfrm>
+          <a:prstGeom prst="rect">
+            <a:avLst/>
+          </a:prstGeom>
+          <a:noFill/>
+          <a:ln/>
+        </p:spPr>
+        <p:txBody>
+          <a:bodyPr wrap="square" lIns="0" tIns="0" rIns="0" bIns="0" rtlCol="0" anchor="t"/>
+          <a:lstStyle/>
+          <a:p>
+            <a:pPr indent="0" marL="0">
+              <a:buNone/>
+            </a:pPr>
+            <a:r>
+              <a:rPr lang="en-US" sz="2000" dirty="0">
+                <a:solidFill>
+                  <a:srgbClr val="E6EDF3"/>
+                </a:solidFill>
+                <a:latin typeface="Calibri" pitchFamily="34" charset="0"/>
+                <a:ea typeface="Calibri" pitchFamily="34" charset="-122"/>
+                <a:cs typeface="Calibri" pitchFamily="34" charset="-120"/>
+              </a:rPr>
+              <a:t>Train the neural agent in C / on real netem</a:t>
+            </a:r>
+            <a:endParaRPr lang="en-US" sz="2000" dirty="0"/>
+          </a:p>
+          <a:p>
+            <a:pPr indent="0" marL="0">
+              <a:buNone/>
+            </a:pPr>
+            <a:r>
+              <a:rPr lang="en-US" sz="2000" dirty="0">
+                <a:solidFill>
+                  <a:srgbClr val="E6EDF3"/>
+                </a:solidFill>
+                <a:latin typeface="Calibri" pitchFamily="34" charset="0"/>
+                <a:ea typeface="Calibri" pitchFamily="34" charset="-122"/>
+                <a:cs typeface="Calibri" pitchFamily="34" charset="-120"/>
+              </a:rPr>
+              <a:t>Selective ACK where throughput limits the path</a:t>
+            </a:r>
+            <a:endParaRPr lang="en-US" sz="2000" dirty="0"/>
+          </a:p>
+          <a:p>
+            <a:pPr indent="0" marL="0">
+              <a:buNone/>
+            </a:pPr>
+            <a:r>
+              <a:rPr lang="en-US" sz="2000" dirty="0">
+                <a:solidFill>
+                  <a:srgbClr val="E6EDF3"/>
+                </a:solidFill>
+                <a:latin typeface="Calibri" pitchFamily="34" charset="0"/>
+                <a:ea typeface="Calibri" pitchFamily="34" charset="-122"/>
+                <a:cs typeface="Calibri" pitchFamily="34" charset="-120"/>
+              </a:rPr>
+              <a:t>Kernel netem and real multi-machine tests</a:t>
+            </a:r>
+            <a:endParaRPr lang="en-US" sz="2000" dirty="0"/>
+          </a:p>
+        </p:txBody>
+      </p:sp>
+      <p:sp>
+        <p:nvSpPr>
+          <p:cNvPr id="10" name="Text 8"/>
+          <p:cNvSpPr/>
+          <p:nvPr/>
+        </p:nvSpPr>
+        <p:spPr>
+          <a:xfrm>
+            <a:off x="548640" y="5852160"/>
+            <a:ext cx="10972800" cy="365760"/>
+          </a:xfrm>
+          <a:prstGeom prst="rect">
+            <a:avLst/>
+          </a:prstGeom>
+          <a:noFill/>
+          <a:ln/>
+        </p:spPr>
+        <p:txBody>
+          <a:bodyPr wrap="square" lIns="0" tIns="0" rIns="0" bIns="0" rtlCol="0" anchor="ctr"/>
+          <a:lstStyle/>
+          <a:p>
+            <a:pPr indent="0" marL="0">
+              <a:buNone/>
+            </a:pPr>
+            <a:r>
+              <a:rPr lang="en-US" sz="1400" dirty="0">
+                <a:solidFill>
+                  <a:srgbClr val="8B98A5"/>
+                </a:solidFill>
+                <a:latin typeface="Calibri" pitchFamily="34" charset="0"/>
+                <a:ea typeface="Calibri" pitchFamily="34" charset="-122"/>
+                <a:cs typeface="Calibri" pitchFamily="34" charset="-120"/>
+              </a:rPr>
+              <a:t>Limits: Go-Back-N wastes bandwidth and suffers under reordering; C tests use an emulated path; the tabular agent did not beat AIMD in C.</a:t>
+            </a:r>
+            <a:endParaRPr lang="en-US" sz="1400" dirty="0"/>
           </a:p>
         </p:txBody>
       </p:sp>
@@ -14839,6 +16457,155 @@
         </p:nvSpPr>
         <p:spPr>
           <a:xfrm>
+            <a:off x="731520" y="2103120"/>
+            <a:ext cx="10058400" cy="1097280"/>
+          </a:xfrm>
+          <a:prstGeom prst="rect">
+            <a:avLst/>
+          </a:prstGeom>
+          <a:noFill/>
+          <a:ln/>
+        </p:spPr>
+        <p:txBody>
+          <a:bodyPr wrap="square" lIns="0" tIns="0" rIns="0" bIns="0" rtlCol="0" anchor="ctr"/>
+          <a:lstStyle/>
+          <a:p>
+            <a:pPr indent="0" marL="0">
+              <a:buNone/>
+            </a:pPr>
+            <a:r>
+              <a:rPr lang="en-US" sz="6400" b="1" dirty="0">
+                <a:solidFill>
+                  <a:srgbClr val="39FF88"/>
+                </a:solidFill>
+                <a:latin typeface="Courier New" pitchFamily="34" charset="0"/>
+                <a:ea typeface="Courier New" pitchFamily="34" charset="-122"/>
+                <a:cs typeface="Courier New" pitchFamily="34" charset="-120"/>
+              </a:rPr>
+              <a:t>Thank you</a:t>
+            </a:r>
+            <a:endParaRPr lang="en-US" sz="6400" dirty="0"/>
+          </a:p>
+        </p:txBody>
+      </p:sp>
+      <p:sp>
+        <p:nvSpPr>
+          <p:cNvPr id="3" name="Text 1"/>
+          <p:cNvSpPr/>
+          <p:nvPr/>
+        </p:nvSpPr>
+        <p:spPr>
+          <a:xfrm>
+            <a:off x="731520" y="3474720"/>
+            <a:ext cx="10058400" cy="548640"/>
+          </a:xfrm>
+          <a:prstGeom prst="rect">
+            <a:avLst/>
+          </a:prstGeom>
+          <a:noFill/>
+          <a:ln/>
+        </p:spPr>
+        <p:txBody>
+          <a:bodyPr wrap="square" lIns="0" tIns="0" rIns="0" bIns="0" rtlCol="0" anchor="ctr"/>
+          <a:lstStyle/>
+          <a:p>
+            <a:pPr indent="0" marL="0">
+              <a:buNone/>
+            </a:pPr>
+            <a:r>
+              <a:rPr lang="en-US" sz="2600" dirty="0">
+                <a:solidFill>
+                  <a:srgbClr val="E6EDF3"/>
+                </a:solidFill>
+                <a:latin typeface="Courier New" pitchFamily="34" charset="0"/>
+                <a:ea typeface="Courier New" pitchFamily="34" charset="-122"/>
+                <a:cs typeface="Courier New" pitchFamily="34" charset="-120"/>
+              </a:rPr>
+              <a:t>github.com/Capsturrrr/rudp</a:t>
+            </a:r>
+            <a:endParaRPr lang="en-US" sz="2600" dirty="0"/>
+          </a:p>
+        </p:txBody>
+      </p:sp>
+      <p:sp>
+        <p:nvSpPr>
+          <p:cNvPr id="4" name="Text 2"/>
+          <p:cNvSpPr/>
+          <p:nvPr/>
+        </p:nvSpPr>
+        <p:spPr>
+          <a:xfrm>
+            <a:off x="731520" y="4206240"/>
+            <a:ext cx="10058400" cy="457200"/>
+          </a:xfrm>
+          <a:prstGeom prst="rect">
+            <a:avLst/>
+          </a:prstGeom>
+          <a:noFill/>
+          <a:ln/>
+        </p:spPr>
+        <p:txBody>
+          <a:bodyPr wrap="square" lIns="0" tIns="0" rIns="0" bIns="0" rtlCol="0" anchor="ctr"/>
+          <a:lstStyle/>
+          <a:p>
+            <a:pPr indent="0" marL="0">
+              <a:buNone/>
+            </a:pPr>
+            <a:r>
+              <a:rPr lang="en-US" sz="1800" dirty="0">
+                <a:solidFill>
+                  <a:srgbClr val="8B98A5"/>
+                </a:solidFill>
+                <a:latin typeface="Calibri" pitchFamily="34" charset="0"/>
+                <a:ea typeface="Calibri" pitchFamily="34" charset="-122"/>
+                <a:cs typeface="Calibri" pitchFamily="34" charset="-120"/>
+              </a:rPr>
+              <a:t>Harshavardhan Mallela   Rohit Arya   Shloak Sinha</a:t>
+            </a:r>
+            <a:endParaRPr lang="en-US" sz="1800" dirty="0"/>
+          </a:p>
+        </p:txBody>
+      </p:sp>
+    </p:spTree>
+  </p:cSld>
+  <p:clrMapOvr>
+    <a:masterClrMapping/>
+  </p:clrMapOvr>
+</p:sld>
+</file>
+
+<file path=ppt/slides/slide28.xml><?xml version="1.0" encoding="utf-8"?>
+<p:sld xmlns:a="http://schemas.openxmlformats.org/drawingml/2006/main" xmlns:r="http://schemas.openxmlformats.org/officeDocument/2006/relationships" xmlns:p="http://schemas.openxmlformats.org/presentationml/2006/main">
+  <p:cSld name="Slide 28">
+    <p:bg>
+      <p:bgPr>
+        <a:solidFill>
+          <a:srgbClr val="0B0F14"/>
+        </a:solidFill>
+      </p:bgPr>
+    </p:bg>
+    <p:spTree>
+      <p:nvGrpSpPr>
+        <p:cNvPr id="1" name=""/>
+        <p:cNvGrpSpPr/>
+        <p:nvPr/>
+      </p:nvGrpSpPr>
+      <p:grpSpPr>
+        <a:xfrm>
+          <a:off x="0" y="0"/>
+          <a:ext cx="0" cy="0"/>
+          <a:chOff x="0" y="0"/>
+          <a:chExt cx="0" cy="0"/>
+        </a:xfrm>
+      </p:grpSpPr>
+      <p:sp>
+        <p:nvSpPr>
+          <p:cNvPr id="2" name="Text 0"/>
+          <p:cNvSpPr/>
+          <p:nvPr/>
+        </p:nvSpPr>
+        <p:spPr>
+          <a:xfrm>
             <a:off x="548640" y="320040"/>
             <a:ext cx="11064240" cy="731520"/>
           </a:xfrm>
@@ -15143,7 +16910,7 @@
                 <a:ea typeface="Courier New" pitchFamily="34" charset="-122"/>
                 <a:cs typeface="Courier New" pitchFamily="34" charset="-120"/>
               </a:rPr>
-              <a:t>3 / 26   Smart-RUDP</a:t>
+              <a:t>3 / 27   Smart-RUDP</a:t>
             </a:r>
             <a:endParaRPr lang="en-US" sz="1000" dirty="0"/>
           </a:p>
@@ -15537,7 +17304,7 @@
                 <a:ea typeface="Courier New" pitchFamily="34" charset="-122"/>
                 <a:cs typeface="Courier New" pitchFamily="34" charset="-120"/>
               </a:rPr>
-              <a:t>4 / 26   Smart-RUDP</a:t>
+              <a:t>4 / 27   Smart-RUDP</a:t>
             </a:r>
             <a:endParaRPr lang="en-US" sz="1000" dirty="0"/>
           </a:p>
@@ -16098,7 +17865,7 @@
                 <a:ea typeface="Courier New" pitchFamily="34" charset="-122"/>
                 <a:cs typeface="Courier New" pitchFamily="34" charset="-120"/>
               </a:rPr>
-              <a:t>5 / 26   Smart-RUDP</a:t>
+              <a:t>5 / 27   Smart-RUDP</a:t>
             </a:r>
             <a:endParaRPr lang="en-US" sz="1000" dirty="0"/>
           </a:p>
@@ -17537,7 +19304,7 @@
                 <a:ea typeface="Courier New" pitchFamily="34" charset="-122"/>
                 <a:cs typeface="Courier New" pitchFamily="34" charset="-120"/>
               </a:rPr>
-              <a:t>6 / 26   Smart-RUDP</a:t>
+              <a:t>6 / 27   Smart-RUDP</a:t>
             </a:r>
             <a:endParaRPr lang="en-US" sz="1000" dirty="0"/>
           </a:p>
@@ -18772,7 +20539,7 @@
                 <a:ea typeface="Courier New" pitchFamily="34" charset="-122"/>
                 <a:cs typeface="Courier New" pitchFamily="34" charset="-120"/>
               </a:rPr>
-              <a:t>7 / 26   Smart-RUDP</a:t>
+              <a:t>7 / 27   Smart-RUDP</a:t>
             </a:r>
             <a:endParaRPr lang="en-US" sz="1000" dirty="0"/>
           </a:p>
@@ -19215,7 +20982,7 @@
                 <a:ea typeface="Courier New" pitchFamily="34" charset="-122"/>
                 <a:cs typeface="Courier New" pitchFamily="34" charset="-120"/>
               </a:rPr>
-              <a:t>8 / 26   Smart-RUDP</a:t>
+              <a:t>8 / 27   Smart-RUDP</a:t>
             </a:r>
             <a:endParaRPr lang="en-US" sz="1000" dirty="0"/>
           </a:p>
@@ -19515,7 +21282,7 @@
                 <a:ea typeface="Courier New" pitchFamily="34" charset="-122"/>
                 <a:cs typeface="Courier New" pitchFamily="34" charset="-120"/>
               </a:rPr>
-              <a:t>9 / 26   Smart-RUDP</a:t>
+              <a:t>9 / 27   Smart-RUDP</a:t>
             </a:r>
             <a:endParaRPr lang="en-US" sz="1000" dirty="0"/>
           </a:p>

</xml_diff>

<commit_message>
Performance pass: 256-packet receive window, larger caps, tuned AIMD baseline, CUBIC, neural agent defaults (cap 128 + hand-over); eval_perf*; docs
Co-Authored-By: Claude Sonnet 5.5 <noreply@anthropic.com>
Claude-Session: https://claude.ai/code/session_01NX2zRNpdVAnzFNKmqomzKu
</commit_message>
<xml_diff>
--- a/docs/RUDP_Presentation.pptx
+++ b/docs/RUDP_Presentation.pptx
@@ -33,9 +33,10 @@
     <p:sldId id="281" r:id="rId27"/>
     <p:sldId id="282" r:id="rId28"/>
     <p:sldId id="283" r:id="rId29"/>
+    <p:sldId id="284" r:id="rId30"/>
   </p:sldIdLst>
   <p:notesMasterIdLst>
-    <p:notesMasterId r:id="rId30"/>
+    <p:notesMasterId r:id="rId31"/>
   </p:notesMasterIdLst>
   <p:sldSz cx="12192000" cy="6858000"/>
   <p:notesSz cx="6858000" cy="12192000"/>
@@ -2313,6 +2314,94 @@
             <a:fld id="{F7021451-1387-4CA6-816F-3879F97B5CBC}" type="slidenum">
               <a:rPr lang="en-US"/>
               <a:t>28</a:t>
+            </a:fld>
+            <a:endParaRPr lang="en-US"/>
+          </a:p>
+        </p:txBody>
+      </p:sp>
+    </p:spTree>
+    <p:extLst>
+      <p:ext uri="{BB962C8B-B14F-4D97-AF65-F5344CB8AC3E}">
+        <p14:creationId xmlns:p14="http://schemas.microsoft.com/office/powerpoint/2010/main" val="1024086991"/>
+      </p:ext>
+    </p:extLst>
+  </p:cSld>
+  <p:clrMapOvr>
+    <a:masterClrMapping/>
+  </p:clrMapOvr>
+</p:notes>
+</file>
+
+<file path=ppt/notesSlides/notesSlide29.xml><?xml version="1.0" encoding="utf-8"?>
+<p:notes xmlns:a="http://schemas.openxmlformats.org/drawingml/2006/main" xmlns:r="http://schemas.openxmlformats.org/officeDocument/2006/relationships" xmlns:p="http://schemas.openxmlformats.org/presentationml/2006/main">
+  <p:cSld>
+    <p:spTree>
+      <p:nvGrpSpPr>
+        <p:cNvPr id="1" name=""/>
+        <p:cNvGrpSpPr/>
+        <p:nvPr/>
+      </p:nvGrpSpPr>
+      <p:grpSpPr>
+        <a:xfrm>
+          <a:off x="0" y="0"/>
+          <a:ext cx="0" cy="0"/>
+          <a:chOff x="0" y="0"/>
+          <a:chExt cx="0" cy="0"/>
+        </a:xfrm>
+      </p:grpSpPr>
+      <p:sp>
+        <p:nvSpPr>
+          <p:cNvPr id="2" name="Slide Image Placeholder 1"/>
+          <p:cNvSpPr>
+            <a:spLocks noGrp="1" noRot="1" noChangeAspect="1"/>
+          </p:cNvSpPr>
+          <p:nvPr>
+            <p:ph type="sldImg"/>
+          </p:nvPr>
+        </p:nvSpPr>
+        <p:spPr/>
+      </p:sp>
+      <p:sp>
+        <p:nvSpPr>
+          <p:cNvPr id="3" name="Notes Placeholder 2"/>
+          <p:cNvSpPr>
+            <a:spLocks noGrp="1"/>
+          </p:cNvSpPr>
+          <p:nvPr>
+            <p:ph type="body" idx="1"/>
+          </p:nvPr>
+        </p:nvSpPr>
+        <p:spPr/>
+        <p:txBody>
+          <a:bodyPr/>
+          <a:lstStyle/>
+          <a:p>
+            <a:r>
+              <a:rPr lang="en-US" dirty="0"/>
+              <a:t/>
+            </a:r>
+            <a:endParaRPr lang="en-US" dirty="0"/>
+          </a:p>
+        </p:txBody>
+      </p:sp>
+      <p:sp>
+        <p:nvSpPr>
+          <p:cNvPr id="4" name="Slide Number Placeholder 3"/>
+          <p:cNvSpPr>
+            <a:spLocks noGrp="1"/>
+          </p:cNvSpPr>
+          <p:nvPr>
+            <p:ph type="sldNum" sz="quarter" idx="10"/>
+          </p:nvPr>
+        </p:nvSpPr>
+        <p:spPr/>
+        <p:txBody>
+          <a:bodyPr/>
+          <a:lstStyle/>
+          <a:p>
+            <a:fld id="{F7021451-1387-4CA6-816F-3879F97B5CBC}" type="slidenum">
+              <a:rPr lang="en-US"/>
+              <a:t>29</a:t>
             </a:fld>
             <a:endParaRPr lang="en-US"/>
           </a:p>
@@ -3538,7 +3627,7 @@
                 <a:ea typeface="Courier New" pitchFamily="34" charset="-122"/>
                 <a:cs typeface="Courier New" pitchFamily="34" charset="-120"/>
               </a:rPr>
-              <a:t>10 / 27   Smart-RUDP</a:t>
+              <a:t>10 / 28   Smart-RUDP</a:t>
             </a:r>
             <a:endParaRPr lang="en-US" sz="1000" dirty="0"/>
           </a:p>
@@ -3735,7 +3824,7 @@
                 <a:ea typeface="Courier New" pitchFamily="34" charset="-122"/>
                 <a:cs typeface="Courier New" pitchFamily="34" charset="-120"/>
               </a:rPr>
-              <a:t>11 / 27   Smart-RUDP</a:t>
+              <a:t>11 / 28   Smart-RUDP</a:t>
             </a:r>
             <a:endParaRPr lang="en-US" sz="1000" dirty="0"/>
           </a:p>
@@ -4565,7 +4654,7 @@
                 <a:ea typeface="Courier New" pitchFamily="34" charset="-122"/>
                 <a:cs typeface="Courier New" pitchFamily="34" charset="-120"/>
               </a:rPr>
-              <a:t>12 / 27   Smart-RUDP</a:t>
+              <a:t>12 / 28   Smart-RUDP</a:t>
             </a:r>
             <a:endParaRPr lang="en-US" sz="1000" dirty="0"/>
           </a:p>
@@ -4862,7 +4951,7 @@
                 <a:ea typeface="Courier New" pitchFamily="34" charset="-122"/>
                 <a:cs typeface="Courier New" pitchFamily="34" charset="-120"/>
               </a:rPr>
-              <a:t>13 / 27   Smart-RUDP</a:t>
+              <a:t>13 / 28   Smart-RUDP</a:t>
             </a:r>
             <a:endParaRPr lang="en-US" sz="1000" dirty="0"/>
           </a:p>
@@ -5162,7 +5251,7 @@
                 <a:ea typeface="Courier New" pitchFamily="34" charset="-122"/>
                 <a:cs typeface="Courier New" pitchFamily="34" charset="-120"/>
               </a:rPr>
-              <a:t>14 / 27   Smart-RUDP</a:t>
+              <a:t>14 / 28   Smart-RUDP</a:t>
             </a:r>
             <a:endParaRPr lang="en-US" sz="1000" dirty="0"/>
           </a:p>
@@ -5546,7 +5635,7 @@
                 <a:ea typeface="Courier New" pitchFamily="34" charset="-122"/>
                 <a:cs typeface="Courier New" pitchFamily="34" charset="-120"/>
               </a:rPr>
-              <a:t>15 / 27   Smart-RUDP</a:t>
+              <a:t>15 / 28   Smart-RUDP</a:t>
             </a:r>
             <a:endParaRPr lang="en-US" sz="1000" dirty="0"/>
           </a:p>
@@ -6004,7 +6093,7 @@
                 <a:ea typeface="Courier New" pitchFamily="34" charset="-122"/>
                 <a:cs typeface="Courier New" pitchFamily="34" charset="-120"/>
               </a:rPr>
-              <a:t>16 / 27   Smart-RUDP</a:t>
+              <a:t>16 / 28   Smart-RUDP</a:t>
             </a:r>
             <a:endParaRPr lang="en-US" sz="1000" dirty="0"/>
           </a:p>
@@ -6689,7 +6778,7 @@
                 <a:ea typeface="Courier New" pitchFamily="34" charset="-122"/>
                 <a:cs typeface="Courier New" pitchFamily="34" charset="-120"/>
               </a:rPr>
-              <a:t>17 / 27   Smart-RUDP</a:t>
+              <a:t>17 / 28   Smart-RUDP</a:t>
             </a:r>
             <a:endParaRPr lang="en-US" sz="1000" dirty="0"/>
           </a:p>
@@ -6929,7 +7018,7 @@
                 <a:ea typeface="Courier New" pitchFamily="34" charset="-122"/>
                 <a:cs typeface="Courier New" pitchFamily="34" charset="-120"/>
               </a:rPr>
-              <a:t>18 / 27   Smart-RUDP</a:t>
+              <a:t>18 / 28   Smart-RUDP</a:t>
             </a:r>
             <a:endParaRPr lang="en-US" sz="1000" dirty="0"/>
           </a:p>
@@ -7169,7 +7258,7 @@
                 <a:ea typeface="Courier New" pitchFamily="34" charset="-122"/>
                 <a:cs typeface="Courier New" pitchFamily="34" charset="-120"/>
               </a:rPr>
-              <a:t>19 / 27   Smart-RUDP</a:t>
+              <a:t>19 / 28   Smart-RUDP</a:t>
             </a:r>
             <a:endParaRPr lang="en-US" sz="1000" dirty="0"/>
           </a:p>
@@ -7391,7 +7480,7 @@
                 <a:ea typeface="Courier New" pitchFamily="34" charset="-122"/>
                 <a:cs typeface="Courier New" pitchFamily="34" charset="-120"/>
               </a:rPr>
-              <a:t>2 / 27   Smart-RUDP</a:t>
+              <a:t>2 / 28   Smart-RUDP</a:t>
             </a:r>
             <a:endParaRPr lang="en-US" sz="1000" dirty="0"/>
           </a:p>
@@ -7785,7 +7874,7 @@
                 <a:ea typeface="Courier New" pitchFamily="34" charset="-122"/>
                 <a:cs typeface="Courier New" pitchFamily="34" charset="-120"/>
               </a:rPr>
-              <a:t>20 / 27   Smart-RUDP</a:t>
+              <a:t>20 / 28   Smart-RUDP</a:t>
             </a:r>
             <a:endParaRPr lang="en-US" sz="1000" dirty="0"/>
           </a:p>
@@ -8109,7 +8198,7 @@
                 <a:ea typeface="Courier New" pitchFamily="34" charset="-122"/>
                 <a:cs typeface="Courier New" pitchFamily="34" charset="-120"/>
               </a:rPr>
-              <a:t>21 / 27   Smart-RUDP</a:t>
+              <a:t>21 / 28   Smart-RUDP</a:t>
             </a:r>
             <a:endParaRPr lang="en-US" sz="1000" dirty="0"/>
           </a:p>
@@ -9816,7 +9905,7 @@
                 <a:ea typeface="Courier New" pitchFamily="34" charset="-122"/>
                 <a:cs typeface="Courier New" pitchFamily="34" charset="-120"/>
               </a:rPr>
-              <a:t>22 / 27   Smart-RUDP</a:t>
+              <a:t>22 / 28   Smart-RUDP</a:t>
             </a:r>
             <a:endParaRPr lang="en-US" sz="1000" dirty="0"/>
           </a:p>
@@ -11199,7 +11288,7 @@
                 <a:ea typeface="Courier New" pitchFamily="34" charset="-122"/>
                 <a:cs typeface="Courier New" pitchFamily="34" charset="-120"/>
               </a:rPr>
-              <a:t>23 / 27   Smart-RUDP</a:t>
+              <a:t>23 / 28   Smart-RUDP</a:t>
             </a:r>
             <a:endParaRPr lang="en-US" sz="1000" dirty="0"/>
           </a:p>
@@ -12742,7 +12831,7 @@
                 <a:ea typeface="Courier New" pitchFamily="34" charset="-122"/>
                 <a:cs typeface="Courier New" pitchFamily="34" charset="-120"/>
               </a:rPr>
-              <a:t>24 / 27   Smart-RUDP</a:t>
+              <a:t>24 / 28   Smart-RUDP</a:t>
             </a:r>
             <a:endParaRPr lang="en-US" sz="1000" dirty="0"/>
           </a:p>
@@ -14420,7 +14509,7 @@
                 <a:ea typeface="Courier New" pitchFamily="34" charset="-122"/>
                 <a:cs typeface="Courier New" pitchFamily="34" charset="-120"/>
               </a:rPr>
-              <a:t>25 / 27   Smart-RUDP</a:t>
+              <a:t>25 / 28   Smart-RUDP</a:t>
             </a:r>
             <a:endParaRPr lang="en-US" sz="1000" dirty="0"/>
           </a:p>
@@ -16059,7 +16148,7 @@
                 <a:ea typeface="Courier New" pitchFamily="34" charset="-122"/>
                 <a:cs typeface="Courier New" pitchFamily="34" charset="-120"/>
               </a:rPr>
-              <a:t>Learnings and future work</a:t>
+              <a:t>Performance: bigger windows, tuned baseline</a:t>
             </a:r>
             <a:endParaRPr lang="en-US" sz="3000" dirty="0"/>
           </a:p>
@@ -16098,47 +16187,1825 @@
                 <a:ea typeface="Courier New" pitchFamily="34" charset="-122"/>
                 <a:cs typeface="Courier New" pitchFamily="34" charset="-120"/>
               </a:rPr>
-              <a:t>26 / 27   Smart-RUDP</a:t>
+              <a:t>26 / 28   Smart-RUDP</a:t>
             </a:r>
             <a:endParaRPr lang="en-US" sz="1000" dirty="0"/>
           </a:p>
         </p:txBody>
       </p:sp>
-      <p:sp>
-        <p:nvSpPr>
-          <p:cNvPr id="4" name="Shape 2"/>
+      <p:graphicFrame>
+        <p:nvGraphicFramePr>
+          <p:cNvPr id="27" name="Table 0"/>
+          <p:cNvGraphicFramePr>
+            <a:graphicFrameLocks noGrp="1"/>
+          </p:cNvGraphicFramePr>
+          <p:nvPr>
+            <p:extLst>
+              <p:ext uri="{D42A27DB-BD31-4B8C-83A1-F6EECF244321}">
+                <p14:modId xmlns:p14="http://schemas.microsoft.com/office/powerpoint/2010/main" val="1579011935"/>
+              </p:ext>
+            </p:extLst>
+          </p:nvPr>
+        </p:nvGraphicFramePr>
+        <p:xfrm>
+          <a:off x="548640" y="1188720"/>
+          <a:ext cx="6217920" cy="914400"/>
+        </p:xfrm>
+        <a:graphic>
+          <a:graphicData uri="http://schemas.openxmlformats.org/drawingml/2006/table">
+            <a:tbl>
+              <a:tblPr/>
+              <a:tblGrid>
+                <a:gridCol w="2286000"/>
+                <a:gridCol w="1371600"/>
+                <a:gridCol w="1280160"/>
+                <a:gridCol w="1280160"/>
+              </a:tblGrid>
+              <a:tr h="402336">
+                <a:tc>
+                  <a:txBody>
+                    <a:bodyPr/>
+                    <a:lstStyle/>
+                    <a:p>
+                      <a:pPr indent="0" marL="0">
+                        <a:buNone/>
+                      </a:pPr>
+                      <a:r>
+                        <a:rPr lang="en-US" sz="1300" b="1" dirty="0">
+                          <a:solidFill>
+                            <a:srgbClr val="0B0F14"/>
+                          </a:solidFill>
+                          <a:latin typeface="Courier New" pitchFamily="34" charset="0"/>
+                          <a:ea typeface="Courier New" pitchFamily="34" charset="-122"/>
+                          <a:cs typeface="Courier New" pitchFamily="34" charset="-120"/>
+                        </a:rPr>
+                        <a:t>C transport, seconds</a:t>
+                      </a:r>
+                      <a:endParaRPr lang="en-US" sz="1300" dirty="0">
+                        <a:latin typeface="Courier New" charset="0"/>
+                        <a:ea typeface="Courier New" charset="0"/>
+                        <a:cs typeface="Courier New" charset="0"/>
+                      </a:endParaRPr>
+                    </a:p>
+                  </a:txBody>
+                  <a:tcPr marL="91440" marR="91440" marT="45720" marB="45720">
+                    <a:lnL w="12700" cap="flat" cmpd="sng" algn="ctr">
+                      <a:solidFill>
+                        <a:srgbClr val="2A3441"/>
+                      </a:solidFill>
+                      <a:prstDash val="solid"/>
+                      <a:round/>
+                      <a:headEnd type="none" w="med" len="med"/>
+                      <a:tailEnd type="none" w="med" len="med"/>
+                    </a:lnL>
+                    <a:lnR w="12700" cap="flat" cmpd="sng" algn="ctr">
+                      <a:solidFill>
+                        <a:srgbClr val="2A3441"/>
+                      </a:solidFill>
+                      <a:prstDash val="solid"/>
+                      <a:round/>
+                      <a:headEnd type="none" w="med" len="med"/>
+                      <a:tailEnd type="none" w="med" len="med"/>
+                    </a:lnR>
+                    <a:lnT w="12700" cap="flat" cmpd="sng" algn="ctr">
+                      <a:solidFill>
+                        <a:srgbClr val="2A3441"/>
+                      </a:solidFill>
+                      <a:prstDash val="solid"/>
+                      <a:round/>
+                      <a:headEnd type="none" w="med" len="med"/>
+                      <a:tailEnd type="none" w="med" len="med"/>
+                    </a:lnT>
+                    <a:lnB w="12700" cap="flat" cmpd="sng" algn="ctr">
+                      <a:solidFill>
+                        <a:srgbClr val="2A3441"/>
+                      </a:solidFill>
+                      <a:prstDash val="solid"/>
+                      <a:round/>
+                      <a:headEnd type="none" w="med" len="med"/>
+                      <a:tailEnd type="none" w="med" len="med"/>
+                    </a:lnB>
+                    <a:solidFill>
+                      <a:srgbClr val="39FF88"/>
+                    </a:solidFill>
+                  </a:tcPr>
+                </a:tc>
+                <a:tc>
+                  <a:txBody>
+                    <a:bodyPr/>
+                    <a:lstStyle/>
+                    <a:p>
+                      <a:pPr indent="0" marL="0">
+                        <a:buNone/>
+                      </a:pPr>
+                      <a:r>
+                        <a:rPr lang="en-US" sz="1300" b="1" dirty="0">
+                          <a:solidFill>
+                            <a:srgbClr val="0B0F14"/>
+                          </a:solidFill>
+                          <a:latin typeface="Courier New" pitchFamily="34" charset="0"/>
+                          <a:ea typeface="Courier New" pitchFamily="34" charset="-122"/>
+                          <a:cs typeface="Courier New" pitchFamily="34" charset="-120"/>
+                        </a:rPr>
+                        <a:t>AIMD cap 32</a:t>
+                      </a:r>
+                      <a:endParaRPr lang="en-US" sz="1300" dirty="0">
+                        <a:latin typeface="Courier New" charset="0"/>
+                        <a:ea typeface="Courier New" charset="0"/>
+                        <a:cs typeface="Courier New" charset="0"/>
+                      </a:endParaRPr>
+                    </a:p>
+                  </a:txBody>
+                  <a:tcPr marL="91440" marR="91440" marT="45720" marB="45720">
+                    <a:lnL w="12700" cap="flat" cmpd="sng" algn="ctr">
+                      <a:solidFill>
+                        <a:srgbClr val="2A3441"/>
+                      </a:solidFill>
+                      <a:prstDash val="solid"/>
+                      <a:round/>
+                      <a:headEnd type="none" w="med" len="med"/>
+                      <a:tailEnd type="none" w="med" len="med"/>
+                    </a:lnL>
+                    <a:lnR w="12700" cap="flat" cmpd="sng" algn="ctr">
+                      <a:solidFill>
+                        <a:srgbClr val="2A3441"/>
+                      </a:solidFill>
+                      <a:prstDash val="solid"/>
+                      <a:round/>
+                      <a:headEnd type="none" w="med" len="med"/>
+                      <a:tailEnd type="none" w="med" len="med"/>
+                    </a:lnR>
+                    <a:lnT w="12700" cap="flat" cmpd="sng" algn="ctr">
+                      <a:solidFill>
+                        <a:srgbClr val="2A3441"/>
+                      </a:solidFill>
+                      <a:prstDash val="solid"/>
+                      <a:round/>
+                      <a:headEnd type="none" w="med" len="med"/>
+                      <a:tailEnd type="none" w="med" len="med"/>
+                    </a:lnT>
+                    <a:lnB w="12700" cap="flat" cmpd="sng" algn="ctr">
+                      <a:solidFill>
+                        <a:srgbClr val="2A3441"/>
+                      </a:solidFill>
+                      <a:prstDash val="solid"/>
+                      <a:round/>
+                      <a:headEnd type="none" w="med" len="med"/>
+                      <a:tailEnd type="none" w="med" len="med"/>
+                    </a:lnB>
+                    <a:solidFill>
+                      <a:srgbClr val="39FF88"/>
+                    </a:solidFill>
+                  </a:tcPr>
+                </a:tc>
+                <a:tc>
+                  <a:txBody>
+                    <a:bodyPr/>
+                    <a:lstStyle/>
+                    <a:p>
+                      <a:pPr indent="0" marL="0">
+                        <a:buNone/>
+                      </a:pPr>
+                      <a:r>
+                        <a:rPr lang="en-US" sz="1300" b="1" dirty="0">
+                          <a:solidFill>
+                            <a:srgbClr val="0B0F14"/>
+                          </a:solidFill>
+                          <a:latin typeface="Courier New" pitchFamily="34" charset="0"/>
+                          <a:ea typeface="Courier New" pitchFamily="34" charset="-122"/>
+                          <a:cs typeface="Courier New" pitchFamily="34" charset="-120"/>
+                        </a:rPr>
+                        <a:t>AIMD tuned</a:t>
+                      </a:r>
+                      <a:endParaRPr lang="en-US" sz="1300" dirty="0">
+                        <a:latin typeface="Courier New" charset="0"/>
+                        <a:ea typeface="Courier New" charset="0"/>
+                        <a:cs typeface="Courier New" charset="0"/>
+                      </a:endParaRPr>
+                    </a:p>
+                  </a:txBody>
+                  <a:tcPr marL="91440" marR="91440" marT="45720" marB="45720">
+                    <a:lnL w="12700" cap="flat" cmpd="sng" algn="ctr">
+                      <a:solidFill>
+                        <a:srgbClr val="2A3441"/>
+                      </a:solidFill>
+                      <a:prstDash val="solid"/>
+                      <a:round/>
+                      <a:headEnd type="none" w="med" len="med"/>
+                      <a:tailEnd type="none" w="med" len="med"/>
+                    </a:lnL>
+                    <a:lnR w="12700" cap="flat" cmpd="sng" algn="ctr">
+                      <a:solidFill>
+                        <a:srgbClr val="2A3441"/>
+                      </a:solidFill>
+                      <a:prstDash val="solid"/>
+                      <a:round/>
+                      <a:headEnd type="none" w="med" len="med"/>
+                      <a:tailEnd type="none" w="med" len="med"/>
+                    </a:lnR>
+                    <a:lnT w="12700" cap="flat" cmpd="sng" algn="ctr">
+                      <a:solidFill>
+                        <a:srgbClr val="2A3441"/>
+                      </a:solidFill>
+                      <a:prstDash val="solid"/>
+                      <a:round/>
+                      <a:headEnd type="none" w="med" len="med"/>
+                      <a:tailEnd type="none" w="med" len="med"/>
+                    </a:lnT>
+                    <a:lnB w="12700" cap="flat" cmpd="sng" algn="ctr">
+                      <a:solidFill>
+                        <a:srgbClr val="2A3441"/>
+                      </a:solidFill>
+                      <a:prstDash val="solid"/>
+                      <a:round/>
+                      <a:headEnd type="none" w="med" len="med"/>
+                      <a:tailEnd type="none" w="med" len="med"/>
+                    </a:lnB>
+                    <a:solidFill>
+                      <a:srgbClr val="39FF88"/>
+                    </a:solidFill>
+                  </a:tcPr>
+                </a:tc>
+                <a:tc>
+                  <a:txBody>
+                    <a:bodyPr/>
+                    <a:lstStyle/>
+                    <a:p>
+                      <a:pPr indent="0" marL="0">
+                        <a:buNone/>
+                      </a:pPr>
+                      <a:r>
+                        <a:rPr lang="en-US" sz="1300" b="1" dirty="0">
+                          <a:solidFill>
+                            <a:srgbClr val="0B0F14"/>
+                          </a:solidFill>
+                          <a:latin typeface="Courier New" pitchFamily="34" charset="0"/>
+                          <a:ea typeface="Courier New" pitchFamily="34" charset="-122"/>
+                          <a:cs typeface="Courier New" pitchFamily="34" charset="-120"/>
+                        </a:rPr>
+                        <a:t>Neural</a:t>
+                      </a:r>
+                      <a:endParaRPr lang="en-US" sz="1300" dirty="0">
+                        <a:latin typeface="Courier New" charset="0"/>
+                        <a:ea typeface="Courier New" charset="0"/>
+                        <a:cs typeface="Courier New" charset="0"/>
+                      </a:endParaRPr>
+                    </a:p>
+                  </a:txBody>
+                  <a:tcPr marL="91440" marR="91440" marT="45720" marB="45720">
+                    <a:lnL w="12700" cap="flat" cmpd="sng" algn="ctr">
+                      <a:solidFill>
+                        <a:srgbClr val="2A3441"/>
+                      </a:solidFill>
+                      <a:prstDash val="solid"/>
+                      <a:round/>
+                      <a:headEnd type="none" w="med" len="med"/>
+                      <a:tailEnd type="none" w="med" len="med"/>
+                    </a:lnL>
+                    <a:lnR w="12700" cap="flat" cmpd="sng" algn="ctr">
+                      <a:solidFill>
+                        <a:srgbClr val="2A3441"/>
+                      </a:solidFill>
+                      <a:prstDash val="solid"/>
+                      <a:round/>
+                      <a:headEnd type="none" w="med" len="med"/>
+                      <a:tailEnd type="none" w="med" len="med"/>
+                    </a:lnR>
+                    <a:lnT w="12700" cap="flat" cmpd="sng" algn="ctr">
+                      <a:solidFill>
+                        <a:srgbClr val="2A3441"/>
+                      </a:solidFill>
+                      <a:prstDash val="solid"/>
+                      <a:round/>
+                      <a:headEnd type="none" w="med" len="med"/>
+                      <a:tailEnd type="none" w="med" len="med"/>
+                    </a:lnT>
+                    <a:lnB w="12700" cap="flat" cmpd="sng" algn="ctr">
+                      <a:solidFill>
+                        <a:srgbClr val="2A3441"/>
+                      </a:solidFill>
+                      <a:prstDash val="solid"/>
+                      <a:round/>
+                      <a:headEnd type="none" w="med" len="med"/>
+                      <a:tailEnd type="none" w="med" len="med"/>
+                    </a:lnB>
+                    <a:solidFill>
+                      <a:srgbClr val="39FF88"/>
+                    </a:solidFill>
+                  </a:tcPr>
+                </a:tc>
+              </a:tr>
+              <a:tr h="402336">
+                <a:tc>
+                  <a:txBody>
+                    <a:bodyPr/>
+                    <a:lstStyle/>
+                    <a:p>
+                      <a:pPr indent="0" marL="0">
+                        <a:buNone/>
+                      </a:pPr>
+                      <a:r>
+                        <a:rPr lang="en-US" sz="1300" dirty="0">
+                          <a:solidFill>
+                            <a:srgbClr val="E6EDF3"/>
+                          </a:solidFill>
+                          <a:latin typeface="Calibri" pitchFamily="34" charset="0"/>
+                          <a:ea typeface="Calibri" pitchFamily="34" charset="-122"/>
+                          <a:cs typeface="Calibri" pitchFamily="34" charset="-120"/>
+                        </a:rPr>
+                        <a:t>Lossy 2%</a:t>
+                      </a:r>
+                      <a:endParaRPr lang="en-US" sz="1300" dirty="0">
+                        <a:latin typeface="Calibri" charset="0"/>
+                        <a:ea typeface="Calibri" charset="0"/>
+                        <a:cs typeface="Calibri" charset="0"/>
+                      </a:endParaRPr>
+                    </a:p>
+                  </a:txBody>
+                  <a:tcPr marL="91440" marR="91440" marT="45720" marB="45720">
+                    <a:lnL w="12700" cap="flat" cmpd="sng" algn="ctr">
+                      <a:solidFill>
+                        <a:srgbClr val="2A3441"/>
+                      </a:solidFill>
+                      <a:prstDash val="solid"/>
+                      <a:round/>
+                      <a:headEnd type="none" w="med" len="med"/>
+                      <a:tailEnd type="none" w="med" len="med"/>
+                    </a:lnL>
+                    <a:lnR w="12700" cap="flat" cmpd="sng" algn="ctr">
+                      <a:solidFill>
+                        <a:srgbClr val="2A3441"/>
+                      </a:solidFill>
+                      <a:prstDash val="solid"/>
+                      <a:round/>
+                      <a:headEnd type="none" w="med" len="med"/>
+                      <a:tailEnd type="none" w="med" len="med"/>
+                    </a:lnR>
+                    <a:lnT w="12700" cap="flat" cmpd="sng" algn="ctr">
+                      <a:solidFill>
+                        <a:srgbClr val="2A3441"/>
+                      </a:solidFill>
+                      <a:prstDash val="solid"/>
+                      <a:round/>
+                      <a:headEnd type="none" w="med" len="med"/>
+                      <a:tailEnd type="none" w="med" len="med"/>
+                    </a:lnT>
+                    <a:lnB w="12700" cap="flat" cmpd="sng" algn="ctr">
+                      <a:solidFill>
+                        <a:srgbClr val="2A3441"/>
+                      </a:solidFill>
+                      <a:prstDash val="solid"/>
+                      <a:round/>
+                      <a:headEnd type="none" w="med" len="med"/>
+                      <a:tailEnd type="none" w="med" len="med"/>
+                    </a:lnB>
+                    <a:solidFill>
+                      <a:srgbClr val="141B24"/>
+                    </a:solidFill>
+                  </a:tcPr>
+                </a:tc>
+                <a:tc>
+                  <a:txBody>
+                    <a:bodyPr/>
+                    <a:lstStyle/>
+                    <a:p>
+                      <a:pPr indent="0" marL="0">
+                        <a:buNone/>
+                      </a:pPr>
+                      <a:r>
+                        <a:rPr lang="en-US" sz="1300" dirty="0">
+                          <a:solidFill>
+                            <a:srgbClr val="E6EDF3"/>
+                          </a:solidFill>
+                          <a:latin typeface="Calibri" pitchFamily="34" charset="0"/>
+                          <a:ea typeface="Calibri" pitchFamily="34" charset="-122"/>
+                          <a:cs typeface="Calibri" pitchFamily="34" charset="-120"/>
+                        </a:rPr>
+                        <a:t>8.4</a:t>
+                      </a:r>
+                      <a:endParaRPr lang="en-US" sz="1300" dirty="0">
+                        <a:latin typeface="Calibri" charset="0"/>
+                        <a:ea typeface="Calibri" charset="0"/>
+                        <a:cs typeface="Calibri" charset="0"/>
+                      </a:endParaRPr>
+                    </a:p>
+                  </a:txBody>
+                  <a:tcPr marL="91440" marR="91440" marT="45720" marB="45720">
+                    <a:lnL w="12700" cap="flat" cmpd="sng" algn="ctr">
+                      <a:solidFill>
+                        <a:srgbClr val="2A3441"/>
+                      </a:solidFill>
+                      <a:prstDash val="solid"/>
+                      <a:round/>
+                      <a:headEnd type="none" w="med" len="med"/>
+                      <a:tailEnd type="none" w="med" len="med"/>
+                    </a:lnL>
+                    <a:lnR w="12700" cap="flat" cmpd="sng" algn="ctr">
+                      <a:solidFill>
+                        <a:srgbClr val="2A3441"/>
+                      </a:solidFill>
+                      <a:prstDash val="solid"/>
+                      <a:round/>
+                      <a:headEnd type="none" w="med" len="med"/>
+                      <a:tailEnd type="none" w="med" len="med"/>
+                    </a:lnR>
+                    <a:lnT w="12700" cap="flat" cmpd="sng" algn="ctr">
+                      <a:solidFill>
+                        <a:srgbClr val="2A3441"/>
+                      </a:solidFill>
+                      <a:prstDash val="solid"/>
+                      <a:round/>
+                      <a:headEnd type="none" w="med" len="med"/>
+                      <a:tailEnd type="none" w="med" len="med"/>
+                    </a:lnT>
+                    <a:lnB w="12700" cap="flat" cmpd="sng" algn="ctr">
+                      <a:solidFill>
+                        <a:srgbClr val="2A3441"/>
+                      </a:solidFill>
+                      <a:prstDash val="solid"/>
+                      <a:round/>
+                      <a:headEnd type="none" w="med" len="med"/>
+                      <a:tailEnd type="none" w="med" len="med"/>
+                    </a:lnB>
+                    <a:solidFill>
+                      <a:srgbClr val="141B24"/>
+                    </a:solidFill>
+                  </a:tcPr>
+                </a:tc>
+                <a:tc>
+                  <a:txBody>
+                    <a:bodyPr/>
+                    <a:lstStyle/>
+                    <a:p>
+                      <a:pPr indent="0" marL="0">
+                        <a:buNone/>
+                      </a:pPr>
+                      <a:r>
+                        <a:rPr lang="en-US" sz="1300" dirty="0">
+                          <a:solidFill>
+                            <a:srgbClr val="E6EDF3"/>
+                          </a:solidFill>
+                          <a:latin typeface="Calibri" pitchFamily="34" charset="0"/>
+                          <a:ea typeface="Calibri" pitchFamily="34" charset="-122"/>
+                          <a:cs typeface="Calibri" pitchFamily="34" charset="-120"/>
+                        </a:rPr>
+                        <a:t>8.3</a:t>
+                      </a:r>
+                      <a:endParaRPr lang="en-US" sz="1300" dirty="0">
+                        <a:latin typeface="Calibri" charset="0"/>
+                        <a:ea typeface="Calibri" charset="0"/>
+                        <a:cs typeface="Calibri" charset="0"/>
+                      </a:endParaRPr>
+                    </a:p>
+                  </a:txBody>
+                  <a:tcPr marL="91440" marR="91440" marT="45720" marB="45720">
+                    <a:lnL w="12700" cap="flat" cmpd="sng" algn="ctr">
+                      <a:solidFill>
+                        <a:srgbClr val="2A3441"/>
+                      </a:solidFill>
+                      <a:prstDash val="solid"/>
+                      <a:round/>
+                      <a:headEnd type="none" w="med" len="med"/>
+                      <a:tailEnd type="none" w="med" len="med"/>
+                    </a:lnL>
+                    <a:lnR w="12700" cap="flat" cmpd="sng" algn="ctr">
+                      <a:solidFill>
+                        <a:srgbClr val="2A3441"/>
+                      </a:solidFill>
+                      <a:prstDash val="solid"/>
+                      <a:round/>
+                      <a:headEnd type="none" w="med" len="med"/>
+                      <a:tailEnd type="none" w="med" len="med"/>
+                    </a:lnR>
+                    <a:lnT w="12700" cap="flat" cmpd="sng" algn="ctr">
+                      <a:solidFill>
+                        <a:srgbClr val="2A3441"/>
+                      </a:solidFill>
+                      <a:prstDash val="solid"/>
+                      <a:round/>
+                      <a:headEnd type="none" w="med" len="med"/>
+                      <a:tailEnd type="none" w="med" len="med"/>
+                    </a:lnT>
+                    <a:lnB w="12700" cap="flat" cmpd="sng" algn="ctr">
+                      <a:solidFill>
+                        <a:srgbClr val="2A3441"/>
+                      </a:solidFill>
+                      <a:prstDash val="solid"/>
+                      <a:round/>
+                      <a:headEnd type="none" w="med" len="med"/>
+                      <a:tailEnd type="none" w="med" len="med"/>
+                    </a:lnB>
+                    <a:solidFill>
+                      <a:srgbClr val="141B24"/>
+                    </a:solidFill>
+                  </a:tcPr>
+                </a:tc>
+                <a:tc>
+                  <a:txBody>
+                    <a:bodyPr/>
+                    <a:lstStyle/>
+                    <a:p>
+                      <a:pPr indent="0" marL="0">
+                        <a:buNone/>
+                      </a:pPr>
+                      <a:r>
+                        <a:rPr lang="en-US" sz="1300" dirty="0">
+                          <a:solidFill>
+                            <a:srgbClr val="E6EDF3"/>
+                          </a:solidFill>
+                          <a:latin typeface="Calibri" pitchFamily="34" charset="0"/>
+                          <a:ea typeface="Calibri" pitchFamily="34" charset="-122"/>
+                          <a:cs typeface="Calibri" pitchFamily="34" charset="-120"/>
+                        </a:rPr>
+                        <a:t>4.5</a:t>
+                      </a:r>
+                      <a:endParaRPr lang="en-US" sz="1300" dirty="0">
+                        <a:latin typeface="Calibri" charset="0"/>
+                        <a:ea typeface="Calibri" charset="0"/>
+                        <a:cs typeface="Calibri" charset="0"/>
+                      </a:endParaRPr>
+                    </a:p>
+                  </a:txBody>
+                  <a:tcPr marL="91440" marR="91440" marT="45720" marB="45720">
+                    <a:lnL w="12700" cap="flat" cmpd="sng" algn="ctr">
+                      <a:solidFill>
+                        <a:srgbClr val="2A3441"/>
+                      </a:solidFill>
+                      <a:prstDash val="solid"/>
+                      <a:round/>
+                      <a:headEnd type="none" w="med" len="med"/>
+                      <a:tailEnd type="none" w="med" len="med"/>
+                    </a:lnL>
+                    <a:lnR w="12700" cap="flat" cmpd="sng" algn="ctr">
+                      <a:solidFill>
+                        <a:srgbClr val="2A3441"/>
+                      </a:solidFill>
+                      <a:prstDash val="solid"/>
+                      <a:round/>
+                      <a:headEnd type="none" w="med" len="med"/>
+                      <a:tailEnd type="none" w="med" len="med"/>
+                    </a:lnR>
+                    <a:lnT w="12700" cap="flat" cmpd="sng" algn="ctr">
+                      <a:solidFill>
+                        <a:srgbClr val="2A3441"/>
+                      </a:solidFill>
+                      <a:prstDash val="solid"/>
+                      <a:round/>
+                      <a:headEnd type="none" w="med" len="med"/>
+                      <a:tailEnd type="none" w="med" len="med"/>
+                    </a:lnT>
+                    <a:lnB w="12700" cap="flat" cmpd="sng" algn="ctr">
+                      <a:solidFill>
+                        <a:srgbClr val="2A3441"/>
+                      </a:solidFill>
+                      <a:prstDash val="solid"/>
+                      <a:round/>
+                      <a:headEnd type="none" w="med" len="med"/>
+                      <a:tailEnd type="none" w="med" len="med"/>
+                    </a:lnB>
+                    <a:solidFill>
+                      <a:srgbClr val="141B24"/>
+                    </a:solidFill>
+                  </a:tcPr>
+                </a:tc>
+              </a:tr>
+              <a:tr h="402336">
+                <a:tc>
+                  <a:txBody>
+                    <a:bodyPr/>
+                    <a:lstStyle/>
+                    <a:p>
+                      <a:pPr indent="0" marL="0">
+                        <a:buNone/>
+                      </a:pPr>
+                      <a:r>
+                        <a:rPr lang="en-US" sz="1300" dirty="0">
+                          <a:solidFill>
+                            <a:srgbClr val="E6EDF3"/>
+                          </a:solidFill>
+                          <a:latin typeface="Calibri" pitchFamily="34" charset="0"/>
+                          <a:ea typeface="Calibri" pitchFamily="34" charset="-122"/>
+                          <a:cs typeface="Calibri" pitchFamily="34" charset="-120"/>
+                        </a:rPr>
+                        <a:t>Satellite-like</a:t>
+                      </a:r>
+                      <a:endParaRPr lang="en-US" sz="1300" dirty="0">
+                        <a:latin typeface="Calibri" charset="0"/>
+                        <a:ea typeface="Calibri" charset="0"/>
+                        <a:cs typeface="Calibri" charset="0"/>
+                      </a:endParaRPr>
+                    </a:p>
+                  </a:txBody>
+                  <a:tcPr marL="91440" marR="91440" marT="45720" marB="45720">
+                    <a:lnL w="12700" cap="flat" cmpd="sng" algn="ctr">
+                      <a:solidFill>
+                        <a:srgbClr val="2A3441"/>
+                      </a:solidFill>
+                      <a:prstDash val="solid"/>
+                      <a:round/>
+                      <a:headEnd type="none" w="med" len="med"/>
+                      <a:tailEnd type="none" w="med" len="med"/>
+                    </a:lnL>
+                    <a:lnR w="12700" cap="flat" cmpd="sng" algn="ctr">
+                      <a:solidFill>
+                        <a:srgbClr val="2A3441"/>
+                      </a:solidFill>
+                      <a:prstDash val="solid"/>
+                      <a:round/>
+                      <a:headEnd type="none" w="med" len="med"/>
+                      <a:tailEnd type="none" w="med" len="med"/>
+                    </a:lnR>
+                    <a:lnT w="12700" cap="flat" cmpd="sng" algn="ctr">
+                      <a:solidFill>
+                        <a:srgbClr val="2A3441"/>
+                      </a:solidFill>
+                      <a:prstDash val="solid"/>
+                      <a:round/>
+                      <a:headEnd type="none" w="med" len="med"/>
+                      <a:tailEnd type="none" w="med" len="med"/>
+                    </a:lnT>
+                    <a:lnB w="12700" cap="flat" cmpd="sng" algn="ctr">
+                      <a:solidFill>
+                        <a:srgbClr val="2A3441"/>
+                      </a:solidFill>
+                      <a:prstDash val="solid"/>
+                      <a:round/>
+                      <a:headEnd type="none" w="med" len="med"/>
+                      <a:tailEnd type="none" w="med" len="med"/>
+                    </a:lnB>
+                    <a:solidFill>
+                      <a:srgbClr val="141B24"/>
+                    </a:solidFill>
+                  </a:tcPr>
+                </a:tc>
+                <a:tc>
+                  <a:txBody>
+                    <a:bodyPr/>
+                    <a:lstStyle/>
+                    <a:p>
+                      <a:pPr indent="0" marL="0">
+                        <a:buNone/>
+                      </a:pPr>
+                      <a:r>
+                        <a:rPr lang="en-US" sz="1300" dirty="0">
+                          <a:solidFill>
+                            <a:srgbClr val="E6EDF3"/>
+                          </a:solidFill>
+                          <a:latin typeface="Calibri" pitchFamily="34" charset="0"/>
+                          <a:ea typeface="Calibri" pitchFamily="34" charset="-122"/>
+                          <a:cs typeface="Calibri" pitchFamily="34" charset="-120"/>
+                        </a:rPr>
+                        <a:t>25.1</a:t>
+                      </a:r>
+                      <a:endParaRPr lang="en-US" sz="1300" dirty="0">
+                        <a:latin typeface="Calibri" charset="0"/>
+                        <a:ea typeface="Calibri" charset="0"/>
+                        <a:cs typeface="Calibri" charset="0"/>
+                      </a:endParaRPr>
+                    </a:p>
+                  </a:txBody>
+                  <a:tcPr marL="91440" marR="91440" marT="45720" marB="45720">
+                    <a:lnL w="12700" cap="flat" cmpd="sng" algn="ctr">
+                      <a:solidFill>
+                        <a:srgbClr val="2A3441"/>
+                      </a:solidFill>
+                      <a:prstDash val="solid"/>
+                      <a:round/>
+                      <a:headEnd type="none" w="med" len="med"/>
+                      <a:tailEnd type="none" w="med" len="med"/>
+                    </a:lnL>
+                    <a:lnR w="12700" cap="flat" cmpd="sng" algn="ctr">
+                      <a:solidFill>
+                        <a:srgbClr val="2A3441"/>
+                      </a:solidFill>
+                      <a:prstDash val="solid"/>
+                      <a:round/>
+                      <a:headEnd type="none" w="med" len="med"/>
+                      <a:tailEnd type="none" w="med" len="med"/>
+                    </a:lnR>
+                    <a:lnT w="12700" cap="flat" cmpd="sng" algn="ctr">
+                      <a:solidFill>
+                        <a:srgbClr val="2A3441"/>
+                      </a:solidFill>
+                      <a:prstDash val="solid"/>
+                      <a:round/>
+                      <a:headEnd type="none" w="med" len="med"/>
+                      <a:tailEnd type="none" w="med" len="med"/>
+                    </a:lnT>
+                    <a:lnB w="12700" cap="flat" cmpd="sng" algn="ctr">
+                      <a:solidFill>
+                        <a:srgbClr val="2A3441"/>
+                      </a:solidFill>
+                      <a:prstDash val="solid"/>
+                      <a:round/>
+                      <a:headEnd type="none" w="med" len="med"/>
+                      <a:tailEnd type="none" w="med" len="med"/>
+                    </a:lnB>
+                    <a:solidFill>
+                      <a:srgbClr val="141B24"/>
+                    </a:solidFill>
+                  </a:tcPr>
+                </a:tc>
+                <a:tc>
+                  <a:txBody>
+                    <a:bodyPr/>
+                    <a:lstStyle/>
+                    <a:p>
+                      <a:pPr indent="0" marL="0">
+                        <a:buNone/>
+                      </a:pPr>
+                      <a:r>
+                        <a:rPr lang="en-US" sz="1300" dirty="0">
+                          <a:solidFill>
+                            <a:srgbClr val="E6EDF3"/>
+                          </a:solidFill>
+                          <a:latin typeface="Calibri" pitchFamily="34" charset="0"/>
+                          <a:ea typeface="Calibri" pitchFamily="34" charset="-122"/>
+                          <a:cs typeface="Calibri" pitchFamily="34" charset="-120"/>
+                        </a:rPr>
+                        <a:t>20.0</a:t>
+                      </a:r>
+                      <a:endParaRPr lang="en-US" sz="1300" dirty="0">
+                        <a:latin typeface="Calibri" charset="0"/>
+                        <a:ea typeface="Calibri" charset="0"/>
+                        <a:cs typeface="Calibri" charset="0"/>
+                      </a:endParaRPr>
+                    </a:p>
+                  </a:txBody>
+                  <a:tcPr marL="91440" marR="91440" marT="45720" marB="45720">
+                    <a:lnL w="12700" cap="flat" cmpd="sng" algn="ctr">
+                      <a:solidFill>
+                        <a:srgbClr val="2A3441"/>
+                      </a:solidFill>
+                      <a:prstDash val="solid"/>
+                      <a:round/>
+                      <a:headEnd type="none" w="med" len="med"/>
+                      <a:tailEnd type="none" w="med" len="med"/>
+                    </a:lnL>
+                    <a:lnR w="12700" cap="flat" cmpd="sng" algn="ctr">
+                      <a:solidFill>
+                        <a:srgbClr val="2A3441"/>
+                      </a:solidFill>
+                      <a:prstDash val="solid"/>
+                      <a:round/>
+                      <a:headEnd type="none" w="med" len="med"/>
+                      <a:tailEnd type="none" w="med" len="med"/>
+                    </a:lnR>
+                    <a:lnT w="12700" cap="flat" cmpd="sng" algn="ctr">
+                      <a:solidFill>
+                        <a:srgbClr val="2A3441"/>
+                      </a:solidFill>
+                      <a:prstDash val="solid"/>
+                      <a:round/>
+                      <a:headEnd type="none" w="med" len="med"/>
+                      <a:tailEnd type="none" w="med" len="med"/>
+                    </a:lnT>
+                    <a:lnB w="12700" cap="flat" cmpd="sng" algn="ctr">
+                      <a:solidFill>
+                        <a:srgbClr val="2A3441"/>
+                      </a:solidFill>
+                      <a:prstDash val="solid"/>
+                      <a:round/>
+                      <a:headEnd type="none" w="med" len="med"/>
+                      <a:tailEnd type="none" w="med" len="med"/>
+                    </a:lnB>
+                    <a:solidFill>
+                      <a:srgbClr val="141B24"/>
+                    </a:solidFill>
+                  </a:tcPr>
+                </a:tc>
+                <a:tc>
+                  <a:txBody>
+                    <a:bodyPr/>
+                    <a:lstStyle/>
+                    <a:p>
+                      <a:pPr indent="0" marL="0">
+                        <a:buNone/>
+                      </a:pPr>
+                      <a:r>
+                        <a:rPr lang="en-US" sz="1300" dirty="0">
+                          <a:solidFill>
+                            <a:srgbClr val="E6EDF3"/>
+                          </a:solidFill>
+                          <a:latin typeface="Calibri" pitchFamily="34" charset="0"/>
+                          <a:ea typeface="Calibri" pitchFamily="34" charset="-122"/>
+                          <a:cs typeface="Calibri" pitchFamily="34" charset="-120"/>
+                        </a:rPr>
+                        <a:t>6.3</a:t>
+                      </a:r>
+                      <a:endParaRPr lang="en-US" sz="1300" dirty="0">
+                        <a:latin typeface="Calibri" charset="0"/>
+                        <a:ea typeface="Calibri" charset="0"/>
+                        <a:cs typeface="Calibri" charset="0"/>
+                      </a:endParaRPr>
+                    </a:p>
+                  </a:txBody>
+                  <a:tcPr marL="91440" marR="91440" marT="45720" marB="45720">
+                    <a:lnL w="12700" cap="flat" cmpd="sng" algn="ctr">
+                      <a:solidFill>
+                        <a:srgbClr val="2A3441"/>
+                      </a:solidFill>
+                      <a:prstDash val="solid"/>
+                      <a:round/>
+                      <a:headEnd type="none" w="med" len="med"/>
+                      <a:tailEnd type="none" w="med" len="med"/>
+                    </a:lnL>
+                    <a:lnR w="12700" cap="flat" cmpd="sng" algn="ctr">
+                      <a:solidFill>
+                        <a:srgbClr val="2A3441"/>
+                      </a:solidFill>
+                      <a:prstDash val="solid"/>
+                      <a:round/>
+                      <a:headEnd type="none" w="med" len="med"/>
+                      <a:tailEnd type="none" w="med" len="med"/>
+                    </a:lnR>
+                    <a:lnT w="12700" cap="flat" cmpd="sng" algn="ctr">
+                      <a:solidFill>
+                        <a:srgbClr val="2A3441"/>
+                      </a:solidFill>
+                      <a:prstDash val="solid"/>
+                      <a:round/>
+                      <a:headEnd type="none" w="med" len="med"/>
+                      <a:tailEnd type="none" w="med" len="med"/>
+                    </a:lnT>
+                    <a:lnB w="12700" cap="flat" cmpd="sng" algn="ctr">
+                      <a:solidFill>
+                        <a:srgbClr val="2A3441"/>
+                      </a:solidFill>
+                      <a:prstDash val="solid"/>
+                      <a:round/>
+                      <a:headEnd type="none" w="med" len="med"/>
+                      <a:tailEnd type="none" w="med" len="med"/>
+                    </a:lnB>
+                    <a:solidFill>
+                      <a:srgbClr val="141B24"/>
+                    </a:solidFill>
+                  </a:tcPr>
+                </a:tc>
+              </a:tr>
+              <a:tr h="402336">
+                <a:tc>
+                  <a:txBody>
+                    <a:bodyPr/>
+                    <a:lstStyle/>
+                    <a:p>
+                      <a:pPr indent="0" marL="0">
+                        <a:buNone/>
+                      </a:pPr>
+                      <a:r>
+                        <a:rPr lang="en-US" sz="1300" dirty="0">
+                          <a:solidFill>
+                            <a:srgbClr val="E6EDF3"/>
+                          </a:solidFill>
+                          <a:latin typeface="Calibri" pitchFamily="34" charset="0"/>
+                          <a:ea typeface="Calibri" pitchFamily="34" charset="-122"/>
+                          <a:cs typeface="Calibri" pitchFamily="34" charset="-120"/>
+                        </a:rPr>
+                        <a:t>Fast (3,000 pkts)</a:t>
+                      </a:r>
+                      <a:endParaRPr lang="en-US" sz="1300" dirty="0">
+                        <a:latin typeface="Calibri" charset="0"/>
+                        <a:ea typeface="Calibri" charset="0"/>
+                        <a:cs typeface="Calibri" charset="0"/>
+                      </a:endParaRPr>
+                    </a:p>
+                  </a:txBody>
+                  <a:tcPr marL="91440" marR="91440" marT="45720" marB="45720">
+                    <a:lnL w="12700" cap="flat" cmpd="sng" algn="ctr">
+                      <a:solidFill>
+                        <a:srgbClr val="2A3441"/>
+                      </a:solidFill>
+                      <a:prstDash val="solid"/>
+                      <a:round/>
+                      <a:headEnd type="none" w="med" len="med"/>
+                      <a:tailEnd type="none" w="med" len="med"/>
+                    </a:lnL>
+                    <a:lnR w="12700" cap="flat" cmpd="sng" algn="ctr">
+                      <a:solidFill>
+                        <a:srgbClr val="2A3441"/>
+                      </a:solidFill>
+                      <a:prstDash val="solid"/>
+                      <a:round/>
+                      <a:headEnd type="none" w="med" len="med"/>
+                      <a:tailEnd type="none" w="med" len="med"/>
+                    </a:lnR>
+                    <a:lnT w="12700" cap="flat" cmpd="sng" algn="ctr">
+                      <a:solidFill>
+                        <a:srgbClr val="2A3441"/>
+                      </a:solidFill>
+                      <a:prstDash val="solid"/>
+                      <a:round/>
+                      <a:headEnd type="none" w="med" len="med"/>
+                      <a:tailEnd type="none" w="med" len="med"/>
+                    </a:lnT>
+                    <a:lnB w="12700" cap="flat" cmpd="sng" algn="ctr">
+                      <a:solidFill>
+                        <a:srgbClr val="2A3441"/>
+                      </a:solidFill>
+                      <a:prstDash val="solid"/>
+                      <a:round/>
+                      <a:headEnd type="none" w="med" len="med"/>
+                      <a:tailEnd type="none" w="med" len="med"/>
+                    </a:lnB>
+                    <a:solidFill>
+                      <a:srgbClr val="141B24"/>
+                    </a:solidFill>
+                  </a:tcPr>
+                </a:tc>
+                <a:tc>
+                  <a:txBody>
+                    <a:bodyPr/>
+                    <a:lstStyle/>
+                    <a:p>
+                      <a:pPr indent="0" marL="0">
+                        <a:buNone/>
+                      </a:pPr>
+                      <a:r>
+                        <a:rPr lang="en-US" sz="1300" dirty="0">
+                          <a:solidFill>
+                            <a:srgbClr val="E6EDF3"/>
+                          </a:solidFill>
+                          <a:latin typeface="Calibri" pitchFamily="34" charset="0"/>
+                          <a:ea typeface="Calibri" pitchFamily="34" charset="-122"/>
+                          <a:cs typeface="Calibri" pitchFamily="34" charset="-120"/>
+                        </a:rPr>
+                        <a:t>19.8</a:t>
+                      </a:r>
+                      <a:endParaRPr lang="en-US" sz="1300" dirty="0">
+                        <a:latin typeface="Calibri" charset="0"/>
+                        <a:ea typeface="Calibri" charset="0"/>
+                        <a:cs typeface="Calibri" charset="0"/>
+                      </a:endParaRPr>
+                    </a:p>
+                  </a:txBody>
+                  <a:tcPr marL="91440" marR="91440" marT="45720" marB="45720">
+                    <a:lnL w="12700" cap="flat" cmpd="sng" algn="ctr">
+                      <a:solidFill>
+                        <a:srgbClr val="2A3441"/>
+                      </a:solidFill>
+                      <a:prstDash val="solid"/>
+                      <a:round/>
+                      <a:headEnd type="none" w="med" len="med"/>
+                      <a:tailEnd type="none" w="med" len="med"/>
+                    </a:lnL>
+                    <a:lnR w="12700" cap="flat" cmpd="sng" algn="ctr">
+                      <a:solidFill>
+                        <a:srgbClr val="2A3441"/>
+                      </a:solidFill>
+                      <a:prstDash val="solid"/>
+                      <a:round/>
+                      <a:headEnd type="none" w="med" len="med"/>
+                      <a:tailEnd type="none" w="med" len="med"/>
+                    </a:lnR>
+                    <a:lnT w="12700" cap="flat" cmpd="sng" algn="ctr">
+                      <a:solidFill>
+                        <a:srgbClr val="2A3441"/>
+                      </a:solidFill>
+                      <a:prstDash val="solid"/>
+                      <a:round/>
+                      <a:headEnd type="none" w="med" len="med"/>
+                      <a:tailEnd type="none" w="med" len="med"/>
+                    </a:lnT>
+                    <a:lnB w="12700" cap="flat" cmpd="sng" algn="ctr">
+                      <a:solidFill>
+                        <a:srgbClr val="2A3441"/>
+                      </a:solidFill>
+                      <a:prstDash val="solid"/>
+                      <a:round/>
+                      <a:headEnd type="none" w="med" len="med"/>
+                      <a:tailEnd type="none" w="med" len="med"/>
+                    </a:lnB>
+                    <a:solidFill>
+                      <a:srgbClr val="141B24"/>
+                    </a:solidFill>
+                  </a:tcPr>
+                </a:tc>
+                <a:tc>
+                  <a:txBody>
+                    <a:bodyPr/>
+                    <a:lstStyle/>
+                    <a:p>
+                      <a:pPr indent="0" marL="0">
+                        <a:buNone/>
+                      </a:pPr>
+                      <a:r>
+                        <a:rPr lang="en-US" sz="1300" dirty="0">
+                          <a:solidFill>
+                            <a:srgbClr val="E6EDF3"/>
+                          </a:solidFill>
+                          <a:latin typeface="Calibri" pitchFamily="34" charset="0"/>
+                          <a:ea typeface="Calibri" pitchFamily="34" charset="-122"/>
+                          <a:cs typeface="Calibri" pitchFamily="34" charset="-120"/>
+                        </a:rPr>
+                        <a:t>17.3</a:t>
+                      </a:r>
+                      <a:endParaRPr lang="en-US" sz="1300" dirty="0">
+                        <a:latin typeface="Calibri" charset="0"/>
+                        <a:ea typeface="Calibri" charset="0"/>
+                        <a:cs typeface="Calibri" charset="0"/>
+                      </a:endParaRPr>
+                    </a:p>
+                  </a:txBody>
+                  <a:tcPr marL="91440" marR="91440" marT="45720" marB="45720">
+                    <a:lnL w="12700" cap="flat" cmpd="sng" algn="ctr">
+                      <a:solidFill>
+                        <a:srgbClr val="2A3441"/>
+                      </a:solidFill>
+                      <a:prstDash val="solid"/>
+                      <a:round/>
+                      <a:headEnd type="none" w="med" len="med"/>
+                      <a:tailEnd type="none" w="med" len="med"/>
+                    </a:lnL>
+                    <a:lnR w="12700" cap="flat" cmpd="sng" algn="ctr">
+                      <a:solidFill>
+                        <a:srgbClr val="2A3441"/>
+                      </a:solidFill>
+                      <a:prstDash val="solid"/>
+                      <a:round/>
+                      <a:headEnd type="none" w="med" len="med"/>
+                      <a:tailEnd type="none" w="med" len="med"/>
+                    </a:lnR>
+                    <a:lnT w="12700" cap="flat" cmpd="sng" algn="ctr">
+                      <a:solidFill>
+                        <a:srgbClr val="2A3441"/>
+                      </a:solidFill>
+                      <a:prstDash val="solid"/>
+                      <a:round/>
+                      <a:headEnd type="none" w="med" len="med"/>
+                      <a:tailEnd type="none" w="med" len="med"/>
+                    </a:lnT>
+                    <a:lnB w="12700" cap="flat" cmpd="sng" algn="ctr">
+                      <a:solidFill>
+                        <a:srgbClr val="2A3441"/>
+                      </a:solidFill>
+                      <a:prstDash val="solid"/>
+                      <a:round/>
+                      <a:headEnd type="none" w="med" len="med"/>
+                      <a:tailEnd type="none" w="med" len="med"/>
+                    </a:lnB>
+                    <a:solidFill>
+                      <a:srgbClr val="141B24"/>
+                    </a:solidFill>
+                  </a:tcPr>
+                </a:tc>
+                <a:tc>
+                  <a:txBody>
+                    <a:bodyPr/>
+                    <a:lstStyle/>
+                    <a:p>
+                      <a:pPr indent="0" marL="0">
+                        <a:buNone/>
+                      </a:pPr>
+                      <a:r>
+                        <a:rPr lang="en-US" sz="1300" dirty="0">
+                          <a:solidFill>
+                            <a:srgbClr val="E6EDF3"/>
+                          </a:solidFill>
+                          <a:latin typeface="Calibri" pitchFamily="34" charset="0"/>
+                          <a:ea typeface="Calibri" pitchFamily="34" charset="-122"/>
+                          <a:cs typeface="Calibri" pitchFamily="34" charset="-120"/>
+                        </a:rPr>
+                        <a:t>4.0</a:t>
+                      </a:r>
+                      <a:endParaRPr lang="en-US" sz="1300" dirty="0">
+                        <a:latin typeface="Calibri" charset="0"/>
+                        <a:ea typeface="Calibri" charset="0"/>
+                        <a:cs typeface="Calibri" charset="0"/>
+                      </a:endParaRPr>
+                    </a:p>
+                  </a:txBody>
+                  <a:tcPr marL="91440" marR="91440" marT="45720" marB="45720">
+                    <a:lnL w="12700" cap="flat" cmpd="sng" algn="ctr">
+                      <a:solidFill>
+                        <a:srgbClr val="2A3441"/>
+                      </a:solidFill>
+                      <a:prstDash val="solid"/>
+                      <a:round/>
+                      <a:headEnd type="none" w="med" len="med"/>
+                      <a:tailEnd type="none" w="med" len="med"/>
+                    </a:lnL>
+                    <a:lnR w="12700" cap="flat" cmpd="sng" algn="ctr">
+                      <a:solidFill>
+                        <a:srgbClr val="2A3441"/>
+                      </a:solidFill>
+                      <a:prstDash val="solid"/>
+                      <a:round/>
+                      <a:headEnd type="none" w="med" len="med"/>
+                      <a:tailEnd type="none" w="med" len="med"/>
+                    </a:lnR>
+                    <a:lnT w="12700" cap="flat" cmpd="sng" algn="ctr">
+                      <a:solidFill>
+                        <a:srgbClr val="2A3441"/>
+                      </a:solidFill>
+                      <a:prstDash val="solid"/>
+                      <a:round/>
+                      <a:headEnd type="none" w="med" len="med"/>
+                      <a:tailEnd type="none" w="med" len="med"/>
+                    </a:lnT>
+                    <a:lnB w="12700" cap="flat" cmpd="sng" algn="ctr">
+                      <a:solidFill>
+                        <a:srgbClr val="2A3441"/>
+                      </a:solidFill>
+                      <a:prstDash val="solid"/>
+                      <a:round/>
+                      <a:headEnd type="none" w="med" len="med"/>
+                      <a:tailEnd type="none" w="med" len="med"/>
+                    </a:lnB>
+                    <a:solidFill>
+                      <a:srgbClr val="141B24"/>
+                    </a:solidFill>
+                  </a:tcPr>
+                </a:tc>
+              </a:tr>
+              <a:tr h="402336">
+                <a:tc>
+                  <a:txBody>
+                    <a:bodyPr/>
+                    <a:lstStyle/>
+                    <a:p>
+                      <a:pPr indent="0" marL="0">
+                        <a:buNone/>
+                      </a:pPr>
+                      <a:r>
+                        <a:rPr lang="en-US" sz="1300" dirty="0">
+                          <a:solidFill>
+                            <a:srgbClr val="E6EDF3"/>
+                          </a:solidFill>
+                          <a:latin typeface="Calibri" pitchFamily="34" charset="0"/>
+                          <a:ea typeface="Calibri" pitchFamily="34" charset="-122"/>
+                          <a:cs typeface="Calibri" pitchFamily="34" charset="-120"/>
+                        </a:rPr>
+                        <a:t>5G-like</a:t>
+                      </a:r>
+                      <a:endParaRPr lang="en-US" sz="1300" dirty="0">
+                        <a:latin typeface="Calibri" charset="0"/>
+                        <a:ea typeface="Calibri" charset="0"/>
+                        <a:cs typeface="Calibri" charset="0"/>
+                      </a:endParaRPr>
+                    </a:p>
+                  </a:txBody>
+                  <a:tcPr marL="91440" marR="91440" marT="45720" marB="45720">
+                    <a:lnL w="12700" cap="flat" cmpd="sng" algn="ctr">
+                      <a:solidFill>
+                        <a:srgbClr val="2A3441"/>
+                      </a:solidFill>
+                      <a:prstDash val="solid"/>
+                      <a:round/>
+                      <a:headEnd type="none" w="med" len="med"/>
+                      <a:tailEnd type="none" w="med" len="med"/>
+                    </a:lnL>
+                    <a:lnR w="12700" cap="flat" cmpd="sng" algn="ctr">
+                      <a:solidFill>
+                        <a:srgbClr val="2A3441"/>
+                      </a:solidFill>
+                      <a:prstDash val="solid"/>
+                      <a:round/>
+                      <a:headEnd type="none" w="med" len="med"/>
+                      <a:tailEnd type="none" w="med" len="med"/>
+                    </a:lnR>
+                    <a:lnT w="12700" cap="flat" cmpd="sng" algn="ctr">
+                      <a:solidFill>
+                        <a:srgbClr val="2A3441"/>
+                      </a:solidFill>
+                      <a:prstDash val="solid"/>
+                      <a:round/>
+                      <a:headEnd type="none" w="med" len="med"/>
+                      <a:tailEnd type="none" w="med" len="med"/>
+                    </a:lnT>
+                    <a:lnB w="12700" cap="flat" cmpd="sng" algn="ctr">
+                      <a:solidFill>
+                        <a:srgbClr val="2A3441"/>
+                      </a:solidFill>
+                      <a:prstDash val="solid"/>
+                      <a:round/>
+                      <a:headEnd type="none" w="med" len="med"/>
+                      <a:tailEnd type="none" w="med" len="med"/>
+                    </a:lnB>
+                    <a:solidFill>
+                      <a:srgbClr val="141B24"/>
+                    </a:solidFill>
+                  </a:tcPr>
+                </a:tc>
+                <a:tc>
+                  <a:txBody>
+                    <a:bodyPr/>
+                    <a:lstStyle/>
+                    <a:p>
+                      <a:pPr indent="0" marL="0">
+                        <a:buNone/>
+                      </a:pPr>
+                      <a:r>
+                        <a:rPr lang="en-US" sz="1300" dirty="0">
+                          <a:solidFill>
+                            <a:srgbClr val="E6EDF3"/>
+                          </a:solidFill>
+                          <a:latin typeface="Calibri" pitchFamily="34" charset="0"/>
+                          <a:ea typeface="Calibri" pitchFamily="34" charset="-122"/>
+                          <a:cs typeface="Calibri" pitchFamily="34" charset="-120"/>
+                        </a:rPr>
+                        <a:t>1.30</a:t>
+                      </a:r>
+                      <a:endParaRPr lang="en-US" sz="1300" dirty="0">
+                        <a:latin typeface="Calibri" charset="0"/>
+                        <a:ea typeface="Calibri" charset="0"/>
+                        <a:cs typeface="Calibri" charset="0"/>
+                      </a:endParaRPr>
+                    </a:p>
+                  </a:txBody>
+                  <a:tcPr marL="91440" marR="91440" marT="45720" marB="45720">
+                    <a:lnL w="12700" cap="flat" cmpd="sng" algn="ctr">
+                      <a:solidFill>
+                        <a:srgbClr val="2A3441"/>
+                      </a:solidFill>
+                      <a:prstDash val="solid"/>
+                      <a:round/>
+                      <a:headEnd type="none" w="med" len="med"/>
+                      <a:tailEnd type="none" w="med" len="med"/>
+                    </a:lnL>
+                    <a:lnR w="12700" cap="flat" cmpd="sng" algn="ctr">
+                      <a:solidFill>
+                        <a:srgbClr val="2A3441"/>
+                      </a:solidFill>
+                      <a:prstDash val="solid"/>
+                      <a:round/>
+                      <a:headEnd type="none" w="med" len="med"/>
+                      <a:tailEnd type="none" w="med" len="med"/>
+                    </a:lnR>
+                    <a:lnT w="12700" cap="flat" cmpd="sng" algn="ctr">
+                      <a:solidFill>
+                        <a:srgbClr val="2A3441"/>
+                      </a:solidFill>
+                      <a:prstDash val="solid"/>
+                      <a:round/>
+                      <a:headEnd type="none" w="med" len="med"/>
+                      <a:tailEnd type="none" w="med" len="med"/>
+                    </a:lnT>
+                    <a:lnB w="12700" cap="flat" cmpd="sng" algn="ctr">
+                      <a:solidFill>
+                        <a:srgbClr val="2A3441"/>
+                      </a:solidFill>
+                      <a:prstDash val="solid"/>
+                      <a:round/>
+                      <a:headEnd type="none" w="med" len="med"/>
+                      <a:tailEnd type="none" w="med" len="med"/>
+                    </a:lnB>
+                    <a:solidFill>
+                      <a:srgbClr val="141B24"/>
+                    </a:solidFill>
+                  </a:tcPr>
+                </a:tc>
+                <a:tc>
+                  <a:txBody>
+                    <a:bodyPr/>
+                    <a:lstStyle/>
+                    <a:p>
+                      <a:pPr indent="0" marL="0">
+                        <a:buNone/>
+                      </a:pPr>
+                      <a:r>
+                        <a:rPr lang="en-US" sz="1300" dirty="0">
+                          <a:solidFill>
+                            <a:srgbClr val="E6EDF3"/>
+                          </a:solidFill>
+                          <a:latin typeface="Calibri" pitchFamily="34" charset="0"/>
+                          <a:ea typeface="Calibri" pitchFamily="34" charset="-122"/>
+                          <a:cs typeface="Calibri" pitchFamily="34" charset="-120"/>
+                        </a:rPr>
+                        <a:t>1.09</a:t>
+                      </a:r>
+                      <a:endParaRPr lang="en-US" sz="1300" dirty="0">
+                        <a:latin typeface="Calibri" charset="0"/>
+                        <a:ea typeface="Calibri" charset="0"/>
+                        <a:cs typeface="Calibri" charset="0"/>
+                      </a:endParaRPr>
+                    </a:p>
+                  </a:txBody>
+                  <a:tcPr marL="91440" marR="91440" marT="45720" marB="45720">
+                    <a:lnL w="12700" cap="flat" cmpd="sng" algn="ctr">
+                      <a:solidFill>
+                        <a:srgbClr val="2A3441"/>
+                      </a:solidFill>
+                      <a:prstDash val="solid"/>
+                      <a:round/>
+                      <a:headEnd type="none" w="med" len="med"/>
+                      <a:tailEnd type="none" w="med" len="med"/>
+                    </a:lnL>
+                    <a:lnR w="12700" cap="flat" cmpd="sng" algn="ctr">
+                      <a:solidFill>
+                        <a:srgbClr val="2A3441"/>
+                      </a:solidFill>
+                      <a:prstDash val="solid"/>
+                      <a:round/>
+                      <a:headEnd type="none" w="med" len="med"/>
+                      <a:tailEnd type="none" w="med" len="med"/>
+                    </a:lnR>
+                    <a:lnT w="12700" cap="flat" cmpd="sng" algn="ctr">
+                      <a:solidFill>
+                        <a:srgbClr val="2A3441"/>
+                      </a:solidFill>
+                      <a:prstDash val="solid"/>
+                      <a:round/>
+                      <a:headEnd type="none" w="med" len="med"/>
+                      <a:tailEnd type="none" w="med" len="med"/>
+                    </a:lnT>
+                    <a:lnB w="12700" cap="flat" cmpd="sng" algn="ctr">
+                      <a:solidFill>
+                        <a:srgbClr val="2A3441"/>
+                      </a:solidFill>
+                      <a:prstDash val="solid"/>
+                      <a:round/>
+                      <a:headEnd type="none" w="med" len="med"/>
+                      <a:tailEnd type="none" w="med" len="med"/>
+                    </a:lnB>
+                    <a:solidFill>
+                      <a:srgbClr val="141B24"/>
+                    </a:solidFill>
+                  </a:tcPr>
+                </a:tc>
+                <a:tc>
+                  <a:txBody>
+                    <a:bodyPr/>
+                    <a:lstStyle/>
+                    <a:p>
+                      <a:pPr indent="0" marL="0">
+                        <a:buNone/>
+                      </a:pPr>
+                      <a:r>
+                        <a:rPr lang="en-US" sz="1300" dirty="0">
+                          <a:solidFill>
+                            <a:srgbClr val="E6EDF3"/>
+                          </a:solidFill>
+                          <a:latin typeface="Calibri" pitchFamily="34" charset="0"/>
+                          <a:ea typeface="Calibri" pitchFamily="34" charset="-122"/>
+                          <a:cs typeface="Calibri" pitchFamily="34" charset="-120"/>
+                        </a:rPr>
+                        <a:t>1.09</a:t>
+                      </a:r>
+                      <a:endParaRPr lang="en-US" sz="1300" dirty="0">
+                        <a:latin typeface="Calibri" charset="0"/>
+                        <a:ea typeface="Calibri" charset="0"/>
+                        <a:cs typeface="Calibri" charset="0"/>
+                      </a:endParaRPr>
+                    </a:p>
+                  </a:txBody>
+                  <a:tcPr marL="91440" marR="91440" marT="45720" marB="45720">
+                    <a:lnL w="12700" cap="flat" cmpd="sng" algn="ctr">
+                      <a:solidFill>
+                        <a:srgbClr val="2A3441"/>
+                      </a:solidFill>
+                      <a:prstDash val="solid"/>
+                      <a:round/>
+                      <a:headEnd type="none" w="med" len="med"/>
+                      <a:tailEnd type="none" w="med" len="med"/>
+                    </a:lnL>
+                    <a:lnR w="12700" cap="flat" cmpd="sng" algn="ctr">
+                      <a:solidFill>
+                        <a:srgbClr val="2A3441"/>
+                      </a:solidFill>
+                      <a:prstDash val="solid"/>
+                      <a:round/>
+                      <a:headEnd type="none" w="med" len="med"/>
+                      <a:tailEnd type="none" w="med" len="med"/>
+                    </a:lnR>
+                    <a:lnT w="12700" cap="flat" cmpd="sng" algn="ctr">
+                      <a:solidFill>
+                        <a:srgbClr val="2A3441"/>
+                      </a:solidFill>
+                      <a:prstDash val="solid"/>
+                      <a:round/>
+                      <a:headEnd type="none" w="med" len="med"/>
+                      <a:tailEnd type="none" w="med" len="med"/>
+                    </a:lnT>
+                    <a:lnB w="12700" cap="flat" cmpd="sng" algn="ctr">
+                      <a:solidFill>
+                        <a:srgbClr val="2A3441"/>
+                      </a:solidFill>
+                      <a:prstDash val="solid"/>
+                      <a:round/>
+                      <a:headEnd type="none" w="med" len="med"/>
+                      <a:tailEnd type="none" w="med" len="med"/>
+                    </a:lnB>
+                    <a:solidFill>
+                      <a:srgbClr val="141B24"/>
+                    </a:solidFill>
+                  </a:tcPr>
+                </a:tc>
+              </a:tr>
+              <a:tr h="402336">
+                <a:tc>
+                  <a:txBody>
+                    <a:bodyPr/>
+                    <a:lstStyle/>
+                    <a:p>
+                      <a:pPr indent="0" marL="0">
+                        <a:buNone/>
+                      </a:pPr>
+                      <a:r>
+                        <a:rPr lang="en-US" sz="1300" dirty="0">
+                          <a:solidFill>
+                            <a:srgbClr val="E6EDF3"/>
+                          </a:solidFill>
+                          <a:latin typeface="Calibri" pitchFamily="34" charset="0"/>
+                          <a:ea typeface="Calibri" pitchFamily="34" charset="-122"/>
+                          <a:cs typeface="Calibri" pitchFamily="34" charset="-120"/>
+                        </a:rPr>
+                        <a:t>Hostile, 10% loss</a:t>
+                      </a:r>
+                      <a:endParaRPr lang="en-US" sz="1300" dirty="0">
+                        <a:latin typeface="Calibri" charset="0"/>
+                        <a:ea typeface="Calibri" charset="0"/>
+                        <a:cs typeface="Calibri" charset="0"/>
+                      </a:endParaRPr>
+                    </a:p>
+                  </a:txBody>
+                  <a:tcPr marL="91440" marR="91440" marT="45720" marB="45720">
+                    <a:lnL w="12700" cap="flat" cmpd="sng" algn="ctr">
+                      <a:solidFill>
+                        <a:srgbClr val="2A3441"/>
+                      </a:solidFill>
+                      <a:prstDash val="solid"/>
+                      <a:round/>
+                      <a:headEnd type="none" w="med" len="med"/>
+                      <a:tailEnd type="none" w="med" len="med"/>
+                    </a:lnL>
+                    <a:lnR w="12700" cap="flat" cmpd="sng" algn="ctr">
+                      <a:solidFill>
+                        <a:srgbClr val="2A3441"/>
+                      </a:solidFill>
+                      <a:prstDash val="solid"/>
+                      <a:round/>
+                      <a:headEnd type="none" w="med" len="med"/>
+                      <a:tailEnd type="none" w="med" len="med"/>
+                    </a:lnR>
+                    <a:lnT w="12700" cap="flat" cmpd="sng" algn="ctr">
+                      <a:solidFill>
+                        <a:srgbClr val="2A3441"/>
+                      </a:solidFill>
+                      <a:prstDash val="solid"/>
+                      <a:round/>
+                      <a:headEnd type="none" w="med" len="med"/>
+                      <a:tailEnd type="none" w="med" len="med"/>
+                    </a:lnT>
+                    <a:lnB w="12700" cap="flat" cmpd="sng" algn="ctr">
+                      <a:solidFill>
+                        <a:srgbClr val="2A3441"/>
+                      </a:solidFill>
+                      <a:prstDash val="solid"/>
+                      <a:round/>
+                      <a:headEnd type="none" w="med" len="med"/>
+                      <a:tailEnd type="none" w="med" len="med"/>
+                    </a:lnB>
+                    <a:solidFill>
+                      <a:srgbClr val="141B24"/>
+                    </a:solidFill>
+                  </a:tcPr>
+                </a:tc>
+                <a:tc>
+                  <a:txBody>
+                    <a:bodyPr/>
+                    <a:lstStyle/>
+                    <a:p>
+                      <a:pPr indent="0" marL="0">
+                        <a:buNone/>
+                      </a:pPr>
+                      <a:r>
+                        <a:rPr lang="en-US" sz="1300" dirty="0">
+                          <a:solidFill>
+                            <a:srgbClr val="E6EDF3"/>
+                          </a:solidFill>
+                          <a:latin typeface="Calibri" pitchFamily="34" charset="0"/>
+                          <a:ea typeface="Calibri" pitchFamily="34" charset="-122"/>
+                          <a:cs typeface="Calibri" pitchFamily="34" charset="-120"/>
+                        </a:rPr>
+                        <a:t>7.5</a:t>
+                      </a:r>
+                      <a:endParaRPr lang="en-US" sz="1300" dirty="0">
+                        <a:latin typeface="Calibri" charset="0"/>
+                        <a:ea typeface="Calibri" charset="0"/>
+                        <a:cs typeface="Calibri" charset="0"/>
+                      </a:endParaRPr>
+                    </a:p>
+                  </a:txBody>
+                  <a:tcPr marL="91440" marR="91440" marT="45720" marB="45720">
+                    <a:lnL w="12700" cap="flat" cmpd="sng" algn="ctr">
+                      <a:solidFill>
+                        <a:srgbClr val="2A3441"/>
+                      </a:solidFill>
+                      <a:prstDash val="solid"/>
+                      <a:round/>
+                      <a:headEnd type="none" w="med" len="med"/>
+                      <a:tailEnd type="none" w="med" len="med"/>
+                    </a:lnL>
+                    <a:lnR w="12700" cap="flat" cmpd="sng" algn="ctr">
+                      <a:solidFill>
+                        <a:srgbClr val="2A3441"/>
+                      </a:solidFill>
+                      <a:prstDash val="solid"/>
+                      <a:round/>
+                      <a:headEnd type="none" w="med" len="med"/>
+                      <a:tailEnd type="none" w="med" len="med"/>
+                    </a:lnR>
+                    <a:lnT w="12700" cap="flat" cmpd="sng" algn="ctr">
+                      <a:solidFill>
+                        <a:srgbClr val="2A3441"/>
+                      </a:solidFill>
+                      <a:prstDash val="solid"/>
+                      <a:round/>
+                      <a:headEnd type="none" w="med" len="med"/>
+                      <a:tailEnd type="none" w="med" len="med"/>
+                    </a:lnT>
+                    <a:lnB w="12700" cap="flat" cmpd="sng" algn="ctr">
+                      <a:solidFill>
+                        <a:srgbClr val="2A3441"/>
+                      </a:solidFill>
+                      <a:prstDash val="solid"/>
+                      <a:round/>
+                      <a:headEnd type="none" w="med" len="med"/>
+                      <a:tailEnd type="none" w="med" len="med"/>
+                    </a:lnB>
+                    <a:solidFill>
+                      <a:srgbClr val="141B24"/>
+                    </a:solidFill>
+                  </a:tcPr>
+                </a:tc>
+                <a:tc>
+                  <a:txBody>
+                    <a:bodyPr/>
+                    <a:lstStyle/>
+                    <a:p>
+                      <a:pPr indent="0" marL="0">
+                        <a:buNone/>
+                      </a:pPr>
+                      <a:r>
+                        <a:rPr lang="en-US" sz="1300" dirty="0">
+                          <a:solidFill>
+                            <a:srgbClr val="E6EDF3"/>
+                          </a:solidFill>
+                          <a:latin typeface="Calibri" pitchFamily="34" charset="0"/>
+                          <a:ea typeface="Calibri" pitchFamily="34" charset="-122"/>
+                          <a:cs typeface="Calibri" pitchFamily="34" charset="-120"/>
+                        </a:rPr>
+                        <a:t>8.5</a:t>
+                      </a:r>
+                      <a:endParaRPr lang="en-US" sz="1300" dirty="0">
+                        <a:latin typeface="Calibri" charset="0"/>
+                        <a:ea typeface="Calibri" charset="0"/>
+                        <a:cs typeface="Calibri" charset="0"/>
+                      </a:endParaRPr>
+                    </a:p>
+                  </a:txBody>
+                  <a:tcPr marL="91440" marR="91440" marT="45720" marB="45720">
+                    <a:lnL w="12700" cap="flat" cmpd="sng" algn="ctr">
+                      <a:solidFill>
+                        <a:srgbClr val="2A3441"/>
+                      </a:solidFill>
+                      <a:prstDash val="solid"/>
+                      <a:round/>
+                      <a:headEnd type="none" w="med" len="med"/>
+                      <a:tailEnd type="none" w="med" len="med"/>
+                    </a:lnL>
+                    <a:lnR w="12700" cap="flat" cmpd="sng" algn="ctr">
+                      <a:solidFill>
+                        <a:srgbClr val="2A3441"/>
+                      </a:solidFill>
+                      <a:prstDash val="solid"/>
+                      <a:round/>
+                      <a:headEnd type="none" w="med" len="med"/>
+                      <a:tailEnd type="none" w="med" len="med"/>
+                    </a:lnR>
+                    <a:lnT w="12700" cap="flat" cmpd="sng" algn="ctr">
+                      <a:solidFill>
+                        <a:srgbClr val="2A3441"/>
+                      </a:solidFill>
+                      <a:prstDash val="solid"/>
+                      <a:round/>
+                      <a:headEnd type="none" w="med" len="med"/>
+                      <a:tailEnd type="none" w="med" len="med"/>
+                    </a:lnT>
+                    <a:lnB w="12700" cap="flat" cmpd="sng" algn="ctr">
+                      <a:solidFill>
+                        <a:srgbClr val="2A3441"/>
+                      </a:solidFill>
+                      <a:prstDash val="solid"/>
+                      <a:round/>
+                      <a:headEnd type="none" w="med" len="med"/>
+                      <a:tailEnd type="none" w="med" len="med"/>
+                    </a:lnB>
+                    <a:solidFill>
+                      <a:srgbClr val="141B24"/>
+                    </a:solidFill>
+                  </a:tcPr>
+                </a:tc>
+                <a:tc>
+                  <a:txBody>
+                    <a:bodyPr/>
+                    <a:lstStyle/>
+                    <a:p>
+                      <a:pPr indent="0" marL="0">
+                        <a:buNone/>
+                      </a:pPr>
+                      <a:r>
+                        <a:rPr lang="en-US" sz="1300" dirty="0">
+                          <a:solidFill>
+                            <a:srgbClr val="E6EDF3"/>
+                          </a:solidFill>
+                          <a:latin typeface="Calibri" pitchFamily="34" charset="0"/>
+                          <a:ea typeface="Calibri" pitchFamily="34" charset="-122"/>
+                          <a:cs typeface="Calibri" pitchFamily="34" charset="-120"/>
+                        </a:rPr>
+                        <a:t>5.9</a:t>
+                      </a:r>
+                      <a:endParaRPr lang="en-US" sz="1300" dirty="0">
+                        <a:latin typeface="Calibri" charset="0"/>
+                        <a:ea typeface="Calibri" charset="0"/>
+                        <a:cs typeface="Calibri" charset="0"/>
+                      </a:endParaRPr>
+                    </a:p>
+                  </a:txBody>
+                  <a:tcPr marL="91440" marR="91440" marT="45720" marB="45720">
+                    <a:lnL w="12700" cap="flat" cmpd="sng" algn="ctr">
+                      <a:solidFill>
+                        <a:srgbClr val="2A3441"/>
+                      </a:solidFill>
+                      <a:prstDash val="solid"/>
+                      <a:round/>
+                      <a:headEnd type="none" w="med" len="med"/>
+                      <a:tailEnd type="none" w="med" len="med"/>
+                    </a:lnL>
+                    <a:lnR w="12700" cap="flat" cmpd="sng" algn="ctr">
+                      <a:solidFill>
+                        <a:srgbClr val="2A3441"/>
+                      </a:solidFill>
+                      <a:prstDash val="solid"/>
+                      <a:round/>
+                      <a:headEnd type="none" w="med" len="med"/>
+                      <a:tailEnd type="none" w="med" len="med"/>
+                    </a:lnR>
+                    <a:lnT w="12700" cap="flat" cmpd="sng" algn="ctr">
+                      <a:solidFill>
+                        <a:srgbClr val="2A3441"/>
+                      </a:solidFill>
+                      <a:prstDash val="solid"/>
+                      <a:round/>
+                      <a:headEnd type="none" w="med" len="med"/>
+                      <a:tailEnd type="none" w="med" len="med"/>
+                    </a:lnT>
+                    <a:lnB w="12700" cap="flat" cmpd="sng" algn="ctr">
+                      <a:solidFill>
+                        <a:srgbClr val="2A3441"/>
+                      </a:solidFill>
+                      <a:prstDash val="solid"/>
+                      <a:round/>
+                      <a:headEnd type="none" w="med" len="med"/>
+                      <a:tailEnd type="none" w="med" len="med"/>
+                    </a:lnB>
+                    <a:solidFill>
+                      <a:srgbClr val="141B24"/>
+                    </a:solidFill>
+                  </a:tcPr>
+                </a:tc>
+              </a:tr>
+            </a:tbl>
+          </a:graphicData>
+        </a:graphic>
+      </p:graphicFrame>
+      <p:sp>
+        <p:nvSpPr>
+          <p:cNvPr id="5" name="Text 2"/>
           <p:cNvSpPr/>
           <p:nvPr/>
         </p:nvSpPr>
         <p:spPr>
           <a:xfrm>
-            <a:off x="548640" y="1371600"/>
-            <a:ext cx="5394960" cy="4206240"/>
+            <a:off x="7132320" y="1188720"/>
+            <a:ext cx="4663440" cy="4937760"/>
           </a:xfrm>
           <a:prstGeom prst="rect">
             <a:avLst/>
           </a:prstGeom>
-          <a:solidFill>
-            <a:srgbClr val="141B24"/>
-          </a:solidFill>
-          <a:ln w="12700">
-            <a:solidFill>
-              <a:srgbClr val="39FF88"/>
-            </a:solidFill>
-            <a:prstDash val="solid"/>
-          </a:ln>
+          <a:noFill/>
+          <a:ln/>
         </p:spPr>
-      </p:sp>
-      <p:sp>
-        <p:nvSpPr>
-          <p:cNvPr id="5" name="Text 3"/>
+        <p:txBody>
+          <a:bodyPr wrap="square" lIns="0" tIns="0" rIns="0" bIns="0" rtlCol="0" anchor="t"/>
+          <a:lstStyle/>
+          <a:p>
+            <a:pPr marL="342900" indent="-342900">
+              <a:spcAft>
+                <a:spcPts val="800"/>
+              </a:spcAft>
+              <a:buSzPct val="100000"/>
+              <a:buChar char="•"/>
+            </a:pPr>
+            <a:r>
+              <a:rPr lang="en-US" sz="1400" dirty="0">
+                <a:solidFill>
+                  <a:srgbClr val="E6EDF3"/>
+                </a:solidFill>
+                <a:latin typeface="Calibri" pitchFamily="34" charset="0"/>
+                <a:ea typeface="Calibri" pitchFamily="34" charset="-122"/>
+                <a:cs typeface="Calibri" pitchFamily="34" charset="-120"/>
+              </a:rPr>
+              <a:t>Limit found: window cap 32 caps the satellite path at about 107 packets/s; receive window raised to 256</a:t>
+            </a:r>
+            <a:endParaRPr lang="en-US" sz="1400" dirty="0"/>
+          </a:p>
+          <a:p>
+            <a:pPr marL="342900" indent="-342900">
+              <a:spcAft>
+                <a:spcPts val="800"/>
+              </a:spcAft>
+              <a:buSzPct val="100000"/>
+              <a:buChar char="•"/>
+            </a:pPr>
+            <a:r>
+              <a:rPr lang="en-US" sz="1400" dirty="0">
+                <a:solidFill>
+                  <a:srgbClr val="E6EDF3"/>
+                </a:solidFill>
+                <a:latin typeface="Calibri" pitchFamily="34" charset="0"/>
+                <a:ea typeface="Calibri" pitchFamily="34" charset="-122"/>
+                <a:cs typeface="Calibri" pitchFamily="34" charset="-120"/>
+              </a:rPr>
+              <a:t>Baseline tuned too: AIMD with cap 128 and a high start threshold</a:t>
+            </a:r>
+            <a:endParaRPr lang="en-US" sz="1400" dirty="0"/>
+          </a:p>
+          <a:p>
+            <a:pPr marL="342900" indent="-342900">
+              <a:spcAft>
+                <a:spcPts val="800"/>
+              </a:spcAft>
+              <a:buSzPct val="100000"/>
+              <a:buChar char="•"/>
+            </a:pPr>
+            <a:r>
+              <a:rPr lang="en-US" sz="1400" dirty="0">
+                <a:solidFill>
+                  <a:srgbClr val="E6EDF3"/>
+                </a:solidFill>
+                <a:latin typeface="Calibri" pitchFamily="34" charset="0"/>
+                <a:ea typeface="Calibri" pitchFamily="34" charset="-122"/>
+                <a:cs typeface="Calibri" pitchFamily="34" charset="-120"/>
+              </a:rPr>
+              <a:t>New default for the neural agent: cap 128 plus the AIMD hand-over</a:t>
+            </a:r>
+            <a:endParaRPr lang="en-US" sz="1400" dirty="0"/>
+          </a:p>
+          <a:p>
+            <a:pPr marL="342900" indent="-342900">
+              <a:spcAft>
+                <a:spcPts val="800"/>
+              </a:spcAft>
+              <a:buSzPct val="100000"/>
+              <a:buChar char="•"/>
+            </a:pPr>
+            <a:r>
+              <a:rPr lang="en-US" sz="1400" dirty="0">
+                <a:solidFill>
+                  <a:srgbClr val="E6EDF3"/>
+                </a:solidFill>
+                <a:latin typeface="Calibri" pitchFamily="34" charset="0"/>
+                <a:ea typeface="Calibri" pitchFamily="34" charset="-122"/>
+                <a:cs typeface="Calibri" pitchFamily="34" charset="-120"/>
+              </a:rPr>
+              <a:t>45 to 77% faster than tuned AIMD on lossy, satellite and fast paths; equal on 5G-like and hostile</a:t>
+            </a:r>
+            <a:endParaRPr lang="en-US" sz="1400" dirty="0"/>
+          </a:p>
+          <a:p>
+            <a:pPr marL="342900" indent="-342900">
+              <a:spcAft>
+                <a:spcPts val="800"/>
+              </a:spcAft>
+              <a:buSzPct val="100000"/>
+              <a:buChar char="•"/>
+            </a:pPr>
+            <a:r>
+              <a:rPr lang="en-US" sz="1400" dirty="0">
+                <a:solidFill>
+                  <a:srgbClr val="E6EDF3"/>
+                </a:solidFill>
+                <a:latin typeface="Calibri" pitchFamily="34" charset="0"/>
+                <a:ea typeface="Calibri" pitchFamily="34" charset="-122"/>
+                <a:cs typeface="Calibri" pitchFamily="34" charset="-120"/>
+              </a:rPr>
+              <a:t>CUBIC tried: mixed, never beat the agent. Cost of the agent: more retransmissions on the fast path</a:t>
+            </a:r>
+            <a:endParaRPr lang="en-US" sz="1400" dirty="0"/>
+          </a:p>
+        </p:txBody>
+      </p:sp>
+      <p:sp>
+        <p:nvSpPr>
+          <p:cNvPr id="6" name="Text 3"/>
           <p:cNvSpPr/>
           <p:nvPr/>
         </p:nvSpPr>
         <p:spPr>
           <a:xfrm>
-            <a:off x="731520" y="1508760"/>
-            <a:ext cx="5029200" cy="457200"/>
+            <a:off x="548640" y="4023360"/>
+            <a:ext cx="6217920" cy="731520"/>
           </a:xfrm>
           <a:prstGeom prst="rect">
             <a:avLst/>
@@ -16154,266 +18021,17 @@
               <a:buNone/>
             </a:pPr>
             <a:r>
-              <a:rPr lang="en-US" sz="2000" b="1" dirty="0">
-                <a:solidFill>
-                  <a:srgbClr val="39FF88"/>
-                </a:solidFill>
-                <a:latin typeface="Courier New" pitchFamily="34" charset="0"/>
-                <a:ea typeface="Courier New" pitchFamily="34" charset="-122"/>
-                <a:cs typeface="Courier New" pitchFamily="34" charset="-120"/>
-              </a:rPr>
-              <a:t>Learned</a:t>
-            </a:r>
-            <a:endParaRPr lang="en-US" sz="2000" dirty="0"/>
-          </a:p>
-        </p:txBody>
-      </p:sp>
-      <p:sp>
-        <p:nvSpPr>
-          <p:cNvPr id="6" name="Text 4"/>
-          <p:cNvSpPr/>
-          <p:nvPr/>
-        </p:nvSpPr>
-        <p:spPr>
-          <a:xfrm>
-            <a:off x="731520" y="2011680"/>
-            <a:ext cx="5029200" cy="3429000"/>
-          </a:xfrm>
-          <a:prstGeom prst="rect">
-            <a:avLst/>
-          </a:prstGeom>
-          <a:noFill/>
-          <a:ln/>
-        </p:spPr>
-        <p:txBody>
-          <a:bodyPr wrap="square" lIns="0" tIns="0" rIns="0" bIns="0" rtlCol="0" anchor="t"/>
-          <a:lstStyle/>
-          <a:p>
-            <a:pPr indent="0" marL="0">
-              <a:buNone/>
-            </a:pPr>
-            <a:r>
-              <a:rPr lang="en-US" sz="2000" dirty="0">
-                <a:solidFill>
-                  <a:srgbClr val="E6EDF3"/>
+              <a:rPr lang="en-US" sz="1300" dirty="0">
+                <a:solidFill>
+                  <a:srgbClr val="8B98A5"/>
                 </a:solidFill>
                 <a:latin typeface="Calibri" pitchFamily="34" charset="0"/>
                 <a:ea typeface="Calibri" pitchFamily="34" charset="-122"/>
                 <a:cs typeface="Calibri" pitchFamily="34" charset="-120"/>
               </a:rPr>
-              <a:t>Reliability is a set of simple rules working together.</a:t>
-            </a:r>
-            <a:endParaRPr lang="en-US" sz="2000" dirty="0"/>
-          </a:p>
-          <a:p>
-            <a:pPr indent="0" marL="0">
-              <a:buNone/>
-            </a:pPr>
-            <a:r>
-              <a:rPr lang="en-US" sz="2000" dirty="0">
-                <a:solidFill>
-                  <a:srgbClr val="E6EDF3"/>
-                </a:solidFill>
-                <a:latin typeface="Calibri" pitchFamily="34" charset="0"/>
-                <a:ea typeface="Calibri" pitchFamily="34" charset="-122"/>
-                <a:cs typeface="Calibri" pitchFamily="34" charset="-120"/>
-              </a:rPr>
-              <a:t>Congestion control matters as much as retransmission.</a:t>
-            </a:r>
-            <a:endParaRPr lang="en-US" sz="2000" dirty="0"/>
-          </a:p>
-          <a:p>
-            <a:pPr indent="0" marL="0">
-              <a:buNone/>
-            </a:pPr>
-            <a:r>
-              <a:rPr lang="en-US" sz="2000" dirty="0">
-                <a:solidFill>
-                  <a:srgbClr val="E6EDF3"/>
-                </a:solidFill>
-                <a:latin typeface="Calibri" pitchFamily="34" charset="0"/>
-                <a:ea typeface="Calibri" pitchFamily="34" charset="-122"/>
-                <a:cs typeface="Calibri" pitchFamily="34" charset="-120"/>
-              </a:rPr>
-              <a:t>Testing tools fail in surprising ways.</a:t>
-            </a:r>
-            <a:endParaRPr lang="en-US" sz="2000" dirty="0"/>
-          </a:p>
-        </p:txBody>
-      </p:sp>
-      <p:sp>
-        <p:nvSpPr>
-          <p:cNvPr id="7" name="Shape 5"/>
-          <p:cNvSpPr/>
-          <p:nvPr/>
-        </p:nvSpPr>
-        <p:spPr>
-          <a:xfrm>
-            <a:off x="6217920" y="1371600"/>
-            <a:ext cx="5394960" cy="4206240"/>
-          </a:xfrm>
-          <a:prstGeom prst="rect">
-            <a:avLst/>
-          </a:prstGeom>
-          <a:solidFill>
-            <a:srgbClr val="141B24"/>
-          </a:solidFill>
-          <a:ln w="12700">
-            <a:solidFill>
-              <a:srgbClr val="FFB000"/>
-            </a:solidFill>
-            <a:prstDash val="solid"/>
-          </a:ln>
-        </p:spPr>
-      </p:sp>
-      <p:sp>
-        <p:nvSpPr>
-          <p:cNvPr id="8" name="Text 6"/>
-          <p:cNvSpPr/>
-          <p:nvPr/>
-        </p:nvSpPr>
-        <p:spPr>
-          <a:xfrm>
-            <a:off x="6400800" y="1508760"/>
-            <a:ext cx="5029200" cy="457200"/>
-          </a:xfrm>
-          <a:prstGeom prst="rect">
-            <a:avLst/>
-          </a:prstGeom>
-          <a:noFill/>
-          <a:ln/>
-        </p:spPr>
-        <p:txBody>
-          <a:bodyPr wrap="square" lIns="0" tIns="0" rIns="0" bIns="0" rtlCol="0" anchor="ctr"/>
-          <a:lstStyle/>
-          <a:p>
-            <a:pPr indent="0" marL="0">
-              <a:buNone/>
-            </a:pPr>
-            <a:r>
-              <a:rPr lang="en-US" sz="2000" b="1" dirty="0">
-                <a:solidFill>
-                  <a:srgbClr val="FFB000"/>
-                </a:solidFill>
-                <a:latin typeface="Courier New" pitchFamily="34" charset="0"/>
-                <a:ea typeface="Courier New" pitchFamily="34" charset="-122"/>
-                <a:cs typeface="Courier New" pitchFamily="34" charset="-120"/>
-              </a:rPr>
-              <a:t>Next</a:t>
-            </a:r>
-            <a:endParaRPr lang="en-US" sz="2000" dirty="0"/>
-          </a:p>
-        </p:txBody>
-      </p:sp>
-      <p:sp>
-        <p:nvSpPr>
-          <p:cNvPr id="9" name="Text 7"/>
-          <p:cNvSpPr/>
-          <p:nvPr/>
-        </p:nvSpPr>
-        <p:spPr>
-          <a:xfrm>
-            <a:off x="6400800" y="2011680"/>
-            <a:ext cx="5029200" cy="3429000"/>
-          </a:xfrm>
-          <a:prstGeom prst="rect">
-            <a:avLst/>
-          </a:prstGeom>
-          <a:noFill/>
-          <a:ln/>
-        </p:spPr>
-        <p:txBody>
-          <a:bodyPr wrap="square" lIns="0" tIns="0" rIns="0" bIns="0" rtlCol="0" anchor="t"/>
-          <a:lstStyle/>
-          <a:p>
-            <a:pPr indent="0" marL="0">
-              <a:buNone/>
-            </a:pPr>
-            <a:r>
-              <a:rPr lang="en-US" sz="2000" dirty="0">
-                <a:solidFill>
-                  <a:srgbClr val="E6EDF3"/>
-                </a:solidFill>
-                <a:latin typeface="Calibri" pitchFamily="34" charset="0"/>
-                <a:ea typeface="Calibri" pitchFamily="34" charset="-122"/>
-                <a:cs typeface="Calibri" pitchFamily="34" charset="-120"/>
-              </a:rPr>
-              <a:t>Train the neural agent in C / on real netem</a:t>
-            </a:r>
-            <a:endParaRPr lang="en-US" sz="2000" dirty="0"/>
-          </a:p>
-          <a:p>
-            <a:pPr indent="0" marL="0">
-              <a:buNone/>
-            </a:pPr>
-            <a:r>
-              <a:rPr lang="en-US" sz="2000" dirty="0">
-                <a:solidFill>
-                  <a:srgbClr val="E6EDF3"/>
-                </a:solidFill>
-                <a:latin typeface="Calibri" pitchFamily="34" charset="0"/>
-                <a:ea typeface="Calibri" pitchFamily="34" charset="-122"/>
-                <a:cs typeface="Calibri" pitchFamily="34" charset="-120"/>
-              </a:rPr>
-              <a:t>Selective ACK where throughput limits the path</a:t>
-            </a:r>
-            <a:endParaRPr lang="en-US" sz="2000" dirty="0"/>
-          </a:p>
-          <a:p>
-            <a:pPr indent="0" marL="0">
-              <a:buNone/>
-            </a:pPr>
-            <a:r>
-              <a:rPr lang="en-US" sz="2000" dirty="0">
-                <a:solidFill>
-                  <a:srgbClr val="E6EDF3"/>
-                </a:solidFill>
-                <a:latin typeface="Calibri" pitchFamily="34" charset="0"/>
-                <a:ea typeface="Calibri" pitchFamily="34" charset="-122"/>
-                <a:cs typeface="Calibri" pitchFamily="34" charset="-120"/>
-              </a:rPr>
-              <a:t>Kernel netem and real multi-machine tests</a:t>
-            </a:r>
-            <a:endParaRPr lang="en-US" sz="2000" dirty="0"/>
-          </a:p>
-        </p:txBody>
-      </p:sp>
-      <p:sp>
-        <p:nvSpPr>
-          <p:cNvPr id="10" name="Text 8"/>
-          <p:cNvSpPr/>
-          <p:nvPr/>
-        </p:nvSpPr>
-        <p:spPr>
-          <a:xfrm>
-            <a:off x="548640" y="5852160"/>
-            <a:ext cx="10972800" cy="365760"/>
-          </a:xfrm>
-          <a:prstGeom prst="rect">
-            <a:avLst/>
-          </a:prstGeom>
-          <a:noFill/>
-          <a:ln/>
-        </p:spPr>
-        <p:txBody>
-          <a:bodyPr wrap="square" lIns="0" tIns="0" rIns="0" bIns="0" rtlCol="0" anchor="ctr"/>
-          <a:lstStyle/>
-          <a:p>
-            <a:pPr indent="0" marL="0">
-              <a:buNone/>
-            </a:pPr>
-            <a:r>
-              <a:rPr lang="en-US" sz="1400" dirty="0">
-                <a:solidFill>
-                  <a:srgbClr val="8B98A5"/>
-                </a:solidFill>
-                <a:latin typeface="Calibri" pitchFamily="34" charset="0"/>
-                <a:ea typeface="Calibri" pitchFamily="34" charset="-122"/>
-                <a:cs typeface="Calibri" pitchFamily="34" charset="-120"/>
-              </a:rPr>
-              <a:t>Limits: Go-Back-N wastes bandwidth and suffers under reordering; C tests use an emulated path; the tabular agent did not beat AIMD in C.</a:t>
-            </a:r>
-            <a:endParaRPr lang="en-US" sz="1400" dirty="0"/>
+              <a:t>10 runs per cell (hostile: 5), 95% intervals. Flags: --maxcwnd, --ssthresh, --hybrid, --mode cubic. Code: eval_perf*.sh.</a:t>
+            </a:r>
+            <a:endParaRPr lang="en-US" sz="1300" dirty="0"/>
           </a:p>
         </p:txBody>
       </p:sp>
@@ -16457,8 +18075,8 @@
         </p:nvSpPr>
         <p:spPr>
           <a:xfrm>
-            <a:off x="731520" y="2103120"/>
-            <a:ext cx="10058400" cy="1097280"/>
+            <a:off x="548640" y="320040"/>
+            <a:ext cx="11064240" cy="731520"/>
           </a:xfrm>
           <a:prstGeom prst="rect">
             <a:avLst/>
@@ -16474,7 +18092,7 @@
               <a:buNone/>
             </a:pPr>
             <a:r>
-              <a:rPr lang="en-US" sz="6400" b="1" dirty="0">
+              <a:rPr lang="en-US" sz="3000" b="1" dirty="0">
                 <a:solidFill>
                   <a:srgbClr val="39FF88"/>
                 </a:solidFill>
@@ -16482,9 +18100,9 @@
                 <a:ea typeface="Courier New" pitchFamily="34" charset="-122"/>
                 <a:cs typeface="Courier New" pitchFamily="34" charset="-120"/>
               </a:rPr>
-              <a:t>Thank you</a:t>
-            </a:r>
-            <a:endParaRPr lang="en-US" sz="6400" dirty="0"/>
+              <a:t>Learnings and future work</a:t>
+            </a:r>
+            <a:endParaRPr lang="en-US" sz="3000" dirty="0"/>
           </a:p>
         </p:txBody>
       </p:sp>
@@ -16496,8 +18114,8 @@
         </p:nvSpPr>
         <p:spPr>
           <a:xfrm>
-            <a:off x="731520" y="3474720"/>
-            <a:ext cx="10058400" cy="548640"/>
+            <a:off x="9418320" y="6446520"/>
+            <a:ext cx="2377440" cy="274320"/>
           </a:xfrm>
           <a:prstGeom prst="rect">
             <a:avLst/>
@@ -16509,34 +18127,59 @@
           <a:bodyPr wrap="square" lIns="0" tIns="0" rIns="0" bIns="0" rtlCol="0" anchor="ctr"/>
           <a:lstStyle/>
           <a:p>
-            <a:pPr indent="0" marL="0">
+            <a:pPr algn="r" indent="0" marL="0">
               <a:buNone/>
             </a:pPr>
             <a:r>
-              <a:rPr lang="en-US" sz="2600" dirty="0">
-                <a:solidFill>
-                  <a:srgbClr val="E6EDF3"/>
+              <a:rPr lang="en-US" sz="1000" dirty="0">
+                <a:solidFill>
+                  <a:srgbClr val="8B98A5"/>
                 </a:solidFill>
                 <a:latin typeface="Courier New" pitchFamily="34" charset="0"/>
                 <a:ea typeface="Courier New" pitchFamily="34" charset="-122"/>
                 <a:cs typeface="Courier New" pitchFamily="34" charset="-120"/>
               </a:rPr>
-              <a:t>github.com/Capsturrrr/rudp</a:t>
-            </a:r>
-            <a:endParaRPr lang="en-US" sz="2600" dirty="0"/>
+              <a:t>27 / 28   Smart-RUDP</a:t>
+            </a:r>
+            <a:endParaRPr lang="en-US" sz="1000" dirty="0"/>
           </a:p>
         </p:txBody>
       </p:sp>
       <p:sp>
         <p:nvSpPr>
-          <p:cNvPr id="4" name="Text 2"/>
+          <p:cNvPr id="4" name="Shape 2"/>
           <p:cNvSpPr/>
           <p:nvPr/>
         </p:nvSpPr>
         <p:spPr>
           <a:xfrm>
-            <a:off x="731520" y="4206240"/>
-            <a:ext cx="10058400" cy="457200"/>
+            <a:off x="548640" y="1371600"/>
+            <a:ext cx="5394960" cy="4206240"/>
+          </a:xfrm>
+          <a:prstGeom prst="rect">
+            <a:avLst/>
+          </a:prstGeom>
+          <a:solidFill>
+            <a:srgbClr val="141B24"/>
+          </a:solidFill>
+          <a:ln w="12700">
+            <a:solidFill>
+              <a:srgbClr val="39FF88"/>
+            </a:solidFill>
+            <a:prstDash val="solid"/>
+          </a:ln>
+        </p:spPr>
+      </p:sp>
+      <p:sp>
+        <p:nvSpPr>
+          <p:cNvPr id="5" name="Text 3"/>
+          <p:cNvSpPr/>
+          <p:nvPr/>
+        </p:nvSpPr>
+        <p:spPr>
+          <a:xfrm>
+            <a:off x="731520" y="1508760"/>
+            <a:ext cx="5029200" cy="457200"/>
           </a:xfrm>
           <a:prstGeom prst="rect">
             <a:avLst/>
@@ -16552,17 +18195,266 @@
               <a:buNone/>
             </a:pPr>
             <a:r>
-              <a:rPr lang="en-US" sz="1800" dirty="0">
-                <a:solidFill>
-                  <a:srgbClr val="8B98A5"/>
+              <a:rPr lang="en-US" sz="2000" b="1" dirty="0">
+                <a:solidFill>
+                  <a:srgbClr val="39FF88"/>
+                </a:solidFill>
+                <a:latin typeface="Courier New" pitchFamily="34" charset="0"/>
+                <a:ea typeface="Courier New" pitchFamily="34" charset="-122"/>
+                <a:cs typeface="Courier New" pitchFamily="34" charset="-120"/>
+              </a:rPr>
+              <a:t>Learned</a:t>
+            </a:r>
+            <a:endParaRPr lang="en-US" sz="2000" dirty="0"/>
+          </a:p>
+        </p:txBody>
+      </p:sp>
+      <p:sp>
+        <p:nvSpPr>
+          <p:cNvPr id="6" name="Text 4"/>
+          <p:cNvSpPr/>
+          <p:nvPr/>
+        </p:nvSpPr>
+        <p:spPr>
+          <a:xfrm>
+            <a:off x="731520" y="2011680"/>
+            <a:ext cx="5029200" cy="3429000"/>
+          </a:xfrm>
+          <a:prstGeom prst="rect">
+            <a:avLst/>
+          </a:prstGeom>
+          <a:noFill/>
+          <a:ln/>
+        </p:spPr>
+        <p:txBody>
+          <a:bodyPr wrap="square" lIns="0" tIns="0" rIns="0" bIns="0" rtlCol="0" anchor="t"/>
+          <a:lstStyle/>
+          <a:p>
+            <a:pPr indent="0" marL="0">
+              <a:buNone/>
+            </a:pPr>
+            <a:r>
+              <a:rPr lang="en-US" sz="2000" dirty="0">
+                <a:solidFill>
+                  <a:srgbClr val="E6EDF3"/>
                 </a:solidFill>
                 <a:latin typeface="Calibri" pitchFamily="34" charset="0"/>
                 <a:ea typeface="Calibri" pitchFamily="34" charset="-122"/>
                 <a:cs typeface="Calibri" pitchFamily="34" charset="-120"/>
               </a:rPr>
-              <a:t>Harshavardhan Mallela   Rohit Arya   Shloak Sinha</a:t>
-            </a:r>
-            <a:endParaRPr lang="en-US" sz="1800" dirty="0"/>
+              <a:t>Reliability is a set of simple rules working together.</a:t>
+            </a:r>
+            <a:endParaRPr lang="en-US" sz="2000" dirty="0"/>
+          </a:p>
+          <a:p>
+            <a:pPr indent="0" marL="0">
+              <a:buNone/>
+            </a:pPr>
+            <a:r>
+              <a:rPr lang="en-US" sz="2000" dirty="0">
+                <a:solidFill>
+                  <a:srgbClr val="E6EDF3"/>
+                </a:solidFill>
+                <a:latin typeface="Calibri" pitchFamily="34" charset="0"/>
+                <a:ea typeface="Calibri" pitchFamily="34" charset="-122"/>
+                <a:cs typeface="Calibri" pitchFamily="34" charset="-120"/>
+              </a:rPr>
+              <a:t>Congestion control matters as much as retransmission.</a:t>
+            </a:r>
+            <a:endParaRPr lang="en-US" sz="2000" dirty="0"/>
+          </a:p>
+          <a:p>
+            <a:pPr indent="0" marL="0">
+              <a:buNone/>
+            </a:pPr>
+            <a:r>
+              <a:rPr lang="en-US" sz="2000" dirty="0">
+                <a:solidFill>
+                  <a:srgbClr val="E6EDF3"/>
+                </a:solidFill>
+                <a:latin typeface="Calibri" pitchFamily="34" charset="0"/>
+                <a:ea typeface="Calibri" pitchFamily="34" charset="-122"/>
+                <a:cs typeface="Calibri" pitchFamily="34" charset="-120"/>
+              </a:rPr>
+              <a:t>Testing tools fail in surprising ways.</a:t>
+            </a:r>
+            <a:endParaRPr lang="en-US" sz="2000" dirty="0"/>
+          </a:p>
+        </p:txBody>
+      </p:sp>
+      <p:sp>
+        <p:nvSpPr>
+          <p:cNvPr id="7" name="Shape 5"/>
+          <p:cNvSpPr/>
+          <p:nvPr/>
+        </p:nvSpPr>
+        <p:spPr>
+          <a:xfrm>
+            <a:off x="6217920" y="1371600"/>
+            <a:ext cx="5394960" cy="4206240"/>
+          </a:xfrm>
+          <a:prstGeom prst="rect">
+            <a:avLst/>
+          </a:prstGeom>
+          <a:solidFill>
+            <a:srgbClr val="141B24"/>
+          </a:solidFill>
+          <a:ln w="12700">
+            <a:solidFill>
+              <a:srgbClr val="FFB000"/>
+            </a:solidFill>
+            <a:prstDash val="solid"/>
+          </a:ln>
+        </p:spPr>
+      </p:sp>
+      <p:sp>
+        <p:nvSpPr>
+          <p:cNvPr id="8" name="Text 6"/>
+          <p:cNvSpPr/>
+          <p:nvPr/>
+        </p:nvSpPr>
+        <p:spPr>
+          <a:xfrm>
+            <a:off x="6400800" y="1508760"/>
+            <a:ext cx="5029200" cy="457200"/>
+          </a:xfrm>
+          <a:prstGeom prst="rect">
+            <a:avLst/>
+          </a:prstGeom>
+          <a:noFill/>
+          <a:ln/>
+        </p:spPr>
+        <p:txBody>
+          <a:bodyPr wrap="square" lIns="0" tIns="0" rIns="0" bIns="0" rtlCol="0" anchor="ctr"/>
+          <a:lstStyle/>
+          <a:p>
+            <a:pPr indent="0" marL="0">
+              <a:buNone/>
+            </a:pPr>
+            <a:r>
+              <a:rPr lang="en-US" sz="2000" b="1" dirty="0">
+                <a:solidFill>
+                  <a:srgbClr val="FFB000"/>
+                </a:solidFill>
+                <a:latin typeface="Courier New" pitchFamily="34" charset="0"/>
+                <a:ea typeface="Courier New" pitchFamily="34" charset="-122"/>
+                <a:cs typeface="Courier New" pitchFamily="34" charset="-120"/>
+              </a:rPr>
+              <a:t>Next</a:t>
+            </a:r>
+            <a:endParaRPr lang="en-US" sz="2000" dirty="0"/>
+          </a:p>
+        </p:txBody>
+      </p:sp>
+      <p:sp>
+        <p:nvSpPr>
+          <p:cNvPr id="9" name="Text 7"/>
+          <p:cNvSpPr/>
+          <p:nvPr/>
+        </p:nvSpPr>
+        <p:spPr>
+          <a:xfrm>
+            <a:off x="6400800" y="2011680"/>
+            <a:ext cx="5029200" cy="3429000"/>
+          </a:xfrm>
+          <a:prstGeom prst="rect">
+            <a:avLst/>
+          </a:prstGeom>
+          <a:noFill/>
+          <a:ln/>
+        </p:spPr>
+        <p:txBody>
+          <a:bodyPr wrap="square" lIns="0" tIns="0" rIns="0" bIns="0" rtlCol="0" anchor="t"/>
+          <a:lstStyle/>
+          <a:p>
+            <a:pPr indent="0" marL="0">
+              <a:buNone/>
+            </a:pPr>
+            <a:r>
+              <a:rPr lang="en-US" sz="2000" dirty="0">
+                <a:solidFill>
+                  <a:srgbClr val="E6EDF3"/>
+                </a:solidFill>
+                <a:latin typeface="Calibri" pitchFamily="34" charset="0"/>
+                <a:ea typeface="Calibri" pitchFamily="34" charset="-122"/>
+                <a:cs typeface="Calibri" pitchFamily="34" charset="-120"/>
+              </a:rPr>
+              <a:t>Train the neural agent in C / on real netem</a:t>
+            </a:r>
+            <a:endParaRPr lang="en-US" sz="2000" dirty="0"/>
+          </a:p>
+          <a:p>
+            <a:pPr indent="0" marL="0">
+              <a:buNone/>
+            </a:pPr>
+            <a:r>
+              <a:rPr lang="en-US" sz="2000" dirty="0">
+                <a:solidFill>
+                  <a:srgbClr val="E6EDF3"/>
+                </a:solidFill>
+                <a:latin typeface="Calibri" pitchFamily="34" charset="0"/>
+                <a:ea typeface="Calibri" pitchFamily="34" charset="-122"/>
+                <a:cs typeface="Calibri" pitchFamily="34" charset="-120"/>
+              </a:rPr>
+              <a:t>Selective ACK where throughput limits the path</a:t>
+            </a:r>
+            <a:endParaRPr lang="en-US" sz="2000" dirty="0"/>
+          </a:p>
+          <a:p>
+            <a:pPr indent="0" marL="0">
+              <a:buNone/>
+            </a:pPr>
+            <a:r>
+              <a:rPr lang="en-US" sz="2000" dirty="0">
+                <a:solidFill>
+                  <a:srgbClr val="E6EDF3"/>
+                </a:solidFill>
+                <a:latin typeface="Calibri" pitchFamily="34" charset="0"/>
+                <a:ea typeface="Calibri" pitchFamily="34" charset="-122"/>
+                <a:cs typeface="Calibri" pitchFamily="34" charset="-120"/>
+              </a:rPr>
+              <a:t>Kernel netem and real multi-machine tests</a:t>
+            </a:r>
+            <a:endParaRPr lang="en-US" sz="2000" dirty="0"/>
+          </a:p>
+        </p:txBody>
+      </p:sp>
+      <p:sp>
+        <p:nvSpPr>
+          <p:cNvPr id="10" name="Text 8"/>
+          <p:cNvSpPr/>
+          <p:nvPr/>
+        </p:nvSpPr>
+        <p:spPr>
+          <a:xfrm>
+            <a:off x="548640" y="5852160"/>
+            <a:ext cx="10972800" cy="365760"/>
+          </a:xfrm>
+          <a:prstGeom prst="rect">
+            <a:avLst/>
+          </a:prstGeom>
+          <a:noFill/>
+          <a:ln/>
+        </p:spPr>
+        <p:txBody>
+          <a:bodyPr wrap="square" lIns="0" tIns="0" rIns="0" bIns="0" rtlCol="0" anchor="ctr"/>
+          <a:lstStyle/>
+          <a:p>
+            <a:pPr indent="0" marL="0">
+              <a:buNone/>
+            </a:pPr>
+            <a:r>
+              <a:rPr lang="en-US" sz="1400" dirty="0">
+                <a:solidFill>
+                  <a:srgbClr val="8B98A5"/>
+                </a:solidFill>
+                <a:latin typeface="Calibri" pitchFamily="34" charset="0"/>
+                <a:ea typeface="Calibri" pitchFamily="34" charset="-122"/>
+                <a:cs typeface="Calibri" pitchFamily="34" charset="-120"/>
+              </a:rPr>
+              <a:t>Limits: Go-Back-N wastes bandwidth and suffers under reordering; C tests use an emulated path; the tabular agent did not beat AIMD in C.</a:t>
+            </a:r>
+            <a:endParaRPr lang="en-US" sz="1400" dirty="0"/>
           </a:p>
         </p:txBody>
       </p:sp>
@@ -16606,6 +18498,155 @@
         </p:nvSpPr>
         <p:spPr>
           <a:xfrm>
+            <a:off x="731520" y="2103120"/>
+            <a:ext cx="10058400" cy="1097280"/>
+          </a:xfrm>
+          <a:prstGeom prst="rect">
+            <a:avLst/>
+          </a:prstGeom>
+          <a:noFill/>
+          <a:ln/>
+        </p:spPr>
+        <p:txBody>
+          <a:bodyPr wrap="square" lIns="0" tIns="0" rIns="0" bIns="0" rtlCol="0" anchor="ctr"/>
+          <a:lstStyle/>
+          <a:p>
+            <a:pPr indent="0" marL="0">
+              <a:buNone/>
+            </a:pPr>
+            <a:r>
+              <a:rPr lang="en-US" sz="6400" b="1" dirty="0">
+                <a:solidFill>
+                  <a:srgbClr val="39FF88"/>
+                </a:solidFill>
+                <a:latin typeface="Courier New" pitchFamily="34" charset="0"/>
+                <a:ea typeface="Courier New" pitchFamily="34" charset="-122"/>
+                <a:cs typeface="Courier New" pitchFamily="34" charset="-120"/>
+              </a:rPr>
+              <a:t>Thank you</a:t>
+            </a:r>
+            <a:endParaRPr lang="en-US" sz="6400" dirty="0"/>
+          </a:p>
+        </p:txBody>
+      </p:sp>
+      <p:sp>
+        <p:nvSpPr>
+          <p:cNvPr id="3" name="Text 1"/>
+          <p:cNvSpPr/>
+          <p:nvPr/>
+        </p:nvSpPr>
+        <p:spPr>
+          <a:xfrm>
+            <a:off x="731520" y="3474720"/>
+            <a:ext cx="10058400" cy="548640"/>
+          </a:xfrm>
+          <a:prstGeom prst="rect">
+            <a:avLst/>
+          </a:prstGeom>
+          <a:noFill/>
+          <a:ln/>
+        </p:spPr>
+        <p:txBody>
+          <a:bodyPr wrap="square" lIns="0" tIns="0" rIns="0" bIns="0" rtlCol="0" anchor="ctr"/>
+          <a:lstStyle/>
+          <a:p>
+            <a:pPr indent="0" marL="0">
+              <a:buNone/>
+            </a:pPr>
+            <a:r>
+              <a:rPr lang="en-US" sz="2600" dirty="0">
+                <a:solidFill>
+                  <a:srgbClr val="E6EDF3"/>
+                </a:solidFill>
+                <a:latin typeface="Courier New" pitchFamily="34" charset="0"/>
+                <a:ea typeface="Courier New" pitchFamily="34" charset="-122"/>
+                <a:cs typeface="Courier New" pitchFamily="34" charset="-120"/>
+              </a:rPr>
+              <a:t>github.com/Capsturrrr/rudp</a:t>
+            </a:r>
+            <a:endParaRPr lang="en-US" sz="2600" dirty="0"/>
+          </a:p>
+        </p:txBody>
+      </p:sp>
+      <p:sp>
+        <p:nvSpPr>
+          <p:cNvPr id="4" name="Text 2"/>
+          <p:cNvSpPr/>
+          <p:nvPr/>
+        </p:nvSpPr>
+        <p:spPr>
+          <a:xfrm>
+            <a:off x="731520" y="4206240"/>
+            <a:ext cx="10058400" cy="457200"/>
+          </a:xfrm>
+          <a:prstGeom prst="rect">
+            <a:avLst/>
+          </a:prstGeom>
+          <a:noFill/>
+          <a:ln/>
+        </p:spPr>
+        <p:txBody>
+          <a:bodyPr wrap="square" lIns="0" tIns="0" rIns="0" bIns="0" rtlCol="0" anchor="ctr"/>
+          <a:lstStyle/>
+          <a:p>
+            <a:pPr indent="0" marL="0">
+              <a:buNone/>
+            </a:pPr>
+            <a:r>
+              <a:rPr lang="en-US" sz="1800" dirty="0">
+                <a:solidFill>
+                  <a:srgbClr val="8B98A5"/>
+                </a:solidFill>
+                <a:latin typeface="Calibri" pitchFamily="34" charset="0"/>
+                <a:ea typeface="Calibri" pitchFamily="34" charset="-122"/>
+                <a:cs typeface="Calibri" pitchFamily="34" charset="-120"/>
+              </a:rPr>
+              <a:t>Harshavardhan Mallela   Rohit Arya   Shloak Sinha</a:t>
+            </a:r>
+            <a:endParaRPr lang="en-US" sz="1800" dirty="0"/>
+          </a:p>
+        </p:txBody>
+      </p:sp>
+    </p:spTree>
+  </p:cSld>
+  <p:clrMapOvr>
+    <a:masterClrMapping/>
+  </p:clrMapOvr>
+</p:sld>
+</file>
+
+<file path=ppt/slides/slide29.xml><?xml version="1.0" encoding="utf-8"?>
+<p:sld xmlns:a="http://schemas.openxmlformats.org/drawingml/2006/main" xmlns:r="http://schemas.openxmlformats.org/officeDocument/2006/relationships" xmlns:p="http://schemas.openxmlformats.org/presentationml/2006/main">
+  <p:cSld name="Slide 29">
+    <p:bg>
+      <p:bgPr>
+        <a:solidFill>
+          <a:srgbClr val="0B0F14"/>
+        </a:solidFill>
+      </p:bgPr>
+    </p:bg>
+    <p:spTree>
+      <p:nvGrpSpPr>
+        <p:cNvPr id="1" name=""/>
+        <p:cNvGrpSpPr/>
+        <p:nvPr/>
+      </p:nvGrpSpPr>
+      <p:grpSpPr>
+        <a:xfrm>
+          <a:off x="0" y="0"/>
+          <a:ext cx="0" cy="0"/>
+          <a:chOff x="0" y="0"/>
+          <a:chExt cx="0" cy="0"/>
+        </a:xfrm>
+      </p:grpSpPr>
+      <p:sp>
+        <p:nvSpPr>
+          <p:cNvPr id="2" name="Text 0"/>
+          <p:cNvSpPr/>
+          <p:nvPr/>
+        </p:nvSpPr>
+        <p:spPr>
+          <a:xfrm>
             <a:off x="548640" y="320040"/>
             <a:ext cx="11064240" cy="731520"/>
           </a:xfrm>
@@ -16910,7 +18951,7 @@
                 <a:ea typeface="Courier New" pitchFamily="34" charset="-122"/>
                 <a:cs typeface="Courier New" pitchFamily="34" charset="-120"/>
               </a:rPr>
-              <a:t>3 / 27   Smart-RUDP</a:t>
+              <a:t>3 / 28   Smart-RUDP</a:t>
             </a:r>
             <a:endParaRPr lang="en-US" sz="1000" dirty="0"/>
           </a:p>
@@ -17304,7 +19345,7 @@
                 <a:ea typeface="Courier New" pitchFamily="34" charset="-122"/>
                 <a:cs typeface="Courier New" pitchFamily="34" charset="-120"/>
               </a:rPr>
-              <a:t>4 / 27   Smart-RUDP</a:t>
+              <a:t>4 / 28   Smart-RUDP</a:t>
             </a:r>
             <a:endParaRPr lang="en-US" sz="1000" dirty="0"/>
           </a:p>
@@ -17865,7 +19906,7 @@
                 <a:ea typeface="Courier New" pitchFamily="34" charset="-122"/>
                 <a:cs typeface="Courier New" pitchFamily="34" charset="-120"/>
               </a:rPr>
-              <a:t>5 / 27   Smart-RUDP</a:t>
+              <a:t>5 / 28   Smart-RUDP</a:t>
             </a:r>
             <a:endParaRPr lang="en-US" sz="1000" dirty="0"/>
           </a:p>
@@ -19304,7 +21345,7 @@
                 <a:ea typeface="Courier New" pitchFamily="34" charset="-122"/>
                 <a:cs typeface="Courier New" pitchFamily="34" charset="-120"/>
               </a:rPr>
-              <a:t>6 / 27   Smart-RUDP</a:t>
+              <a:t>6 / 28   Smart-RUDP</a:t>
             </a:r>
             <a:endParaRPr lang="en-US" sz="1000" dirty="0"/>
           </a:p>
@@ -20539,7 +22580,7 @@
                 <a:ea typeface="Courier New" pitchFamily="34" charset="-122"/>
                 <a:cs typeface="Courier New" pitchFamily="34" charset="-120"/>
               </a:rPr>
-              <a:t>7 / 27   Smart-RUDP</a:t>
+              <a:t>7 / 28   Smart-RUDP</a:t>
             </a:r>
             <a:endParaRPr lang="en-US" sz="1000" dirty="0"/>
           </a:p>
@@ -20982,7 +23023,7 @@
                 <a:ea typeface="Courier New" pitchFamily="34" charset="-122"/>
                 <a:cs typeface="Courier New" pitchFamily="34" charset="-120"/>
               </a:rPr>
-              <a:t>8 / 27   Smart-RUDP</a:t>
+              <a:t>8 / 28   Smart-RUDP</a:t>
             </a:r>
             <a:endParaRPr lang="en-US" sz="1000" dirty="0"/>
           </a:p>
@@ -21282,7 +23323,7 @@
                 <a:ea typeface="Courier New" pitchFamily="34" charset="-122"/>
                 <a:cs typeface="Courier New" pitchFamily="34" charset="-120"/>
               </a:rPr>
-              <a:t>9 / 27   Smart-RUDP</a:t>
+              <a:t>9 / 28   Smart-RUDP</a:t>
             </a:r>
             <a:endParaRPr lang="en-US" sz="1000" dirty="0"/>
           </a:p>

</xml_diff>